<commit_message>
Neues Konzept: 510 m² Gastro, 2 Ankermieter-Büros, 3+5 Wohnungen; Excel, Decks, Businessplan angepasst
Co-Authored-By: Claude Sonnet 5.5 <noreply@anthropic.com>
Claude-Session: https://claude.ai/code/session_01HJGZfxHv7bzYyqdLwg8aFJ
</commit_message>
<xml_diff>
--- a/praesentation/Neue-Mitte-Werlte_Baufeld3_Gastro-Konzept.pptx
+++ b/praesentation/Neue-Mitte-Werlte_Baufeld3_Gastro-Konzept.pptx
@@ -604,7 +604,7 @@
           <a:p>
             <a:r>
               <a:rPr lang="en-US" dirty="0"/>
-              <a:t>Plausibilitätsrechnung mit Annahmen für Gäste und Bon. Die Gastro hat ca. 150 Plätze, die Annahme ist vorsichtig.</a:t>
+              <a:t>Plausibilitätsrechnung mit Annahmen für Gäste und Bon. Die Gastro hat ca. 190 Plätze (ca. 4.100 € Umsatz je Sitzplatz und Jahr), die Annahme ist vorsichtig.</a:t>
             </a:r>
             <a:endParaRPr lang="en-US" dirty="0"/>
           </a:p>
@@ -868,7 +868,7 @@
           <a:p>
             <a:r>
               <a:rPr lang="en-US" dirty="0"/>
-              <a:t>Annahme des Bauherrn: 150.000 € für einen einfachen Ausbau. Für 460 m² und ca. 150 Plätze ist das knapp, Angebote von Küchen- und Lüftungsbauern müssen es bestätigen.</a:t>
+              <a:t>Hochgerechnet vom Budget des Bauherrn (150.000 € für 150 Plätze): 1.000 € je Platz bei 190 Plätzen. Angebote von Küchen- und Lüftungsbauern müssen es bestätigen.</a:t>
             </a:r>
             <a:endParaRPr lang="en-US" dirty="0"/>
           </a:p>
@@ -2472,7 +2472,7 @@
                 <a:ea typeface="Arial" pitchFamily="34" charset="-122"/>
                 <a:cs typeface="Arial" pitchFamily="34" charset="-120"/>
               </a:rPr>
-              <a:t>Bar-Restaurant für den ganzen Tag, ca. 460 m² im ganzen EG</a:t>
+              <a:t>Bar-Restaurant für den ganzen Tag, ca. 510 m² im ganzen EG</a:t>
             </a:r>
             <a:endParaRPr lang="en-US" sz="1700" dirty="0"/>
           </a:p>
@@ -2611,7 +2611,7 @@
                 <a:ea typeface="Georgia" pitchFamily="34" charset="-122"/>
                 <a:cs typeface="Georgia" pitchFamily="34" charset="-120"/>
               </a:rPr>
-              <a:t>Wie 50.000 € Umsatz im Monat zusammenkommen</a:t>
+              <a:t>Wie 65.000 € Umsatz im Monat zusammenkommen</a:t>
             </a:r>
             <a:endParaRPr lang="en-US" sz="2700" dirty="0"/>
           </a:p>
@@ -3172,7 +3172,7 @@
                           <a:ea typeface="Arial" pitchFamily="34" charset="-122"/>
                           <a:cs typeface="Arial" pitchFamily="34" charset="-120"/>
                         </a:rPr>
-                        <a:t>40</a:t>
+                        <a:t>50</a:t>
                       </a:r>
                       <a:endParaRPr lang="en-US" sz="1250" dirty="0">
                         <a:latin typeface="Arial" charset="0"/>
@@ -3302,7 +3302,7 @@
                           <a:ea typeface="Arial" pitchFamily="34" charset="-122"/>
                           <a:cs typeface="Arial" pitchFamily="34" charset="-120"/>
                         </a:rPr>
-                        <a:t>9.688 €</a:t>
+                        <a:t>12.110 €</a:t>
                       </a:r>
                       <a:endParaRPr lang="en-US" sz="1250" dirty="0">
                         <a:latin typeface="Arial" charset="0"/>
@@ -3499,7 +3499,7 @@
                           <a:ea typeface="Arial" pitchFamily="34" charset="-122"/>
                           <a:cs typeface="Arial" pitchFamily="34" charset="-120"/>
                         </a:rPr>
-                        <a:t>45</a:t>
+                        <a:t>60</a:t>
                       </a:r>
                       <a:endParaRPr lang="en-US" sz="1250" dirty="0">
                         <a:latin typeface="Arial" charset="0"/>
@@ -3629,7 +3629,7 @@
                           <a:ea typeface="Arial" pitchFamily="34" charset="-122"/>
                           <a:cs typeface="Arial" pitchFamily="34" charset="-120"/>
                         </a:rPr>
-                        <a:t>5.089 €</a:t>
+                        <a:t>6.786 €</a:t>
                       </a:r>
                       <a:endParaRPr lang="en-US" sz="1250" dirty="0">
                         <a:latin typeface="Arial" charset="0"/>
@@ -3826,7 +3826,7 @@
                           <a:ea typeface="Arial" pitchFamily="34" charset="-122"/>
                           <a:cs typeface="Arial" pitchFamily="34" charset="-120"/>
                         </a:rPr>
-                        <a:t>38</a:t>
+                        <a:t>48</a:t>
                       </a:r>
                       <a:endParaRPr lang="en-US" sz="1250" dirty="0">
                         <a:latin typeface="Arial" charset="0"/>
@@ -3956,7 +3956,7 @@
                           <a:ea typeface="Arial" pitchFamily="34" charset="-122"/>
                           <a:cs typeface="Arial" pitchFamily="34" charset="-120"/>
                         </a:rPr>
-                        <a:t>28.652 €</a:t>
+                        <a:t>36.192 €</a:t>
                       </a:r>
                       <a:endParaRPr lang="en-US" sz="1250" dirty="0">
                         <a:latin typeface="Arial" charset="0"/>
@@ -4153,7 +4153,7 @@
                           <a:ea typeface="Arial" pitchFamily="34" charset="-122"/>
                           <a:cs typeface="Arial" pitchFamily="34" charset="-120"/>
                         </a:rPr>
-                        <a:t>35</a:t>
+                        <a:t>45</a:t>
                       </a:r>
                       <a:endParaRPr lang="en-US" sz="1250" dirty="0">
                         <a:latin typeface="Arial" charset="0"/>
@@ -4283,7 +4283,7 @@
                           <a:ea typeface="Arial" pitchFamily="34" charset="-122"/>
                           <a:cs typeface="Arial" pitchFamily="34" charset="-120"/>
                         </a:rPr>
-                        <a:t>4.568 €</a:t>
+                        <a:t>5.872 €</a:t>
                       </a:r>
                       <a:endParaRPr lang="en-US" sz="1250" dirty="0">
                         <a:latin typeface="Arial" charset="0"/>
@@ -4350,7 +4350,7 @@
                           <a:ea typeface="Arial" pitchFamily="34" charset="-122"/>
                           <a:cs typeface="Arial" pitchFamily="34" charset="-120"/>
                         </a:rPr>
-                        <a:t>Feiern im Séparée (2 pro Monat)</a:t>
+                        <a:t>Feiern im Séparée (3 pro Monat)</a:t>
                       </a:r>
                       <a:endParaRPr lang="en-US" sz="1250" dirty="0">
                         <a:latin typeface="Arial" charset="0"/>
@@ -4415,7 +4415,7 @@
                           <a:ea typeface="Arial" pitchFamily="34" charset="-122"/>
                           <a:cs typeface="Arial" pitchFamily="34" charset="-120"/>
                         </a:rPr>
-                        <a:t>2</a:t>
+                        <a:t>3</a:t>
                       </a:r>
                       <a:endParaRPr lang="en-US" sz="1250" dirty="0">
                         <a:latin typeface="Arial" charset="0"/>
@@ -4480,7 +4480,7 @@
                           <a:ea typeface="Arial" pitchFamily="34" charset="-122"/>
                           <a:cs typeface="Arial" pitchFamily="34" charset="-120"/>
                         </a:rPr>
-                        <a:t>20</a:t>
+                        <a:t>30</a:t>
                       </a:r>
                       <a:endParaRPr lang="en-US" sz="1250" dirty="0">
                         <a:latin typeface="Arial" charset="0"/>
@@ -4610,7 +4610,7 @@
                           <a:ea typeface="Arial" pitchFamily="34" charset="-122"/>
                           <a:cs typeface="Arial" pitchFamily="34" charset="-120"/>
                         </a:rPr>
-                        <a:t>1.800 €</a:t>
+                        <a:t>4.050 €</a:t>
                       </a:r>
                       <a:endParaRPr lang="en-US" sz="1250" dirty="0">
                         <a:latin typeface="Arial" charset="0"/>
@@ -4904,7 +4904,7 @@
                           <a:ea typeface="Arial" pitchFamily="34" charset="-122"/>
                           <a:cs typeface="Arial" pitchFamily="34" charset="-120"/>
                         </a:rPr>
-                        <a:t>49.797 €</a:t>
+                        <a:t>65.011 €</a:t>
                       </a:r>
                       <a:endParaRPr lang="en-US" sz="1250" dirty="0">
                         <a:latin typeface="Arial" charset="0"/>
@@ -5034,7 +5034,7 @@
                 <a:ea typeface="Arial" pitchFamily="34" charset="-122"/>
                 <a:cs typeface="Arial" pitchFamily="34" charset="-120"/>
               </a:rPr>
-              <a:t>Ca. 2.416 Gäste im Monat, im Schnitt ca. 93 pro Öffnungstag bei 150 Plätzen.</a:t>
+              <a:t>Ca. 3.117 Gäste im Monat, im Schnitt ca. 120 pro Öffnungstag bei 190 Plätzen.</a:t>
             </a:r>
             <a:endParaRPr lang="en-US" sz="1300" dirty="0"/>
           </a:p>
@@ -5883,7 +5883,7 @@
                           <a:ea typeface="Arial" pitchFamily="34" charset="-122"/>
                           <a:cs typeface="Arial" pitchFamily="34" charset="-120"/>
                         </a:rPr>
-                        <a:t>Küchenhilfe, Spülen</a:t>
+                        <a:t>Koch</a:t>
                       </a:r>
                       <a:endParaRPr lang="en-US" sz="1250" dirty="0">
                         <a:latin typeface="Arial" charset="0"/>
@@ -6013,7 +6013,204 @@
                           <a:ea typeface="Arial" pitchFamily="34" charset="-122"/>
                           <a:cs typeface="Arial" pitchFamily="34" charset="-120"/>
                         </a:rPr>
-                        <a:t>1.600 €</a:t>
+                        <a:t>2.400 €</a:t>
+                      </a:r>
+                      <a:endParaRPr lang="en-US" sz="1250" dirty="0">
+                        <a:latin typeface="Arial" charset="0"/>
+                        <a:ea typeface="Arial" charset="0"/>
+                        <a:cs typeface="Arial" charset="0"/>
+                      </a:endParaRPr>
+                    </a:p>
+                  </a:txBody>
+                  <a:tcPr marL="91440" marR="91440" marT="45720" marB="45720">
+                    <a:lnL w="12700" cap="flat" cmpd="sng" algn="ctr">
+                      <a:solidFill>
+                        <a:srgbClr val="FFFFFF"/>
+                      </a:solidFill>
+                      <a:prstDash val="solid"/>
+                      <a:round/>
+                      <a:headEnd type="none" w="med" len="med"/>
+                      <a:tailEnd type="none" w="med" len="med"/>
+                    </a:lnL>
+                    <a:lnR w="12700" cap="flat" cmpd="sng" algn="ctr">
+                      <a:solidFill>
+                        <a:srgbClr val="FFFFFF"/>
+                      </a:solidFill>
+                      <a:prstDash val="solid"/>
+                      <a:round/>
+                      <a:headEnd type="none" w="med" len="med"/>
+                      <a:tailEnd type="none" w="med" len="med"/>
+                    </a:lnR>
+                    <a:lnT w="12700" cap="flat" cmpd="sng" algn="ctr">
+                      <a:solidFill>
+                        <a:srgbClr val="FFFFFF"/>
+                      </a:solidFill>
+                      <a:prstDash val="solid"/>
+                      <a:round/>
+                      <a:headEnd type="none" w="med" len="med"/>
+                      <a:tailEnd type="none" w="med" len="med"/>
+                    </a:lnT>
+                    <a:lnB w="12700" cap="flat" cmpd="sng" algn="ctr">
+                      <a:solidFill>
+                        <a:srgbClr val="FFFFFF"/>
+                      </a:solidFill>
+                      <a:prstDash val="solid"/>
+                      <a:round/>
+                      <a:headEnd type="none" w="med" len="med"/>
+                      <a:tailEnd type="none" w="med" len="med"/>
+                    </a:lnB>
+                  </a:tcPr>
+                </a:tc>
+              </a:tr>
+              <a:tr h="502920">
+                <a:tc>
+                  <a:txBody>
+                    <a:bodyPr/>
+                    <a:lstStyle/>
+                    <a:p>
+                      <a:pPr indent="0" marL="0">
+                        <a:buNone/>
+                      </a:pPr>
+                      <a:r>
+                        <a:rPr lang="en-US" sz="1250" dirty="0">
+                          <a:solidFill>
+                            <a:srgbClr val="000000"/>
+                          </a:solidFill>
+                          <a:latin typeface="Arial" pitchFamily="34" charset="0"/>
+                          <a:ea typeface="Arial" pitchFamily="34" charset="-122"/>
+                          <a:cs typeface="Arial" pitchFamily="34" charset="-120"/>
+                        </a:rPr>
+                        <a:t>Küchenhilfe, Spülen</a:t>
+                      </a:r>
+                      <a:endParaRPr lang="en-US" sz="1250" dirty="0">
+                        <a:latin typeface="Arial" charset="0"/>
+                        <a:ea typeface="Arial" charset="0"/>
+                        <a:cs typeface="Arial" charset="0"/>
+                      </a:endParaRPr>
+                    </a:p>
+                  </a:txBody>
+                  <a:tcPr marL="91440" marR="91440" marT="45720" marB="45720">
+                    <a:lnL w="12700" cap="flat" cmpd="sng" algn="ctr">
+                      <a:solidFill>
+                        <a:srgbClr val="FFFFFF"/>
+                      </a:solidFill>
+                      <a:prstDash val="solid"/>
+                      <a:round/>
+                      <a:headEnd type="none" w="med" len="med"/>
+                      <a:tailEnd type="none" w="med" len="med"/>
+                    </a:lnL>
+                    <a:lnR w="12700" cap="flat" cmpd="sng" algn="ctr">
+                      <a:solidFill>
+                        <a:srgbClr val="FFFFFF"/>
+                      </a:solidFill>
+                      <a:prstDash val="solid"/>
+                      <a:round/>
+                      <a:headEnd type="none" w="med" len="med"/>
+                      <a:tailEnd type="none" w="med" len="med"/>
+                    </a:lnR>
+                    <a:lnT w="12700" cap="flat" cmpd="sng" algn="ctr">
+                      <a:solidFill>
+                        <a:srgbClr val="FFFFFF"/>
+                      </a:solidFill>
+                      <a:prstDash val="solid"/>
+                      <a:round/>
+                      <a:headEnd type="none" w="med" len="med"/>
+                      <a:tailEnd type="none" w="med" len="med"/>
+                    </a:lnT>
+                    <a:lnB w="12700" cap="flat" cmpd="sng" algn="ctr">
+                      <a:solidFill>
+                        <a:srgbClr val="FFFFFF"/>
+                      </a:solidFill>
+                      <a:prstDash val="solid"/>
+                      <a:round/>
+                      <a:headEnd type="none" w="med" len="med"/>
+                      <a:tailEnd type="none" w="med" len="med"/>
+                    </a:lnB>
+                  </a:tcPr>
+                </a:tc>
+                <a:tc>
+                  <a:txBody>
+                    <a:bodyPr/>
+                    <a:lstStyle/>
+                    <a:p>
+                      <a:pPr indent="0" marL="0">
+                        <a:buNone/>
+                      </a:pPr>
+                      <a:r>
+                        <a:rPr lang="en-US" sz="1250" dirty="0">
+                          <a:solidFill>
+                            <a:srgbClr val="000000"/>
+                          </a:solidFill>
+                          <a:latin typeface="Arial" pitchFamily="34" charset="0"/>
+                          <a:ea typeface="Arial" pitchFamily="34" charset="-122"/>
+                          <a:cs typeface="Arial" pitchFamily="34" charset="-120"/>
+                        </a:rPr>
+                        <a:t>2 Teilzeit</a:t>
+                      </a:r>
+                      <a:endParaRPr lang="en-US" sz="1250" dirty="0">
+                        <a:latin typeface="Arial" charset="0"/>
+                        <a:ea typeface="Arial" charset="0"/>
+                        <a:cs typeface="Arial" charset="0"/>
+                      </a:endParaRPr>
+                    </a:p>
+                  </a:txBody>
+                  <a:tcPr marL="91440" marR="91440" marT="45720" marB="45720">
+                    <a:lnL w="12700" cap="flat" cmpd="sng" algn="ctr">
+                      <a:solidFill>
+                        <a:srgbClr val="FFFFFF"/>
+                      </a:solidFill>
+                      <a:prstDash val="solid"/>
+                      <a:round/>
+                      <a:headEnd type="none" w="med" len="med"/>
+                      <a:tailEnd type="none" w="med" len="med"/>
+                    </a:lnL>
+                    <a:lnR w="12700" cap="flat" cmpd="sng" algn="ctr">
+                      <a:solidFill>
+                        <a:srgbClr val="FFFFFF"/>
+                      </a:solidFill>
+                      <a:prstDash val="solid"/>
+                      <a:round/>
+                      <a:headEnd type="none" w="med" len="med"/>
+                      <a:tailEnd type="none" w="med" len="med"/>
+                    </a:lnR>
+                    <a:lnT w="12700" cap="flat" cmpd="sng" algn="ctr">
+                      <a:solidFill>
+                        <a:srgbClr val="FFFFFF"/>
+                      </a:solidFill>
+                      <a:prstDash val="solid"/>
+                      <a:round/>
+                      <a:headEnd type="none" w="med" len="med"/>
+                      <a:tailEnd type="none" w="med" len="med"/>
+                    </a:lnT>
+                    <a:lnB w="12700" cap="flat" cmpd="sng" algn="ctr">
+                      <a:solidFill>
+                        <a:srgbClr val="FFFFFF"/>
+                      </a:solidFill>
+                      <a:prstDash val="solid"/>
+                      <a:round/>
+                      <a:headEnd type="none" w="med" len="med"/>
+                      <a:tailEnd type="none" w="med" len="med"/>
+                    </a:lnB>
+                  </a:tcPr>
+                </a:tc>
+                <a:tc>
+                  <a:txBody>
+                    <a:bodyPr/>
+                    <a:lstStyle/>
+                    <a:p>
+                      <a:pPr algn="r" indent="0" marL="0">
+                        <a:buNone/>
+                      </a:pPr>
+                      <a:r>
+                        <a:rPr lang="en-US" sz="1250" dirty="0">
+                          <a:solidFill>
+                            <a:srgbClr val="000000"/>
+                          </a:solidFill>
+                          <a:latin typeface="Arial" pitchFamily="34" charset="0"/>
+                          <a:ea typeface="Arial" pitchFamily="34" charset="-122"/>
+                          <a:cs typeface="Arial" pitchFamily="34" charset="-120"/>
+                        </a:rPr>
+                        <a:t>2.800 €</a:t>
                       </a:r>
                       <a:endParaRPr lang="en-US" sz="1250" dirty="0">
                         <a:latin typeface="Arial" charset="0"/>
@@ -6145,7 +6342,7 @@
                           <a:ea typeface="Arial" pitchFamily="34" charset="-122"/>
                           <a:cs typeface="Arial" pitchFamily="34" charset="-120"/>
                         </a:rPr>
-                        <a:t>ca. 5 Teilzeit und Minijobs</a:t>
+                        <a:t>ca. 7 Teilzeit und Minijobs</a:t>
                       </a:r>
                       <a:endParaRPr lang="en-US" sz="1250" dirty="0">
                         <a:latin typeface="Arial" charset="0"/>
@@ -6210,7 +6407,7 @@
                           <a:ea typeface="Arial" pitchFamily="34" charset="-122"/>
                           <a:cs typeface="Arial" pitchFamily="34" charset="-120"/>
                         </a:rPr>
-                        <a:t>5.800 €</a:t>
+                        <a:t>6.700 €</a:t>
                       </a:r>
                       <a:endParaRPr lang="en-US" sz="1250" dirty="0">
                         <a:latin typeface="Arial" charset="0"/>
@@ -6407,7 +6604,7 @@
                           <a:ea typeface="Arial" pitchFamily="34" charset="-122"/>
                           <a:cs typeface="Arial" pitchFamily="34" charset="-120"/>
                         </a:rPr>
-                        <a:t>15.000 €</a:t>
+                        <a:t>19.500 €</a:t>
                       </a:r>
                       <a:endParaRPr lang="en-US" sz="1250" dirty="0">
                         <a:latin typeface="Arial" charset="0"/>
@@ -6537,7 +6734,7 @@
                 <a:ea typeface="Arial" pitchFamily="34" charset="-122"/>
                 <a:cs typeface="Arial" pitchFamily="34" charset="-120"/>
               </a:rPr>
-              <a:t>Du führst die Gastro selbst oder verpachtest sie. Bei Verpachtung zahlt der Betreiber ca. 12 €/m² Pacht, das sind bei 460 m² ca. 5.520 € im Monat.</a:t>
+              <a:t>Du führst die Gastro selbst oder verpachtest sie. Bei Verpachtung zahlt der Betreiber ca. 10 €/m² Pacht, das sind bei 510 m² ca. 5.100 € im Monat (ca. 8 % vom Umsatz).</a:t>
             </a:r>
             <a:endParaRPr lang="en-US" sz="1300" dirty="0"/>
           </a:p>
@@ -7061,271 +7258,6 @@
                           <a:ea typeface="Arial" pitchFamily="34" charset="-122"/>
                           <a:cs typeface="Arial" pitchFamily="34" charset="-120"/>
                         </a:rPr>
-                        <a:t>30.000 €</a:t>
-                      </a:r>
-                      <a:endParaRPr lang="en-US" sz="1250" dirty="0">
-                        <a:latin typeface="Arial" charset="0"/>
-                        <a:ea typeface="Arial" charset="0"/>
-                        <a:cs typeface="Arial" charset="0"/>
-                      </a:endParaRPr>
-                    </a:p>
-                  </a:txBody>
-                  <a:tcPr marL="91440" marR="91440" marT="45720" marB="45720">
-                    <a:lnL w="12700" cap="flat" cmpd="sng" algn="ctr">
-                      <a:solidFill>
-                        <a:srgbClr val="FFFFFF"/>
-                      </a:solidFill>
-                      <a:prstDash val="solid"/>
-                      <a:round/>
-                      <a:headEnd type="none" w="med" len="med"/>
-                      <a:tailEnd type="none" w="med" len="med"/>
-                    </a:lnL>
-                    <a:lnR w="12700" cap="flat" cmpd="sng" algn="ctr">
-                      <a:solidFill>
-                        <a:srgbClr val="FFFFFF"/>
-                      </a:solidFill>
-                      <a:prstDash val="solid"/>
-                      <a:round/>
-                      <a:headEnd type="none" w="med" len="med"/>
-                      <a:tailEnd type="none" w="med" len="med"/>
-                    </a:lnR>
-                    <a:lnT w="12700" cap="flat" cmpd="sng" algn="ctr">
-                      <a:solidFill>
-                        <a:srgbClr val="FFFFFF"/>
-                      </a:solidFill>
-                      <a:prstDash val="solid"/>
-                      <a:round/>
-                      <a:headEnd type="none" w="med" len="med"/>
-                      <a:tailEnd type="none" w="med" len="med"/>
-                    </a:lnT>
-                    <a:lnB w="12700" cap="flat" cmpd="sng" algn="ctr">
-                      <a:solidFill>
-                        <a:srgbClr val="FFFFFF"/>
-                      </a:solidFill>
-                      <a:prstDash val="solid"/>
-                      <a:round/>
-                      <a:headEnd type="none" w="med" len="med"/>
-                      <a:tailEnd type="none" w="med" len="med"/>
-                    </a:lnB>
-                  </a:tcPr>
-                </a:tc>
-                <a:tc>
-                  <a:txBody>
-                    <a:bodyPr/>
-                    <a:lstStyle/>
-                    <a:p>
-                      <a:pPr algn="r" indent="0" marL="0">
-                        <a:buNone/>
-                      </a:pPr>
-                      <a:r>
-                        <a:rPr lang="en-US" sz="1250" dirty="0">
-                          <a:solidFill>
-                            <a:srgbClr val="000000"/>
-                          </a:solidFill>
-                          <a:latin typeface="Arial" pitchFamily="34" charset="0"/>
-                          <a:ea typeface="Arial" pitchFamily="34" charset="-122"/>
-                          <a:cs typeface="Arial" pitchFamily="34" charset="-120"/>
-                        </a:rPr>
-                        <a:t>9.150 €</a:t>
-                      </a:r>
-                      <a:endParaRPr lang="en-US" sz="1250" dirty="0">
-                        <a:latin typeface="Arial" charset="0"/>
-                        <a:ea typeface="Arial" charset="0"/>
-                        <a:cs typeface="Arial" charset="0"/>
-                      </a:endParaRPr>
-                    </a:p>
-                  </a:txBody>
-                  <a:tcPr marL="91440" marR="91440" marT="45720" marB="45720">
-                    <a:lnL w="12700" cap="flat" cmpd="sng" algn="ctr">
-                      <a:solidFill>
-                        <a:srgbClr val="FFFFFF"/>
-                      </a:solidFill>
-                      <a:prstDash val="solid"/>
-                      <a:round/>
-                      <a:headEnd type="none" w="med" len="med"/>
-                      <a:tailEnd type="none" w="med" len="med"/>
-                    </a:lnL>
-                    <a:lnR w="12700" cap="flat" cmpd="sng" algn="ctr">
-                      <a:solidFill>
-                        <a:srgbClr val="FFFFFF"/>
-                      </a:solidFill>
-                      <a:prstDash val="solid"/>
-                      <a:round/>
-                      <a:headEnd type="none" w="med" len="med"/>
-                      <a:tailEnd type="none" w="med" len="med"/>
-                    </a:lnR>
-                    <a:lnT w="12700" cap="flat" cmpd="sng" algn="ctr">
-                      <a:solidFill>
-                        <a:srgbClr val="FFFFFF"/>
-                      </a:solidFill>
-                      <a:prstDash val="solid"/>
-                      <a:round/>
-                      <a:headEnd type="none" w="med" len="med"/>
-                      <a:tailEnd type="none" w="med" len="med"/>
-                    </a:lnT>
-                    <a:lnB w="12700" cap="flat" cmpd="sng" algn="ctr">
-                      <a:solidFill>
-                        <a:srgbClr val="FFFFFF"/>
-                      </a:solidFill>
-                      <a:prstDash val="solid"/>
-                      <a:round/>
-                      <a:headEnd type="none" w="med" len="med"/>
-                      <a:tailEnd type="none" w="med" len="med"/>
-                    </a:lnB>
-                  </a:tcPr>
-                </a:tc>
-                <a:tc>
-                  <a:txBody>
-                    <a:bodyPr/>
-                    <a:lstStyle/>
-                    <a:p>
-                      <a:pPr algn="r" indent="0" marL="0">
-                        <a:buNone/>
-                      </a:pPr>
-                      <a:r>
-                        <a:rPr lang="en-US" sz="1250" dirty="0">
-                          <a:solidFill>
-                            <a:srgbClr val="000000"/>
-                          </a:solidFill>
-                          <a:latin typeface="Arial" pitchFamily="34" charset="0"/>
-                          <a:ea typeface="Arial" pitchFamily="34" charset="-122"/>
-                          <a:cs typeface="Arial" pitchFamily="34" charset="-120"/>
-                        </a:rPr>
-                        <a:t>−5.520 €</a:t>
-                      </a:r>
-                      <a:endParaRPr lang="en-US" sz="1250" dirty="0">
-                        <a:latin typeface="Arial" charset="0"/>
-                        <a:ea typeface="Arial" charset="0"/>
-                        <a:cs typeface="Arial" charset="0"/>
-                      </a:endParaRPr>
-                    </a:p>
-                  </a:txBody>
-                  <a:tcPr marL="91440" marR="91440" marT="45720" marB="45720">
-                    <a:lnL w="12700" cap="flat" cmpd="sng" algn="ctr">
-                      <a:solidFill>
-                        <a:srgbClr val="FFFFFF"/>
-                      </a:solidFill>
-                      <a:prstDash val="solid"/>
-                      <a:round/>
-                      <a:headEnd type="none" w="med" len="med"/>
-                      <a:tailEnd type="none" w="med" len="med"/>
-                    </a:lnL>
-                    <a:lnR w="12700" cap="flat" cmpd="sng" algn="ctr">
-                      <a:solidFill>
-                        <a:srgbClr val="FFFFFF"/>
-                      </a:solidFill>
-                      <a:prstDash val="solid"/>
-                      <a:round/>
-                      <a:headEnd type="none" w="med" len="med"/>
-                      <a:tailEnd type="none" w="med" len="med"/>
-                    </a:lnR>
-                    <a:lnT w="12700" cap="flat" cmpd="sng" algn="ctr">
-                      <a:solidFill>
-                        <a:srgbClr val="FFFFFF"/>
-                      </a:solidFill>
-                      <a:prstDash val="solid"/>
-                      <a:round/>
-                      <a:headEnd type="none" w="med" len="med"/>
-                      <a:tailEnd type="none" w="med" len="med"/>
-                    </a:lnT>
-                    <a:lnB w="12700" cap="flat" cmpd="sng" algn="ctr">
-                      <a:solidFill>
-                        <a:srgbClr val="FFFFFF"/>
-                      </a:solidFill>
-                      <a:prstDash val="solid"/>
-                      <a:round/>
-                      <a:headEnd type="none" w="med" len="med"/>
-                      <a:tailEnd type="none" w="med" len="med"/>
-                    </a:lnB>
-                  </a:tcPr>
-                </a:tc>
-                <a:tc>
-                  <a:txBody>
-                    <a:bodyPr/>
-                    <a:lstStyle/>
-                    <a:p>
-                      <a:pPr algn="r" indent="0" marL="0">
-                        <a:buNone/>
-                      </a:pPr>
-                      <a:r>
-                        <a:rPr lang="en-US" sz="1250" b="1" dirty="0">
-                          <a:solidFill>
-                            <a:schemeClr val="accent5"/>
-                          </a:solidFill>
-                          <a:latin typeface="Arial" pitchFamily="34" charset="0"/>
-                          <a:ea typeface="Arial" pitchFamily="34" charset="-122"/>
-                          <a:cs typeface="Arial" pitchFamily="34" charset="-120"/>
-                        </a:rPr>
-                        <a:t>+3.630 €</a:t>
-                      </a:r>
-                      <a:endParaRPr lang="en-US" sz="1250" dirty="0">
-                        <a:latin typeface="Arial" charset="0"/>
-                        <a:ea typeface="Arial" charset="0"/>
-                        <a:cs typeface="Arial" charset="0"/>
-                      </a:endParaRPr>
-                    </a:p>
-                  </a:txBody>
-                  <a:tcPr marL="91440" marR="91440" marT="45720" marB="45720">
-                    <a:lnL w="12700" cap="flat" cmpd="sng" algn="ctr">
-                      <a:solidFill>
-                        <a:srgbClr val="FFFFFF"/>
-                      </a:solidFill>
-                      <a:prstDash val="solid"/>
-                      <a:round/>
-                      <a:headEnd type="none" w="med" len="med"/>
-                      <a:tailEnd type="none" w="med" len="med"/>
-                    </a:lnL>
-                    <a:lnR w="12700" cap="flat" cmpd="sng" algn="ctr">
-                      <a:solidFill>
-                        <a:srgbClr val="FFFFFF"/>
-                      </a:solidFill>
-                      <a:prstDash val="solid"/>
-                      <a:round/>
-                      <a:headEnd type="none" w="med" len="med"/>
-                      <a:tailEnd type="none" w="med" len="med"/>
-                    </a:lnR>
-                    <a:lnT w="12700" cap="flat" cmpd="sng" algn="ctr">
-                      <a:solidFill>
-                        <a:srgbClr val="FFFFFF"/>
-                      </a:solidFill>
-                      <a:prstDash val="solid"/>
-                      <a:round/>
-                      <a:headEnd type="none" w="med" len="med"/>
-                      <a:tailEnd type="none" w="med" len="med"/>
-                    </a:lnT>
-                    <a:lnB w="12700" cap="flat" cmpd="sng" algn="ctr">
-                      <a:solidFill>
-                        <a:srgbClr val="FFFFFF"/>
-                      </a:solidFill>
-                      <a:prstDash val="solid"/>
-                      <a:round/>
-                      <a:headEnd type="none" w="med" len="med"/>
-                      <a:tailEnd type="none" w="med" len="med"/>
-                    </a:lnB>
-                    <a:solidFill>
-                      <a:srgbClr val="E3F1EA"/>
-                    </a:solidFill>
-                  </a:tcPr>
-                </a:tc>
-              </a:tr>
-              <a:tr h="502920">
-                <a:tc>
-                  <a:txBody>
-                    <a:bodyPr/>
-                    <a:lstStyle/>
-                    <a:p>
-                      <a:pPr indent="0" marL="0">
-                        <a:buNone/>
-                      </a:pPr>
-                      <a:r>
-                        <a:rPr lang="en-US" sz="1250" dirty="0">
-                          <a:solidFill>
-                            <a:srgbClr val="000000"/>
-                          </a:solidFill>
-                          <a:latin typeface="Arial" pitchFamily="34" charset="0"/>
-                          <a:ea typeface="Arial" pitchFamily="34" charset="-122"/>
-                          <a:cs typeface="Arial" pitchFamily="34" charset="-120"/>
-                        </a:rPr>
                         <a:t>40.000 €</a:t>
                       </a:r>
                       <a:endParaRPr lang="en-US" sz="1250" dirty="0">
@@ -7456,7 +7388,7 @@
                           <a:ea typeface="Arial" pitchFamily="34" charset="-122"/>
                           <a:cs typeface="Arial" pitchFamily="34" charset="-120"/>
                         </a:rPr>
-                        <a:t>−5.520 €</a:t>
+                        <a:t>−5.100 €</a:t>
                       </a:r>
                       <a:endParaRPr lang="en-US" sz="1250" dirty="0">
                         <a:latin typeface="Arial" charset="0"/>
@@ -7521,7 +7453,7 @@
                           <a:ea typeface="Arial" pitchFamily="34" charset="-122"/>
                           <a:cs typeface="Arial" pitchFamily="34" charset="-120"/>
                         </a:rPr>
-                        <a:t>+6.680 €</a:t>
+                        <a:t>+7.100 €</a:t>
                       </a:r>
                       <a:endParaRPr lang="en-US" sz="1250" dirty="0">
                         <a:latin typeface="Arial" charset="0"/>
@@ -7583,7 +7515,7 @@
                         <a:buNone/>
                       </a:pPr>
                       <a:r>
-                        <a:rPr lang="en-US" sz="1250" b="1" dirty="0">
+                        <a:rPr lang="en-US" sz="1250" dirty="0">
                           <a:solidFill>
                             <a:srgbClr val="000000"/>
                           </a:solidFill>
@@ -7721,7 +7653,7 @@
                           <a:ea typeface="Arial" pitchFamily="34" charset="-122"/>
                           <a:cs typeface="Arial" pitchFamily="34" charset="-120"/>
                         </a:rPr>
-                        <a:t>−5.520 €</a:t>
+                        <a:t>−5.100 €</a:t>
                       </a:r>
                       <a:endParaRPr lang="en-US" sz="1250" dirty="0">
                         <a:latin typeface="Arial" charset="0"/>
@@ -7786,7 +7718,272 @@
                           <a:ea typeface="Arial" pitchFamily="34" charset="-122"/>
                           <a:cs typeface="Arial" pitchFamily="34" charset="-120"/>
                         </a:rPr>
-                        <a:t>+9.730 €</a:t>
+                        <a:t>+10.150 €</a:t>
+                      </a:r>
+                      <a:endParaRPr lang="en-US" sz="1250" dirty="0">
+                        <a:latin typeface="Arial" charset="0"/>
+                        <a:ea typeface="Arial" charset="0"/>
+                        <a:cs typeface="Arial" charset="0"/>
+                      </a:endParaRPr>
+                    </a:p>
+                  </a:txBody>
+                  <a:tcPr marL="91440" marR="91440" marT="45720" marB="45720">
+                    <a:lnL w="12700" cap="flat" cmpd="sng" algn="ctr">
+                      <a:solidFill>
+                        <a:srgbClr val="FFFFFF"/>
+                      </a:solidFill>
+                      <a:prstDash val="solid"/>
+                      <a:round/>
+                      <a:headEnd type="none" w="med" len="med"/>
+                      <a:tailEnd type="none" w="med" len="med"/>
+                    </a:lnL>
+                    <a:lnR w="12700" cap="flat" cmpd="sng" algn="ctr">
+                      <a:solidFill>
+                        <a:srgbClr val="FFFFFF"/>
+                      </a:solidFill>
+                      <a:prstDash val="solid"/>
+                      <a:round/>
+                      <a:headEnd type="none" w="med" len="med"/>
+                      <a:tailEnd type="none" w="med" len="med"/>
+                    </a:lnR>
+                    <a:lnT w="12700" cap="flat" cmpd="sng" algn="ctr">
+                      <a:solidFill>
+                        <a:srgbClr val="FFFFFF"/>
+                      </a:solidFill>
+                      <a:prstDash val="solid"/>
+                      <a:round/>
+                      <a:headEnd type="none" w="med" len="med"/>
+                      <a:tailEnd type="none" w="med" len="med"/>
+                    </a:lnT>
+                    <a:lnB w="12700" cap="flat" cmpd="sng" algn="ctr">
+                      <a:solidFill>
+                        <a:srgbClr val="FFFFFF"/>
+                      </a:solidFill>
+                      <a:prstDash val="solid"/>
+                      <a:round/>
+                      <a:headEnd type="none" w="med" len="med"/>
+                      <a:tailEnd type="none" w="med" len="med"/>
+                    </a:lnB>
+                    <a:solidFill>
+                      <a:srgbClr val="E3F1EA"/>
+                    </a:solidFill>
+                  </a:tcPr>
+                </a:tc>
+              </a:tr>
+              <a:tr h="502920">
+                <a:tc>
+                  <a:txBody>
+                    <a:bodyPr/>
+                    <a:lstStyle/>
+                    <a:p>
+                      <a:pPr indent="0" marL="0">
+                        <a:buNone/>
+                      </a:pPr>
+                      <a:r>
+                        <a:rPr lang="en-US" sz="1250" b="1" dirty="0">
+                          <a:solidFill>
+                            <a:srgbClr val="000000"/>
+                          </a:solidFill>
+                          <a:latin typeface="Arial" pitchFamily="34" charset="0"/>
+                          <a:ea typeface="Arial" pitchFamily="34" charset="-122"/>
+                          <a:cs typeface="Arial" pitchFamily="34" charset="-120"/>
+                        </a:rPr>
+                        <a:t>65.000 €</a:t>
+                      </a:r>
+                      <a:endParaRPr lang="en-US" sz="1250" dirty="0">
+                        <a:latin typeface="Arial" charset="0"/>
+                        <a:ea typeface="Arial" charset="0"/>
+                        <a:cs typeface="Arial" charset="0"/>
+                      </a:endParaRPr>
+                    </a:p>
+                  </a:txBody>
+                  <a:tcPr marL="91440" marR="91440" marT="45720" marB="45720">
+                    <a:lnL w="12700" cap="flat" cmpd="sng" algn="ctr">
+                      <a:solidFill>
+                        <a:srgbClr val="FFFFFF"/>
+                      </a:solidFill>
+                      <a:prstDash val="solid"/>
+                      <a:round/>
+                      <a:headEnd type="none" w="med" len="med"/>
+                      <a:tailEnd type="none" w="med" len="med"/>
+                    </a:lnL>
+                    <a:lnR w="12700" cap="flat" cmpd="sng" algn="ctr">
+                      <a:solidFill>
+                        <a:srgbClr val="FFFFFF"/>
+                      </a:solidFill>
+                      <a:prstDash val="solid"/>
+                      <a:round/>
+                      <a:headEnd type="none" w="med" len="med"/>
+                      <a:tailEnd type="none" w="med" len="med"/>
+                    </a:lnR>
+                    <a:lnT w="12700" cap="flat" cmpd="sng" algn="ctr">
+                      <a:solidFill>
+                        <a:srgbClr val="FFFFFF"/>
+                      </a:solidFill>
+                      <a:prstDash val="solid"/>
+                      <a:round/>
+                      <a:headEnd type="none" w="med" len="med"/>
+                      <a:tailEnd type="none" w="med" len="med"/>
+                    </a:lnT>
+                    <a:lnB w="12700" cap="flat" cmpd="sng" algn="ctr">
+                      <a:solidFill>
+                        <a:srgbClr val="FFFFFF"/>
+                      </a:solidFill>
+                      <a:prstDash val="solid"/>
+                      <a:round/>
+                      <a:headEnd type="none" w="med" len="med"/>
+                      <a:tailEnd type="none" w="med" len="med"/>
+                    </a:lnB>
+                  </a:tcPr>
+                </a:tc>
+                <a:tc>
+                  <a:txBody>
+                    <a:bodyPr/>
+                    <a:lstStyle/>
+                    <a:p>
+                      <a:pPr algn="r" indent="0" marL="0">
+                        <a:buNone/>
+                      </a:pPr>
+                      <a:r>
+                        <a:rPr lang="en-US" sz="1250" dirty="0">
+                          <a:solidFill>
+                            <a:srgbClr val="000000"/>
+                          </a:solidFill>
+                          <a:latin typeface="Arial" pitchFamily="34" charset="0"/>
+                          <a:ea typeface="Arial" pitchFamily="34" charset="-122"/>
+                          <a:cs typeface="Arial" pitchFamily="34" charset="-120"/>
+                        </a:rPr>
+                        <a:t>19.825 €</a:t>
+                      </a:r>
+                      <a:endParaRPr lang="en-US" sz="1250" dirty="0">
+                        <a:latin typeface="Arial" charset="0"/>
+                        <a:ea typeface="Arial" charset="0"/>
+                        <a:cs typeface="Arial" charset="0"/>
+                      </a:endParaRPr>
+                    </a:p>
+                  </a:txBody>
+                  <a:tcPr marL="91440" marR="91440" marT="45720" marB="45720">
+                    <a:lnL w="12700" cap="flat" cmpd="sng" algn="ctr">
+                      <a:solidFill>
+                        <a:srgbClr val="FFFFFF"/>
+                      </a:solidFill>
+                      <a:prstDash val="solid"/>
+                      <a:round/>
+                      <a:headEnd type="none" w="med" len="med"/>
+                      <a:tailEnd type="none" w="med" len="med"/>
+                    </a:lnL>
+                    <a:lnR w="12700" cap="flat" cmpd="sng" algn="ctr">
+                      <a:solidFill>
+                        <a:srgbClr val="FFFFFF"/>
+                      </a:solidFill>
+                      <a:prstDash val="solid"/>
+                      <a:round/>
+                      <a:headEnd type="none" w="med" len="med"/>
+                      <a:tailEnd type="none" w="med" len="med"/>
+                    </a:lnR>
+                    <a:lnT w="12700" cap="flat" cmpd="sng" algn="ctr">
+                      <a:solidFill>
+                        <a:srgbClr val="FFFFFF"/>
+                      </a:solidFill>
+                      <a:prstDash val="solid"/>
+                      <a:round/>
+                      <a:headEnd type="none" w="med" len="med"/>
+                      <a:tailEnd type="none" w="med" len="med"/>
+                    </a:lnT>
+                    <a:lnB w="12700" cap="flat" cmpd="sng" algn="ctr">
+                      <a:solidFill>
+                        <a:srgbClr val="FFFFFF"/>
+                      </a:solidFill>
+                      <a:prstDash val="solid"/>
+                      <a:round/>
+                      <a:headEnd type="none" w="med" len="med"/>
+                      <a:tailEnd type="none" w="med" len="med"/>
+                    </a:lnB>
+                  </a:tcPr>
+                </a:tc>
+                <a:tc>
+                  <a:txBody>
+                    <a:bodyPr/>
+                    <a:lstStyle/>
+                    <a:p>
+                      <a:pPr algn="r" indent="0" marL="0">
+                        <a:buNone/>
+                      </a:pPr>
+                      <a:r>
+                        <a:rPr lang="en-US" sz="1250" dirty="0">
+                          <a:solidFill>
+                            <a:srgbClr val="000000"/>
+                          </a:solidFill>
+                          <a:latin typeface="Arial" pitchFamily="34" charset="0"/>
+                          <a:ea typeface="Arial" pitchFamily="34" charset="-122"/>
+                          <a:cs typeface="Arial" pitchFamily="34" charset="-120"/>
+                        </a:rPr>
+                        <a:t>−5.100 €</a:t>
+                      </a:r>
+                      <a:endParaRPr lang="en-US" sz="1250" dirty="0">
+                        <a:latin typeface="Arial" charset="0"/>
+                        <a:ea typeface="Arial" charset="0"/>
+                        <a:cs typeface="Arial" charset="0"/>
+                      </a:endParaRPr>
+                    </a:p>
+                  </a:txBody>
+                  <a:tcPr marL="91440" marR="91440" marT="45720" marB="45720">
+                    <a:lnL w="12700" cap="flat" cmpd="sng" algn="ctr">
+                      <a:solidFill>
+                        <a:srgbClr val="FFFFFF"/>
+                      </a:solidFill>
+                      <a:prstDash val="solid"/>
+                      <a:round/>
+                      <a:headEnd type="none" w="med" len="med"/>
+                      <a:tailEnd type="none" w="med" len="med"/>
+                    </a:lnL>
+                    <a:lnR w="12700" cap="flat" cmpd="sng" algn="ctr">
+                      <a:solidFill>
+                        <a:srgbClr val="FFFFFF"/>
+                      </a:solidFill>
+                      <a:prstDash val="solid"/>
+                      <a:round/>
+                      <a:headEnd type="none" w="med" len="med"/>
+                      <a:tailEnd type="none" w="med" len="med"/>
+                    </a:lnR>
+                    <a:lnT w="12700" cap="flat" cmpd="sng" algn="ctr">
+                      <a:solidFill>
+                        <a:srgbClr val="FFFFFF"/>
+                      </a:solidFill>
+                      <a:prstDash val="solid"/>
+                      <a:round/>
+                      <a:headEnd type="none" w="med" len="med"/>
+                      <a:tailEnd type="none" w="med" len="med"/>
+                    </a:lnT>
+                    <a:lnB w="12700" cap="flat" cmpd="sng" algn="ctr">
+                      <a:solidFill>
+                        <a:srgbClr val="FFFFFF"/>
+                      </a:solidFill>
+                      <a:prstDash val="solid"/>
+                      <a:round/>
+                      <a:headEnd type="none" w="med" len="med"/>
+                      <a:tailEnd type="none" w="med" len="med"/>
+                    </a:lnB>
+                  </a:tcPr>
+                </a:tc>
+                <a:tc>
+                  <a:txBody>
+                    <a:bodyPr/>
+                    <a:lstStyle/>
+                    <a:p>
+                      <a:pPr algn="r" indent="0" marL="0">
+                        <a:buNone/>
+                      </a:pPr>
+                      <a:r>
+                        <a:rPr lang="en-US" sz="1250" b="1" dirty="0">
+                          <a:solidFill>
+                            <a:schemeClr val="accent5"/>
+                          </a:solidFill>
+                          <a:latin typeface="Arial" pitchFamily="34" charset="0"/>
+                          <a:ea typeface="Arial" pitchFamily="34" charset="-122"/>
+                          <a:cs typeface="Arial" pitchFamily="34" charset="-120"/>
+                        </a:rPr>
+                        <a:t>+14.725 €</a:t>
                       </a:r>
                       <a:endParaRPr lang="en-US" sz="1250" dirty="0">
                         <a:latin typeface="Arial" charset="0"/>
@@ -7856,7 +8053,7 @@
                           <a:ea typeface="Arial" pitchFamily="34" charset="-122"/>
                           <a:cs typeface="Arial" pitchFamily="34" charset="-120"/>
                         </a:rPr>
-                        <a:t>60.000 €</a:t>
+                        <a:t>80.000 €</a:t>
                       </a:r>
                       <a:endParaRPr lang="en-US" sz="1250" dirty="0">
                         <a:latin typeface="Arial" charset="0"/>
@@ -7921,7 +8118,7 @@
                           <a:ea typeface="Arial" pitchFamily="34" charset="-122"/>
                           <a:cs typeface="Arial" pitchFamily="34" charset="-120"/>
                         </a:rPr>
-                        <a:t>18.300 €</a:t>
+                        <a:t>24.400 €</a:t>
                       </a:r>
                       <a:endParaRPr lang="en-US" sz="1250" dirty="0">
                         <a:latin typeface="Arial" charset="0"/>
@@ -7986,7 +8183,7 @@
                           <a:ea typeface="Arial" pitchFamily="34" charset="-122"/>
                           <a:cs typeface="Arial" pitchFamily="34" charset="-120"/>
                         </a:rPr>
-                        <a:t>−5.520 €</a:t>
+                        <a:t>−5.100 €</a:t>
                       </a:r>
                       <a:endParaRPr lang="en-US" sz="1250" dirty="0">
                         <a:latin typeface="Arial" charset="0"/>
@@ -8051,7 +8248,7 @@
                           <a:ea typeface="Arial" pitchFamily="34" charset="-122"/>
                           <a:cs typeface="Arial" pitchFamily="34" charset="-120"/>
                         </a:rPr>
-                        <a:t>+12.780 €</a:t>
+                        <a:t>+19.300 €</a:t>
                       </a:r>
                       <a:endParaRPr lang="en-US" sz="1250" dirty="0">
                         <a:latin typeface="Arial" charset="0"/>
@@ -8121,7 +8318,7 @@
                           <a:ea typeface="Arial" pitchFamily="34" charset="-122"/>
                           <a:cs typeface="Arial" pitchFamily="34" charset="-120"/>
                         </a:rPr>
-                        <a:t>70.000 €</a:t>
+                        <a:t>90.000 €</a:t>
                       </a:r>
                       <a:endParaRPr lang="en-US" sz="1250" dirty="0">
                         <a:latin typeface="Arial" charset="0"/>
@@ -8186,7 +8383,7 @@
                           <a:ea typeface="Arial" pitchFamily="34" charset="-122"/>
                           <a:cs typeface="Arial" pitchFamily="34" charset="-120"/>
                         </a:rPr>
-                        <a:t>21.350 €</a:t>
+                        <a:t>27.450 €</a:t>
                       </a:r>
                       <a:endParaRPr lang="en-US" sz="1250" dirty="0">
                         <a:latin typeface="Arial" charset="0"/>
@@ -8251,7 +8448,7 @@
                           <a:ea typeface="Arial" pitchFamily="34" charset="-122"/>
                           <a:cs typeface="Arial" pitchFamily="34" charset="-120"/>
                         </a:rPr>
-                        <a:t>−5.520 €</a:t>
+                        <a:t>−5.100 €</a:t>
                       </a:r>
                       <a:endParaRPr lang="en-US" sz="1250" dirty="0">
                         <a:latin typeface="Arial" charset="0"/>
@@ -8316,7 +8513,7 @@
                           <a:ea typeface="Arial" pitchFamily="34" charset="-122"/>
                           <a:cs typeface="Arial" pitchFamily="34" charset="-120"/>
                         </a:rPr>
-                        <a:t>+15.830 €</a:t>
+                        <a:t>+22.350 €</a:t>
                       </a:r>
                       <a:endParaRPr lang="en-US" sz="1250" dirty="0">
                         <a:latin typeface="Arial" charset="0"/>
@@ -8449,7 +8646,7 @@
                 <a:ea typeface="Arial" pitchFamily="34" charset="-122"/>
                 <a:cs typeface="Arial" pitchFamily="34" charset="-120"/>
               </a:rPr>
-              <a:t>Mit 50.000 € Umsatz bleiben im ganzen Haus +5.430 € pro Monat nach Zinsen und Tilgung (KfW-Kredite und Hausbank, ohne Lohn). Die Gastro braucht für Break-even im Haus ca. 32.200 € Umsatz.</a:t>
+              <a:t>Mit 65.000 € Umsatz bleiben im ganzen Haus +9.610 € pro Monat nach Zinsen und Tilgung (KfW-Kredite und Hausbank, ohne Lohn). Die Gastro braucht für Break-even im Haus ca. 33.500 € Umsatz.</a:t>
             </a:r>
             <a:endParaRPr lang="en-US" sz="1300" dirty="0"/>
           </a:p>
@@ -8888,7 +9085,7 @@
                           <a:ea typeface="Arial" pitchFamily="34" charset="-122"/>
                           <a:cs typeface="Arial" pitchFamily="34" charset="-120"/>
                         </a:rPr>
-                        <a:t>30.000 €</a:t>
+                        <a:t>38.000 €</a:t>
                       </a:r>
                       <a:endParaRPr lang="en-US" sz="1250" dirty="0">
                         <a:latin typeface="Arial" charset="0"/>
@@ -9020,7 +9217,7 @@
                           <a:ea typeface="Arial" pitchFamily="34" charset="-122"/>
                           <a:cs typeface="Arial" pitchFamily="34" charset="-120"/>
                         </a:rPr>
-                        <a:t>18.000 €</a:t>
+                        <a:t>23.000 €</a:t>
                       </a:r>
                       <a:endParaRPr lang="en-US" sz="1250" dirty="0">
                         <a:latin typeface="Arial" charset="0"/>
@@ -9152,7 +9349,7 @@
                           <a:ea typeface="Arial" pitchFamily="34" charset="-122"/>
                           <a:cs typeface="Arial" pitchFamily="34" charset="-120"/>
                         </a:rPr>
-                        <a:t>20.000 €</a:t>
+                        <a:t>25.000 €</a:t>
                       </a:r>
                       <a:endParaRPr lang="en-US" sz="1250" dirty="0">
                         <a:latin typeface="Arial" charset="0"/>
@@ -9219,7 +9416,7 @@
                           <a:ea typeface="Arial" pitchFamily="34" charset="-122"/>
                           <a:cs typeface="Arial" pitchFamily="34" charset="-120"/>
                         </a:rPr>
-                        <a:t>Möbel (ca. 150 Plätze, Lounge, Séparée)</a:t>
+                        <a:t>Möbel (ca. 190 Plätze, Lounge, Séparée)</a:t>
                       </a:r>
                       <a:endParaRPr lang="en-US" sz="1250" dirty="0">
                         <a:latin typeface="Arial" charset="0"/>
@@ -9284,7 +9481,7 @@
                           <a:ea typeface="Arial" pitchFamily="34" charset="-122"/>
                           <a:cs typeface="Arial" pitchFamily="34" charset="-120"/>
                         </a:rPr>
-                        <a:t>28.000 €</a:t>
+                        <a:t>36.000 €</a:t>
                       </a:r>
                       <a:endParaRPr lang="en-US" sz="1250" dirty="0">
                         <a:latin typeface="Arial" charset="0"/>
@@ -9416,7 +9613,7 @@
                           <a:ea typeface="Arial" pitchFamily="34" charset="-122"/>
                           <a:cs typeface="Arial" pitchFamily="34" charset="-120"/>
                         </a:rPr>
-                        <a:t>8.000 €</a:t>
+                        <a:t>10.000 €</a:t>
                       </a:r>
                       <a:endParaRPr lang="en-US" sz="1250" dirty="0">
                         <a:latin typeface="Arial" charset="0"/>
@@ -9548,7 +9745,7 @@
                           <a:ea typeface="Arial" pitchFamily="34" charset="-122"/>
                           <a:cs typeface="Arial" pitchFamily="34" charset="-120"/>
                         </a:rPr>
-                        <a:t>15.000 €</a:t>
+                        <a:t>19.000 €</a:t>
                       </a:r>
                       <a:endParaRPr lang="en-US" sz="1250" dirty="0">
                         <a:latin typeface="Arial" charset="0"/>
@@ -9680,7 +9877,7 @@
                           <a:ea typeface="Arial" pitchFamily="34" charset="-122"/>
                           <a:cs typeface="Arial" pitchFamily="34" charset="-120"/>
                         </a:rPr>
-                        <a:t>5.000 €</a:t>
+                        <a:t>6.000 €</a:t>
                       </a:r>
                       <a:endParaRPr lang="en-US" sz="1250" dirty="0">
                         <a:latin typeface="Arial" charset="0"/>
@@ -9812,7 +10009,7 @@
                           <a:ea typeface="Arial" pitchFamily="34" charset="-122"/>
                           <a:cs typeface="Arial" pitchFamily="34" charset="-120"/>
                         </a:rPr>
-                        <a:t>5.000 €</a:t>
+                        <a:t>6.000 €</a:t>
                       </a:r>
                       <a:endParaRPr lang="en-US" sz="1250" dirty="0">
                         <a:latin typeface="Arial" charset="0"/>
@@ -9879,7 +10076,7 @@
                           <a:ea typeface="Arial" pitchFamily="34" charset="-122"/>
                           <a:cs typeface="Arial" pitchFamily="34" charset="-120"/>
                         </a:rPr>
-                        <a:t>Terrasse (Holzdeck, Möbel, Heizstrahler)</a:t>
+                        <a:t>Terrasse (Holzdeck, Möbel, Heizstrahler, 60 Plätze)</a:t>
                       </a:r>
                       <a:endParaRPr lang="en-US" sz="1250" dirty="0">
                         <a:latin typeface="Arial" charset="0"/>
@@ -9944,7 +10141,7 @@
                           <a:ea typeface="Arial" pitchFamily="34" charset="-122"/>
                           <a:cs typeface="Arial" pitchFamily="34" charset="-120"/>
                         </a:rPr>
-                        <a:t>6.000 €</a:t>
+                        <a:t>8.000 €</a:t>
                       </a:r>
                       <a:endParaRPr lang="en-US" sz="1250" dirty="0">
                         <a:latin typeface="Arial" charset="0"/>
@@ -10076,7 +10273,7 @@
                           <a:ea typeface="Arial" pitchFamily="34" charset="-122"/>
                           <a:cs typeface="Arial" pitchFamily="34" charset="-120"/>
                         </a:rPr>
-                        <a:t>5.000 €</a:t>
+                        <a:t>6.000 €</a:t>
                       </a:r>
                       <a:endParaRPr lang="en-US" sz="1250" dirty="0">
                         <a:latin typeface="Arial" charset="0"/>
@@ -10208,7 +10405,7 @@
                           <a:ea typeface="Arial" pitchFamily="34" charset="-122"/>
                           <a:cs typeface="Arial" pitchFamily="34" charset="-120"/>
                         </a:rPr>
-                        <a:t>3.000 €</a:t>
+                        <a:t>4.000 €</a:t>
                       </a:r>
                       <a:endParaRPr lang="en-US" sz="1250" dirty="0">
                         <a:latin typeface="Arial" charset="0"/>
@@ -10340,7 +10537,7 @@
                           <a:ea typeface="Arial" pitchFamily="34" charset="-122"/>
                           <a:cs typeface="Arial" pitchFamily="34" charset="-120"/>
                         </a:rPr>
-                        <a:t>7.150 €</a:t>
+                        <a:t>9.050 €</a:t>
                       </a:r>
                       <a:endParaRPr lang="en-US" sz="1250" dirty="0">
                         <a:latin typeface="Arial" charset="0"/>
@@ -10407,7 +10604,7 @@
                           <a:ea typeface="Arial" pitchFamily="34" charset="-122"/>
                           <a:cs typeface="Arial" pitchFamily="34" charset="-120"/>
                         </a:rPr>
-                        <a:t>Summe (im Modell: 150.000 €)</a:t>
+                        <a:t>Summe (im Modell: 190.000 €)</a:t>
                       </a:r>
                       <a:endParaRPr lang="en-US" sz="1250" dirty="0">
                         <a:latin typeface="Arial" charset="0"/>
@@ -10472,7 +10669,7 @@
                           <a:ea typeface="Arial" pitchFamily="34" charset="-122"/>
                           <a:cs typeface="Arial" pitchFamily="34" charset="-120"/>
                         </a:rPr>
-                        <a:t>150.150 €</a:t>
+                        <a:t>190.050 €</a:t>
                       </a:r>
                       <a:endParaRPr lang="en-US" sz="1250" dirty="0">
                         <a:latin typeface="Arial" charset="0"/>
@@ -10585,7 +10782,7 @@
                 <a:ea typeface="Arial" pitchFamily="34" charset="-122"/>
                 <a:cs typeface="Arial" pitchFamily="34" charset="-120"/>
               </a:rPr>
-              <a:t>Bei 200.000 € Ausbau steigt die Rate des Hauses um ca. 190 € im Monat. Der Schallschutz zur Decke und die Küchenabluft (über Dach, weg von den Wohnungen) gehören unbedingt in die Planung.</a:t>
+              <a:t>Bei 250.000 € Ausbau steigt die Rate des Hauses um ca. 228 € im Monat. Der Schallschutz zur Decke und die Küchenabluft (über Dach, weg von den Wohnungen) gehören unbedingt in die Planung.</a:t>
             </a:r>
             <a:endParaRPr lang="en-US" sz="1400" dirty="0"/>
           </a:p>
@@ -11047,7 +11244,7 @@
                 <a:ea typeface="Arial" pitchFamily="34" charset="-122"/>
                 <a:cs typeface="Arial" pitchFamily="34" charset="-120"/>
               </a:rPr>
-              <a:t>Bedarf der großen Gastro ca. 33 Plätze plus Wohnungen. Auf dem Grundstück passen nur ca. 8–10, Rest über die öffentliche Parkfläche oder Ablöse.</a:t>
+              <a:t>Bedarf der großen Gastro ca. 37 Plätze, mit Büros und Wohnungen ca. 55. Auf dem Grundstück passen nur ca. 6–8, Rest über die öffentliche Parkfläche oder Ablöse.</a:t>
             </a:r>
             <a:endParaRPr lang="en-US" sz="1300" dirty="0"/>
           </a:p>
@@ -11725,7 +11922,7 @@
                 <a:ea typeface="Arial" pitchFamily="34" charset="-122"/>
                 <a:cs typeface="Arial" pitchFamily="34" charset="-120"/>
               </a:rPr>
-              <a:t>Angebote für Ausbau einholen, Budget prüfen (150.000 € ist knapp)</a:t>
+              <a:t>Angebote für Ausbau einholen, Budget prüfen (190.000 €)</a:t>
             </a:r>
             <a:endParaRPr lang="en-US" sz="1500" dirty="0"/>
           </a:p>
@@ -12613,7 +12810,7 @@
                 <a:ea typeface="Arial" pitchFamily="34" charset="-122"/>
                 <a:cs typeface="Arial" pitchFamily="34" charset="-120"/>
               </a:rPr>
-              <a:t>Cocktails, Wein und Bier an der Theke. Séparée mit 20 Plätzen für Geburtstage, Firmen- und Vereinsfeiern.</a:t>
+              <a:t>Cocktails, Wein und Bier an der Theke. Séparée mit 30 Plätzen für Geburtstage, Firmen- und Vereinsfeiern.</a:t>
             </a:r>
             <a:endParaRPr lang="en-US" sz="1400" dirty="0"/>
           </a:p>
@@ -12679,7 +12876,7 @@
                 <a:ea typeface="Georgia" pitchFamily="34" charset="-122"/>
                 <a:cs typeface="Georgia" pitchFamily="34" charset="-120"/>
               </a:rPr>
-              <a:t>ca. 460 m²</a:t>
+              <a:t>ca. 510 m²</a:t>
             </a:r>
             <a:endParaRPr lang="en-US" sz="2800" dirty="0"/>
           </a:p>
@@ -12726,7 +12923,7 @@
       </p:sp>
       <p:sp>
         <p:nvSpPr>
-          <p:cNvPr id="17" name="Kennzahl Plätze innen (130 Gastraum, 20 Séparée)"/>
+          <p:cNvPr id="17" name="Kennzahl Plätze innen (160 Gastraum, 30 Séparée)"/>
           <p:cNvSpPr/>
           <p:nvPr/>
         </p:nvSpPr>
@@ -12784,7 +12981,7 @@
                 <a:ea typeface="Georgia" pitchFamily="34" charset="-122"/>
                 <a:cs typeface="Georgia" pitchFamily="34" charset="-120"/>
               </a:rPr>
-              <a:t>ca. 150</a:t>
+              <a:t>ca. 190</a:t>
             </a:r>
             <a:endParaRPr lang="en-US" sz="2800" dirty="0"/>
           </a:p>
@@ -12823,7 +13020,7 @@
                 <a:ea typeface="Arial" pitchFamily="34" charset="-122"/>
                 <a:cs typeface="Arial" pitchFamily="34" charset="-120"/>
               </a:rPr>
-              <a:t>Plätze innen (130 Gastraum, 20 Séparée)</a:t>
+              <a:t>Plätze innen (160 Gastraum, 30 Séparée)</a:t>
             </a:r>
             <a:endParaRPr lang="en-US" sz="1300" dirty="0"/>
           </a:p>
@@ -12889,7 +13086,7 @@
                 <a:ea typeface="Georgia" pitchFamily="34" charset="-122"/>
                 <a:cs typeface="Georgia" pitchFamily="34" charset="-120"/>
               </a:rPr>
-              <a:t>ca. 40</a:t>
+              <a:t>ca. 60</a:t>
             </a:r>
             <a:endParaRPr lang="en-US" sz="2800" dirty="0"/>
           </a:p>
@@ -12994,7 +13191,7 @@
                 <a:ea typeface="Georgia" pitchFamily="34" charset="-122"/>
                 <a:cs typeface="Georgia" pitchFamily="34" charset="-120"/>
               </a:rPr>
-              <a:t>10</a:t>
+              <a:t>12</a:t>
             </a:r>
             <a:endParaRPr lang="en-US" sz="2800" dirty="0"/>
           </a:p>
@@ -17052,7 +17249,7 @@
         <p:spPr>
           <a:xfrm>
             <a:off x="548640" y="1371600"/>
-            <a:ext cx="4873752" cy="3374136"/>
+            <a:ext cx="4864608" cy="3127248"/>
           </a:xfrm>
           <a:prstGeom prst="rect">
             <a:avLst/>
@@ -17076,8 +17273,8 @@
         </p:nvSpPr>
         <p:spPr>
           <a:xfrm>
-            <a:off x="1110996" y="4745736"/>
-            <a:ext cx="4311396" cy="524866"/>
+            <a:off x="1069848" y="4498848"/>
+            <a:ext cx="4343400" cy="486461"/>
           </a:xfrm>
           <a:prstGeom prst="rect">
             <a:avLst/>
@@ -17101,8 +17298,8 @@
         </p:nvSpPr>
         <p:spPr>
           <a:xfrm>
-            <a:off x="1110996" y="4745736"/>
-            <a:ext cx="4311396" cy="524866"/>
+            <a:off x="1069848" y="4498848"/>
+            <a:ext cx="4343400" cy="486461"/>
           </a:xfrm>
           <a:prstGeom prst="rect">
             <a:avLst/>
@@ -17126,7 +17323,7 @@
                 <a:ea typeface="Arial" pitchFamily="34" charset="-122"/>
                 <a:cs typeface="Arial" pitchFamily="34" charset="-120"/>
               </a:rPr>
-              <a:t>Terrasse, ca. 40 Plätze</a:t>
+              <a:t>Terrasse, ca. 60 Plätze</a:t>
             </a:r>
             <a:endParaRPr lang="en-US" sz="1000" dirty="0"/>
           </a:p>
@@ -17140,8 +17337,8 @@
         </p:nvSpPr>
         <p:spPr>
           <a:xfrm>
-            <a:off x="773582" y="4483303"/>
-            <a:ext cx="487375" cy="262433"/>
+            <a:off x="757123" y="4255618"/>
+            <a:ext cx="451714" cy="243230"/>
           </a:xfrm>
           <a:prstGeom prst="rect">
             <a:avLst/>
@@ -17165,8 +17362,8 @@
         </p:nvSpPr>
         <p:spPr>
           <a:xfrm>
-            <a:off x="773582" y="4483303"/>
-            <a:ext cx="487375" cy="262433"/>
+            <a:off x="757123" y="4255618"/>
+            <a:ext cx="451714" cy="243230"/>
           </a:xfrm>
           <a:prstGeom prst="rect">
             <a:avLst/>
@@ -17204,8 +17401,8 @@
         </p:nvSpPr>
         <p:spPr>
           <a:xfrm>
-            <a:off x="1148486" y="4080281"/>
-            <a:ext cx="318668" cy="178079"/>
+            <a:off x="1069848" y="3882085"/>
+            <a:ext cx="295351" cy="165049"/>
           </a:xfrm>
           <a:prstGeom prst="rect">
             <a:avLst/>
@@ -17229,8 +17426,8 @@
         </p:nvSpPr>
         <p:spPr>
           <a:xfrm>
-            <a:off x="1879549" y="4080281"/>
-            <a:ext cx="318668" cy="178079"/>
+            <a:off x="1747418" y="3882085"/>
+            <a:ext cx="295351" cy="165049"/>
           </a:xfrm>
           <a:prstGeom prst="rect">
             <a:avLst/>
@@ -17254,8 +17451,8 @@
         </p:nvSpPr>
         <p:spPr>
           <a:xfrm>
-            <a:off x="2610612" y="4080281"/>
-            <a:ext cx="318668" cy="178079"/>
+            <a:off x="2424989" y="3882085"/>
+            <a:ext cx="295351" cy="165049"/>
           </a:xfrm>
           <a:prstGeom prst="rect">
             <a:avLst/>
@@ -17279,8 +17476,8 @@
         </p:nvSpPr>
         <p:spPr>
           <a:xfrm>
-            <a:off x="3341675" y="4080281"/>
-            <a:ext cx="318668" cy="178079"/>
+            <a:off x="3102559" y="3882085"/>
+            <a:ext cx="295351" cy="165049"/>
           </a:xfrm>
           <a:prstGeom prst="rect">
             <a:avLst/>
@@ -17304,8 +17501,8 @@
         </p:nvSpPr>
         <p:spPr>
           <a:xfrm>
-            <a:off x="4072738" y="4080281"/>
-            <a:ext cx="318668" cy="178079"/>
+            <a:off x="3780130" y="3882085"/>
+            <a:ext cx="295351" cy="165049"/>
           </a:xfrm>
           <a:prstGeom prst="rect">
             <a:avLst/>
@@ -17329,8 +17526,8 @@
         </p:nvSpPr>
         <p:spPr>
           <a:xfrm>
-            <a:off x="1148486" y="3677260"/>
-            <a:ext cx="318668" cy="178079"/>
+            <a:off x="1069848" y="3578047"/>
+            <a:ext cx="295351" cy="165049"/>
           </a:xfrm>
           <a:prstGeom prst="rect">
             <a:avLst/>
@@ -17354,8 +17551,8 @@
         </p:nvSpPr>
         <p:spPr>
           <a:xfrm>
-            <a:off x="1879549" y="3677260"/>
-            <a:ext cx="318668" cy="178079"/>
+            <a:off x="1747418" y="3578047"/>
+            <a:ext cx="295351" cy="165049"/>
           </a:xfrm>
           <a:prstGeom prst="rect">
             <a:avLst/>
@@ -17379,8 +17576,8 @@
         </p:nvSpPr>
         <p:spPr>
           <a:xfrm>
-            <a:off x="2610612" y="3677260"/>
-            <a:ext cx="318668" cy="178079"/>
+            <a:off x="2424989" y="3578047"/>
+            <a:ext cx="295351" cy="165049"/>
           </a:xfrm>
           <a:prstGeom prst="rect">
             <a:avLst/>
@@ -17404,8 +17601,8 @@
         </p:nvSpPr>
         <p:spPr>
           <a:xfrm>
-            <a:off x="3341675" y="3677260"/>
-            <a:ext cx="318668" cy="178079"/>
+            <a:off x="3102559" y="3578047"/>
+            <a:ext cx="295351" cy="165049"/>
           </a:xfrm>
           <a:prstGeom prst="rect">
             <a:avLst/>
@@ -17429,8 +17626,8 @@
         </p:nvSpPr>
         <p:spPr>
           <a:xfrm>
-            <a:off x="4072738" y="3677260"/>
-            <a:ext cx="318668" cy="178079"/>
+            <a:off x="3780130" y="3578047"/>
+            <a:ext cx="295351" cy="165049"/>
           </a:xfrm>
           <a:prstGeom prst="rect">
             <a:avLst/>
@@ -17454,8 +17651,8 @@
         </p:nvSpPr>
         <p:spPr>
           <a:xfrm>
-            <a:off x="1148486" y="3274238"/>
-            <a:ext cx="318668" cy="178079"/>
+            <a:off x="1069848" y="3274009"/>
+            <a:ext cx="295351" cy="165049"/>
           </a:xfrm>
           <a:prstGeom prst="rect">
             <a:avLst/>
@@ -17479,8 +17676,8 @@
         </p:nvSpPr>
         <p:spPr>
           <a:xfrm>
-            <a:off x="1879549" y="3274238"/>
-            <a:ext cx="318668" cy="178079"/>
+            <a:off x="1747418" y="3274009"/>
+            <a:ext cx="295351" cy="165049"/>
           </a:xfrm>
           <a:prstGeom prst="rect">
             <a:avLst/>
@@ -17504,8 +17701,8 @@
         </p:nvSpPr>
         <p:spPr>
           <a:xfrm>
-            <a:off x="2610612" y="3274238"/>
-            <a:ext cx="318668" cy="178079"/>
+            <a:off x="2424989" y="3274009"/>
+            <a:ext cx="295351" cy="165049"/>
           </a:xfrm>
           <a:prstGeom prst="rect">
             <a:avLst/>
@@ -17529,8 +17726,8 @@
         </p:nvSpPr>
         <p:spPr>
           <a:xfrm>
-            <a:off x="3341675" y="3274238"/>
-            <a:ext cx="318668" cy="178079"/>
+            <a:off x="3102559" y="3274009"/>
+            <a:ext cx="295351" cy="165049"/>
           </a:xfrm>
           <a:prstGeom prst="rect">
             <a:avLst/>
@@ -17554,8 +17751,8 @@
         </p:nvSpPr>
         <p:spPr>
           <a:xfrm>
-            <a:off x="4072738" y="3274238"/>
-            <a:ext cx="318668" cy="178079"/>
+            <a:off x="3780130" y="3274009"/>
+            <a:ext cx="295351" cy="165049"/>
           </a:xfrm>
           <a:prstGeom prst="rect">
             <a:avLst/>
@@ -17579,8 +17776,8 @@
         </p:nvSpPr>
         <p:spPr>
           <a:xfrm>
-            <a:off x="1148486" y="2871216"/>
-            <a:ext cx="318668" cy="178079"/>
+            <a:off x="1069848" y="2969971"/>
+            <a:ext cx="295351" cy="165049"/>
           </a:xfrm>
           <a:prstGeom prst="rect">
             <a:avLst/>
@@ -17604,8 +17801,8 @@
         </p:nvSpPr>
         <p:spPr>
           <a:xfrm>
-            <a:off x="1879549" y="2871216"/>
-            <a:ext cx="318668" cy="178079"/>
+            <a:off x="1747418" y="2969971"/>
+            <a:ext cx="295351" cy="165049"/>
           </a:xfrm>
           <a:prstGeom prst="rect">
             <a:avLst/>
@@ -17629,8 +17826,8 @@
         </p:nvSpPr>
         <p:spPr>
           <a:xfrm>
-            <a:off x="2610612" y="2871216"/>
-            <a:ext cx="318668" cy="178079"/>
+            <a:off x="2424989" y="2969971"/>
+            <a:ext cx="295351" cy="165049"/>
           </a:xfrm>
           <a:prstGeom prst="rect">
             <a:avLst/>
@@ -17654,8 +17851,8 @@
         </p:nvSpPr>
         <p:spPr>
           <a:xfrm>
-            <a:off x="3341675" y="2871216"/>
-            <a:ext cx="318668" cy="178079"/>
+            <a:off x="3102559" y="2969971"/>
+            <a:ext cx="295351" cy="165049"/>
           </a:xfrm>
           <a:prstGeom prst="rect">
             <a:avLst/>
@@ -17679,8 +17876,8 @@
         </p:nvSpPr>
         <p:spPr>
           <a:xfrm>
-            <a:off x="4072738" y="2871216"/>
-            <a:ext cx="318668" cy="178079"/>
+            <a:off x="3780130" y="2969971"/>
+            <a:ext cx="295351" cy="165049"/>
           </a:xfrm>
           <a:prstGeom prst="rect">
             <a:avLst/>
@@ -17698,14 +17895,139 @@
       </p:sp>
       <p:sp>
         <p:nvSpPr>
-          <p:cNvPr id="30" name="Fenstertisch 1"/>
+          <p:cNvPr id="30" name="Tisch 21"/>
           <p:cNvSpPr/>
           <p:nvPr/>
         </p:nvSpPr>
         <p:spPr>
           <a:xfrm>
-            <a:off x="1036015" y="4492676"/>
-            <a:ext cx="149962" cy="149962"/>
+            <a:off x="1069848" y="2665933"/>
+            <a:ext cx="295351" cy="165049"/>
+          </a:xfrm>
+          <a:prstGeom prst="rect">
+            <a:avLst/>
+          </a:prstGeom>
+          <a:solidFill>
+            <a:srgbClr val="8A6A45"/>
+          </a:solidFill>
+          <a:ln w="6350">
+            <a:solidFill>
+              <a:srgbClr val="FFFFFF"/>
+            </a:solidFill>
+            <a:prstDash val="solid"/>
+          </a:ln>
+        </p:spPr>
+      </p:sp>
+      <p:sp>
+        <p:nvSpPr>
+          <p:cNvPr id="31" name="Tisch 22"/>
+          <p:cNvSpPr/>
+          <p:nvPr/>
+        </p:nvSpPr>
+        <p:spPr>
+          <a:xfrm>
+            <a:off x="1747418" y="2665933"/>
+            <a:ext cx="295351" cy="165049"/>
+          </a:xfrm>
+          <a:prstGeom prst="rect">
+            <a:avLst/>
+          </a:prstGeom>
+          <a:solidFill>
+            <a:srgbClr val="8A6A45"/>
+          </a:solidFill>
+          <a:ln w="6350">
+            <a:solidFill>
+              <a:srgbClr val="FFFFFF"/>
+            </a:solidFill>
+            <a:prstDash val="solid"/>
+          </a:ln>
+        </p:spPr>
+      </p:sp>
+      <p:sp>
+        <p:nvSpPr>
+          <p:cNvPr id="32" name="Tisch 23"/>
+          <p:cNvSpPr/>
+          <p:nvPr/>
+        </p:nvSpPr>
+        <p:spPr>
+          <a:xfrm>
+            <a:off x="2424989" y="2665933"/>
+            <a:ext cx="295351" cy="165049"/>
+          </a:xfrm>
+          <a:prstGeom prst="rect">
+            <a:avLst/>
+          </a:prstGeom>
+          <a:solidFill>
+            <a:srgbClr val="8A6A45"/>
+          </a:solidFill>
+          <a:ln w="6350">
+            <a:solidFill>
+              <a:srgbClr val="FFFFFF"/>
+            </a:solidFill>
+            <a:prstDash val="solid"/>
+          </a:ln>
+        </p:spPr>
+      </p:sp>
+      <p:sp>
+        <p:nvSpPr>
+          <p:cNvPr id="33" name="Tisch 24"/>
+          <p:cNvSpPr/>
+          <p:nvPr/>
+        </p:nvSpPr>
+        <p:spPr>
+          <a:xfrm>
+            <a:off x="3102559" y="2665933"/>
+            <a:ext cx="295351" cy="165049"/>
+          </a:xfrm>
+          <a:prstGeom prst="rect">
+            <a:avLst/>
+          </a:prstGeom>
+          <a:solidFill>
+            <a:srgbClr val="8A6A45"/>
+          </a:solidFill>
+          <a:ln w="6350">
+            <a:solidFill>
+              <a:srgbClr val="FFFFFF"/>
+            </a:solidFill>
+            <a:prstDash val="solid"/>
+          </a:ln>
+        </p:spPr>
+      </p:sp>
+      <p:sp>
+        <p:nvSpPr>
+          <p:cNvPr id="34" name="Tisch 25"/>
+          <p:cNvSpPr/>
+          <p:nvPr/>
+        </p:nvSpPr>
+        <p:spPr>
+          <a:xfrm>
+            <a:off x="3780130" y="2665933"/>
+            <a:ext cx="295351" cy="165049"/>
+          </a:xfrm>
+          <a:prstGeom prst="rect">
+            <a:avLst/>
+          </a:prstGeom>
+          <a:solidFill>
+            <a:srgbClr val="8A6A45"/>
+          </a:solidFill>
+          <a:ln w="6350">
+            <a:solidFill>
+              <a:srgbClr val="FFFFFF"/>
+            </a:solidFill>
+            <a:prstDash val="solid"/>
+          </a:ln>
+        </p:spPr>
+      </p:sp>
+      <p:sp>
+        <p:nvSpPr>
+          <p:cNvPr id="35" name="Fenstertisch 1"/>
+          <p:cNvSpPr/>
+          <p:nvPr/>
+        </p:nvSpPr>
+        <p:spPr>
+          <a:xfrm>
+            <a:off x="965606" y="4264304"/>
+            <a:ext cx="138989" cy="138989"/>
           </a:xfrm>
           <a:prstGeom prst="rect">
             <a:avLst/>
@@ -17723,14 +18045,14 @@
       </p:sp>
       <p:sp>
         <p:nvSpPr>
-          <p:cNvPr id="31" name="Fenstertisch 2"/>
+          <p:cNvPr id="36" name="Fenstertisch 2"/>
           <p:cNvSpPr/>
           <p:nvPr/>
         </p:nvSpPr>
         <p:spPr>
           <a:xfrm>
-            <a:off x="1476527" y="4492676"/>
-            <a:ext cx="149962" cy="149962"/>
+            <a:off x="1434694" y="4264304"/>
+            <a:ext cx="138989" cy="138989"/>
           </a:xfrm>
           <a:prstGeom prst="rect">
             <a:avLst/>
@@ -17748,14 +18070,14 @@
       </p:sp>
       <p:sp>
         <p:nvSpPr>
-          <p:cNvPr id="32" name="Fenstertisch 3"/>
+          <p:cNvPr id="37" name="Fenstertisch 3"/>
           <p:cNvSpPr/>
           <p:nvPr/>
         </p:nvSpPr>
         <p:spPr>
           <a:xfrm>
-            <a:off x="1917040" y="4492676"/>
-            <a:ext cx="149962" cy="149962"/>
+            <a:off x="1903781" y="4264304"/>
+            <a:ext cx="138989" cy="138989"/>
           </a:xfrm>
           <a:prstGeom prst="rect">
             <a:avLst/>
@@ -17773,14 +18095,14 @@
       </p:sp>
       <p:sp>
         <p:nvSpPr>
-          <p:cNvPr id="33" name="Fenstertisch 4"/>
+          <p:cNvPr id="38" name="Fenstertisch 4"/>
           <p:cNvSpPr/>
           <p:nvPr/>
         </p:nvSpPr>
         <p:spPr>
           <a:xfrm>
-            <a:off x="2357552" y="4492676"/>
-            <a:ext cx="149962" cy="149962"/>
+            <a:off x="2372868" y="4264304"/>
+            <a:ext cx="138989" cy="138989"/>
           </a:xfrm>
           <a:prstGeom prst="rect">
             <a:avLst/>
@@ -17798,14 +18120,14 @@
       </p:sp>
       <p:sp>
         <p:nvSpPr>
-          <p:cNvPr id="34" name="Fenstertisch 5"/>
+          <p:cNvPr id="39" name="Fenstertisch 5"/>
           <p:cNvSpPr/>
           <p:nvPr/>
         </p:nvSpPr>
         <p:spPr>
           <a:xfrm>
-            <a:off x="2798064" y="4492676"/>
-            <a:ext cx="149962" cy="149962"/>
+            <a:off x="2841955" y="4264304"/>
+            <a:ext cx="138989" cy="138989"/>
           </a:xfrm>
           <a:prstGeom prst="rect">
             <a:avLst/>
@@ -17823,14 +18145,14 @@
       </p:sp>
       <p:sp>
         <p:nvSpPr>
-          <p:cNvPr id="35" name="Fenstertisch 6"/>
+          <p:cNvPr id="40" name="Fenstertisch 6"/>
           <p:cNvSpPr/>
           <p:nvPr/>
         </p:nvSpPr>
         <p:spPr>
           <a:xfrm>
-            <a:off x="3238576" y="4492676"/>
-            <a:ext cx="149962" cy="149962"/>
+            <a:off x="3311042" y="4264304"/>
+            <a:ext cx="138989" cy="138989"/>
           </a:xfrm>
           <a:prstGeom prst="rect">
             <a:avLst/>
@@ -17848,14 +18170,14 @@
       </p:sp>
       <p:sp>
         <p:nvSpPr>
-          <p:cNvPr id="36" name="Fenstertisch 7"/>
+          <p:cNvPr id="41" name="Fenstertisch 7"/>
           <p:cNvSpPr/>
           <p:nvPr/>
         </p:nvSpPr>
         <p:spPr>
           <a:xfrm>
-            <a:off x="3679088" y="4492676"/>
-            <a:ext cx="149962" cy="149962"/>
+            <a:off x="3780130" y="4264304"/>
+            <a:ext cx="138989" cy="138989"/>
           </a:xfrm>
           <a:prstGeom prst="rect">
             <a:avLst/>
@@ -17873,14 +18195,14 @@
       </p:sp>
       <p:sp>
         <p:nvSpPr>
-          <p:cNvPr id="37" name="Fenstertisch 8"/>
+          <p:cNvPr id="42" name="Fenstertisch 8"/>
           <p:cNvSpPr/>
           <p:nvPr/>
         </p:nvSpPr>
         <p:spPr>
           <a:xfrm>
-            <a:off x="4119601" y="4492676"/>
-            <a:ext cx="149962" cy="149962"/>
+            <a:off x="4249217" y="4264304"/>
+            <a:ext cx="138989" cy="138989"/>
           </a:xfrm>
           <a:prstGeom prst="rect">
             <a:avLst/>
@@ -17898,14 +18220,14 @@
       </p:sp>
       <p:sp>
         <p:nvSpPr>
-          <p:cNvPr id="38" name="Lounge"/>
+          <p:cNvPr id="43" name="Lounge"/>
           <p:cNvSpPr/>
           <p:nvPr/>
         </p:nvSpPr>
         <p:spPr>
           <a:xfrm>
-            <a:off x="4485132" y="2964942"/>
-            <a:ext cx="862279" cy="1405890"/>
+            <a:off x="4509821" y="2691994"/>
+            <a:ext cx="833933" cy="1459382"/>
           </a:xfrm>
           <a:prstGeom prst="rect">
             <a:avLst/>
@@ -17923,14 +18245,14 @@
       </p:sp>
       <p:sp>
         <p:nvSpPr>
-          <p:cNvPr id="39" name="Text 36"/>
+          <p:cNvPr id="44" name="Text 41"/>
           <p:cNvSpPr txBox="1"/>
           <p:nvPr/>
         </p:nvSpPr>
         <p:spPr>
           <a:xfrm>
-            <a:off x="4485132" y="2964942"/>
-            <a:ext cx="862279" cy="1405890"/>
+            <a:off x="4509821" y="2691994"/>
+            <a:ext cx="833933" cy="1459382"/>
           </a:xfrm>
           <a:prstGeom prst="rect">
             <a:avLst/>
@@ -17971,7 +18293,7 @@
                 <a:ea typeface="Arial" pitchFamily="34" charset="-122"/>
                 <a:cs typeface="Arial" pitchFamily="34" charset="-120"/>
               </a:rPr>
-              <a:t>14 Plätze</a:t>
+              <a:t>20 Plätze</a:t>
             </a:r>
             <a:endParaRPr lang="en-US" sz="1000" dirty="0"/>
           </a:p>
@@ -17979,14 +18301,14 @@
       </p:sp>
       <p:sp>
         <p:nvSpPr>
-          <p:cNvPr id="40" name="Bar"/>
+          <p:cNvPr id="45" name="Bar"/>
           <p:cNvSpPr/>
           <p:nvPr/>
         </p:nvSpPr>
         <p:spPr>
           <a:xfrm>
-            <a:off x="2048256" y="2365096"/>
-            <a:ext cx="2249424" cy="262433"/>
+            <a:off x="1938528" y="2292401"/>
+            <a:ext cx="2258568" cy="243230"/>
           </a:xfrm>
           <a:prstGeom prst="rect">
             <a:avLst/>
@@ -18004,14 +18326,14 @@
       </p:sp>
       <p:sp>
         <p:nvSpPr>
-          <p:cNvPr id="41" name="Text 38"/>
+          <p:cNvPr id="46" name="Text 43"/>
           <p:cNvSpPr txBox="1"/>
           <p:nvPr/>
         </p:nvSpPr>
         <p:spPr>
           <a:xfrm>
-            <a:off x="2048256" y="2365096"/>
-            <a:ext cx="2249424" cy="262433"/>
+            <a:off x="1938528" y="2292401"/>
+            <a:ext cx="2258568" cy="243230"/>
           </a:xfrm>
           <a:prstGeom prst="rect">
             <a:avLst/>
@@ -18035,7 +18357,7 @@
                 <a:ea typeface="Arial" pitchFamily="34" charset="-122"/>
                 <a:cs typeface="Arial" pitchFamily="34" charset="-120"/>
               </a:rPr>
-              <a:t>Bar, 10 Barhocker</a:t>
+              <a:t>Bar, 12 Barhocker</a:t>
             </a:r>
             <a:endParaRPr lang="en-US" sz="1000" dirty="0"/>
           </a:p>
@@ -18043,14 +18365,14 @@
       </p:sp>
       <p:sp>
         <p:nvSpPr>
-          <p:cNvPr id="42" name="Backbar"/>
+          <p:cNvPr id="47" name="Backbar"/>
           <p:cNvSpPr/>
           <p:nvPr/>
         </p:nvSpPr>
         <p:spPr>
           <a:xfrm>
-            <a:off x="2048256" y="2187016"/>
-            <a:ext cx="2249424" cy="103099"/>
+            <a:off x="1938528" y="2127352"/>
+            <a:ext cx="2258568" cy="95555"/>
           </a:xfrm>
           <a:prstGeom prst="rect">
             <a:avLst/>
@@ -18068,14 +18390,14 @@
       </p:sp>
       <p:sp>
         <p:nvSpPr>
-          <p:cNvPr id="43" name="Séparée"/>
+          <p:cNvPr id="48" name="Séparée"/>
           <p:cNvSpPr/>
           <p:nvPr/>
         </p:nvSpPr>
         <p:spPr>
           <a:xfrm>
-            <a:off x="623621" y="1446581"/>
-            <a:ext cx="1237183" cy="956005"/>
+            <a:off x="618134" y="1441094"/>
+            <a:ext cx="1250899" cy="886054"/>
           </a:xfrm>
           <a:prstGeom prst="rect">
             <a:avLst/>
@@ -18093,14 +18415,14 @@
       </p:sp>
       <p:sp>
         <p:nvSpPr>
-          <p:cNvPr id="44" name="Text 41"/>
+          <p:cNvPr id="49" name="Text 46"/>
           <p:cNvSpPr txBox="1"/>
           <p:nvPr/>
         </p:nvSpPr>
         <p:spPr>
           <a:xfrm>
-            <a:off x="623621" y="1446581"/>
-            <a:ext cx="1237183" cy="956005"/>
+            <a:off x="618134" y="1441094"/>
+            <a:ext cx="1250899" cy="886054"/>
           </a:xfrm>
           <a:prstGeom prst="rect">
             <a:avLst/>
@@ -18141,7 +18463,7 @@
                 <a:ea typeface="Arial" pitchFamily="34" charset="-122"/>
                 <a:cs typeface="Arial" pitchFamily="34" charset="-120"/>
               </a:rPr>
-              <a:t>20 Plätze</a:t>
+              <a:t>30 Plätze</a:t>
             </a:r>
             <a:endParaRPr lang="en-US" sz="1000" dirty="0"/>
           </a:p>
@@ -18158,7 +18480,7 @@
                 <a:ea typeface="Arial" pitchFamily="34" charset="-122"/>
                 <a:cs typeface="Arial" pitchFamily="34" charset="-120"/>
               </a:rPr>
-              <a:t>mit Stahl-Glas-Wand</a:t>
+              <a:t>Stahl-Glas-Wand</a:t>
             </a:r>
             <a:endParaRPr lang="en-US" sz="1000" dirty="0"/>
           </a:p>
@@ -18166,14 +18488,14 @@
       </p:sp>
       <p:sp>
         <p:nvSpPr>
-          <p:cNvPr id="45" name="Küche"/>
+          <p:cNvPr id="50" name="Küche"/>
           <p:cNvSpPr/>
           <p:nvPr/>
         </p:nvSpPr>
         <p:spPr>
           <a:xfrm>
-            <a:off x="2123237" y="1446581"/>
-            <a:ext cx="1199693" cy="637337"/>
+            <a:off x="2008022" y="1441094"/>
+            <a:ext cx="1111910" cy="590702"/>
           </a:xfrm>
           <a:prstGeom prst="rect">
             <a:avLst/>
@@ -18191,14 +18513,14 @@
       </p:sp>
       <p:sp>
         <p:nvSpPr>
-          <p:cNvPr id="46" name="Text 43"/>
+          <p:cNvPr id="51" name="Text 48"/>
           <p:cNvSpPr txBox="1"/>
           <p:nvPr/>
         </p:nvSpPr>
         <p:spPr>
           <a:xfrm>
-            <a:off x="2123237" y="1446581"/>
-            <a:ext cx="1199693" cy="637337"/>
+            <a:off x="2008022" y="1441094"/>
+            <a:ext cx="1111910" cy="590702"/>
           </a:xfrm>
           <a:prstGeom prst="rect">
             <a:avLst/>
@@ -18230,14 +18552,14 @@
       </p:sp>
       <p:sp>
         <p:nvSpPr>
-          <p:cNvPr id="47" name="Lager und Kühlung"/>
+          <p:cNvPr id="52" name="Lager und Kühlung"/>
           <p:cNvSpPr/>
           <p:nvPr/>
         </p:nvSpPr>
         <p:spPr>
           <a:xfrm>
-            <a:off x="3341675" y="1446581"/>
-            <a:ext cx="862279" cy="637337"/>
+            <a:off x="3137306" y="1441094"/>
+            <a:ext cx="799186" cy="590702"/>
           </a:xfrm>
           <a:prstGeom prst="rect">
             <a:avLst/>
@@ -18255,14 +18577,14 @@
       </p:sp>
       <p:sp>
         <p:nvSpPr>
-          <p:cNvPr id="48" name="Text 45"/>
+          <p:cNvPr id="53" name="Text 50"/>
           <p:cNvSpPr txBox="1"/>
           <p:nvPr/>
         </p:nvSpPr>
         <p:spPr>
           <a:xfrm>
-            <a:off x="3341675" y="1446581"/>
-            <a:ext cx="862279" cy="637337"/>
+            <a:off x="3137306" y="1441094"/>
+            <a:ext cx="799186" cy="590702"/>
           </a:xfrm>
           <a:prstGeom prst="rect">
             <a:avLst/>
@@ -18311,14 +18633,14 @@
       </p:sp>
       <p:sp>
         <p:nvSpPr>
-          <p:cNvPr id="49" name="WC"/>
+          <p:cNvPr id="54" name="WC"/>
           <p:cNvSpPr/>
           <p:nvPr/>
         </p:nvSpPr>
         <p:spPr>
           <a:xfrm>
-            <a:off x="4222699" y="1446581"/>
-            <a:ext cx="1124712" cy="637337"/>
+            <a:off x="3953866" y="1441094"/>
+            <a:ext cx="1389888" cy="590702"/>
           </a:xfrm>
           <a:prstGeom prst="rect">
             <a:avLst/>
@@ -18336,14 +18658,14 @@
       </p:sp>
       <p:sp>
         <p:nvSpPr>
-          <p:cNvPr id="50" name="Text 47"/>
+          <p:cNvPr id="55" name="Text 52"/>
           <p:cNvSpPr txBox="1"/>
           <p:nvPr/>
         </p:nvSpPr>
         <p:spPr>
           <a:xfrm>
-            <a:off x="4222699" y="1446581"/>
-            <a:ext cx="1124712" cy="637337"/>
+            <a:off x="3953866" y="1441094"/>
+            <a:ext cx="1389888" cy="590702"/>
           </a:xfrm>
           <a:prstGeom prst="rect">
             <a:avLst/>
@@ -18624,7 +18946,7 @@
                           <a:ea typeface="Arial" pitchFamily="34" charset="-122"/>
                           <a:cs typeface="Arial" pitchFamily="34" charset="-120"/>
                         </a:rPr>
-                        <a:t>Gastraum mit Tischen und Gängen</a:t>
+                        <a:t>Gastraum (Tische, Fenster, Gänge)</a:t>
                       </a:r>
                       <a:endParaRPr lang="en-US" sz="1250" dirty="0">
                         <a:latin typeface="Arial" charset="0"/>
@@ -18689,7 +19011,7 @@
                           <a:ea typeface="Arial" pitchFamily="34" charset="-122"/>
                           <a:cs typeface="Arial" pitchFamily="34" charset="-120"/>
                         </a:rPr>
-                        <a:t>ca. 280 m²</a:t>
+                        <a:t>ca. 304 m²</a:t>
                       </a:r>
                       <a:endParaRPr lang="en-US" sz="1250" dirty="0">
                         <a:latin typeface="Arial" charset="0"/>
@@ -18754,7 +19076,7 @@
                           <a:ea typeface="Arial" pitchFamily="34" charset="-122"/>
                           <a:cs typeface="Arial" pitchFamily="34" charset="-120"/>
                         </a:rPr>
-                        <a:t>ca. 80</a:t>
+                        <a:t>116</a:t>
                       </a:r>
                       <a:endParaRPr lang="en-US" sz="1250" dirty="0">
                         <a:latin typeface="Arial" charset="0"/>
@@ -18886,7 +19208,7 @@
                           <a:ea typeface="Arial" pitchFamily="34" charset="-122"/>
                           <a:cs typeface="Arial" pitchFamily="34" charset="-120"/>
                         </a:rPr>
-                        <a:t>ca. 35 m²</a:t>
+                        <a:t>im Gastraum</a:t>
                       </a:r>
                       <a:endParaRPr lang="en-US" sz="1250" dirty="0">
                         <a:latin typeface="Arial" charset="0"/>
@@ -18951,7 +19273,7 @@
                           <a:ea typeface="Arial" pitchFamily="34" charset="-122"/>
                           <a:cs typeface="Arial" pitchFamily="34" charset="-120"/>
                         </a:rPr>
-                        <a:t>14</a:t>
+                        <a:t>20</a:t>
                       </a:r>
                       <a:endParaRPr lang="en-US" sz="1250" dirty="0">
                         <a:latin typeface="Arial" charset="0"/>
@@ -19018,7 +19340,7 @@
                           <a:ea typeface="Arial" pitchFamily="34" charset="-122"/>
                           <a:cs typeface="Arial" pitchFamily="34" charset="-120"/>
                         </a:rPr>
-                        <a:t>Fenstertische (2er)</a:t>
+                        <a:t>Bar und Theken-Zone</a:t>
                       </a:r>
                       <a:endParaRPr lang="en-US" sz="1250" dirty="0">
                         <a:latin typeface="Arial" charset="0"/>
@@ -19083,7 +19405,7 @@
                           <a:ea typeface="Arial" pitchFamily="34" charset="-122"/>
                           <a:cs typeface="Arial" pitchFamily="34" charset="-120"/>
                         </a:rPr>
-                        <a:t>im Gastraum</a:t>
+                        <a:t>ca. 25 m²</a:t>
                       </a:r>
                       <a:endParaRPr lang="en-US" sz="1250" dirty="0">
                         <a:latin typeface="Arial" charset="0"/>
@@ -19148,204 +19470,7 @@
                           <a:ea typeface="Arial" pitchFamily="34" charset="-122"/>
                           <a:cs typeface="Arial" pitchFamily="34" charset="-120"/>
                         </a:rPr>
-                        <a:t>16</a:t>
-                      </a:r>
-                      <a:endParaRPr lang="en-US" sz="1250" dirty="0">
-                        <a:latin typeface="Arial" charset="0"/>
-                        <a:ea typeface="Arial" charset="0"/>
-                        <a:cs typeface="Arial" charset="0"/>
-                      </a:endParaRPr>
-                    </a:p>
-                  </a:txBody>
-                  <a:tcPr marL="91440" marR="91440" marT="45720" marB="45720">
-                    <a:lnL w="12700" cap="flat" cmpd="sng" algn="ctr">
-                      <a:solidFill>
-                        <a:srgbClr val="FFFFFF"/>
-                      </a:solidFill>
-                      <a:prstDash val="solid"/>
-                      <a:round/>
-                      <a:headEnd type="none" w="med" len="med"/>
-                      <a:tailEnd type="none" w="med" len="med"/>
-                    </a:lnL>
-                    <a:lnR w="12700" cap="flat" cmpd="sng" algn="ctr">
-                      <a:solidFill>
-                        <a:srgbClr val="FFFFFF"/>
-                      </a:solidFill>
-                      <a:prstDash val="solid"/>
-                      <a:round/>
-                      <a:headEnd type="none" w="med" len="med"/>
-                      <a:tailEnd type="none" w="med" len="med"/>
-                    </a:lnR>
-                    <a:lnT w="12700" cap="flat" cmpd="sng" algn="ctr">
-                      <a:solidFill>
-                        <a:srgbClr val="FFFFFF"/>
-                      </a:solidFill>
-                      <a:prstDash val="solid"/>
-                      <a:round/>
-                      <a:headEnd type="none" w="med" len="med"/>
-                      <a:tailEnd type="none" w="med" len="med"/>
-                    </a:lnT>
-                    <a:lnB w="12700" cap="flat" cmpd="sng" algn="ctr">
-                      <a:solidFill>
-                        <a:srgbClr val="FFFFFF"/>
-                      </a:solidFill>
-                      <a:prstDash val="solid"/>
-                      <a:round/>
-                      <a:headEnd type="none" w="med" len="med"/>
-                      <a:tailEnd type="none" w="med" len="med"/>
-                    </a:lnB>
-                  </a:tcPr>
-                </a:tc>
-              </a:tr>
-              <a:tr h="402336">
-                <a:tc>
-                  <a:txBody>
-                    <a:bodyPr/>
-                    <a:lstStyle/>
-                    <a:p>
-                      <a:pPr indent="0" marL="0">
-                        <a:buNone/>
-                      </a:pPr>
-                      <a:r>
-                        <a:rPr lang="en-US" sz="1250" dirty="0">
-                          <a:solidFill>
-                            <a:srgbClr val="000000"/>
-                          </a:solidFill>
-                          <a:latin typeface="Arial" pitchFamily="34" charset="0"/>
-                          <a:ea typeface="Arial" pitchFamily="34" charset="-122"/>
-                          <a:cs typeface="Arial" pitchFamily="34" charset="-120"/>
-                        </a:rPr>
-                        <a:t>Bar und Backbar</a:t>
-                      </a:r>
-                      <a:endParaRPr lang="en-US" sz="1250" dirty="0">
-                        <a:latin typeface="Arial" charset="0"/>
-                        <a:ea typeface="Arial" charset="0"/>
-                        <a:cs typeface="Arial" charset="0"/>
-                      </a:endParaRPr>
-                    </a:p>
-                  </a:txBody>
-                  <a:tcPr marL="91440" marR="91440" marT="45720" marB="45720">
-                    <a:lnL w="12700" cap="flat" cmpd="sng" algn="ctr">
-                      <a:solidFill>
-                        <a:srgbClr val="FFFFFF"/>
-                      </a:solidFill>
-                      <a:prstDash val="solid"/>
-                      <a:round/>
-                      <a:headEnd type="none" w="med" len="med"/>
-                      <a:tailEnd type="none" w="med" len="med"/>
-                    </a:lnL>
-                    <a:lnR w="12700" cap="flat" cmpd="sng" algn="ctr">
-                      <a:solidFill>
-                        <a:srgbClr val="FFFFFF"/>
-                      </a:solidFill>
-                      <a:prstDash val="solid"/>
-                      <a:round/>
-                      <a:headEnd type="none" w="med" len="med"/>
-                      <a:tailEnd type="none" w="med" len="med"/>
-                    </a:lnR>
-                    <a:lnT w="12700" cap="flat" cmpd="sng" algn="ctr">
-                      <a:solidFill>
-                        <a:srgbClr val="FFFFFF"/>
-                      </a:solidFill>
-                      <a:prstDash val="solid"/>
-                      <a:round/>
-                      <a:headEnd type="none" w="med" len="med"/>
-                      <a:tailEnd type="none" w="med" len="med"/>
-                    </a:lnT>
-                    <a:lnB w="12700" cap="flat" cmpd="sng" algn="ctr">
-                      <a:solidFill>
-                        <a:srgbClr val="FFFFFF"/>
-                      </a:solidFill>
-                      <a:prstDash val="solid"/>
-                      <a:round/>
-                      <a:headEnd type="none" w="med" len="med"/>
-                      <a:tailEnd type="none" w="med" len="med"/>
-                    </a:lnB>
-                  </a:tcPr>
-                </a:tc>
-                <a:tc>
-                  <a:txBody>
-                    <a:bodyPr/>
-                    <a:lstStyle/>
-                    <a:p>
-                      <a:pPr algn="r" indent="0" marL="0">
-                        <a:buNone/>
-                      </a:pPr>
-                      <a:r>
-                        <a:rPr lang="en-US" sz="1250" dirty="0">
-                          <a:solidFill>
-                            <a:srgbClr val="000000"/>
-                          </a:solidFill>
-                          <a:latin typeface="Arial" pitchFamily="34" charset="0"/>
-                          <a:ea typeface="Arial" pitchFamily="34" charset="-122"/>
-                          <a:cs typeface="Arial" pitchFamily="34" charset="-120"/>
-                        </a:rPr>
-                        <a:t>ca. 30 m²</a:t>
-                      </a:r>
-                      <a:endParaRPr lang="en-US" sz="1250" dirty="0">
-                        <a:latin typeface="Arial" charset="0"/>
-                        <a:ea typeface="Arial" charset="0"/>
-                        <a:cs typeface="Arial" charset="0"/>
-                      </a:endParaRPr>
-                    </a:p>
-                  </a:txBody>
-                  <a:tcPr marL="91440" marR="91440" marT="45720" marB="45720">
-                    <a:lnL w="12700" cap="flat" cmpd="sng" algn="ctr">
-                      <a:solidFill>
-                        <a:srgbClr val="FFFFFF"/>
-                      </a:solidFill>
-                      <a:prstDash val="solid"/>
-                      <a:round/>
-                      <a:headEnd type="none" w="med" len="med"/>
-                      <a:tailEnd type="none" w="med" len="med"/>
-                    </a:lnL>
-                    <a:lnR w="12700" cap="flat" cmpd="sng" algn="ctr">
-                      <a:solidFill>
-                        <a:srgbClr val="FFFFFF"/>
-                      </a:solidFill>
-                      <a:prstDash val="solid"/>
-                      <a:round/>
-                      <a:headEnd type="none" w="med" len="med"/>
-                      <a:tailEnd type="none" w="med" len="med"/>
-                    </a:lnR>
-                    <a:lnT w="12700" cap="flat" cmpd="sng" algn="ctr">
-                      <a:solidFill>
-                        <a:srgbClr val="FFFFFF"/>
-                      </a:solidFill>
-                      <a:prstDash val="solid"/>
-                      <a:round/>
-                      <a:headEnd type="none" w="med" len="med"/>
-                      <a:tailEnd type="none" w="med" len="med"/>
-                    </a:lnT>
-                    <a:lnB w="12700" cap="flat" cmpd="sng" algn="ctr">
-                      <a:solidFill>
-                        <a:srgbClr val="FFFFFF"/>
-                      </a:solidFill>
-                      <a:prstDash val="solid"/>
-                      <a:round/>
-                      <a:headEnd type="none" w="med" len="med"/>
-                      <a:tailEnd type="none" w="med" len="med"/>
-                    </a:lnB>
-                  </a:tcPr>
-                </a:tc>
-                <a:tc>
-                  <a:txBody>
-                    <a:bodyPr/>
-                    <a:lstStyle/>
-                    <a:p>
-                      <a:pPr algn="r" indent="0" marL="0">
-                        <a:buNone/>
-                      </a:pPr>
-                      <a:r>
-                        <a:rPr lang="en-US" sz="1250" dirty="0">
-                          <a:solidFill>
-                            <a:srgbClr val="000000"/>
-                          </a:solidFill>
-                          <a:latin typeface="Arial" pitchFamily="34" charset="0"/>
-                          <a:ea typeface="Arial" pitchFamily="34" charset="-122"/>
-                          <a:cs typeface="Arial" pitchFamily="34" charset="-120"/>
-                        </a:rPr>
-                        <a:t>10</a:t>
+                        <a:t>12</a:t>
                       </a:r>
                       <a:endParaRPr lang="en-US" sz="1250" dirty="0">
                         <a:latin typeface="Arial" charset="0"/>
@@ -19542,7 +19667,7 @@
                           <a:ea typeface="Arial" pitchFamily="34" charset="-122"/>
                           <a:cs typeface="Arial" pitchFamily="34" charset="-120"/>
                         </a:rPr>
-                        <a:t>8</a:t>
+                        <a:t>12</a:t>
                       </a:r>
                       <a:endParaRPr lang="en-US" sz="1250" dirty="0">
                         <a:latin typeface="Arial" charset="0"/>
@@ -19674,7 +19799,7 @@
                           <a:ea typeface="Arial" pitchFamily="34" charset="-122"/>
                           <a:cs typeface="Arial" pitchFamily="34" charset="-120"/>
                         </a:rPr>
-                        <a:t>ca. 34 m²</a:t>
+                        <a:t>ca. 42 m²</a:t>
                       </a:r>
                       <a:endParaRPr lang="en-US" sz="1250" dirty="0">
                         <a:latin typeface="Arial" charset="0"/>
@@ -19739,7 +19864,7 @@
                           <a:ea typeface="Arial" pitchFamily="34" charset="-122"/>
                           <a:cs typeface="Arial" pitchFamily="34" charset="-120"/>
                         </a:rPr>
-                        <a:t>20</a:t>
+                        <a:t>30</a:t>
                       </a:r>
                       <a:endParaRPr lang="en-US" sz="1250" dirty="0">
                         <a:latin typeface="Arial" charset="0"/>
@@ -19871,7 +19996,7 @@
                           <a:ea typeface="Arial" pitchFamily="34" charset="-122"/>
                           <a:cs typeface="Arial" pitchFamily="34" charset="-120"/>
                         </a:rPr>
-                        <a:t>ca. 80 m²</a:t>
+                        <a:t>ca. 139 m²</a:t>
                       </a:r>
                       <a:endParaRPr lang="en-US" sz="1250" dirty="0">
                         <a:latin typeface="Arial" charset="0"/>
@@ -20068,7 +20193,7 @@
                           <a:ea typeface="Arial" pitchFamily="34" charset="-122"/>
                           <a:cs typeface="Arial" pitchFamily="34" charset="-120"/>
                         </a:rPr>
-                        <a:t>ca. 460 m²</a:t>
+                        <a:t>ca. 510 m²</a:t>
                       </a:r>
                       <a:endParaRPr lang="en-US" sz="1250" dirty="0">
                         <a:latin typeface="Arial" charset="0"/>
@@ -20133,7 +20258,7 @@
                           <a:ea typeface="Arial" pitchFamily="34" charset="-122"/>
                           <a:cs typeface="Arial" pitchFamily="34" charset="-120"/>
                         </a:rPr>
-                        <a:t>ca. 150</a:t>
+                        <a:t>ca. 190</a:t>
                       </a:r>
                       <a:endParaRPr lang="en-US" sz="1250" dirty="0">
                         <a:latin typeface="Arial" charset="0"/>
@@ -20188,7 +20313,7 @@
       </p:graphicFrame>
       <p:sp>
         <p:nvSpPr>
-          <p:cNvPr id="52" name="Text 48"/>
+          <p:cNvPr id="57" name="Text 53"/>
           <p:cNvSpPr txBox="1"/>
           <p:nvPr/>
         </p:nvSpPr>
@@ -21620,7 +21745,7 @@
                 <a:ea typeface="Arial" pitchFamily="34" charset="-122"/>
                 <a:cs typeface="Arial" pitchFamily="34" charset="-120"/>
               </a:rPr>
-              <a:t>Séparée für Feiern mit 20 Plätzen, hinter Stahl und Glas</a:t>
+              <a:t>Séparée für Feiern mit 30 Plätzen, hinter Stahl und Glas</a:t>
             </a:r>
             <a:endParaRPr lang="en-US" sz="1200" dirty="0"/>
           </a:p>
@@ -21858,7 +21983,7 @@
                 <a:ea typeface="Arial" pitchFamily="34" charset="-122"/>
                 <a:cs typeface="Arial" pitchFamily="34" charset="-120"/>
               </a:rPr>
-              <a:t>ca. 40 Plätze auf Holzdeck unter dunklem Stahl-Vordach, Heizstrahler und Windschutz verlängern die Saison.</a:t>
+              <a:t>ca. 60 Plätze auf Holzdeck unter dunklem Stahl-Vordach, Heizstrahler und Windschutz verlängern die Saison.</a:t>
             </a:r>
             <a:endParaRPr lang="en-US" sz="1400" dirty="0"/>
           </a:p>

</xml_diff>

<commit_message>
Gastro-Konzept: Frühstück und Bowls tagsüber, abends Bar mit Snacks; Umsatzmodell, Flächen, Personal angepasst
Co-Authored-By: Claude Sonnet 5.5 <noreply@anthropic.com>
Claude-Session: https://claude.ai/code/session_01HJGZfxHv7bzYyqdLwg8aFJ
</commit_message>
<xml_diff>
--- a/praesentation/Neue-Mitte-Werlte_Baufeld3_Gastro-Konzept.pptx
+++ b/praesentation/Neue-Mitte-Werlte_Baufeld3_Gastro-Konzept.pptx
@@ -693,7 +693,7 @@
           <a:p>
             <a:r>
               <a:rPr lang="en-US" dirty="0"/>
-              <a:t>Plausibilitätsrechnung mit Annahmen für Gäste und Bon. Ca. 6.000 € Umsatz je Sitzplatz und Jahr bei 190 Plätzen, Branchen-Median Österreich ca. 12.000 €.</a:t>
+              <a:t>Plausibilitätsrechnung mit Annahmen für Gäste und Bon. Ca. 4.100 € Umsatz je Sitzplatz und Jahr bei 190 Plätzen, Branchen-Median Österreich ca. 12.000 €.</a:t>
             </a:r>
             <a:endParaRPr lang="en-US" dirty="0"/>
           </a:p>
@@ -1397,7 +1397,7 @@
           <a:p>
             <a:r>
               <a:rPr lang="en-US" dirty="0"/>
-              <a:t>Vorschlag für Öffnungszeiten, Ruhetag Montag. Hauptfokus ist der Abend. Küche warm bis ca. 21:30 Uhr.</a:t>
+              <a:t>Vorschlag für Öffnungszeiten, Ruhetag Montag. Hauptfokus ist der Abend an der Bar. Snacks bis kurz vor Schluss.</a:t>
             </a:r>
             <a:endParaRPr lang="en-US" dirty="0"/>
           </a:p>
@@ -2561,7 +2561,7 @@
                 <a:ea typeface="Arial" pitchFamily="34" charset="-122"/>
                 <a:cs typeface="Arial" pitchFamily="34" charset="-120"/>
               </a:rPr>
-              <a:t>Bar-Restaurant für den ganzen Tag, ca. 510 m² im ganzen EG</a:t>
+              <a:t>Frühstück, Bowls und Bar für den ganzen Tag, ca. 510 m² im ganzen EG</a:t>
             </a:r>
             <a:endParaRPr lang="en-US" sz="1700" dirty="0"/>
           </a:p>
@@ -2980,7 +2980,7 @@
                 <a:ea typeface="Georgia" pitchFamily="34" charset="-122"/>
                 <a:cs typeface="Georgia" pitchFamily="34" charset="-120"/>
               </a:rPr>
-              <a:t>Wie 95.635 € Umsatz im Monat zusammenkommen</a:t>
+              <a:t>Wie 65.010 € Umsatz im Monat zusammenkommen</a:t>
             </a:r>
             <a:endParaRPr lang="en-US" sz="2700" dirty="0"/>
           </a:p>
@@ -3541,7 +3541,7 @@
                           <a:ea typeface="Arial" pitchFamily="34" charset="-122"/>
                           <a:cs typeface="Arial" pitchFamily="34" charset="-120"/>
                         </a:rPr>
-                        <a:t>25</a:t>
+                        <a:t>30</a:t>
                       </a:r>
                       <a:endParaRPr lang="en-US" sz="1250" dirty="0">
                         <a:latin typeface="Arial" charset="0"/>
@@ -3671,7 +3671,7 @@
                           <a:ea typeface="Arial" pitchFamily="34" charset="-122"/>
                           <a:cs typeface="Arial" pitchFamily="34" charset="-120"/>
                         </a:rPr>
-                        <a:t>4.675 €</a:t>
+                        <a:t>5.610 €</a:t>
                       </a:r>
                       <a:endParaRPr lang="en-US" sz="1250" dirty="0">
                         <a:latin typeface="Arial" charset="0"/>
@@ -4065,7 +4065,7 @@
                           <a:ea typeface="Arial" pitchFamily="34" charset="-122"/>
                           <a:cs typeface="Arial" pitchFamily="34" charset="-120"/>
                         </a:rPr>
-                        <a:t>Mittagstisch (Di–Fr 11:30–14:30)</a:t>
+                        <a:t>Mittag: Bowls, Salate, Suppe (Di–Fr 11:30–14:30)</a:t>
                       </a:r>
                       <a:endParaRPr lang="en-US" sz="1250" dirty="0">
                         <a:latin typeface="Arial" charset="0"/>
@@ -4195,7 +4195,7 @@
                           <a:ea typeface="Arial" pitchFamily="34" charset="-122"/>
                           <a:cs typeface="Arial" pitchFamily="34" charset="-120"/>
                         </a:rPr>
-                        <a:t>50</a:t>
+                        <a:t>40</a:t>
                       </a:r>
                       <a:endParaRPr lang="en-US" sz="1250" dirty="0">
                         <a:latin typeface="Arial" charset="0"/>
@@ -4260,7 +4260,661 @@
                           <a:ea typeface="Arial" pitchFamily="34" charset="-122"/>
                           <a:cs typeface="Arial" pitchFamily="34" charset="-120"/>
                         </a:rPr>
-                        <a:t>14 €</a:t>
+                        <a:t>13 €</a:t>
+                      </a:r>
+                      <a:endParaRPr lang="en-US" sz="1250" dirty="0">
+                        <a:latin typeface="Arial" charset="0"/>
+                        <a:ea typeface="Arial" charset="0"/>
+                        <a:cs typeface="Arial" charset="0"/>
+                      </a:endParaRPr>
+                    </a:p>
+                  </a:txBody>
+                  <a:tcPr marL="91440" marR="91440" marT="45720" marB="45720">
+                    <a:lnL w="12700" cap="flat" cmpd="sng" algn="ctr">
+                      <a:solidFill>
+                        <a:srgbClr val="FFFFFF"/>
+                      </a:solidFill>
+                      <a:prstDash val="solid"/>
+                      <a:round/>
+                      <a:headEnd type="none" w="med" len="med"/>
+                      <a:tailEnd type="none" w="med" len="med"/>
+                    </a:lnL>
+                    <a:lnR w="12700" cap="flat" cmpd="sng" algn="ctr">
+                      <a:solidFill>
+                        <a:srgbClr val="FFFFFF"/>
+                      </a:solidFill>
+                      <a:prstDash val="solid"/>
+                      <a:round/>
+                      <a:headEnd type="none" w="med" len="med"/>
+                      <a:tailEnd type="none" w="med" len="med"/>
+                    </a:lnR>
+                    <a:lnT w="12700" cap="flat" cmpd="sng" algn="ctr">
+                      <a:solidFill>
+                        <a:srgbClr val="FFFFFF"/>
+                      </a:solidFill>
+                      <a:prstDash val="solid"/>
+                      <a:round/>
+                      <a:headEnd type="none" w="med" len="med"/>
+                      <a:tailEnd type="none" w="med" len="med"/>
+                    </a:lnT>
+                    <a:lnB w="12700" cap="flat" cmpd="sng" algn="ctr">
+                      <a:solidFill>
+                        <a:srgbClr val="FFFFFF"/>
+                      </a:solidFill>
+                      <a:prstDash val="solid"/>
+                      <a:round/>
+                      <a:headEnd type="none" w="med" len="med"/>
+                      <a:tailEnd type="none" w="med" len="med"/>
+                    </a:lnB>
+                  </a:tcPr>
+                </a:tc>
+                <a:tc>
+                  <a:txBody>
+                    <a:bodyPr/>
+                    <a:lstStyle/>
+                    <a:p>
+                      <a:pPr algn="r" indent="0" marL="0">
+                        <a:buNone/>
+                      </a:pPr>
+                      <a:r>
+                        <a:rPr lang="en-US" sz="1250" dirty="0">
+                          <a:solidFill>
+                            <a:srgbClr val="000000"/>
+                          </a:solidFill>
+                          <a:latin typeface="Arial" pitchFamily="34" charset="0"/>
+                          <a:ea typeface="Arial" pitchFamily="34" charset="-122"/>
+                          <a:cs typeface="Arial" pitchFamily="34" charset="-120"/>
+                        </a:rPr>
+                        <a:t>8.840 €</a:t>
+                      </a:r>
+                      <a:endParaRPr lang="en-US" sz="1250" dirty="0">
+                        <a:latin typeface="Arial" charset="0"/>
+                        <a:ea typeface="Arial" charset="0"/>
+                        <a:cs typeface="Arial" charset="0"/>
+                      </a:endParaRPr>
+                    </a:p>
+                  </a:txBody>
+                  <a:tcPr marL="91440" marR="91440" marT="45720" marB="45720">
+                    <a:lnL w="12700" cap="flat" cmpd="sng" algn="ctr">
+                      <a:solidFill>
+                        <a:srgbClr val="FFFFFF"/>
+                      </a:solidFill>
+                      <a:prstDash val="solid"/>
+                      <a:round/>
+                      <a:headEnd type="none" w="med" len="med"/>
+                      <a:tailEnd type="none" w="med" len="med"/>
+                    </a:lnL>
+                    <a:lnR w="12700" cap="flat" cmpd="sng" algn="ctr">
+                      <a:solidFill>
+                        <a:srgbClr val="FFFFFF"/>
+                      </a:solidFill>
+                      <a:prstDash val="solid"/>
+                      <a:round/>
+                      <a:headEnd type="none" w="med" len="med"/>
+                      <a:tailEnd type="none" w="med" len="med"/>
+                    </a:lnR>
+                    <a:lnT w="12700" cap="flat" cmpd="sng" algn="ctr">
+                      <a:solidFill>
+                        <a:srgbClr val="FFFFFF"/>
+                      </a:solidFill>
+                      <a:prstDash val="solid"/>
+                      <a:round/>
+                      <a:headEnd type="none" w="med" len="med"/>
+                      <a:tailEnd type="none" w="med" len="med"/>
+                    </a:lnT>
+                    <a:lnB w="12700" cap="flat" cmpd="sng" algn="ctr">
+                      <a:solidFill>
+                        <a:srgbClr val="FFFFFF"/>
+                      </a:solidFill>
+                      <a:prstDash val="solid"/>
+                      <a:round/>
+                      <a:headEnd type="none" w="med" len="med"/>
+                      <a:tailEnd type="none" w="med" len="med"/>
+                    </a:lnB>
+                  </a:tcPr>
+                </a:tc>
+              </a:tr>
+              <a:tr h="457200">
+                <a:tc>
+                  <a:txBody>
+                    <a:bodyPr/>
+                    <a:lstStyle/>
+                    <a:p>
+                      <a:pPr indent="0" marL="0">
+                        <a:buNone/>
+                      </a:pPr>
+                      <a:r>
+                        <a:rPr lang="en-US" sz="1250" dirty="0">
+                          <a:solidFill>
+                            <a:srgbClr val="000000"/>
+                          </a:solidFill>
+                          <a:latin typeface="Arial" pitchFamily="34" charset="0"/>
+                          <a:ea typeface="Arial" pitchFamily="34" charset="-122"/>
+                          <a:cs typeface="Arial" pitchFamily="34" charset="-120"/>
+                        </a:rPr>
+                        <a:t>Nachmittag: Kaffee, Kuchen, Snacks (Di–So 14:30–17:00)</a:t>
+                      </a:r>
+                      <a:endParaRPr lang="en-US" sz="1250" dirty="0">
+                        <a:latin typeface="Arial" charset="0"/>
+                        <a:ea typeface="Arial" charset="0"/>
+                        <a:cs typeface="Arial" charset="0"/>
+                      </a:endParaRPr>
+                    </a:p>
+                  </a:txBody>
+                  <a:tcPr marL="91440" marR="91440" marT="45720" marB="45720">
+                    <a:lnL w="12700" cap="flat" cmpd="sng" algn="ctr">
+                      <a:solidFill>
+                        <a:srgbClr val="FFFFFF"/>
+                      </a:solidFill>
+                      <a:prstDash val="solid"/>
+                      <a:round/>
+                      <a:headEnd type="none" w="med" len="med"/>
+                      <a:tailEnd type="none" w="med" len="med"/>
+                    </a:lnL>
+                    <a:lnR w="12700" cap="flat" cmpd="sng" algn="ctr">
+                      <a:solidFill>
+                        <a:srgbClr val="FFFFFF"/>
+                      </a:solidFill>
+                      <a:prstDash val="solid"/>
+                      <a:round/>
+                      <a:headEnd type="none" w="med" len="med"/>
+                      <a:tailEnd type="none" w="med" len="med"/>
+                    </a:lnR>
+                    <a:lnT w="12700" cap="flat" cmpd="sng" algn="ctr">
+                      <a:solidFill>
+                        <a:srgbClr val="FFFFFF"/>
+                      </a:solidFill>
+                      <a:prstDash val="solid"/>
+                      <a:round/>
+                      <a:headEnd type="none" w="med" len="med"/>
+                      <a:tailEnd type="none" w="med" len="med"/>
+                    </a:lnT>
+                    <a:lnB w="12700" cap="flat" cmpd="sng" algn="ctr">
+                      <a:solidFill>
+                        <a:srgbClr val="FFFFFF"/>
+                      </a:solidFill>
+                      <a:prstDash val="solid"/>
+                      <a:round/>
+                      <a:headEnd type="none" w="med" len="med"/>
+                      <a:tailEnd type="none" w="med" len="med"/>
+                    </a:lnB>
+                  </a:tcPr>
+                </a:tc>
+                <a:tc>
+                  <a:txBody>
+                    <a:bodyPr/>
+                    <a:lstStyle/>
+                    <a:p>
+                      <a:pPr algn="r" indent="0" marL="0">
+                        <a:buNone/>
+                      </a:pPr>
+                      <a:r>
+                        <a:rPr lang="en-US" sz="1250" dirty="0">
+                          <a:solidFill>
+                            <a:srgbClr val="000000"/>
+                          </a:solidFill>
+                          <a:latin typeface="Arial" pitchFamily="34" charset="0"/>
+                          <a:ea typeface="Arial" pitchFamily="34" charset="-122"/>
+                          <a:cs typeface="Arial" pitchFamily="34" charset="-120"/>
+                        </a:rPr>
+                        <a:t>26</a:t>
+                      </a:r>
+                      <a:endParaRPr lang="en-US" sz="1250" dirty="0">
+                        <a:latin typeface="Arial" charset="0"/>
+                        <a:ea typeface="Arial" charset="0"/>
+                        <a:cs typeface="Arial" charset="0"/>
+                      </a:endParaRPr>
+                    </a:p>
+                  </a:txBody>
+                  <a:tcPr marL="91440" marR="91440" marT="45720" marB="45720">
+                    <a:lnL w="12700" cap="flat" cmpd="sng" algn="ctr">
+                      <a:solidFill>
+                        <a:srgbClr val="FFFFFF"/>
+                      </a:solidFill>
+                      <a:prstDash val="solid"/>
+                      <a:round/>
+                      <a:headEnd type="none" w="med" len="med"/>
+                      <a:tailEnd type="none" w="med" len="med"/>
+                    </a:lnL>
+                    <a:lnR w="12700" cap="flat" cmpd="sng" algn="ctr">
+                      <a:solidFill>
+                        <a:srgbClr val="FFFFFF"/>
+                      </a:solidFill>
+                      <a:prstDash val="solid"/>
+                      <a:round/>
+                      <a:headEnd type="none" w="med" len="med"/>
+                      <a:tailEnd type="none" w="med" len="med"/>
+                    </a:lnR>
+                    <a:lnT w="12700" cap="flat" cmpd="sng" algn="ctr">
+                      <a:solidFill>
+                        <a:srgbClr val="FFFFFF"/>
+                      </a:solidFill>
+                      <a:prstDash val="solid"/>
+                      <a:round/>
+                      <a:headEnd type="none" w="med" len="med"/>
+                      <a:tailEnd type="none" w="med" len="med"/>
+                    </a:lnT>
+                    <a:lnB w="12700" cap="flat" cmpd="sng" algn="ctr">
+                      <a:solidFill>
+                        <a:srgbClr val="FFFFFF"/>
+                      </a:solidFill>
+                      <a:prstDash val="solid"/>
+                      <a:round/>
+                      <a:headEnd type="none" w="med" len="med"/>
+                      <a:tailEnd type="none" w="med" len="med"/>
+                    </a:lnB>
+                  </a:tcPr>
+                </a:tc>
+                <a:tc>
+                  <a:txBody>
+                    <a:bodyPr/>
+                    <a:lstStyle/>
+                    <a:p>
+                      <a:pPr algn="r" indent="0" marL="0">
+                        <a:buNone/>
+                      </a:pPr>
+                      <a:r>
+                        <a:rPr lang="en-US" sz="1250" dirty="0">
+                          <a:solidFill>
+                            <a:srgbClr val="000000"/>
+                          </a:solidFill>
+                          <a:latin typeface="Arial" pitchFamily="34" charset="0"/>
+                          <a:ea typeface="Arial" pitchFamily="34" charset="-122"/>
+                          <a:cs typeface="Arial" pitchFamily="34" charset="-120"/>
+                        </a:rPr>
+                        <a:t>20</a:t>
+                      </a:r>
+                      <a:endParaRPr lang="en-US" sz="1250" dirty="0">
+                        <a:latin typeface="Arial" charset="0"/>
+                        <a:ea typeface="Arial" charset="0"/>
+                        <a:cs typeface="Arial" charset="0"/>
+                      </a:endParaRPr>
+                    </a:p>
+                  </a:txBody>
+                  <a:tcPr marL="91440" marR="91440" marT="45720" marB="45720">
+                    <a:lnL w="12700" cap="flat" cmpd="sng" algn="ctr">
+                      <a:solidFill>
+                        <a:srgbClr val="FFFFFF"/>
+                      </a:solidFill>
+                      <a:prstDash val="solid"/>
+                      <a:round/>
+                      <a:headEnd type="none" w="med" len="med"/>
+                      <a:tailEnd type="none" w="med" len="med"/>
+                    </a:lnL>
+                    <a:lnR w="12700" cap="flat" cmpd="sng" algn="ctr">
+                      <a:solidFill>
+                        <a:srgbClr val="FFFFFF"/>
+                      </a:solidFill>
+                      <a:prstDash val="solid"/>
+                      <a:round/>
+                      <a:headEnd type="none" w="med" len="med"/>
+                      <a:tailEnd type="none" w="med" len="med"/>
+                    </a:lnR>
+                    <a:lnT w="12700" cap="flat" cmpd="sng" algn="ctr">
+                      <a:solidFill>
+                        <a:srgbClr val="FFFFFF"/>
+                      </a:solidFill>
+                      <a:prstDash val="solid"/>
+                      <a:round/>
+                      <a:headEnd type="none" w="med" len="med"/>
+                      <a:tailEnd type="none" w="med" len="med"/>
+                    </a:lnT>
+                    <a:lnB w="12700" cap="flat" cmpd="sng" algn="ctr">
+                      <a:solidFill>
+                        <a:srgbClr val="FFFFFF"/>
+                      </a:solidFill>
+                      <a:prstDash val="solid"/>
+                      <a:round/>
+                      <a:headEnd type="none" w="med" len="med"/>
+                      <a:tailEnd type="none" w="med" len="med"/>
+                    </a:lnB>
+                  </a:tcPr>
+                </a:tc>
+                <a:tc>
+                  <a:txBody>
+                    <a:bodyPr/>
+                    <a:lstStyle/>
+                    <a:p>
+                      <a:pPr algn="r" indent="0" marL="0">
+                        <a:buNone/>
+                      </a:pPr>
+                      <a:r>
+                        <a:rPr lang="en-US" sz="1250" dirty="0">
+                          <a:solidFill>
+                            <a:srgbClr val="000000"/>
+                          </a:solidFill>
+                          <a:latin typeface="Arial" pitchFamily="34" charset="0"/>
+                          <a:ea typeface="Arial" pitchFamily="34" charset="-122"/>
+                          <a:cs typeface="Arial" pitchFamily="34" charset="-120"/>
+                        </a:rPr>
+                        <a:t>7 €</a:t>
+                      </a:r>
+                      <a:endParaRPr lang="en-US" sz="1250" dirty="0">
+                        <a:latin typeface="Arial" charset="0"/>
+                        <a:ea typeface="Arial" charset="0"/>
+                        <a:cs typeface="Arial" charset="0"/>
+                      </a:endParaRPr>
+                    </a:p>
+                  </a:txBody>
+                  <a:tcPr marL="91440" marR="91440" marT="45720" marB="45720">
+                    <a:lnL w="12700" cap="flat" cmpd="sng" algn="ctr">
+                      <a:solidFill>
+                        <a:srgbClr val="FFFFFF"/>
+                      </a:solidFill>
+                      <a:prstDash val="solid"/>
+                      <a:round/>
+                      <a:headEnd type="none" w="med" len="med"/>
+                      <a:tailEnd type="none" w="med" len="med"/>
+                    </a:lnL>
+                    <a:lnR w="12700" cap="flat" cmpd="sng" algn="ctr">
+                      <a:solidFill>
+                        <a:srgbClr val="FFFFFF"/>
+                      </a:solidFill>
+                      <a:prstDash val="solid"/>
+                      <a:round/>
+                      <a:headEnd type="none" w="med" len="med"/>
+                      <a:tailEnd type="none" w="med" len="med"/>
+                    </a:lnR>
+                    <a:lnT w="12700" cap="flat" cmpd="sng" algn="ctr">
+                      <a:solidFill>
+                        <a:srgbClr val="FFFFFF"/>
+                      </a:solidFill>
+                      <a:prstDash val="solid"/>
+                      <a:round/>
+                      <a:headEnd type="none" w="med" len="med"/>
+                      <a:tailEnd type="none" w="med" len="med"/>
+                    </a:lnT>
+                    <a:lnB w="12700" cap="flat" cmpd="sng" algn="ctr">
+                      <a:solidFill>
+                        <a:srgbClr val="FFFFFF"/>
+                      </a:solidFill>
+                      <a:prstDash val="solid"/>
+                      <a:round/>
+                      <a:headEnd type="none" w="med" len="med"/>
+                      <a:tailEnd type="none" w="med" len="med"/>
+                    </a:lnB>
+                  </a:tcPr>
+                </a:tc>
+                <a:tc>
+                  <a:txBody>
+                    <a:bodyPr/>
+                    <a:lstStyle/>
+                    <a:p>
+                      <a:pPr algn="r" indent="0" marL="0">
+                        <a:buNone/>
+                      </a:pPr>
+                      <a:r>
+                        <a:rPr lang="en-US" sz="1250" dirty="0">
+                          <a:solidFill>
+                            <a:srgbClr val="000000"/>
+                          </a:solidFill>
+                          <a:latin typeface="Arial" pitchFamily="34" charset="0"/>
+                          <a:ea typeface="Arial" pitchFamily="34" charset="-122"/>
+                          <a:cs typeface="Arial" pitchFamily="34" charset="-120"/>
+                        </a:rPr>
+                        <a:t>3.640 €</a:t>
+                      </a:r>
+                      <a:endParaRPr lang="en-US" sz="1250" dirty="0">
+                        <a:latin typeface="Arial" charset="0"/>
+                        <a:ea typeface="Arial" charset="0"/>
+                        <a:cs typeface="Arial" charset="0"/>
+                      </a:endParaRPr>
+                    </a:p>
+                  </a:txBody>
+                  <a:tcPr marL="91440" marR="91440" marT="45720" marB="45720">
+                    <a:lnL w="12700" cap="flat" cmpd="sng" algn="ctr">
+                      <a:solidFill>
+                        <a:srgbClr val="FFFFFF"/>
+                      </a:solidFill>
+                      <a:prstDash val="solid"/>
+                      <a:round/>
+                      <a:headEnd type="none" w="med" len="med"/>
+                      <a:tailEnd type="none" w="med" len="med"/>
+                    </a:lnL>
+                    <a:lnR w="12700" cap="flat" cmpd="sng" algn="ctr">
+                      <a:solidFill>
+                        <a:srgbClr val="FFFFFF"/>
+                      </a:solidFill>
+                      <a:prstDash val="solid"/>
+                      <a:round/>
+                      <a:headEnd type="none" w="med" len="med"/>
+                      <a:tailEnd type="none" w="med" len="med"/>
+                    </a:lnR>
+                    <a:lnT w="12700" cap="flat" cmpd="sng" algn="ctr">
+                      <a:solidFill>
+                        <a:srgbClr val="FFFFFF"/>
+                      </a:solidFill>
+                      <a:prstDash val="solid"/>
+                      <a:round/>
+                      <a:headEnd type="none" w="med" len="med"/>
+                      <a:tailEnd type="none" w="med" len="med"/>
+                    </a:lnT>
+                    <a:lnB w="12700" cap="flat" cmpd="sng" algn="ctr">
+                      <a:solidFill>
+                        <a:srgbClr val="FFFFFF"/>
+                      </a:solidFill>
+                      <a:prstDash val="solid"/>
+                      <a:round/>
+                      <a:headEnd type="none" w="med" len="med"/>
+                      <a:tailEnd type="none" w="med" len="med"/>
+                    </a:lnB>
+                  </a:tcPr>
+                </a:tc>
+              </a:tr>
+              <a:tr h="457200">
+                <a:tc>
+                  <a:txBody>
+                    <a:bodyPr/>
+                    <a:lstStyle/>
+                    <a:p>
+                      <a:pPr indent="0" marL="0">
+                        <a:buNone/>
+                      </a:pPr>
+                      <a:r>
+                        <a:rPr lang="en-US" sz="1250" dirty="0">
+                          <a:solidFill>
+                            <a:srgbClr val="000000"/>
+                          </a:solidFill>
+                          <a:latin typeface="Arial" pitchFamily="34" charset="0"/>
+                          <a:ea typeface="Arial" pitchFamily="34" charset="-122"/>
+                          <a:cs typeface="Arial" pitchFamily="34" charset="-120"/>
+                        </a:rPr>
+                        <a:t>Bar mit Snacks Di–Do, So (ab 17:00)</a:t>
+                      </a:r>
+                      <a:endParaRPr lang="en-US" sz="1250" dirty="0">
+                        <a:latin typeface="Arial" charset="0"/>
+                        <a:ea typeface="Arial" charset="0"/>
+                        <a:cs typeface="Arial" charset="0"/>
+                      </a:endParaRPr>
+                    </a:p>
+                  </a:txBody>
+                  <a:tcPr marL="91440" marR="91440" marT="45720" marB="45720">
+                    <a:lnL w="12700" cap="flat" cmpd="sng" algn="ctr">
+                      <a:solidFill>
+                        <a:srgbClr val="FFFFFF"/>
+                      </a:solidFill>
+                      <a:prstDash val="solid"/>
+                      <a:round/>
+                      <a:headEnd type="none" w="med" len="med"/>
+                      <a:tailEnd type="none" w="med" len="med"/>
+                    </a:lnL>
+                    <a:lnR w="12700" cap="flat" cmpd="sng" algn="ctr">
+                      <a:solidFill>
+                        <a:srgbClr val="FFFFFF"/>
+                      </a:solidFill>
+                      <a:prstDash val="solid"/>
+                      <a:round/>
+                      <a:headEnd type="none" w="med" len="med"/>
+                      <a:tailEnd type="none" w="med" len="med"/>
+                    </a:lnR>
+                    <a:lnT w="12700" cap="flat" cmpd="sng" algn="ctr">
+                      <a:solidFill>
+                        <a:srgbClr val="FFFFFF"/>
+                      </a:solidFill>
+                      <a:prstDash val="solid"/>
+                      <a:round/>
+                      <a:headEnd type="none" w="med" len="med"/>
+                      <a:tailEnd type="none" w="med" len="med"/>
+                    </a:lnT>
+                    <a:lnB w="12700" cap="flat" cmpd="sng" algn="ctr">
+                      <a:solidFill>
+                        <a:srgbClr val="FFFFFF"/>
+                      </a:solidFill>
+                      <a:prstDash val="solid"/>
+                      <a:round/>
+                      <a:headEnd type="none" w="med" len="med"/>
+                      <a:tailEnd type="none" w="med" len="med"/>
+                    </a:lnB>
+                  </a:tcPr>
+                </a:tc>
+                <a:tc>
+                  <a:txBody>
+                    <a:bodyPr/>
+                    <a:lstStyle/>
+                    <a:p>
+                      <a:pPr algn="r" indent="0" marL="0">
+                        <a:buNone/>
+                      </a:pPr>
+                      <a:r>
+                        <a:rPr lang="en-US" sz="1250" dirty="0">
+                          <a:solidFill>
+                            <a:srgbClr val="000000"/>
+                          </a:solidFill>
+                          <a:latin typeface="Arial" pitchFamily="34" charset="0"/>
+                          <a:ea typeface="Arial" pitchFamily="34" charset="-122"/>
+                          <a:cs typeface="Arial" pitchFamily="34" charset="-120"/>
+                        </a:rPr>
+                        <a:t>17</a:t>
+                      </a:r>
+                      <a:endParaRPr lang="en-US" sz="1250" dirty="0">
+                        <a:latin typeface="Arial" charset="0"/>
+                        <a:ea typeface="Arial" charset="0"/>
+                        <a:cs typeface="Arial" charset="0"/>
+                      </a:endParaRPr>
+                    </a:p>
+                  </a:txBody>
+                  <a:tcPr marL="91440" marR="91440" marT="45720" marB="45720">
+                    <a:lnL w="12700" cap="flat" cmpd="sng" algn="ctr">
+                      <a:solidFill>
+                        <a:srgbClr val="FFFFFF"/>
+                      </a:solidFill>
+                      <a:prstDash val="solid"/>
+                      <a:round/>
+                      <a:headEnd type="none" w="med" len="med"/>
+                      <a:tailEnd type="none" w="med" len="med"/>
+                    </a:lnL>
+                    <a:lnR w="12700" cap="flat" cmpd="sng" algn="ctr">
+                      <a:solidFill>
+                        <a:srgbClr val="FFFFFF"/>
+                      </a:solidFill>
+                      <a:prstDash val="solid"/>
+                      <a:round/>
+                      <a:headEnd type="none" w="med" len="med"/>
+                      <a:tailEnd type="none" w="med" len="med"/>
+                    </a:lnR>
+                    <a:lnT w="12700" cap="flat" cmpd="sng" algn="ctr">
+                      <a:solidFill>
+                        <a:srgbClr val="FFFFFF"/>
+                      </a:solidFill>
+                      <a:prstDash val="solid"/>
+                      <a:round/>
+                      <a:headEnd type="none" w="med" len="med"/>
+                      <a:tailEnd type="none" w="med" len="med"/>
+                    </a:lnT>
+                    <a:lnB w="12700" cap="flat" cmpd="sng" algn="ctr">
+                      <a:solidFill>
+                        <a:srgbClr val="FFFFFF"/>
+                      </a:solidFill>
+                      <a:prstDash val="solid"/>
+                      <a:round/>
+                      <a:headEnd type="none" w="med" len="med"/>
+                      <a:tailEnd type="none" w="med" len="med"/>
+                    </a:lnB>
+                  </a:tcPr>
+                </a:tc>
+                <a:tc>
+                  <a:txBody>
+                    <a:bodyPr/>
+                    <a:lstStyle/>
+                    <a:p>
+                      <a:pPr algn="r" indent="0" marL="0">
+                        <a:buNone/>
+                      </a:pPr>
+                      <a:r>
+                        <a:rPr lang="en-US" sz="1250" dirty="0">
+                          <a:solidFill>
+                            <a:srgbClr val="000000"/>
+                          </a:solidFill>
+                          <a:latin typeface="Arial" pitchFamily="34" charset="0"/>
+                          <a:ea typeface="Arial" pitchFamily="34" charset="-122"/>
+                          <a:cs typeface="Arial" pitchFamily="34" charset="-120"/>
+                        </a:rPr>
+                        <a:t>35</a:t>
+                      </a:r>
+                      <a:endParaRPr lang="en-US" sz="1250" dirty="0">
+                        <a:latin typeface="Arial" charset="0"/>
+                        <a:ea typeface="Arial" charset="0"/>
+                        <a:cs typeface="Arial" charset="0"/>
+                      </a:endParaRPr>
+                    </a:p>
+                  </a:txBody>
+                  <a:tcPr marL="91440" marR="91440" marT="45720" marB="45720">
+                    <a:lnL w="12700" cap="flat" cmpd="sng" algn="ctr">
+                      <a:solidFill>
+                        <a:srgbClr val="FFFFFF"/>
+                      </a:solidFill>
+                      <a:prstDash val="solid"/>
+                      <a:round/>
+                      <a:headEnd type="none" w="med" len="med"/>
+                      <a:tailEnd type="none" w="med" len="med"/>
+                    </a:lnL>
+                    <a:lnR w="12700" cap="flat" cmpd="sng" algn="ctr">
+                      <a:solidFill>
+                        <a:srgbClr val="FFFFFF"/>
+                      </a:solidFill>
+                      <a:prstDash val="solid"/>
+                      <a:round/>
+                      <a:headEnd type="none" w="med" len="med"/>
+                      <a:tailEnd type="none" w="med" len="med"/>
+                    </a:lnR>
+                    <a:lnT w="12700" cap="flat" cmpd="sng" algn="ctr">
+                      <a:solidFill>
+                        <a:srgbClr val="FFFFFF"/>
+                      </a:solidFill>
+                      <a:prstDash val="solid"/>
+                      <a:round/>
+                      <a:headEnd type="none" w="med" len="med"/>
+                      <a:tailEnd type="none" w="med" len="med"/>
+                    </a:lnT>
+                    <a:lnB w="12700" cap="flat" cmpd="sng" algn="ctr">
+                      <a:solidFill>
+                        <a:srgbClr val="FFFFFF"/>
+                      </a:solidFill>
+                      <a:prstDash val="solid"/>
+                      <a:round/>
+                      <a:headEnd type="none" w="med" len="med"/>
+                      <a:tailEnd type="none" w="med" len="med"/>
+                    </a:lnB>
+                  </a:tcPr>
+                </a:tc>
+                <a:tc>
+                  <a:txBody>
+                    <a:bodyPr/>
+                    <a:lstStyle/>
+                    <a:p>
+                      <a:pPr algn="r" indent="0" marL="0">
+                        <a:buNone/>
+                      </a:pPr>
+                      <a:r>
+                        <a:rPr lang="en-US" sz="1250" dirty="0">
+                          <a:solidFill>
+                            <a:srgbClr val="000000"/>
+                          </a:solidFill>
+                          <a:latin typeface="Arial" pitchFamily="34" charset="0"/>
+                          <a:ea typeface="Arial" pitchFamily="34" charset="-122"/>
+                          <a:cs typeface="Arial" pitchFamily="34" charset="-120"/>
+                        </a:rPr>
+                        <a:t>20 €</a:t>
                       </a:r>
                       <a:endParaRPr lang="en-US" sz="1250" dirty="0">
                         <a:latin typeface="Arial" charset="0"/>
@@ -4392,661 +5046,7 @@
                           <a:ea typeface="Arial" pitchFamily="34" charset="-122"/>
                           <a:cs typeface="Arial" pitchFamily="34" charset="-120"/>
                         </a:rPr>
-                        <a:t>Abendessen Restaurant (Di–So 17:30–22:00)</a:t>
-                      </a:r>
-                      <a:endParaRPr lang="en-US" sz="1250" dirty="0">
-                        <a:latin typeface="Arial" charset="0"/>
-                        <a:ea typeface="Arial" charset="0"/>
-                        <a:cs typeface="Arial" charset="0"/>
-                      </a:endParaRPr>
-                    </a:p>
-                  </a:txBody>
-                  <a:tcPr marL="91440" marR="91440" marT="45720" marB="45720">
-                    <a:lnL w="12700" cap="flat" cmpd="sng" algn="ctr">
-                      <a:solidFill>
-                        <a:srgbClr val="FFFFFF"/>
-                      </a:solidFill>
-                      <a:prstDash val="solid"/>
-                      <a:round/>
-                      <a:headEnd type="none" w="med" len="med"/>
-                      <a:tailEnd type="none" w="med" len="med"/>
-                    </a:lnL>
-                    <a:lnR w="12700" cap="flat" cmpd="sng" algn="ctr">
-                      <a:solidFill>
-                        <a:srgbClr val="FFFFFF"/>
-                      </a:solidFill>
-                      <a:prstDash val="solid"/>
-                      <a:round/>
-                      <a:headEnd type="none" w="med" len="med"/>
-                      <a:tailEnd type="none" w="med" len="med"/>
-                    </a:lnR>
-                    <a:lnT w="12700" cap="flat" cmpd="sng" algn="ctr">
-                      <a:solidFill>
-                        <a:srgbClr val="FFFFFF"/>
-                      </a:solidFill>
-                      <a:prstDash val="solid"/>
-                      <a:round/>
-                      <a:headEnd type="none" w="med" len="med"/>
-                      <a:tailEnd type="none" w="med" len="med"/>
-                    </a:lnT>
-                    <a:lnB w="12700" cap="flat" cmpd="sng" algn="ctr">
-                      <a:solidFill>
-                        <a:srgbClr val="FFFFFF"/>
-                      </a:solidFill>
-                      <a:prstDash val="solid"/>
-                      <a:round/>
-                      <a:headEnd type="none" w="med" len="med"/>
-                      <a:tailEnd type="none" w="med" len="med"/>
-                    </a:lnB>
-                  </a:tcPr>
-                </a:tc>
-                <a:tc>
-                  <a:txBody>
-                    <a:bodyPr/>
-                    <a:lstStyle/>
-                    <a:p>
-                      <a:pPr algn="r" indent="0" marL="0">
-                        <a:buNone/>
-                      </a:pPr>
-                      <a:r>
-                        <a:rPr lang="en-US" sz="1250" dirty="0">
-                          <a:solidFill>
-                            <a:srgbClr val="000000"/>
-                          </a:solidFill>
-                          <a:latin typeface="Arial" pitchFamily="34" charset="0"/>
-                          <a:ea typeface="Arial" pitchFamily="34" charset="-122"/>
-                          <a:cs typeface="Arial" pitchFamily="34" charset="-120"/>
-                        </a:rPr>
-                        <a:t>26</a:t>
-                      </a:r>
-                      <a:endParaRPr lang="en-US" sz="1250" dirty="0">
-                        <a:latin typeface="Arial" charset="0"/>
-                        <a:ea typeface="Arial" charset="0"/>
-                        <a:cs typeface="Arial" charset="0"/>
-                      </a:endParaRPr>
-                    </a:p>
-                  </a:txBody>
-                  <a:tcPr marL="91440" marR="91440" marT="45720" marB="45720">
-                    <a:lnL w="12700" cap="flat" cmpd="sng" algn="ctr">
-                      <a:solidFill>
-                        <a:srgbClr val="FFFFFF"/>
-                      </a:solidFill>
-                      <a:prstDash val="solid"/>
-                      <a:round/>
-                      <a:headEnd type="none" w="med" len="med"/>
-                      <a:tailEnd type="none" w="med" len="med"/>
-                    </a:lnL>
-                    <a:lnR w="12700" cap="flat" cmpd="sng" algn="ctr">
-                      <a:solidFill>
-                        <a:srgbClr val="FFFFFF"/>
-                      </a:solidFill>
-                      <a:prstDash val="solid"/>
-                      <a:round/>
-                      <a:headEnd type="none" w="med" len="med"/>
-                      <a:tailEnd type="none" w="med" len="med"/>
-                    </a:lnR>
-                    <a:lnT w="12700" cap="flat" cmpd="sng" algn="ctr">
-                      <a:solidFill>
-                        <a:srgbClr val="FFFFFF"/>
-                      </a:solidFill>
-                      <a:prstDash val="solid"/>
-                      <a:round/>
-                      <a:headEnd type="none" w="med" len="med"/>
-                      <a:tailEnd type="none" w="med" len="med"/>
-                    </a:lnT>
-                    <a:lnB w="12700" cap="flat" cmpd="sng" algn="ctr">
-                      <a:solidFill>
-                        <a:srgbClr val="FFFFFF"/>
-                      </a:solidFill>
-                      <a:prstDash val="solid"/>
-                      <a:round/>
-                      <a:headEnd type="none" w="med" len="med"/>
-                      <a:tailEnd type="none" w="med" len="med"/>
-                    </a:lnB>
-                  </a:tcPr>
-                </a:tc>
-                <a:tc>
-                  <a:txBody>
-                    <a:bodyPr/>
-                    <a:lstStyle/>
-                    <a:p>
-                      <a:pPr algn="r" indent="0" marL="0">
-                        <a:buNone/>
-                      </a:pPr>
-                      <a:r>
-                        <a:rPr lang="en-US" sz="1250" dirty="0">
-                          <a:solidFill>
-                            <a:srgbClr val="000000"/>
-                          </a:solidFill>
-                          <a:latin typeface="Arial" pitchFamily="34" charset="0"/>
-                          <a:ea typeface="Arial" pitchFamily="34" charset="-122"/>
-                          <a:cs typeface="Arial" pitchFamily="34" charset="-120"/>
-                        </a:rPr>
-                        <a:t>55</a:t>
-                      </a:r>
-                      <a:endParaRPr lang="en-US" sz="1250" dirty="0">
-                        <a:latin typeface="Arial" charset="0"/>
-                        <a:ea typeface="Arial" charset="0"/>
-                        <a:cs typeface="Arial" charset="0"/>
-                      </a:endParaRPr>
-                    </a:p>
-                  </a:txBody>
-                  <a:tcPr marL="91440" marR="91440" marT="45720" marB="45720">
-                    <a:lnL w="12700" cap="flat" cmpd="sng" algn="ctr">
-                      <a:solidFill>
-                        <a:srgbClr val="FFFFFF"/>
-                      </a:solidFill>
-                      <a:prstDash val="solid"/>
-                      <a:round/>
-                      <a:headEnd type="none" w="med" len="med"/>
-                      <a:tailEnd type="none" w="med" len="med"/>
-                    </a:lnL>
-                    <a:lnR w="12700" cap="flat" cmpd="sng" algn="ctr">
-                      <a:solidFill>
-                        <a:srgbClr val="FFFFFF"/>
-                      </a:solidFill>
-                      <a:prstDash val="solid"/>
-                      <a:round/>
-                      <a:headEnd type="none" w="med" len="med"/>
-                      <a:tailEnd type="none" w="med" len="med"/>
-                    </a:lnR>
-                    <a:lnT w="12700" cap="flat" cmpd="sng" algn="ctr">
-                      <a:solidFill>
-                        <a:srgbClr val="FFFFFF"/>
-                      </a:solidFill>
-                      <a:prstDash val="solid"/>
-                      <a:round/>
-                      <a:headEnd type="none" w="med" len="med"/>
-                      <a:tailEnd type="none" w="med" len="med"/>
-                    </a:lnT>
-                    <a:lnB w="12700" cap="flat" cmpd="sng" algn="ctr">
-                      <a:solidFill>
-                        <a:srgbClr val="FFFFFF"/>
-                      </a:solidFill>
-                      <a:prstDash val="solid"/>
-                      <a:round/>
-                      <a:headEnd type="none" w="med" len="med"/>
-                      <a:tailEnd type="none" w="med" len="med"/>
-                    </a:lnB>
-                  </a:tcPr>
-                </a:tc>
-                <a:tc>
-                  <a:txBody>
-                    <a:bodyPr/>
-                    <a:lstStyle/>
-                    <a:p>
-                      <a:pPr algn="r" indent="0" marL="0">
-                        <a:buNone/>
-                      </a:pPr>
-                      <a:r>
-                        <a:rPr lang="en-US" sz="1250" dirty="0">
-                          <a:solidFill>
-                            <a:srgbClr val="000000"/>
-                          </a:solidFill>
-                          <a:latin typeface="Arial" pitchFamily="34" charset="0"/>
-                          <a:ea typeface="Arial" pitchFamily="34" charset="-122"/>
-                          <a:cs typeface="Arial" pitchFamily="34" charset="-120"/>
-                        </a:rPr>
-                        <a:t>32 €</a:t>
-                      </a:r>
-                      <a:endParaRPr lang="en-US" sz="1250" dirty="0">
-                        <a:latin typeface="Arial" charset="0"/>
-                        <a:ea typeface="Arial" charset="0"/>
-                        <a:cs typeface="Arial" charset="0"/>
-                      </a:endParaRPr>
-                    </a:p>
-                  </a:txBody>
-                  <a:tcPr marL="91440" marR="91440" marT="45720" marB="45720">
-                    <a:lnL w="12700" cap="flat" cmpd="sng" algn="ctr">
-                      <a:solidFill>
-                        <a:srgbClr val="FFFFFF"/>
-                      </a:solidFill>
-                      <a:prstDash val="solid"/>
-                      <a:round/>
-                      <a:headEnd type="none" w="med" len="med"/>
-                      <a:tailEnd type="none" w="med" len="med"/>
-                    </a:lnL>
-                    <a:lnR w="12700" cap="flat" cmpd="sng" algn="ctr">
-                      <a:solidFill>
-                        <a:srgbClr val="FFFFFF"/>
-                      </a:solidFill>
-                      <a:prstDash val="solid"/>
-                      <a:round/>
-                      <a:headEnd type="none" w="med" len="med"/>
-                      <a:tailEnd type="none" w="med" len="med"/>
-                    </a:lnR>
-                    <a:lnT w="12700" cap="flat" cmpd="sng" algn="ctr">
-                      <a:solidFill>
-                        <a:srgbClr val="FFFFFF"/>
-                      </a:solidFill>
-                      <a:prstDash val="solid"/>
-                      <a:round/>
-                      <a:headEnd type="none" w="med" len="med"/>
-                      <a:tailEnd type="none" w="med" len="med"/>
-                    </a:lnT>
-                    <a:lnB w="12700" cap="flat" cmpd="sng" algn="ctr">
-                      <a:solidFill>
-                        <a:srgbClr val="FFFFFF"/>
-                      </a:solidFill>
-                      <a:prstDash val="solid"/>
-                      <a:round/>
-                      <a:headEnd type="none" w="med" len="med"/>
-                      <a:tailEnd type="none" w="med" len="med"/>
-                    </a:lnB>
-                  </a:tcPr>
-                </a:tc>
-                <a:tc>
-                  <a:txBody>
-                    <a:bodyPr/>
-                    <a:lstStyle/>
-                    <a:p>
-                      <a:pPr algn="r" indent="0" marL="0">
-                        <a:buNone/>
-                      </a:pPr>
-                      <a:r>
-                        <a:rPr lang="en-US" sz="1250" dirty="0">
-                          <a:solidFill>
-                            <a:srgbClr val="000000"/>
-                          </a:solidFill>
-                          <a:latin typeface="Arial" pitchFamily="34" charset="0"/>
-                          <a:ea typeface="Arial" pitchFamily="34" charset="-122"/>
-                          <a:cs typeface="Arial" pitchFamily="34" charset="-120"/>
-                        </a:rPr>
-                        <a:t>45.760 €</a:t>
-                      </a:r>
-                      <a:endParaRPr lang="en-US" sz="1250" dirty="0">
-                        <a:latin typeface="Arial" charset="0"/>
-                        <a:ea typeface="Arial" charset="0"/>
-                        <a:cs typeface="Arial" charset="0"/>
-                      </a:endParaRPr>
-                    </a:p>
-                  </a:txBody>
-                  <a:tcPr marL="91440" marR="91440" marT="45720" marB="45720">
-                    <a:lnL w="12700" cap="flat" cmpd="sng" algn="ctr">
-                      <a:solidFill>
-                        <a:srgbClr val="FFFFFF"/>
-                      </a:solidFill>
-                      <a:prstDash val="solid"/>
-                      <a:round/>
-                      <a:headEnd type="none" w="med" len="med"/>
-                      <a:tailEnd type="none" w="med" len="med"/>
-                    </a:lnL>
-                    <a:lnR w="12700" cap="flat" cmpd="sng" algn="ctr">
-                      <a:solidFill>
-                        <a:srgbClr val="FFFFFF"/>
-                      </a:solidFill>
-                      <a:prstDash val="solid"/>
-                      <a:round/>
-                      <a:headEnd type="none" w="med" len="med"/>
-                      <a:tailEnd type="none" w="med" len="med"/>
-                    </a:lnR>
-                    <a:lnT w="12700" cap="flat" cmpd="sng" algn="ctr">
-                      <a:solidFill>
-                        <a:srgbClr val="FFFFFF"/>
-                      </a:solidFill>
-                      <a:prstDash val="solid"/>
-                      <a:round/>
-                      <a:headEnd type="none" w="med" len="med"/>
-                      <a:tailEnd type="none" w="med" len="med"/>
-                    </a:lnT>
-                    <a:lnB w="12700" cap="flat" cmpd="sng" algn="ctr">
-                      <a:solidFill>
-                        <a:srgbClr val="FFFFFF"/>
-                      </a:solidFill>
-                      <a:prstDash val="solid"/>
-                      <a:round/>
-                      <a:headEnd type="none" w="med" len="med"/>
-                      <a:tailEnd type="none" w="med" len="med"/>
-                    </a:lnB>
-                  </a:tcPr>
-                </a:tc>
-              </a:tr>
-              <a:tr h="457200">
-                <a:tc>
-                  <a:txBody>
-                    <a:bodyPr/>
-                    <a:lstStyle/>
-                    <a:p>
-                      <a:pPr indent="0" marL="0">
-                        <a:buNone/>
-                      </a:pPr>
-                      <a:r>
-                        <a:rPr lang="en-US" sz="1250" dirty="0">
-                          <a:solidFill>
-                            <a:srgbClr val="000000"/>
-                          </a:solidFill>
-                          <a:latin typeface="Arial" pitchFamily="34" charset="0"/>
-                          <a:ea typeface="Arial" pitchFamily="34" charset="-122"/>
-                          <a:cs typeface="Arial" pitchFamily="34" charset="-120"/>
-                        </a:rPr>
-                        <a:t>Bar Di–Do (ab 21:00)</a:t>
-                      </a:r>
-                      <a:endParaRPr lang="en-US" sz="1250" dirty="0">
-                        <a:latin typeface="Arial" charset="0"/>
-                        <a:ea typeface="Arial" charset="0"/>
-                        <a:cs typeface="Arial" charset="0"/>
-                      </a:endParaRPr>
-                    </a:p>
-                  </a:txBody>
-                  <a:tcPr marL="91440" marR="91440" marT="45720" marB="45720">
-                    <a:lnL w="12700" cap="flat" cmpd="sng" algn="ctr">
-                      <a:solidFill>
-                        <a:srgbClr val="FFFFFF"/>
-                      </a:solidFill>
-                      <a:prstDash val="solid"/>
-                      <a:round/>
-                      <a:headEnd type="none" w="med" len="med"/>
-                      <a:tailEnd type="none" w="med" len="med"/>
-                    </a:lnL>
-                    <a:lnR w="12700" cap="flat" cmpd="sng" algn="ctr">
-                      <a:solidFill>
-                        <a:srgbClr val="FFFFFF"/>
-                      </a:solidFill>
-                      <a:prstDash val="solid"/>
-                      <a:round/>
-                      <a:headEnd type="none" w="med" len="med"/>
-                      <a:tailEnd type="none" w="med" len="med"/>
-                    </a:lnR>
-                    <a:lnT w="12700" cap="flat" cmpd="sng" algn="ctr">
-                      <a:solidFill>
-                        <a:srgbClr val="FFFFFF"/>
-                      </a:solidFill>
-                      <a:prstDash val="solid"/>
-                      <a:round/>
-                      <a:headEnd type="none" w="med" len="med"/>
-                      <a:tailEnd type="none" w="med" len="med"/>
-                    </a:lnT>
-                    <a:lnB w="12700" cap="flat" cmpd="sng" algn="ctr">
-                      <a:solidFill>
-                        <a:srgbClr val="FFFFFF"/>
-                      </a:solidFill>
-                      <a:prstDash val="solid"/>
-                      <a:round/>
-                      <a:headEnd type="none" w="med" len="med"/>
-                      <a:tailEnd type="none" w="med" len="med"/>
-                    </a:lnB>
-                  </a:tcPr>
-                </a:tc>
-                <a:tc>
-                  <a:txBody>
-                    <a:bodyPr/>
-                    <a:lstStyle/>
-                    <a:p>
-                      <a:pPr algn="r" indent="0" marL="0">
-                        <a:buNone/>
-                      </a:pPr>
-                      <a:r>
-                        <a:rPr lang="en-US" sz="1250" dirty="0">
-                          <a:solidFill>
-                            <a:srgbClr val="000000"/>
-                          </a:solidFill>
-                          <a:latin typeface="Arial" pitchFamily="34" charset="0"/>
-                          <a:ea typeface="Arial" pitchFamily="34" charset="-122"/>
-                          <a:cs typeface="Arial" pitchFamily="34" charset="-120"/>
-                        </a:rPr>
-                        <a:t>13</a:t>
-                      </a:r>
-                      <a:endParaRPr lang="en-US" sz="1250" dirty="0">
-                        <a:latin typeface="Arial" charset="0"/>
-                        <a:ea typeface="Arial" charset="0"/>
-                        <a:cs typeface="Arial" charset="0"/>
-                      </a:endParaRPr>
-                    </a:p>
-                  </a:txBody>
-                  <a:tcPr marL="91440" marR="91440" marT="45720" marB="45720">
-                    <a:lnL w="12700" cap="flat" cmpd="sng" algn="ctr">
-                      <a:solidFill>
-                        <a:srgbClr val="FFFFFF"/>
-                      </a:solidFill>
-                      <a:prstDash val="solid"/>
-                      <a:round/>
-                      <a:headEnd type="none" w="med" len="med"/>
-                      <a:tailEnd type="none" w="med" len="med"/>
-                    </a:lnL>
-                    <a:lnR w="12700" cap="flat" cmpd="sng" algn="ctr">
-                      <a:solidFill>
-                        <a:srgbClr val="FFFFFF"/>
-                      </a:solidFill>
-                      <a:prstDash val="solid"/>
-                      <a:round/>
-                      <a:headEnd type="none" w="med" len="med"/>
-                      <a:tailEnd type="none" w="med" len="med"/>
-                    </a:lnR>
-                    <a:lnT w="12700" cap="flat" cmpd="sng" algn="ctr">
-                      <a:solidFill>
-                        <a:srgbClr val="FFFFFF"/>
-                      </a:solidFill>
-                      <a:prstDash val="solid"/>
-                      <a:round/>
-                      <a:headEnd type="none" w="med" len="med"/>
-                      <a:tailEnd type="none" w="med" len="med"/>
-                    </a:lnT>
-                    <a:lnB w="12700" cap="flat" cmpd="sng" algn="ctr">
-                      <a:solidFill>
-                        <a:srgbClr val="FFFFFF"/>
-                      </a:solidFill>
-                      <a:prstDash val="solid"/>
-                      <a:round/>
-                      <a:headEnd type="none" w="med" len="med"/>
-                      <a:tailEnd type="none" w="med" len="med"/>
-                    </a:lnB>
-                  </a:tcPr>
-                </a:tc>
-                <a:tc>
-                  <a:txBody>
-                    <a:bodyPr/>
-                    <a:lstStyle/>
-                    <a:p>
-                      <a:pPr algn="r" indent="0" marL="0">
-                        <a:buNone/>
-                      </a:pPr>
-                      <a:r>
-                        <a:rPr lang="en-US" sz="1250" dirty="0">
-                          <a:solidFill>
-                            <a:srgbClr val="000000"/>
-                          </a:solidFill>
-                          <a:latin typeface="Arial" pitchFamily="34" charset="0"/>
-                          <a:ea typeface="Arial" pitchFamily="34" charset="-122"/>
-                          <a:cs typeface="Arial" pitchFamily="34" charset="-120"/>
-                        </a:rPr>
-                        <a:t>20</a:t>
-                      </a:r>
-                      <a:endParaRPr lang="en-US" sz="1250" dirty="0">
-                        <a:latin typeface="Arial" charset="0"/>
-                        <a:ea typeface="Arial" charset="0"/>
-                        <a:cs typeface="Arial" charset="0"/>
-                      </a:endParaRPr>
-                    </a:p>
-                  </a:txBody>
-                  <a:tcPr marL="91440" marR="91440" marT="45720" marB="45720">
-                    <a:lnL w="12700" cap="flat" cmpd="sng" algn="ctr">
-                      <a:solidFill>
-                        <a:srgbClr val="FFFFFF"/>
-                      </a:solidFill>
-                      <a:prstDash val="solid"/>
-                      <a:round/>
-                      <a:headEnd type="none" w="med" len="med"/>
-                      <a:tailEnd type="none" w="med" len="med"/>
-                    </a:lnL>
-                    <a:lnR w="12700" cap="flat" cmpd="sng" algn="ctr">
-                      <a:solidFill>
-                        <a:srgbClr val="FFFFFF"/>
-                      </a:solidFill>
-                      <a:prstDash val="solid"/>
-                      <a:round/>
-                      <a:headEnd type="none" w="med" len="med"/>
-                      <a:tailEnd type="none" w="med" len="med"/>
-                    </a:lnR>
-                    <a:lnT w="12700" cap="flat" cmpd="sng" algn="ctr">
-                      <a:solidFill>
-                        <a:srgbClr val="FFFFFF"/>
-                      </a:solidFill>
-                      <a:prstDash val="solid"/>
-                      <a:round/>
-                      <a:headEnd type="none" w="med" len="med"/>
-                      <a:tailEnd type="none" w="med" len="med"/>
-                    </a:lnT>
-                    <a:lnB w="12700" cap="flat" cmpd="sng" algn="ctr">
-                      <a:solidFill>
-                        <a:srgbClr val="FFFFFF"/>
-                      </a:solidFill>
-                      <a:prstDash val="solid"/>
-                      <a:round/>
-                      <a:headEnd type="none" w="med" len="med"/>
-                      <a:tailEnd type="none" w="med" len="med"/>
-                    </a:lnB>
-                  </a:tcPr>
-                </a:tc>
-                <a:tc>
-                  <a:txBody>
-                    <a:bodyPr/>
-                    <a:lstStyle/>
-                    <a:p>
-                      <a:pPr algn="r" indent="0" marL="0">
-                        <a:buNone/>
-                      </a:pPr>
-                      <a:r>
-                        <a:rPr lang="en-US" sz="1250" dirty="0">
-                          <a:solidFill>
-                            <a:srgbClr val="000000"/>
-                          </a:solidFill>
-                          <a:latin typeface="Arial" pitchFamily="34" charset="0"/>
-                          <a:ea typeface="Arial" pitchFamily="34" charset="-122"/>
-                          <a:cs typeface="Arial" pitchFamily="34" charset="-120"/>
-                        </a:rPr>
-                        <a:t>18 €</a:t>
-                      </a:r>
-                      <a:endParaRPr lang="en-US" sz="1250" dirty="0">
-                        <a:latin typeface="Arial" charset="0"/>
-                        <a:ea typeface="Arial" charset="0"/>
-                        <a:cs typeface="Arial" charset="0"/>
-                      </a:endParaRPr>
-                    </a:p>
-                  </a:txBody>
-                  <a:tcPr marL="91440" marR="91440" marT="45720" marB="45720">
-                    <a:lnL w="12700" cap="flat" cmpd="sng" algn="ctr">
-                      <a:solidFill>
-                        <a:srgbClr val="FFFFFF"/>
-                      </a:solidFill>
-                      <a:prstDash val="solid"/>
-                      <a:round/>
-                      <a:headEnd type="none" w="med" len="med"/>
-                      <a:tailEnd type="none" w="med" len="med"/>
-                    </a:lnL>
-                    <a:lnR w="12700" cap="flat" cmpd="sng" algn="ctr">
-                      <a:solidFill>
-                        <a:srgbClr val="FFFFFF"/>
-                      </a:solidFill>
-                      <a:prstDash val="solid"/>
-                      <a:round/>
-                      <a:headEnd type="none" w="med" len="med"/>
-                      <a:tailEnd type="none" w="med" len="med"/>
-                    </a:lnR>
-                    <a:lnT w="12700" cap="flat" cmpd="sng" algn="ctr">
-                      <a:solidFill>
-                        <a:srgbClr val="FFFFFF"/>
-                      </a:solidFill>
-                      <a:prstDash val="solid"/>
-                      <a:round/>
-                      <a:headEnd type="none" w="med" len="med"/>
-                      <a:tailEnd type="none" w="med" len="med"/>
-                    </a:lnT>
-                    <a:lnB w="12700" cap="flat" cmpd="sng" algn="ctr">
-                      <a:solidFill>
-                        <a:srgbClr val="FFFFFF"/>
-                      </a:solidFill>
-                      <a:prstDash val="solid"/>
-                      <a:round/>
-                      <a:headEnd type="none" w="med" len="med"/>
-                      <a:tailEnd type="none" w="med" len="med"/>
-                    </a:lnB>
-                  </a:tcPr>
-                </a:tc>
-                <a:tc>
-                  <a:txBody>
-                    <a:bodyPr/>
-                    <a:lstStyle/>
-                    <a:p>
-                      <a:pPr algn="r" indent="0" marL="0">
-                        <a:buNone/>
-                      </a:pPr>
-                      <a:r>
-                        <a:rPr lang="en-US" sz="1250" dirty="0">
-                          <a:solidFill>
-                            <a:srgbClr val="000000"/>
-                          </a:solidFill>
-                          <a:latin typeface="Arial" pitchFamily="34" charset="0"/>
-                          <a:ea typeface="Arial" pitchFamily="34" charset="-122"/>
-                          <a:cs typeface="Arial" pitchFamily="34" charset="-120"/>
-                        </a:rPr>
-                        <a:t>4.680 €</a:t>
-                      </a:r>
-                      <a:endParaRPr lang="en-US" sz="1250" dirty="0">
-                        <a:latin typeface="Arial" charset="0"/>
-                        <a:ea typeface="Arial" charset="0"/>
-                        <a:cs typeface="Arial" charset="0"/>
-                      </a:endParaRPr>
-                    </a:p>
-                  </a:txBody>
-                  <a:tcPr marL="91440" marR="91440" marT="45720" marB="45720">
-                    <a:lnL w="12700" cap="flat" cmpd="sng" algn="ctr">
-                      <a:solidFill>
-                        <a:srgbClr val="FFFFFF"/>
-                      </a:solidFill>
-                      <a:prstDash val="solid"/>
-                      <a:round/>
-                      <a:headEnd type="none" w="med" len="med"/>
-                      <a:tailEnd type="none" w="med" len="med"/>
-                    </a:lnL>
-                    <a:lnR w="12700" cap="flat" cmpd="sng" algn="ctr">
-                      <a:solidFill>
-                        <a:srgbClr val="FFFFFF"/>
-                      </a:solidFill>
-                      <a:prstDash val="solid"/>
-                      <a:round/>
-                      <a:headEnd type="none" w="med" len="med"/>
-                      <a:tailEnd type="none" w="med" len="med"/>
-                    </a:lnR>
-                    <a:lnT w="12700" cap="flat" cmpd="sng" algn="ctr">
-                      <a:solidFill>
-                        <a:srgbClr val="FFFFFF"/>
-                      </a:solidFill>
-                      <a:prstDash val="solid"/>
-                      <a:round/>
-                      <a:headEnd type="none" w="med" len="med"/>
-                      <a:tailEnd type="none" w="med" len="med"/>
-                    </a:lnT>
-                    <a:lnB w="12700" cap="flat" cmpd="sng" algn="ctr">
-                      <a:solidFill>
-                        <a:srgbClr val="FFFFFF"/>
-                      </a:solidFill>
-                      <a:prstDash val="solid"/>
-                      <a:round/>
-                      <a:headEnd type="none" w="med" len="med"/>
-                      <a:tailEnd type="none" w="med" len="med"/>
-                    </a:lnB>
-                  </a:tcPr>
-                </a:tc>
-              </a:tr>
-              <a:tr h="457200">
-                <a:tc>
-                  <a:txBody>
-                    <a:bodyPr/>
-                    <a:lstStyle/>
-                    <a:p>
-                      <a:pPr indent="0" marL="0">
-                        <a:buNone/>
-                      </a:pPr>
-                      <a:r>
-                        <a:rPr lang="en-US" sz="1250" dirty="0">
-                          <a:solidFill>
-                            <a:srgbClr val="000000"/>
-                          </a:solidFill>
-                          <a:latin typeface="Arial" pitchFamily="34" charset="0"/>
-                          <a:ea typeface="Arial" pitchFamily="34" charset="-122"/>
-                          <a:cs typeface="Arial" pitchFamily="34" charset="-120"/>
-                        </a:rPr>
-                        <a:t>Bar Fr, Sa (bis 01:00) (Cocktails, Wein, Bier, Musik)</a:t>
+                        <a:t>Bar Fr, Sa (bis 01:00) (Cocktails, Wein, Bier, Snacks)</a:t>
                       </a:r>
                       <a:endParaRPr lang="en-US" sz="1250" dirty="0">
                         <a:latin typeface="Arial" charset="0"/>
@@ -5176,7 +5176,7 @@
                           <a:ea typeface="Arial" pitchFamily="34" charset="-122"/>
                           <a:cs typeface="Arial" pitchFamily="34" charset="-120"/>
                         </a:rPr>
-                        <a:t>70</a:t>
+                        <a:t>90</a:t>
                       </a:r>
                       <a:endParaRPr lang="en-US" sz="1250" dirty="0">
                         <a:latin typeface="Arial" charset="0"/>
@@ -5241,7 +5241,7 @@
                           <a:ea typeface="Arial" pitchFamily="34" charset="-122"/>
                           <a:cs typeface="Arial" pitchFamily="34" charset="-120"/>
                         </a:rPr>
-                        <a:t>22 €</a:t>
+                        <a:t>26 €</a:t>
                       </a:r>
                       <a:endParaRPr lang="en-US" sz="1250" dirty="0">
                         <a:latin typeface="Arial" charset="0"/>
@@ -5306,7 +5306,7 @@
                           <a:ea typeface="Arial" pitchFamily="34" charset="-122"/>
                           <a:cs typeface="Arial" pitchFamily="34" charset="-120"/>
                         </a:rPr>
-                        <a:t>13.860 €</a:t>
+                        <a:t>21.060 €</a:t>
                       </a:r>
                       <a:endParaRPr lang="en-US" sz="1250" dirty="0">
                         <a:latin typeface="Arial" charset="0"/>
@@ -5373,7 +5373,7 @@
                           <a:ea typeface="Arial" pitchFamily="34" charset="-122"/>
                           <a:cs typeface="Arial" pitchFamily="34" charset="-120"/>
                         </a:rPr>
-                        <a:t>Feiern, Live-Abende, Séparée (nach Absprache, 4 pro Monat)</a:t>
+                        <a:t>Events: Live-Musik, Feiern (nach Absprache, 4 pro Monat)</a:t>
                       </a:r>
                       <a:endParaRPr lang="en-US" sz="1250" dirty="0">
                         <a:latin typeface="Arial" charset="0"/>
@@ -5568,7 +5568,7 @@
                           <a:ea typeface="Arial" pitchFamily="34" charset="-122"/>
                           <a:cs typeface="Arial" pitchFamily="34" charset="-120"/>
                         </a:rPr>
-                        <a:t>45 €</a:t>
+                        <a:t>40 €</a:t>
                       </a:r>
                       <a:endParaRPr lang="en-US" sz="1250" dirty="0">
                         <a:latin typeface="Arial" charset="0"/>
@@ -5633,7 +5633,7 @@
                           <a:ea typeface="Arial" pitchFamily="34" charset="-122"/>
                           <a:cs typeface="Arial" pitchFamily="34" charset="-120"/>
                         </a:rPr>
-                        <a:t>7.200 €</a:t>
+                        <a:t>6.400 €</a:t>
                       </a:r>
                       <a:endParaRPr lang="en-US" sz="1250" dirty="0">
                         <a:latin typeface="Arial" charset="0"/>
@@ -5927,7 +5927,7 @@
                           <a:ea typeface="Arial" pitchFamily="34" charset="-122"/>
                           <a:cs typeface="Arial" pitchFamily="34" charset="-120"/>
                         </a:rPr>
-                        <a:t>95.635 €</a:t>
+                        <a:t>65.010 €</a:t>
                       </a:r>
                       <a:endParaRPr lang="en-US" sz="1250" dirty="0">
                         <a:latin typeface="Arial" charset="0"/>
@@ -6057,7 +6057,7 @@
                 <a:ea typeface="Arial" pitchFamily="34" charset="-122"/>
                 <a:cs typeface="Arial" pitchFamily="34" charset="-120"/>
               </a:rPr>
-              <a:t>Ca. 4.295 Gäste im Monat, im Schnitt ca. 165 pro Öffnungstag bei 190 Plätzen. Der Abend (Restaurant, Bar, Feiern) bringt 75 % vom Umsatz.</a:t>
+              <a:t>Ca. 3.815 Gäste im Monat, im Schnitt ca. 147 pro Öffnungstag bei 190 Plätzen. Der Abend (Bar mit Snacks, Events) bringt 61 % vom Umsatz.</a:t>
             </a:r>
             <a:endParaRPr lang="en-US" sz="1300" dirty="0"/>
           </a:p>
@@ -6512,7 +6512,7 @@
                           <a:ea typeface="Arial" pitchFamily="34" charset="-122"/>
                           <a:cs typeface="Arial" pitchFamily="34" charset="-120"/>
                         </a:rPr>
-                        <a:t>Küchenchef</a:t>
+                        <a:t>Küchenleitung (Bowls, Snacks)</a:t>
                       </a:r>
                       <a:endParaRPr lang="en-US" sz="1250" dirty="0">
                         <a:latin typeface="Arial" charset="0"/>
@@ -6642,7 +6642,7 @@
                           <a:ea typeface="Arial" pitchFamily="34" charset="-122"/>
                           <a:cs typeface="Arial" pitchFamily="34" charset="-120"/>
                         </a:rPr>
-                        <a:t>4.200 €</a:t>
+                        <a:t>3.400 €</a:t>
                       </a:r>
                       <a:endParaRPr lang="en-US" sz="1250" dirty="0">
                         <a:latin typeface="Arial" charset="0"/>
@@ -6709,7 +6709,401 @@
                           <a:ea typeface="Arial" pitchFamily="34" charset="-122"/>
                           <a:cs typeface="Arial" pitchFamily="34" charset="-120"/>
                         </a:rPr>
-                        <a:t>Koch</a:t>
+                        <a:t>Küchenhilfe</a:t>
+                      </a:r>
+                      <a:endParaRPr lang="en-US" sz="1250" dirty="0">
+                        <a:latin typeface="Arial" charset="0"/>
+                        <a:ea typeface="Arial" charset="0"/>
+                        <a:cs typeface="Arial" charset="0"/>
+                      </a:endParaRPr>
+                    </a:p>
+                  </a:txBody>
+                  <a:tcPr marL="91440" marR="91440" marT="45720" marB="45720">
+                    <a:lnL w="12700" cap="flat" cmpd="sng" algn="ctr">
+                      <a:solidFill>
+                        <a:srgbClr val="FFFFFF"/>
+                      </a:solidFill>
+                      <a:prstDash val="solid"/>
+                      <a:round/>
+                      <a:headEnd type="none" w="med" len="med"/>
+                      <a:tailEnd type="none" w="med" len="med"/>
+                    </a:lnL>
+                    <a:lnR w="12700" cap="flat" cmpd="sng" algn="ctr">
+                      <a:solidFill>
+                        <a:srgbClr val="FFFFFF"/>
+                      </a:solidFill>
+                      <a:prstDash val="solid"/>
+                      <a:round/>
+                      <a:headEnd type="none" w="med" len="med"/>
+                      <a:tailEnd type="none" w="med" len="med"/>
+                    </a:lnR>
+                    <a:lnT w="12700" cap="flat" cmpd="sng" algn="ctr">
+                      <a:solidFill>
+                        <a:srgbClr val="FFFFFF"/>
+                      </a:solidFill>
+                      <a:prstDash val="solid"/>
+                      <a:round/>
+                      <a:headEnd type="none" w="med" len="med"/>
+                      <a:tailEnd type="none" w="med" len="med"/>
+                    </a:lnT>
+                    <a:lnB w="12700" cap="flat" cmpd="sng" algn="ctr">
+                      <a:solidFill>
+                        <a:srgbClr val="FFFFFF"/>
+                      </a:solidFill>
+                      <a:prstDash val="solid"/>
+                      <a:round/>
+                      <a:headEnd type="none" w="med" len="med"/>
+                      <a:tailEnd type="none" w="med" len="med"/>
+                    </a:lnB>
+                  </a:tcPr>
+                </a:tc>
+                <a:tc>
+                  <a:txBody>
+                    <a:bodyPr/>
+                    <a:lstStyle/>
+                    <a:p>
+                      <a:pPr indent="0" marL="0">
+                        <a:buNone/>
+                      </a:pPr>
+                      <a:r>
+                        <a:rPr lang="en-US" sz="1250" dirty="0">
+                          <a:solidFill>
+                            <a:srgbClr val="000000"/>
+                          </a:solidFill>
+                          <a:latin typeface="Arial" pitchFamily="34" charset="0"/>
+                          <a:ea typeface="Arial" pitchFamily="34" charset="-122"/>
+                          <a:cs typeface="Arial" pitchFamily="34" charset="-120"/>
+                        </a:rPr>
+                        <a:t>1 Teilzeit</a:t>
+                      </a:r>
+                      <a:endParaRPr lang="en-US" sz="1250" dirty="0">
+                        <a:latin typeface="Arial" charset="0"/>
+                        <a:ea typeface="Arial" charset="0"/>
+                        <a:cs typeface="Arial" charset="0"/>
+                      </a:endParaRPr>
+                    </a:p>
+                  </a:txBody>
+                  <a:tcPr marL="91440" marR="91440" marT="45720" marB="45720">
+                    <a:lnL w="12700" cap="flat" cmpd="sng" algn="ctr">
+                      <a:solidFill>
+                        <a:srgbClr val="FFFFFF"/>
+                      </a:solidFill>
+                      <a:prstDash val="solid"/>
+                      <a:round/>
+                      <a:headEnd type="none" w="med" len="med"/>
+                      <a:tailEnd type="none" w="med" len="med"/>
+                    </a:lnL>
+                    <a:lnR w="12700" cap="flat" cmpd="sng" algn="ctr">
+                      <a:solidFill>
+                        <a:srgbClr val="FFFFFF"/>
+                      </a:solidFill>
+                      <a:prstDash val="solid"/>
+                      <a:round/>
+                      <a:headEnd type="none" w="med" len="med"/>
+                      <a:tailEnd type="none" w="med" len="med"/>
+                    </a:lnR>
+                    <a:lnT w="12700" cap="flat" cmpd="sng" algn="ctr">
+                      <a:solidFill>
+                        <a:srgbClr val="FFFFFF"/>
+                      </a:solidFill>
+                      <a:prstDash val="solid"/>
+                      <a:round/>
+                      <a:headEnd type="none" w="med" len="med"/>
+                      <a:tailEnd type="none" w="med" len="med"/>
+                    </a:lnT>
+                    <a:lnB w="12700" cap="flat" cmpd="sng" algn="ctr">
+                      <a:solidFill>
+                        <a:srgbClr val="FFFFFF"/>
+                      </a:solidFill>
+                      <a:prstDash val="solid"/>
+                      <a:round/>
+                      <a:headEnd type="none" w="med" len="med"/>
+                      <a:tailEnd type="none" w="med" len="med"/>
+                    </a:lnB>
+                  </a:tcPr>
+                </a:tc>
+                <a:tc>
+                  <a:txBody>
+                    <a:bodyPr/>
+                    <a:lstStyle/>
+                    <a:p>
+                      <a:pPr algn="r" indent="0" marL="0">
+                        <a:buNone/>
+                      </a:pPr>
+                      <a:r>
+                        <a:rPr lang="en-US" sz="1250" dirty="0">
+                          <a:solidFill>
+                            <a:srgbClr val="000000"/>
+                          </a:solidFill>
+                          <a:latin typeface="Arial" pitchFamily="34" charset="0"/>
+                          <a:ea typeface="Arial" pitchFamily="34" charset="-122"/>
+                          <a:cs typeface="Arial" pitchFamily="34" charset="-120"/>
+                        </a:rPr>
+                        <a:t>2.400 €</a:t>
+                      </a:r>
+                      <a:endParaRPr lang="en-US" sz="1250" dirty="0">
+                        <a:latin typeface="Arial" charset="0"/>
+                        <a:ea typeface="Arial" charset="0"/>
+                        <a:cs typeface="Arial" charset="0"/>
+                      </a:endParaRPr>
+                    </a:p>
+                  </a:txBody>
+                  <a:tcPr marL="91440" marR="91440" marT="45720" marB="45720">
+                    <a:lnL w="12700" cap="flat" cmpd="sng" algn="ctr">
+                      <a:solidFill>
+                        <a:srgbClr val="FFFFFF"/>
+                      </a:solidFill>
+                      <a:prstDash val="solid"/>
+                      <a:round/>
+                      <a:headEnd type="none" w="med" len="med"/>
+                      <a:tailEnd type="none" w="med" len="med"/>
+                    </a:lnL>
+                    <a:lnR w="12700" cap="flat" cmpd="sng" algn="ctr">
+                      <a:solidFill>
+                        <a:srgbClr val="FFFFFF"/>
+                      </a:solidFill>
+                      <a:prstDash val="solid"/>
+                      <a:round/>
+                      <a:headEnd type="none" w="med" len="med"/>
+                      <a:tailEnd type="none" w="med" len="med"/>
+                    </a:lnR>
+                    <a:lnT w="12700" cap="flat" cmpd="sng" algn="ctr">
+                      <a:solidFill>
+                        <a:srgbClr val="FFFFFF"/>
+                      </a:solidFill>
+                      <a:prstDash val="solid"/>
+                      <a:round/>
+                      <a:headEnd type="none" w="med" len="med"/>
+                      <a:tailEnd type="none" w="med" len="med"/>
+                    </a:lnT>
+                    <a:lnB w="12700" cap="flat" cmpd="sng" algn="ctr">
+                      <a:solidFill>
+                        <a:srgbClr val="FFFFFF"/>
+                      </a:solidFill>
+                      <a:prstDash val="solid"/>
+                      <a:round/>
+                      <a:headEnd type="none" w="med" len="med"/>
+                      <a:tailEnd type="none" w="med" len="med"/>
+                    </a:lnB>
+                  </a:tcPr>
+                </a:tc>
+              </a:tr>
+              <a:tr h="502920">
+                <a:tc>
+                  <a:txBody>
+                    <a:bodyPr/>
+                    <a:lstStyle/>
+                    <a:p>
+                      <a:pPr indent="0" marL="0">
+                        <a:buNone/>
+                      </a:pPr>
+                      <a:r>
+                        <a:rPr lang="en-US" sz="1250" dirty="0">
+                          <a:solidFill>
+                            <a:srgbClr val="000000"/>
+                          </a:solidFill>
+                          <a:latin typeface="Arial" pitchFamily="34" charset="0"/>
+                          <a:ea typeface="Arial" pitchFamily="34" charset="-122"/>
+                          <a:cs typeface="Arial" pitchFamily="34" charset="-120"/>
+                        </a:rPr>
+                        <a:t>Spülen, Frühstücksservice</a:t>
+                      </a:r>
+                      <a:endParaRPr lang="en-US" sz="1250" dirty="0">
+                        <a:latin typeface="Arial" charset="0"/>
+                        <a:ea typeface="Arial" charset="0"/>
+                        <a:cs typeface="Arial" charset="0"/>
+                      </a:endParaRPr>
+                    </a:p>
+                  </a:txBody>
+                  <a:tcPr marL="91440" marR="91440" marT="45720" marB="45720">
+                    <a:lnL w="12700" cap="flat" cmpd="sng" algn="ctr">
+                      <a:solidFill>
+                        <a:srgbClr val="FFFFFF"/>
+                      </a:solidFill>
+                      <a:prstDash val="solid"/>
+                      <a:round/>
+                      <a:headEnd type="none" w="med" len="med"/>
+                      <a:tailEnd type="none" w="med" len="med"/>
+                    </a:lnL>
+                    <a:lnR w="12700" cap="flat" cmpd="sng" algn="ctr">
+                      <a:solidFill>
+                        <a:srgbClr val="FFFFFF"/>
+                      </a:solidFill>
+                      <a:prstDash val="solid"/>
+                      <a:round/>
+                      <a:headEnd type="none" w="med" len="med"/>
+                      <a:tailEnd type="none" w="med" len="med"/>
+                    </a:lnR>
+                    <a:lnT w="12700" cap="flat" cmpd="sng" algn="ctr">
+                      <a:solidFill>
+                        <a:srgbClr val="FFFFFF"/>
+                      </a:solidFill>
+                      <a:prstDash val="solid"/>
+                      <a:round/>
+                      <a:headEnd type="none" w="med" len="med"/>
+                      <a:tailEnd type="none" w="med" len="med"/>
+                    </a:lnT>
+                    <a:lnB w="12700" cap="flat" cmpd="sng" algn="ctr">
+                      <a:solidFill>
+                        <a:srgbClr val="FFFFFF"/>
+                      </a:solidFill>
+                      <a:prstDash val="solid"/>
+                      <a:round/>
+                      <a:headEnd type="none" w="med" len="med"/>
+                      <a:tailEnd type="none" w="med" len="med"/>
+                    </a:lnB>
+                  </a:tcPr>
+                </a:tc>
+                <a:tc>
+                  <a:txBody>
+                    <a:bodyPr/>
+                    <a:lstStyle/>
+                    <a:p>
+                      <a:pPr indent="0" marL="0">
+                        <a:buNone/>
+                      </a:pPr>
+                      <a:r>
+                        <a:rPr lang="en-US" sz="1250" dirty="0">
+                          <a:solidFill>
+                            <a:srgbClr val="000000"/>
+                          </a:solidFill>
+                          <a:latin typeface="Arial" pitchFamily="34" charset="0"/>
+                          <a:ea typeface="Arial" pitchFamily="34" charset="-122"/>
+                          <a:cs typeface="Arial" pitchFamily="34" charset="-120"/>
+                        </a:rPr>
+                        <a:t>1 Teilzeit</a:t>
+                      </a:r>
+                      <a:endParaRPr lang="en-US" sz="1250" dirty="0">
+                        <a:latin typeface="Arial" charset="0"/>
+                        <a:ea typeface="Arial" charset="0"/>
+                        <a:cs typeface="Arial" charset="0"/>
+                      </a:endParaRPr>
+                    </a:p>
+                  </a:txBody>
+                  <a:tcPr marL="91440" marR="91440" marT="45720" marB="45720">
+                    <a:lnL w="12700" cap="flat" cmpd="sng" algn="ctr">
+                      <a:solidFill>
+                        <a:srgbClr val="FFFFFF"/>
+                      </a:solidFill>
+                      <a:prstDash val="solid"/>
+                      <a:round/>
+                      <a:headEnd type="none" w="med" len="med"/>
+                      <a:tailEnd type="none" w="med" len="med"/>
+                    </a:lnL>
+                    <a:lnR w="12700" cap="flat" cmpd="sng" algn="ctr">
+                      <a:solidFill>
+                        <a:srgbClr val="FFFFFF"/>
+                      </a:solidFill>
+                      <a:prstDash val="solid"/>
+                      <a:round/>
+                      <a:headEnd type="none" w="med" len="med"/>
+                      <a:tailEnd type="none" w="med" len="med"/>
+                    </a:lnR>
+                    <a:lnT w="12700" cap="flat" cmpd="sng" algn="ctr">
+                      <a:solidFill>
+                        <a:srgbClr val="FFFFFF"/>
+                      </a:solidFill>
+                      <a:prstDash val="solid"/>
+                      <a:round/>
+                      <a:headEnd type="none" w="med" len="med"/>
+                      <a:tailEnd type="none" w="med" len="med"/>
+                    </a:lnT>
+                    <a:lnB w="12700" cap="flat" cmpd="sng" algn="ctr">
+                      <a:solidFill>
+                        <a:srgbClr val="FFFFFF"/>
+                      </a:solidFill>
+                      <a:prstDash val="solid"/>
+                      <a:round/>
+                      <a:headEnd type="none" w="med" len="med"/>
+                      <a:tailEnd type="none" w="med" len="med"/>
+                    </a:lnB>
+                  </a:tcPr>
+                </a:tc>
+                <a:tc>
+                  <a:txBody>
+                    <a:bodyPr/>
+                    <a:lstStyle/>
+                    <a:p>
+                      <a:pPr algn="r" indent="0" marL="0">
+                        <a:buNone/>
+                      </a:pPr>
+                      <a:r>
+                        <a:rPr lang="en-US" sz="1250" dirty="0">
+                          <a:solidFill>
+                            <a:srgbClr val="000000"/>
+                          </a:solidFill>
+                          <a:latin typeface="Arial" pitchFamily="34" charset="0"/>
+                          <a:ea typeface="Arial" pitchFamily="34" charset="-122"/>
+                          <a:cs typeface="Arial" pitchFamily="34" charset="-120"/>
+                        </a:rPr>
+                        <a:t>1.400 €</a:t>
+                      </a:r>
+                      <a:endParaRPr lang="en-US" sz="1250" dirty="0">
+                        <a:latin typeface="Arial" charset="0"/>
+                        <a:ea typeface="Arial" charset="0"/>
+                        <a:cs typeface="Arial" charset="0"/>
+                      </a:endParaRPr>
+                    </a:p>
+                  </a:txBody>
+                  <a:tcPr marL="91440" marR="91440" marT="45720" marB="45720">
+                    <a:lnL w="12700" cap="flat" cmpd="sng" algn="ctr">
+                      <a:solidFill>
+                        <a:srgbClr val="FFFFFF"/>
+                      </a:solidFill>
+                      <a:prstDash val="solid"/>
+                      <a:round/>
+                      <a:headEnd type="none" w="med" len="med"/>
+                      <a:tailEnd type="none" w="med" len="med"/>
+                    </a:lnL>
+                    <a:lnR w="12700" cap="flat" cmpd="sng" algn="ctr">
+                      <a:solidFill>
+                        <a:srgbClr val="FFFFFF"/>
+                      </a:solidFill>
+                      <a:prstDash val="solid"/>
+                      <a:round/>
+                      <a:headEnd type="none" w="med" len="med"/>
+                      <a:tailEnd type="none" w="med" len="med"/>
+                    </a:lnR>
+                    <a:lnT w="12700" cap="flat" cmpd="sng" algn="ctr">
+                      <a:solidFill>
+                        <a:srgbClr val="FFFFFF"/>
+                      </a:solidFill>
+                      <a:prstDash val="solid"/>
+                      <a:round/>
+                      <a:headEnd type="none" w="med" len="med"/>
+                      <a:tailEnd type="none" w="med" len="med"/>
+                    </a:lnT>
+                    <a:lnB w="12700" cap="flat" cmpd="sng" algn="ctr">
+                      <a:solidFill>
+                        <a:srgbClr val="FFFFFF"/>
+                      </a:solidFill>
+                      <a:prstDash val="solid"/>
+                      <a:round/>
+                      <a:headEnd type="none" w="med" len="med"/>
+                      <a:tailEnd type="none" w="med" len="med"/>
+                    </a:lnB>
+                  </a:tcPr>
+                </a:tc>
+              </a:tr>
+              <a:tr h="502920">
+                <a:tc>
+                  <a:txBody>
+                    <a:bodyPr/>
+                    <a:lstStyle/>
+                    <a:p>
+                      <a:pPr indent="0" marL="0">
+                        <a:buNone/>
+                      </a:pPr>
+                      <a:r>
+                        <a:rPr lang="en-US" sz="1250" dirty="0">
+                          <a:solidFill>
+                            <a:srgbClr val="000000"/>
+                          </a:solidFill>
+                          <a:latin typeface="Arial" pitchFamily="34" charset="0"/>
+                          <a:ea typeface="Arial" pitchFamily="34" charset="-122"/>
+                          <a:cs typeface="Arial" pitchFamily="34" charset="-120"/>
+                        </a:rPr>
+                        <a:t>Barchef</a:t>
                       </a:r>
                       <a:endParaRPr lang="en-US" sz="1250" dirty="0">
                         <a:latin typeface="Arial" charset="0"/>
@@ -6839,401 +7233,7 @@
                           <a:ea typeface="Arial" pitchFamily="34" charset="-122"/>
                           <a:cs typeface="Arial" pitchFamily="34" charset="-120"/>
                         </a:rPr>
-                        <a:t>3.400 €</a:t>
-                      </a:r>
-                      <a:endParaRPr lang="en-US" sz="1250" dirty="0">
-                        <a:latin typeface="Arial" charset="0"/>
-                        <a:ea typeface="Arial" charset="0"/>
-                        <a:cs typeface="Arial" charset="0"/>
-                      </a:endParaRPr>
-                    </a:p>
-                  </a:txBody>
-                  <a:tcPr marL="91440" marR="91440" marT="45720" marB="45720">
-                    <a:lnL w="12700" cap="flat" cmpd="sng" algn="ctr">
-                      <a:solidFill>
-                        <a:srgbClr val="FFFFFF"/>
-                      </a:solidFill>
-                      <a:prstDash val="solid"/>
-                      <a:round/>
-                      <a:headEnd type="none" w="med" len="med"/>
-                      <a:tailEnd type="none" w="med" len="med"/>
-                    </a:lnL>
-                    <a:lnR w="12700" cap="flat" cmpd="sng" algn="ctr">
-                      <a:solidFill>
-                        <a:srgbClr val="FFFFFF"/>
-                      </a:solidFill>
-                      <a:prstDash val="solid"/>
-                      <a:round/>
-                      <a:headEnd type="none" w="med" len="med"/>
-                      <a:tailEnd type="none" w="med" len="med"/>
-                    </a:lnR>
-                    <a:lnT w="12700" cap="flat" cmpd="sng" algn="ctr">
-                      <a:solidFill>
-                        <a:srgbClr val="FFFFFF"/>
-                      </a:solidFill>
-                      <a:prstDash val="solid"/>
-                      <a:round/>
-                      <a:headEnd type="none" w="med" len="med"/>
-                      <a:tailEnd type="none" w="med" len="med"/>
-                    </a:lnT>
-                    <a:lnB w="12700" cap="flat" cmpd="sng" algn="ctr">
-                      <a:solidFill>
-                        <a:srgbClr val="FFFFFF"/>
-                      </a:solidFill>
-                      <a:prstDash val="solid"/>
-                      <a:round/>
-                      <a:headEnd type="none" w="med" len="med"/>
-                      <a:tailEnd type="none" w="med" len="med"/>
-                    </a:lnB>
-                  </a:tcPr>
-                </a:tc>
-              </a:tr>
-              <a:tr h="502920">
-                <a:tc>
-                  <a:txBody>
-                    <a:bodyPr/>
-                    <a:lstStyle/>
-                    <a:p>
-                      <a:pPr indent="0" marL="0">
-                        <a:buNone/>
-                      </a:pPr>
-                      <a:r>
-                        <a:rPr lang="en-US" sz="1250" dirty="0">
-                          <a:solidFill>
-                            <a:srgbClr val="000000"/>
-                          </a:solidFill>
-                          <a:latin typeface="Arial" pitchFamily="34" charset="0"/>
-                          <a:ea typeface="Arial" pitchFamily="34" charset="-122"/>
-                          <a:cs typeface="Arial" pitchFamily="34" charset="-120"/>
-                        </a:rPr>
-                        <a:t>Koch</a:t>
-                      </a:r>
-                      <a:endParaRPr lang="en-US" sz="1250" dirty="0">
-                        <a:latin typeface="Arial" charset="0"/>
-                        <a:ea typeface="Arial" charset="0"/>
-                        <a:cs typeface="Arial" charset="0"/>
-                      </a:endParaRPr>
-                    </a:p>
-                  </a:txBody>
-                  <a:tcPr marL="91440" marR="91440" marT="45720" marB="45720">
-                    <a:lnL w="12700" cap="flat" cmpd="sng" algn="ctr">
-                      <a:solidFill>
-                        <a:srgbClr val="FFFFFF"/>
-                      </a:solidFill>
-                      <a:prstDash val="solid"/>
-                      <a:round/>
-                      <a:headEnd type="none" w="med" len="med"/>
-                      <a:tailEnd type="none" w="med" len="med"/>
-                    </a:lnL>
-                    <a:lnR w="12700" cap="flat" cmpd="sng" algn="ctr">
-                      <a:solidFill>
-                        <a:srgbClr val="FFFFFF"/>
-                      </a:solidFill>
-                      <a:prstDash val="solid"/>
-                      <a:round/>
-                      <a:headEnd type="none" w="med" len="med"/>
-                      <a:tailEnd type="none" w="med" len="med"/>
-                    </a:lnR>
-                    <a:lnT w="12700" cap="flat" cmpd="sng" algn="ctr">
-                      <a:solidFill>
-                        <a:srgbClr val="FFFFFF"/>
-                      </a:solidFill>
-                      <a:prstDash val="solid"/>
-                      <a:round/>
-                      <a:headEnd type="none" w="med" len="med"/>
-                      <a:tailEnd type="none" w="med" len="med"/>
-                    </a:lnT>
-                    <a:lnB w="12700" cap="flat" cmpd="sng" algn="ctr">
-                      <a:solidFill>
-                        <a:srgbClr val="FFFFFF"/>
-                      </a:solidFill>
-                      <a:prstDash val="solid"/>
-                      <a:round/>
-                      <a:headEnd type="none" w="med" len="med"/>
-                      <a:tailEnd type="none" w="med" len="med"/>
-                    </a:lnB>
-                  </a:tcPr>
-                </a:tc>
-                <a:tc>
-                  <a:txBody>
-                    <a:bodyPr/>
-                    <a:lstStyle/>
-                    <a:p>
-                      <a:pPr indent="0" marL="0">
-                        <a:buNone/>
-                      </a:pPr>
-                      <a:r>
-                        <a:rPr lang="en-US" sz="1250" dirty="0">
-                          <a:solidFill>
-                            <a:srgbClr val="000000"/>
-                          </a:solidFill>
-                          <a:latin typeface="Arial" pitchFamily="34" charset="0"/>
-                          <a:ea typeface="Arial" pitchFamily="34" charset="-122"/>
-                          <a:cs typeface="Arial" pitchFamily="34" charset="-120"/>
-                        </a:rPr>
-                        <a:t>1 Teilzeit</a:t>
-                      </a:r>
-                      <a:endParaRPr lang="en-US" sz="1250" dirty="0">
-                        <a:latin typeface="Arial" charset="0"/>
-                        <a:ea typeface="Arial" charset="0"/>
-                        <a:cs typeface="Arial" charset="0"/>
-                      </a:endParaRPr>
-                    </a:p>
-                  </a:txBody>
-                  <a:tcPr marL="91440" marR="91440" marT="45720" marB="45720">
-                    <a:lnL w="12700" cap="flat" cmpd="sng" algn="ctr">
-                      <a:solidFill>
-                        <a:srgbClr val="FFFFFF"/>
-                      </a:solidFill>
-                      <a:prstDash val="solid"/>
-                      <a:round/>
-                      <a:headEnd type="none" w="med" len="med"/>
-                      <a:tailEnd type="none" w="med" len="med"/>
-                    </a:lnL>
-                    <a:lnR w="12700" cap="flat" cmpd="sng" algn="ctr">
-                      <a:solidFill>
-                        <a:srgbClr val="FFFFFF"/>
-                      </a:solidFill>
-                      <a:prstDash val="solid"/>
-                      <a:round/>
-                      <a:headEnd type="none" w="med" len="med"/>
-                      <a:tailEnd type="none" w="med" len="med"/>
-                    </a:lnR>
-                    <a:lnT w="12700" cap="flat" cmpd="sng" algn="ctr">
-                      <a:solidFill>
-                        <a:srgbClr val="FFFFFF"/>
-                      </a:solidFill>
-                      <a:prstDash val="solid"/>
-                      <a:round/>
-                      <a:headEnd type="none" w="med" len="med"/>
-                      <a:tailEnd type="none" w="med" len="med"/>
-                    </a:lnT>
-                    <a:lnB w="12700" cap="flat" cmpd="sng" algn="ctr">
-                      <a:solidFill>
-                        <a:srgbClr val="FFFFFF"/>
-                      </a:solidFill>
-                      <a:prstDash val="solid"/>
-                      <a:round/>
-                      <a:headEnd type="none" w="med" len="med"/>
-                      <a:tailEnd type="none" w="med" len="med"/>
-                    </a:lnB>
-                  </a:tcPr>
-                </a:tc>
-                <a:tc>
-                  <a:txBody>
-                    <a:bodyPr/>
-                    <a:lstStyle/>
-                    <a:p>
-                      <a:pPr algn="r" indent="0" marL="0">
-                        <a:buNone/>
-                      </a:pPr>
-                      <a:r>
-                        <a:rPr lang="en-US" sz="1250" dirty="0">
-                          <a:solidFill>
-                            <a:srgbClr val="000000"/>
-                          </a:solidFill>
-                          <a:latin typeface="Arial" pitchFamily="34" charset="0"/>
-                          <a:ea typeface="Arial" pitchFamily="34" charset="-122"/>
-                          <a:cs typeface="Arial" pitchFamily="34" charset="-120"/>
-                        </a:rPr>
-                        <a:t>2.400 €</a:t>
-                      </a:r>
-                      <a:endParaRPr lang="en-US" sz="1250" dirty="0">
-                        <a:latin typeface="Arial" charset="0"/>
-                        <a:ea typeface="Arial" charset="0"/>
-                        <a:cs typeface="Arial" charset="0"/>
-                      </a:endParaRPr>
-                    </a:p>
-                  </a:txBody>
-                  <a:tcPr marL="91440" marR="91440" marT="45720" marB="45720">
-                    <a:lnL w="12700" cap="flat" cmpd="sng" algn="ctr">
-                      <a:solidFill>
-                        <a:srgbClr val="FFFFFF"/>
-                      </a:solidFill>
-                      <a:prstDash val="solid"/>
-                      <a:round/>
-                      <a:headEnd type="none" w="med" len="med"/>
-                      <a:tailEnd type="none" w="med" len="med"/>
-                    </a:lnL>
-                    <a:lnR w="12700" cap="flat" cmpd="sng" algn="ctr">
-                      <a:solidFill>
-                        <a:srgbClr val="FFFFFF"/>
-                      </a:solidFill>
-                      <a:prstDash val="solid"/>
-                      <a:round/>
-                      <a:headEnd type="none" w="med" len="med"/>
-                      <a:tailEnd type="none" w="med" len="med"/>
-                    </a:lnR>
-                    <a:lnT w="12700" cap="flat" cmpd="sng" algn="ctr">
-                      <a:solidFill>
-                        <a:srgbClr val="FFFFFF"/>
-                      </a:solidFill>
-                      <a:prstDash val="solid"/>
-                      <a:round/>
-                      <a:headEnd type="none" w="med" len="med"/>
-                      <a:tailEnd type="none" w="med" len="med"/>
-                    </a:lnT>
-                    <a:lnB w="12700" cap="flat" cmpd="sng" algn="ctr">
-                      <a:solidFill>
-                        <a:srgbClr val="FFFFFF"/>
-                      </a:solidFill>
-                      <a:prstDash val="solid"/>
-                      <a:round/>
-                      <a:headEnd type="none" w="med" len="med"/>
-                      <a:tailEnd type="none" w="med" len="med"/>
-                    </a:lnB>
-                  </a:tcPr>
-                </a:tc>
-              </a:tr>
-              <a:tr h="502920">
-                <a:tc>
-                  <a:txBody>
-                    <a:bodyPr/>
-                    <a:lstStyle/>
-                    <a:p>
-                      <a:pPr indent="0" marL="0">
-                        <a:buNone/>
-                      </a:pPr>
-                      <a:r>
-                        <a:rPr lang="en-US" sz="1250" dirty="0">
-                          <a:solidFill>
-                            <a:srgbClr val="000000"/>
-                          </a:solidFill>
-                          <a:latin typeface="Arial" pitchFamily="34" charset="0"/>
-                          <a:ea typeface="Arial" pitchFamily="34" charset="-122"/>
-                          <a:cs typeface="Arial" pitchFamily="34" charset="-120"/>
-                        </a:rPr>
-                        <a:t>Küchenhilfe, Spülen</a:t>
-                      </a:r>
-                      <a:endParaRPr lang="en-US" sz="1250" dirty="0">
-                        <a:latin typeface="Arial" charset="0"/>
-                        <a:ea typeface="Arial" charset="0"/>
-                        <a:cs typeface="Arial" charset="0"/>
-                      </a:endParaRPr>
-                    </a:p>
-                  </a:txBody>
-                  <a:tcPr marL="91440" marR="91440" marT="45720" marB="45720">
-                    <a:lnL w="12700" cap="flat" cmpd="sng" algn="ctr">
-                      <a:solidFill>
-                        <a:srgbClr val="FFFFFF"/>
-                      </a:solidFill>
-                      <a:prstDash val="solid"/>
-                      <a:round/>
-                      <a:headEnd type="none" w="med" len="med"/>
-                      <a:tailEnd type="none" w="med" len="med"/>
-                    </a:lnL>
-                    <a:lnR w="12700" cap="flat" cmpd="sng" algn="ctr">
-                      <a:solidFill>
-                        <a:srgbClr val="FFFFFF"/>
-                      </a:solidFill>
-                      <a:prstDash val="solid"/>
-                      <a:round/>
-                      <a:headEnd type="none" w="med" len="med"/>
-                      <a:tailEnd type="none" w="med" len="med"/>
-                    </a:lnR>
-                    <a:lnT w="12700" cap="flat" cmpd="sng" algn="ctr">
-                      <a:solidFill>
-                        <a:srgbClr val="FFFFFF"/>
-                      </a:solidFill>
-                      <a:prstDash val="solid"/>
-                      <a:round/>
-                      <a:headEnd type="none" w="med" len="med"/>
-                      <a:tailEnd type="none" w="med" len="med"/>
-                    </a:lnT>
-                    <a:lnB w="12700" cap="flat" cmpd="sng" algn="ctr">
-                      <a:solidFill>
-                        <a:srgbClr val="FFFFFF"/>
-                      </a:solidFill>
-                      <a:prstDash val="solid"/>
-                      <a:round/>
-                      <a:headEnd type="none" w="med" len="med"/>
-                      <a:tailEnd type="none" w="med" len="med"/>
-                    </a:lnB>
-                  </a:tcPr>
-                </a:tc>
-                <a:tc>
-                  <a:txBody>
-                    <a:bodyPr/>
-                    <a:lstStyle/>
-                    <a:p>
-                      <a:pPr indent="0" marL="0">
-                        <a:buNone/>
-                      </a:pPr>
-                      <a:r>
-                        <a:rPr lang="en-US" sz="1250" dirty="0">
-                          <a:solidFill>
-                            <a:srgbClr val="000000"/>
-                          </a:solidFill>
-                          <a:latin typeface="Arial" pitchFamily="34" charset="0"/>
-                          <a:ea typeface="Arial" pitchFamily="34" charset="-122"/>
-                          <a:cs typeface="Arial" pitchFamily="34" charset="-120"/>
-                        </a:rPr>
-                        <a:t>2 Teilzeit</a:t>
-                      </a:r>
-                      <a:endParaRPr lang="en-US" sz="1250" dirty="0">
-                        <a:latin typeface="Arial" charset="0"/>
-                        <a:ea typeface="Arial" charset="0"/>
-                        <a:cs typeface="Arial" charset="0"/>
-                      </a:endParaRPr>
-                    </a:p>
-                  </a:txBody>
-                  <a:tcPr marL="91440" marR="91440" marT="45720" marB="45720">
-                    <a:lnL w="12700" cap="flat" cmpd="sng" algn="ctr">
-                      <a:solidFill>
-                        <a:srgbClr val="FFFFFF"/>
-                      </a:solidFill>
-                      <a:prstDash val="solid"/>
-                      <a:round/>
-                      <a:headEnd type="none" w="med" len="med"/>
-                      <a:tailEnd type="none" w="med" len="med"/>
-                    </a:lnL>
-                    <a:lnR w="12700" cap="flat" cmpd="sng" algn="ctr">
-                      <a:solidFill>
-                        <a:srgbClr val="FFFFFF"/>
-                      </a:solidFill>
-                      <a:prstDash val="solid"/>
-                      <a:round/>
-                      <a:headEnd type="none" w="med" len="med"/>
-                      <a:tailEnd type="none" w="med" len="med"/>
-                    </a:lnR>
-                    <a:lnT w="12700" cap="flat" cmpd="sng" algn="ctr">
-                      <a:solidFill>
-                        <a:srgbClr val="FFFFFF"/>
-                      </a:solidFill>
-                      <a:prstDash val="solid"/>
-                      <a:round/>
-                      <a:headEnd type="none" w="med" len="med"/>
-                      <a:tailEnd type="none" w="med" len="med"/>
-                    </a:lnT>
-                    <a:lnB w="12700" cap="flat" cmpd="sng" algn="ctr">
-                      <a:solidFill>
-                        <a:srgbClr val="FFFFFF"/>
-                      </a:solidFill>
-                      <a:prstDash val="solid"/>
-                      <a:round/>
-                      <a:headEnd type="none" w="med" len="med"/>
-                      <a:tailEnd type="none" w="med" len="med"/>
-                    </a:lnB>
-                  </a:tcPr>
-                </a:tc>
-                <a:tc>
-                  <a:txBody>
-                    <a:bodyPr/>
-                    <a:lstStyle/>
-                    <a:p>
-                      <a:pPr algn="r" indent="0" marL="0">
-                        <a:buNone/>
-                      </a:pPr>
-                      <a:r>
-                        <a:rPr lang="en-US" sz="1250" dirty="0">
-                          <a:solidFill>
-                            <a:srgbClr val="000000"/>
-                          </a:solidFill>
-                          <a:latin typeface="Arial" pitchFamily="34" charset="0"/>
-                          <a:ea typeface="Arial" pitchFamily="34" charset="-122"/>
-                          <a:cs typeface="Arial" pitchFamily="34" charset="-120"/>
-                        </a:rPr>
-                        <a:t>2.800 €</a:t>
+                        <a:t>3.200 €</a:t>
                       </a:r>
                       <a:endParaRPr lang="en-US" sz="1250" dirty="0">
                         <a:latin typeface="Arial" charset="0"/>
@@ -7365,7 +7365,7 @@
                           <a:ea typeface="Arial" pitchFamily="34" charset="-122"/>
                           <a:cs typeface="Arial" pitchFamily="34" charset="-120"/>
                         </a:rPr>
-                        <a:t>ca. 7 Teilzeit und Minijobs</a:t>
+                        <a:t>ca. 8 Teilzeit und Minijobs</a:t>
                       </a:r>
                       <a:endParaRPr lang="en-US" sz="1250" dirty="0">
                         <a:latin typeface="Arial" charset="0"/>
@@ -7430,7 +7430,7 @@
                           <a:ea typeface="Arial" pitchFamily="34" charset="-122"/>
                           <a:cs typeface="Arial" pitchFamily="34" charset="-120"/>
                         </a:rPr>
-                        <a:t>6.700 €</a:t>
+                        <a:t>7.600 €</a:t>
                       </a:r>
                       <a:endParaRPr lang="en-US" sz="1250" dirty="0">
                         <a:latin typeface="Arial" charset="0"/>
@@ -7562,7 +7562,7 @@
                           <a:ea typeface="Arial" pitchFamily="34" charset="-122"/>
                           <a:cs typeface="Arial" pitchFamily="34" charset="-120"/>
                         </a:rPr>
-                        <a:t>entspricht 20 % vom Umsatz</a:t>
+                        <a:t>entspricht 28 % vom Umsatz</a:t>
                       </a:r>
                       <a:endParaRPr lang="en-US" sz="1250" dirty="0">
                         <a:latin typeface="Arial" charset="0"/>
@@ -7627,7 +7627,7 @@
                           <a:ea typeface="Arial" pitchFamily="34" charset="-122"/>
                           <a:cs typeface="Arial" pitchFamily="34" charset="-120"/>
                         </a:rPr>
-                        <a:t>19.500 €</a:t>
+                        <a:t>18.000 €</a:t>
                       </a:r>
                       <a:endParaRPr lang="en-US" sz="1250" dirty="0">
                         <a:latin typeface="Arial" charset="0"/>
@@ -7757,7 +7757,7 @@
                 <a:ea typeface="Arial" pitchFamily="34" charset="-122"/>
                 <a:cs typeface="Arial" pitchFamily="34" charset="-120"/>
               </a:rPr>
-              <a:t>Du führst die Gastro selbst oder verpachtest sie. Bei Verpachtung zahlt der Betreiber ca. 10 €/m² Pacht, das sind bei 510 m² ca. 5.100 € im Monat (ca. 5.3 % vom Umsatz).</a:t>
+              <a:t>Du führst die Gastro selbst oder verpachtest sie. Bei Verpachtung zahlt der Betreiber ca. 10 €/m² Pacht, das sind bei 510 m² ca. 5.100 € im Monat (ca. 7.8 % vom Umsatz).</a:t>
             </a:r>
             <a:endParaRPr lang="en-US" sz="1300" dirty="0"/>
           </a:p>
@@ -7808,7 +7808,7 @@
                 <a:ea typeface="Arial" pitchFamily="34" charset="-122"/>
                 <a:cs typeface="Arial" pitchFamily="34" charset="-120"/>
               </a:rPr>
-              <a:t>Küchenchef früh einstellen, 4 bis 6 Wochen vor Eröffnung Probebetrieb.</a:t>
+              <a:t>Barchef und Küchenleitung früh einstellen, 4 bis 6 Wochen vor Eröffnung Probebetrieb.</a:t>
             </a:r>
             <a:endParaRPr lang="en-US" sz="1300" dirty="0"/>
           </a:p>
@@ -8281,6 +8281,271 @@
                           <a:ea typeface="Arial" pitchFamily="34" charset="-122"/>
                           <a:cs typeface="Arial" pitchFamily="34" charset="-120"/>
                         </a:rPr>
+                        <a:t>40.000 €</a:t>
+                      </a:r>
+                      <a:endParaRPr lang="en-US" sz="1250" dirty="0">
+                        <a:latin typeface="Arial" charset="0"/>
+                        <a:ea typeface="Arial" charset="0"/>
+                        <a:cs typeface="Arial" charset="0"/>
+                      </a:endParaRPr>
+                    </a:p>
+                  </a:txBody>
+                  <a:tcPr marL="91440" marR="91440" marT="45720" marB="45720">
+                    <a:lnL w="12700" cap="flat" cmpd="sng" algn="ctr">
+                      <a:solidFill>
+                        <a:srgbClr val="FFFFFF"/>
+                      </a:solidFill>
+                      <a:prstDash val="solid"/>
+                      <a:round/>
+                      <a:headEnd type="none" w="med" len="med"/>
+                      <a:tailEnd type="none" w="med" len="med"/>
+                    </a:lnL>
+                    <a:lnR w="12700" cap="flat" cmpd="sng" algn="ctr">
+                      <a:solidFill>
+                        <a:srgbClr val="FFFFFF"/>
+                      </a:solidFill>
+                      <a:prstDash val="solid"/>
+                      <a:round/>
+                      <a:headEnd type="none" w="med" len="med"/>
+                      <a:tailEnd type="none" w="med" len="med"/>
+                    </a:lnR>
+                    <a:lnT w="12700" cap="flat" cmpd="sng" algn="ctr">
+                      <a:solidFill>
+                        <a:srgbClr val="FFFFFF"/>
+                      </a:solidFill>
+                      <a:prstDash val="solid"/>
+                      <a:round/>
+                      <a:headEnd type="none" w="med" len="med"/>
+                      <a:tailEnd type="none" w="med" len="med"/>
+                    </a:lnT>
+                    <a:lnB w="12700" cap="flat" cmpd="sng" algn="ctr">
+                      <a:solidFill>
+                        <a:srgbClr val="FFFFFF"/>
+                      </a:solidFill>
+                      <a:prstDash val="solid"/>
+                      <a:round/>
+                      <a:headEnd type="none" w="med" len="med"/>
+                      <a:tailEnd type="none" w="med" len="med"/>
+                    </a:lnB>
+                  </a:tcPr>
+                </a:tc>
+                <a:tc>
+                  <a:txBody>
+                    <a:bodyPr/>
+                    <a:lstStyle/>
+                    <a:p>
+                      <a:pPr algn="r" indent="0" marL="0">
+                        <a:buNone/>
+                      </a:pPr>
+                      <a:r>
+                        <a:rPr lang="en-US" sz="1250" dirty="0">
+                          <a:solidFill>
+                            <a:srgbClr val="000000"/>
+                          </a:solidFill>
+                          <a:latin typeface="Arial" pitchFamily="34" charset="0"/>
+                          <a:ea typeface="Arial" pitchFamily="34" charset="-122"/>
+                          <a:cs typeface="Arial" pitchFamily="34" charset="-120"/>
+                        </a:rPr>
+                        <a:t>12.200 €</a:t>
+                      </a:r>
+                      <a:endParaRPr lang="en-US" sz="1250" dirty="0">
+                        <a:latin typeface="Arial" charset="0"/>
+                        <a:ea typeface="Arial" charset="0"/>
+                        <a:cs typeface="Arial" charset="0"/>
+                      </a:endParaRPr>
+                    </a:p>
+                  </a:txBody>
+                  <a:tcPr marL="91440" marR="91440" marT="45720" marB="45720">
+                    <a:lnL w="12700" cap="flat" cmpd="sng" algn="ctr">
+                      <a:solidFill>
+                        <a:srgbClr val="FFFFFF"/>
+                      </a:solidFill>
+                      <a:prstDash val="solid"/>
+                      <a:round/>
+                      <a:headEnd type="none" w="med" len="med"/>
+                      <a:tailEnd type="none" w="med" len="med"/>
+                    </a:lnL>
+                    <a:lnR w="12700" cap="flat" cmpd="sng" algn="ctr">
+                      <a:solidFill>
+                        <a:srgbClr val="FFFFFF"/>
+                      </a:solidFill>
+                      <a:prstDash val="solid"/>
+                      <a:round/>
+                      <a:headEnd type="none" w="med" len="med"/>
+                      <a:tailEnd type="none" w="med" len="med"/>
+                    </a:lnR>
+                    <a:lnT w="12700" cap="flat" cmpd="sng" algn="ctr">
+                      <a:solidFill>
+                        <a:srgbClr val="FFFFFF"/>
+                      </a:solidFill>
+                      <a:prstDash val="solid"/>
+                      <a:round/>
+                      <a:headEnd type="none" w="med" len="med"/>
+                      <a:tailEnd type="none" w="med" len="med"/>
+                    </a:lnT>
+                    <a:lnB w="12700" cap="flat" cmpd="sng" algn="ctr">
+                      <a:solidFill>
+                        <a:srgbClr val="FFFFFF"/>
+                      </a:solidFill>
+                      <a:prstDash val="solid"/>
+                      <a:round/>
+                      <a:headEnd type="none" w="med" len="med"/>
+                      <a:tailEnd type="none" w="med" len="med"/>
+                    </a:lnB>
+                  </a:tcPr>
+                </a:tc>
+                <a:tc>
+                  <a:txBody>
+                    <a:bodyPr/>
+                    <a:lstStyle/>
+                    <a:p>
+                      <a:pPr algn="r" indent="0" marL="0">
+                        <a:buNone/>
+                      </a:pPr>
+                      <a:r>
+                        <a:rPr lang="en-US" sz="1250" dirty="0">
+                          <a:solidFill>
+                            <a:srgbClr val="000000"/>
+                          </a:solidFill>
+                          <a:latin typeface="Arial" pitchFamily="34" charset="0"/>
+                          <a:ea typeface="Arial" pitchFamily="34" charset="-122"/>
+                          <a:cs typeface="Arial" pitchFamily="34" charset="-120"/>
+                        </a:rPr>
+                        <a:t>−5.100 €</a:t>
+                      </a:r>
+                      <a:endParaRPr lang="en-US" sz="1250" dirty="0">
+                        <a:latin typeface="Arial" charset="0"/>
+                        <a:ea typeface="Arial" charset="0"/>
+                        <a:cs typeface="Arial" charset="0"/>
+                      </a:endParaRPr>
+                    </a:p>
+                  </a:txBody>
+                  <a:tcPr marL="91440" marR="91440" marT="45720" marB="45720">
+                    <a:lnL w="12700" cap="flat" cmpd="sng" algn="ctr">
+                      <a:solidFill>
+                        <a:srgbClr val="FFFFFF"/>
+                      </a:solidFill>
+                      <a:prstDash val="solid"/>
+                      <a:round/>
+                      <a:headEnd type="none" w="med" len="med"/>
+                      <a:tailEnd type="none" w="med" len="med"/>
+                    </a:lnL>
+                    <a:lnR w="12700" cap="flat" cmpd="sng" algn="ctr">
+                      <a:solidFill>
+                        <a:srgbClr val="FFFFFF"/>
+                      </a:solidFill>
+                      <a:prstDash val="solid"/>
+                      <a:round/>
+                      <a:headEnd type="none" w="med" len="med"/>
+                      <a:tailEnd type="none" w="med" len="med"/>
+                    </a:lnR>
+                    <a:lnT w="12700" cap="flat" cmpd="sng" algn="ctr">
+                      <a:solidFill>
+                        <a:srgbClr val="FFFFFF"/>
+                      </a:solidFill>
+                      <a:prstDash val="solid"/>
+                      <a:round/>
+                      <a:headEnd type="none" w="med" len="med"/>
+                      <a:tailEnd type="none" w="med" len="med"/>
+                    </a:lnT>
+                    <a:lnB w="12700" cap="flat" cmpd="sng" algn="ctr">
+                      <a:solidFill>
+                        <a:srgbClr val="FFFFFF"/>
+                      </a:solidFill>
+                      <a:prstDash val="solid"/>
+                      <a:round/>
+                      <a:headEnd type="none" w="med" len="med"/>
+                      <a:tailEnd type="none" w="med" len="med"/>
+                    </a:lnB>
+                  </a:tcPr>
+                </a:tc>
+                <a:tc>
+                  <a:txBody>
+                    <a:bodyPr/>
+                    <a:lstStyle/>
+                    <a:p>
+                      <a:pPr algn="r" indent="0" marL="0">
+                        <a:buNone/>
+                      </a:pPr>
+                      <a:r>
+                        <a:rPr lang="en-US" sz="1250" b="1" dirty="0">
+                          <a:solidFill>
+                            <a:schemeClr val="accent5"/>
+                          </a:solidFill>
+                          <a:latin typeface="Arial" pitchFamily="34" charset="0"/>
+                          <a:ea typeface="Arial" pitchFamily="34" charset="-122"/>
+                          <a:cs typeface="Arial" pitchFamily="34" charset="-120"/>
+                        </a:rPr>
+                        <a:t>+7.100 €</a:t>
+                      </a:r>
+                      <a:endParaRPr lang="en-US" sz="1250" dirty="0">
+                        <a:latin typeface="Arial" charset="0"/>
+                        <a:ea typeface="Arial" charset="0"/>
+                        <a:cs typeface="Arial" charset="0"/>
+                      </a:endParaRPr>
+                    </a:p>
+                  </a:txBody>
+                  <a:tcPr marL="91440" marR="91440" marT="45720" marB="45720">
+                    <a:lnL w="12700" cap="flat" cmpd="sng" algn="ctr">
+                      <a:solidFill>
+                        <a:srgbClr val="FFFFFF"/>
+                      </a:solidFill>
+                      <a:prstDash val="solid"/>
+                      <a:round/>
+                      <a:headEnd type="none" w="med" len="med"/>
+                      <a:tailEnd type="none" w="med" len="med"/>
+                    </a:lnL>
+                    <a:lnR w="12700" cap="flat" cmpd="sng" algn="ctr">
+                      <a:solidFill>
+                        <a:srgbClr val="FFFFFF"/>
+                      </a:solidFill>
+                      <a:prstDash val="solid"/>
+                      <a:round/>
+                      <a:headEnd type="none" w="med" len="med"/>
+                      <a:tailEnd type="none" w="med" len="med"/>
+                    </a:lnR>
+                    <a:lnT w="12700" cap="flat" cmpd="sng" algn="ctr">
+                      <a:solidFill>
+                        <a:srgbClr val="FFFFFF"/>
+                      </a:solidFill>
+                      <a:prstDash val="solid"/>
+                      <a:round/>
+                      <a:headEnd type="none" w="med" len="med"/>
+                      <a:tailEnd type="none" w="med" len="med"/>
+                    </a:lnT>
+                    <a:lnB w="12700" cap="flat" cmpd="sng" algn="ctr">
+                      <a:solidFill>
+                        <a:srgbClr val="FFFFFF"/>
+                      </a:solidFill>
+                      <a:prstDash val="solid"/>
+                      <a:round/>
+                      <a:headEnd type="none" w="med" len="med"/>
+                      <a:tailEnd type="none" w="med" len="med"/>
+                    </a:lnB>
+                    <a:solidFill>
+                      <a:srgbClr val="E3F1EA"/>
+                    </a:solidFill>
+                  </a:tcPr>
+                </a:tc>
+              </a:tr>
+              <a:tr h="502920">
+                <a:tc>
+                  <a:txBody>
+                    <a:bodyPr/>
+                    <a:lstStyle/>
+                    <a:p>
+                      <a:pPr indent="0" marL="0">
+                        <a:buNone/>
+                      </a:pPr>
+                      <a:r>
+                        <a:rPr lang="en-US" sz="1250" dirty="0">
+                          <a:solidFill>
+                            <a:srgbClr val="000000"/>
+                          </a:solidFill>
+                          <a:latin typeface="Arial" pitchFamily="34" charset="0"/>
+                          <a:ea typeface="Arial" pitchFamily="34" charset="-122"/>
+                          <a:cs typeface="Arial" pitchFamily="34" charset="-120"/>
+                        </a:rPr>
                         <a:t>50.000 €</a:t>
                       </a:r>
                       <a:endParaRPr lang="en-US" sz="1250" dirty="0">
@@ -8538,7 +8803,7 @@
                         <a:buNone/>
                       </a:pPr>
                       <a:r>
-                        <a:rPr lang="en-US" sz="1250" dirty="0">
+                        <a:rPr lang="en-US" sz="1250" b="1" dirty="0">
                           <a:solidFill>
                             <a:srgbClr val="000000"/>
                           </a:solidFill>
@@ -8546,7 +8811,7 @@
                           <a:ea typeface="Arial" pitchFamily="34" charset="-122"/>
                           <a:cs typeface="Arial" pitchFamily="34" charset="-120"/>
                         </a:rPr>
-                        <a:t>65.000 €</a:t>
+                        <a:t>65.010 €</a:t>
                       </a:r>
                       <a:endParaRPr lang="en-US" sz="1250" dirty="0">
                         <a:latin typeface="Arial" charset="0"/>
@@ -8611,7 +8876,7 @@
                           <a:ea typeface="Arial" pitchFamily="34" charset="-122"/>
                           <a:cs typeface="Arial" pitchFamily="34" charset="-120"/>
                         </a:rPr>
-                        <a:t>19.825 €</a:t>
+                        <a:t>19.828 €</a:t>
                       </a:r>
                       <a:endParaRPr lang="en-US" sz="1250" dirty="0">
                         <a:latin typeface="Arial" charset="0"/>
@@ -8741,7 +9006,7 @@
                           <a:ea typeface="Arial" pitchFamily="34" charset="-122"/>
                           <a:cs typeface="Arial" pitchFamily="34" charset="-120"/>
                         </a:rPr>
-                        <a:t>+14.725 €</a:t>
+                        <a:t>+14.728 €</a:t>
                       </a:r>
                       <a:endParaRPr lang="en-US" sz="1250" dirty="0">
                         <a:latin typeface="Arial" charset="0"/>
@@ -9068,7 +9333,7 @@
                         <a:buNone/>
                       </a:pPr>
                       <a:r>
-                        <a:rPr lang="en-US" sz="1250" b="1" dirty="0">
+                        <a:rPr lang="en-US" sz="1250" dirty="0">
                           <a:solidFill>
                             <a:srgbClr val="000000"/>
                           </a:solidFill>
@@ -9076,7 +9341,7 @@
                           <a:ea typeface="Arial" pitchFamily="34" charset="-122"/>
                           <a:cs typeface="Arial" pitchFamily="34" charset="-120"/>
                         </a:rPr>
-                        <a:t>95.635 €</a:t>
+                        <a:t>95.000 €</a:t>
                       </a:r>
                       <a:endParaRPr lang="en-US" sz="1250" dirty="0">
                         <a:latin typeface="Arial" charset="0"/>
@@ -9141,7 +9406,7 @@
                           <a:ea typeface="Arial" pitchFamily="34" charset="-122"/>
                           <a:cs typeface="Arial" pitchFamily="34" charset="-120"/>
                         </a:rPr>
-                        <a:t>29.169 €</a:t>
+                        <a:t>28.975 €</a:t>
                       </a:r>
                       <a:endParaRPr lang="en-US" sz="1250" dirty="0">
                         <a:latin typeface="Arial" charset="0"/>
@@ -9271,272 +9536,7 @@
                           <a:ea typeface="Arial" pitchFamily="34" charset="-122"/>
                           <a:cs typeface="Arial" pitchFamily="34" charset="-120"/>
                         </a:rPr>
-                        <a:t>+24.069 €</a:t>
-                      </a:r>
-                      <a:endParaRPr lang="en-US" sz="1250" dirty="0">
-                        <a:latin typeface="Arial" charset="0"/>
-                        <a:ea typeface="Arial" charset="0"/>
-                        <a:cs typeface="Arial" charset="0"/>
-                      </a:endParaRPr>
-                    </a:p>
-                  </a:txBody>
-                  <a:tcPr marL="91440" marR="91440" marT="45720" marB="45720">
-                    <a:lnL w="12700" cap="flat" cmpd="sng" algn="ctr">
-                      <a:solidFill>
-                        <a:srgbClr val="FFFFFF"/>
-                      </a:solidFill>
-                      <a:prstDash val="solid"/>
-                      <a:round/>
-                      <a:headEnd type="none" w="med" len="med"/>
-                      <a:tailEnd type="none" w="med" len="med"/>
-                    </a:lnL>
-                    <a:lnR w="12700" cap="flat" cmpd="sng" algn="ctr">
-                      <a:solidFill>
-                        <a:srgbClr val="FFFFFF"/>
-                      </a:solidFill>
-                      <a:prstDash val="solid"/>
-                      <a:round/>
-                      <a:headEnd type="none" w="med" len="med"/>
-                      <a:tailEnd type="none" w="med" len="med"/>
-                    </a:lnR>
-                    <a:lnT w="12700" cap="flat" cmpd="sng" algn="ctr">
-                      <a:solidFill>
-                        <a:srgbClr val="FFFFFF"/>
-                      </a:solidFill>
-                      <a:prstDash val="solid"/>
-                      <a:round/>
-                      <a:headEnd type="none" w="med" len="med"/>
-                      <a:tailEnd type="none" w="med" len="med"/>
-                    </a:lnT>
-                    <a:lnB w="12700" cap="flat" cmpd="sng" algn="ctr">
-                      <a:solidFill>
-                        <a:srgbClr val="FFFFFF"/>
-                      </a:solidFill>
-                      <a:prstDash val="solid"/>
-                      <a:round/>
-                      <a:headEnd type="none" w="med" len="med"/>
-                      <a:tailEnd type="none" w="med" len="med"/>
-                    </a:lnB>
-                    <a:solidFill>
-                      <a:srgbClr val="E3F1EA"/>
-                    </a:solidFill>
-                  </a:tcPr>
-                </a:tc>
-              </a:tr>
-              <a:tr h="502920">
-                <a:tc>
-                  <a:txBody>
-                    <a:bodyPr/>
-                    <a:lstStyle/>
-                    <a:p>
-                      <a:pPr indent="0" marL="0">
-                        <a:buNone/>
-                      </a:pPr>
-                      <a:r>
-                        <a:rPr lang="en-US" sz="1250" dirty="0">
-                          <a:solidFill>
-                            <a:srgbClr val="000000"/>
-                          </a:solidFill>
-                          <a:latin typeface="Arial" pitchFamily="34" charset="0"/>
-                          <a:ea typeface="Arial" pitchFamily="34" charset="-122"/>
-                          <a:cs typeface="Arial" pitchFamily="34" charset="-120"/>
-                        </a:rPr>
-                        <a:t>110.000 €</a:t>
-                      </a:r>
-                      <a:endParaRPr lang="en-US" sz="1250" dirty="0">
-                        <a:latin typeface="Arial" charset="0"/>
-                        <a:ea typeface="Arial" charset="0"/>
-                        <a:cs typeface="Arial" charset="0"/>
-                      </a:endParaRPr>
-                    </a:p>
-                  </a:txBody>
-                  <a:tcPr marL="91440" marR="91440" marT="45720" marB="45720">
-                    <a:lnL w="12700" cap="flat" cmpd="sng" algn="ctr">
-                      <a:solidFill>
-                        <a:srgbClr val="FFFFFF"/>
-                      </a:solidFill>
-                      <a:prstDash val="solid"/>
-                      <a:round/>
-                      <a:headEnd type="none" w="med" len="med"/>
-                      <a:tailEnd type="none" w="med" len="med"/>
-                    </a:lnL>
-                    <a:lnR w="12700" cap="flat" cmpd="sng" algn="ctr">
-                      <a:solidFill>
-                        <a:srgbClr val="FFFFFF"/>
-                      </a:solidFill>
-                      <a:prstDash val="solid"/>
-                      <a:round/>
-                      <a:headEnd type="none" w="med" len="med"/>
-                      <a:tailEnd type="none" w="med" len="med"/>
-                    </a:lnR>
-                    <a:lnT w="12700" cap="flat" cmpd="sng" algn="ctr">
-                      <a:solidFill>
-                        <a:srgbClr val="FFFFFF"/>
-                      </a:solidFill>
-                      <a:prstDash val="solid"/>
-                      <a:round/>
-                      <a:headEnd type="none" w="med" len="med"/>
-                      <a:tailEnd type="none" w="med" len="med"/>
-                    </a:lnT>
-                    <a:lnB w="12700" cap="flat" cmpd="sng" algn="ctr">
-                      <a:solidFill>
-                        <a:srgbClr val="FFFFFF"/>
-                      </a:solidFill>
-                      <a:prstDash val="solid"/>
-                      <a:round/>
-                      <a:headEnd type="none" w="med" len="med"/>
-                      <a:tailEnd type="none" w="med" len="med"/>
-                    </a:lnB>
-                  </a:tcPr>
-                </a:tc>
-                <a:tc>
-                  <a:txBody>
-                    <a:bodyPr/>
-                    <a:lstStyle/>
-                    <a:p>
-                      <a:pPr algn="r" indent="0" marL="0">
-                        <a:buNone/>
-                      </a:pPr>
-                      <a:r>
-                        <a:rPr lang="en-US" sz="1250" dirty="0">
-                          <a:solidFill>
-                            <a:srgbClr val="000000"/>
-                          </a:solidFill>
-                          <a:latin typeface="Arial" pitchFamily="34" charset="0"/>
-                          <a:ea typeface="Arial" pitchFamily="34" charset="-122"/>
-                          <a:cs typeface="Arial" pitchFamily="34" charset="-120"/>
-                        </a:rPr>
-                        <a:t>33.550 €</a:t>
-                      </a:r>
-                      <a:endParaRPr lang="en-US" sz="1250" dirty="0">
-                        <a:latin typeface="Arial" charset="0"/>
-                        <a:ea typeface="Arial" charset="0"/>
-                        <a:cs typeface="Arial" charset="0"/>
-                      </a:endParaRPr>
-                    </a:p>
-                  </a:txBody>
-                  <a:tcPr marL="91440" marR="91440" marT="45720" marB="45720">
-                    <a:lnL w="12700" cap="flat" cmpd="sng" algn="ctr">
-                      <a:solidFill>
-                        <a:srgbClr val="FFFFFF"/>
-                      </a:solidFill>
-                      <a:prstDash val="solid"/>
-                      <a:round/>
-                      <a:headEnd type="none" w="med" len="med"/>
-                      <a:tailEnd type="none" w="med" len="med"/>
-                    </a:lnL>
-                    <a:lnR w="12700" cap="flat" cmpd="sng" algn="ctr">
-                      <a:solidFill>
-                        <a:srgbClr val="FFFFFF"/>
-                      </a:solidFill>
-                      <a:prstDash val="solid"/>
-                      <a:round/>
-                      <a:headEnd type="none" w="med" len="med"/>
-                      <a:tailEnd type="none" w="med" len="med"/>
-                    </a:lnR>
-                    <a:lnT w="12700" cap="flat" cmpd="sng" algn="ctr">
-                      <a:solidFill>
-                        <a:srgbClr val="FFFFFF"/>
-                      </a:solidFill>
-                      <a:prstDash val="solid"/>
-                      <a:round/>
-                      <a:headEnd type="none" w="med" len="med"/>
-                      <a:tailEnd type="none" w="med" len="med"/>
-                    </a:lnT>
-                    <a:lnB w="12700" cap="flat" cmpd="sng" algn="ctr">
-                      <a:solidFill>
-                        <a:srgbClr val="FFFFFF"/>
-                      </a:solidFill>
-                      <a:prstDash val="solid"/>
-                      <a:round/>
-                      <a:headEnd type="none" w="med" len="med"/>
-                      <a:tailEnd type="none" w="med" len="med"/>
-                    </a:lnB>
-                  </a:tcPr>
-                </a:tc>
-                <a:tc>
-                  <a:txBody>
-                    <a:bodyPr/>
-                    <a:lstStyle/>
-                    <a:p>
-                      <a:pPr algn="r" indent="0" marL="0">
-                        <a:buNone/>
-                      </a:pPr>
-                      <a:r>
-                        <a:rPr lang="en-US" sz="1250" dirty="0">
-                          <a:solidFill>
-                            <a:srgbClr val="000000"/>
-                          </a:solidFill>
-                          <a:latin typeface="Arial" pitchFamily="34" charset="0"/>
-                          <a:ea typeface="Arial" pitchFamily="34" charset="-122"/>
-                          <a:cs typeface="Arial" pitchFamily="34" charset="-120"/>
-                        </a:rPr>
-                        <a:t>−5.100 €</a:t>
-                      </a:r>
-                      <a:endParaRPr lang="en-US" sz="1250" dirty="0">
-                        <a:latin typeface="Arial" charset="0"/>
-                        <a:ea typeface="Arial" charset="0"/>
-                        <a:cs typeface="Arial" charset="0"/>
-                      </a:endParaRPr>
-                    </a:p>
-                  </a:txBody>
-                  <a:tcPr marL="91440" marR="91440" marT="45720" marB="45720">
-                    <a:lnL w="12700" cap="flat" cmpd="sng" algn="ctr">
-                      <a:solidFill>
-                        <a:srgbClr val="FFFFFF"/>
-                      </a:solidFill>
-                      <a:prstDash val="solid"/>
-                      <a:round/>
-                      <a:headEnd type="none" w="med" len="med"/>
-                      <a:tailEnd type="none" w="med" len="med"/>
-                    </a:lnL>
-                    <a:lnR w="12700" cap="flat" cmpd="sng" algn="ctr">
-                      <a:solidFill>
-                        <a:srgbClr val="FFFFFF"/>
-                      </a:solidFill>
-                      <a:prstDash val="solid"/>
-                      <a:round/>
-                      <a:headEnd type="none" w="med" len="med"/>
-                      <a:tailEnd type="none" w="med" len="med"/>
-                    </a:lnR>
-                    <a:lnT w="12700" cap="flat" cmpd="sng" algn="ctr">
-                      <a:solidFill>
-                        <a:srgbClr val="FFFFFF"/>
-                      </a:solidFill>
-                      <a:prstDash val="solid"/>
-                      <a:round/>
-                      <a:headEnd type="none" w="med" len="med"/>
-                      <a:tailEnd type="none" w="med" len="med"/>
-                    </a:lnT>
-                    <a:lnB w="12700" cap="flat" cmpd="sng" algn="ctr">
-                      <a:solidFill>
-                        <a:srgbClr val="FFFFFF"/>
-                      </a:solidFill>
-                      <a:prstDash val="solid"/>
-                      <a:round/>
-                      <a:headEnd type="none" w="med" len="med"/>
-                      <a:tailEnd type="none" w="med" len="med"/>
-                    </a:lnB>
-                  </a:tcPr>
-                </a:tc>
-                <a:tc>
-                  <a:txBody>
-                    <a:bodyPr/>
-                    <a:lstStyle/>
-                    <a:p>
-                      <a:pPr algn="r" indent="0" marL="0">
-                        <a:buNone/>
-                      </a:pPr>
-                      <a:r>
-                        <a:rPr lang="en-US" sz="1250" b="1" dirty="0">
-                          <a:solidFill>
-                            <a:schemeClr val="accent5"/>
-                          </a:solidFill>
-                          <a:latin typeface="Arial" pitchFamily="34" charset="0"/>
-                          <a:ea typeface="Arial" pitchFamily="34" charset="-122"/>
-                          <a:cs typeface="Arial" pitchFamily="34" charset="-120"/>
-                        </a:rPr>
-                        <a:t>+28.450 €</a:t>
+                        <a:t>+23.875 €</a:t>
                       </a:r>
                       <a:endParaRPr lang="en-US" sz="1250" dirty="0">
                         <a:latin typeface="Arial" charset="0"/>
@@ -9669,7 +9669,7 @@
                 <a:ea typeface="Arial" pitchFamily="34" charset="-122"/>
                 <a:cs typeface="Arial" pitchFamily="34" charset="-120"/>
               </a:rPr>
-              <a:t>Mit 95.635 € Umsatz bleiben im ganzen Haus +18.954 € pro Monat nach Zinsen und Tilgung (KfW-Kredite und Hausbank, ohne Lohn). Die Gastro braucht für Break-even im Haus ca. 33.500 € Umsatz.</a:t>
+              <a:t>Mit 65.010 € Umsatz bleiben im ganzen Haus +9.613 € pro Monat nach Zinsen und Tilgung (KfW-Kredite und Hausbank, ohne Lohn). Die Gastro braucht für Break-even im Haus ca. 33.500 € Umsatz.</a:t>
             </a:r>
             <a:endParaRPr lang="en-US" sz="1300" dirty="0"/>
           </a:p>
@@ -10043,7 +10043,7 @@
                           <a:ea typeface="Arial" pitchFamily="34" charset="-122"/>
                           <a:cs typeface="Arial" pitchFamily="34" charset="-120"/>
                         </a:rPr>
-                        <a:t>Küche (Herd, Kühlräume, Edelstahl, Spülküche)</a:t>
+                        <a:t>Küche (Bowl- und Snackküche, Kühlräume, Spülküche)</a:t>
                       </a:r>
                       <a:endParaRPr lang="en-US" sz="1250" dirty="0">
                         <a:latin typeface="Arial" charset="0"/>
@@ -10108,7 +10108,7 @@
                           <a:ea typeface="Arial" pitchFamily="34" charset="-122"/>
                           <a:cs typeface="Arial" pitchFamily="34" charset="-120"/>
                         </a:rPr>
-                        <a:t>38.000 €</a:t>
+                        <a:t>28.000 €</a:t>
                       </a:r>
                       <a:endParaRPr lang="en-US" sz="1250" dirty="0">
                         <a:latin typeface="Arial" charset="0"/>
@@ -10307,7 +10307,7 @@
                           <a:ea typeface="Arial" pitchFamily="34" charset="-122"/>
                           <a:cs typeface="Arial" pitchFamily="34" charset="-120"/>
                         </a:rPr>
-                        <a:t>Theke und Bar (Zapfanlage, Kühlung, Backbar)</a:t>
+                        <a:t>Theke und Bar (Zapfanlage, Kühlung, Backbar, große Theke)</a:t>
                       </a:r>
                       <a:endParaRPr lang="en-US" sz="1250" dirty="0">
                         <a:latin typeface="Arial" charset="0"/>
@@ -10372,7 +10372,7 @@
                           <a:ea typeface="Arial" pitchFamily="34" charset="-122"/>
                           <a:cs typeface="Arial" pitchFamily="34" charset="-120"/>
                         </a:rPr>
-                        <a:t>25.000 €</a:t>
+                        <a:t>35.000 €</a:t>
                       </a:r>
                       <a:endParaRPr lang="en-US" sz="1250" dirty="0">
                         <a:latin typeface="Arial" charset="0"/>
@@ -12162,7 +12162,7 @@
                 <a:ea typeface="Arial" pitchFamily="34" charset="-122"/>
                 <a:cs typeface="Arial" pitchFamily="34" charset="-120"/>
               </a:rPr>
-              <a:t>Gastro unter Wohnungen: Schallschutz der Decke, leise Technik, Abluft der Küche über Dach. Nutzungszeiten der Terrasse klären.</a:t>
+              <a:t>Gastro unter Wohnungen: Schallschutz der Decke, leise Technik, Abluft der kleinen Küche über Dach. Nutzungszeiten der Terrasse klären.</a:t>
             </a:r>
             <a:endParaRPr lang="en-US" sz="1300" dirty="0"/>
           </a:p>
@@ -12372,7 +12372,7 @@
                 <a:ea typeface="Arial" pitchFamily="34" charset="-122"/>
                 <a:cs typeface="Arial" pitchFamily="34" charset="-120"/>
               </a:rPr>
-              <a:t>Keine Marktdaten für Werlte. Erfahrener Betreiber oder Küchenchef früh gewinnen, Probebetrieb und vorsichtiger Start.</a:t>
+              <a:t>Keine Marktdaten für Werlte. Erfahrener Betreiber oder Barchef früh gewinnen, Probebetrieb und vorsichtiger Start.</a:t>
             </a:r>
             <a:endParaRPr lang="en-US" sz="1300" dirty="0"/>
           </a:p>
@@ -12661,7 +12661,7 @@
                 <a:ea typeface="Arial" pitchFamily="34" charset="-122"/>
                 <a:cs typeface="Arial" pitchFamily="34" charset="-120"/>
               </a:rPr>
-              <a:t>Name, Marke und Zielgruppe festlegen, Betreiber oder Küchenchef ansprechen</a:t>
+              <a:t>Name, Marke und Zielgruppe festlegen, Betreiber oder Barchef ansprechen</a:t>
             </a:r>
             <a:endParaRPr lang="en-US" sz="1500" dirty="0"/>
           </a:p>
@@ -13623,7 +13623,7 @@
                 <a:ea typeface="Arial" pitchFamily="34" charset="-122"/>
                 <a:cs typeface="Arial" pitchFamily="34" charset="-120"/>
               </a:rPr>
-              <a:t>Frühstück, Brunch am Wochenende und Mittagstisch am Marktplatz. Regional, frisch, schnell für Beschäftigte aus Rathaus und Umgebung.</a:t>
+              <a:t>Frühstück, Brunch am Wochenende und Bowls, Salate und Suppe zum Mittag. Frisch, schnell, fair im Preis für Beschäftigte aus Rathaus und Umgebung.</a:t>
             </a:r>
             <a:endParaRPr lang="en-US" sz="1400" dirty="0"/>
           </a:p>
@@ -13631,7 +13631,7 @@
       </p:sp>
       <p:sp>
         <p:nvSpPr>
-          <p:cNvPr id="8" name="Abends (Hauptfokus)"/>
+          <p:cNvPr id="8" name="Abends: Bar mit Snacks"/>
           <p:cNvSpPr/>
           <p:nvPr/>
         </p:nvSpPr>
@@ -13689,7 +13689,7 @@
                 <a:ea typeface="Georgia" pitchFamily="34" charset="-122"/>
                 <a:cs typeface="Georgia" pitchFamily="34" charset="-120"/>
               </a:rPr>
-              <a:t>Abends (Hauptfokus)</a:t>
+              <a:t>Abends: Bar mit Snacks</a:t>
             </a:r>
             <a:endParaRPr lang="en-US" sz="2000" dirty="0"/>
           </a:p>
@@ -13728,7 +13728,7 @@
                 <a:ea typeface="Arial" pitchFamily="34" charset="-122"/>
                 <a:cs typeface="Arial" pitchFamily="34" charset="-120"/>
               </a:rPr>
-              <a:t>Moderne, regionale Küche in warmer, dunkler Atmosphäre mit Cognac-Banketten und Kerzenlicht. Der Abend bringt ca. 75 % vom Umsatz.</a:t>
+              <a:t>Bar mit Snacks in warmer, dunkler Atmosphäre mit Cognac-Banketten und Kerzenlicht, keine große Restaurantküche. Der Abend bringt ca. 61 % vom Umsatz.</a:t>
             </a:r>
             <a:endParaRPr lang="en-US" sz="1400" dirty="0"/>
           </a:p>
@@ -13736,7 +13736,7 @@
       </p:sp>
       <p:sp>
         <p:nvSpPr>
-          <p:cNvPr id="11" name="Bar und Feiern"/>
+          <p:cNvPr id="11" name="Cocktails und Events"/>
           <p:cNvSpPr/>
           <p:nvPr/>
         </p:nvSpPr>
@@ -13794,7 +13794,7 @@
                 <a:ea typeface="Georgia" pitchFamily="34" charset="-122"/>
                 <a:cs typeface="Georgia" pitchFamily="34" charset="-120"/>
               </a:rPr>
-              <a:t>Bar und Feiern</a:t>
+              <a:t>Cocktails und Events</a:t>
             </a:r>
             <a:endParaRPr lang="en-US" sz="2000" dirty="0"/>
           </a:p>
@@ -13833,7 +13833,7 @@
                 <a:ea typeface="Arial" pitchFamily="34" charset="-122"/>
                 <a:cs typeface="Arial" pitchFamily="34" charset="-120"/>
               </a:rPr>
-              <a:t>Ab 21 Uhr Cocktails, Wein und Bier an der Theke, Fr und Sa bis 01 Uhr. Live-Abende, Séparée mit 30 Plätzen für Feiern.</a:t>
+              <a:t>Cocktails, Wein und Bier an der großen Theke, Fr und Sa bis 01 Uhr. Live-Musik, Séparée mit 30 Plätzen für Feiern.</a:t>
             </a:r>
             <a:endParaRPr lang="en-US" sz="1400" dirty="0"/>
           </a:p>
@@ -14292,7 +14292,7 @@
                 <a:ea typeface="Arial" pitchFamily="34" charset="-122"/>
                 <a:cs typeface="Arial" pitchFamily="34" charset="-120"/>
               </a:rPr>
-              <a:t>Arbeitstitel: Bar-Restaurant am Marktplatz. Ein Name und eine Marke sind noch offen.</a:t>
+              <a:t>Arbeitstitel: Café und Bar am Marktplatz. Ein Name und eine Marke sind noch offen.</a:t>
             </a:r>
             <a:endParaRPr lang="en-US" sz="1300" dirty="0"/>
           </a:p>
@@ -15614,7 +15614,7 @@
                           <a:ea typeface="Arial" pitchFamily="34" charset="-122"/>
                           <a:cs typeface="Arial" pitchFamily="34" charset="-120"/>
                         </a:rPr>
-                        <a:t>Terrasse, Kaffee, regionale Küche</a:t>
+                        <a:t>Terrasse, Kaffee, Bowls</a:t>
                       </a:r>
                       <a:endParaRPr lang="en-US" sz="1250" dirty="0">
                         <a:latin typeface="Arial" charset="0"/>
@@ -16407,7 +16407,7 @@
                           <a:ea typeface="Arial" pitchFamily="34" charset="-122"/>
                           <a:cs typeface="Arial" pitchFamily="34" charset="-120"/>
                         </a:rPr>
-                        <a:t>Mittagstisch, Tagesgericht, Suppe</a:t>
+                        <a:t>Bowls, Salate, Suppe des Tages</a:t>
                       </a:r>
                       <a:endParaRPr lang="en-US" sz="1250" dirty="0">
                         <a:latin typeface="Arial" charset="0"/>
@@ -16539,7 +16539,7 @@
                           <a:ea typeface="Arial" pitchFamily="34" charset="-122"/>
                           <a:cs typeface="Arial" pitchFamily="34" charset="-120"/>
                         </a:rPr>
-                        <a:t>14:30–17:30</a:t>
+                        <a:t>14:30–17:00</a:t>
                       </a:r>
                       <a:endParaRPr lang="en-US" sz="1250" dirty="0">
                         <a:latin typeface="Arial" charset="0"/>
@@ -16604,7 +16604,7 @@
                           <a:ea typeface="Arial" pitchFamily="34" charset="-122"/>
                           <a:cs typeface="Arial" pitchFamily="34" charset="-120"/>
                         </a:rPr>
-                        <a:t>Kaffee, Kuchen, kleine Karte</a:t>
+                        <a:t>Kaffee, Kuchen, kleine Snacks</a:t>
                       </a:r>
                       <a:endParaRPr lang="en-US" sz="1250" dirty="0">
                         <a:latin typeface="Arial" charset="0"/>
@@ -16736,7 +16736,7 @@
                           <a:ea typeface="Arial" pitchFamily="34" charset="-122"/>
                           <a:cs typeface="Arial" pitchFamily="34" charset="-120"/>
                         </a:rPr>
-                        <a:t>17:30–22:00 (Di–So)</a:t>
+                        <a:t>ab 17:00 (Di–Do, So bis 22:00)</a:t>
                       </a:r>
                       <a:endParaRPr lang="en-US" sz="1250" dirty="0">
                         <a:latin typeface="Arial" charset="0"/>
@@ -16801,7 +16801,7 @@
                           <a:ea typeface="Arial" pitchFamily="34" charset="-122"/>
                           <a:cs typeface="Arial" pitchFamily="34" charset="-120"/>
                         </a:rPr>
-                        <a:t>Abendessen, Wein, Bier</a:t>
+                        <a:t>Bar mit Snacks, Wein, Bier, Cocktails</a:t>
                       </a:r>
                       <a:endParaRPr lang="en-US" sz="1250" dirty="0">
                         <a:latin typeface="Arial" charset="0"/>
@@ -16933,7 +16933,7 @@
                           <a:ea typeface="Arial" pitchFamily="34" charset="-122"/>
                           <a:cs typeface="Arial" pitchFamily="34" charset="-120"/>
                         </a:rPr>
-                        <a:t>ab 21:00 (Fr, Sa bis 01:00)</a:t>
+                        <a:t>Fr, Sa bis 01:00</a:t>
                       </a:r>
                       <a:endParaRPr lang="en-US" sz="1250" dirty="0">
                         <a:latin typeface="Arial" charset="0"/>
@@ -16998,7 +16998,7 @@
                           <a:ea typeface="Arial" pitchFamily="34" charset="-122"/>
                           <a:cs typeface="Arial" pitchFamily="34" charset="-120"/>
                         </a:rPr>
-                        <a:t>Bar, Cocktails, Live-Abende, leise Musik</a:t>
+                        <a:t>Bar, Cocktails, Snacks, Live-Musik</a:t>
                       </a:r>
                       <a:endParaRPr lang="en-US" sz="1250" dirty="0">
                         <a:latin typeface="Arial" charset="0"/>
@@ -17450,7 +17450,7 @@
                 <a:ea typeface="Arial" pitchFamily="34" charset="-122"/>
                 <a:cs typeface="Arial" pitchFamily="34" charset="-120"/>
               </a:rPr>
-              <a:t>Eggs Benedict 13,90 €</a:t>
+              <a:t>Avocado-Toast mit Ei 10,90 €</a:t>
             </a:r>
             <a:endParaRPr lang="en-US" sz="1300" dirty="0"/>
           </a:p>
@@ -17500,7 +17500,7 @@
       </p:sp>
       <p:sp>
         <p:nvSpPr>
-          <p:cNvPr id="8" name="Mittagstisch"/>
+          <p:cNvPr id="8" name="Bowls und Mittag"/>
           <p:cNvSpPr/>
           <p:nvPr/>
         </p:nvSpPr>
@@ -17558,7 +17558,7 @@
                 <a:ea typeface="Georgia" pitchFamily="34" charset="-122"/>
                 <a:cs typeface="Georgia" pitchFamily="34" charset="-120"/>
               </a:rPr>
-              <a:t>Mittagstisch</a:t>
+              <a:t>Bowls und Mittag</a:t>
             </a:r>
             <a:endParaRPr lang="en-US" sz="1700" dirty="0"/>
           </a:p>
@@ -17601,7 +17601,7 @@
                 <a:ea typeface="Arial" pitchFamily="34" charset="-122"/>
                 <a:cs typeface="Arial" pitchFamily="34" charset="-120"/>
               </a:rPr>
-              <a:t>Tagesgericht 10,90–13,90 €</a:t>
+              <a:t>Bowl mit Huhn und Gemüse 12,90 €</a:t>
             </a:r>
             <a:endParaRPr lang="en-US" sz="1300" dirty="0"/>
           </a:p>
@@ -17622,7 +17622,179 @@
                 <a:ea typeface="Arial" pitchFamily="34" charset="-122"/>
                 <a:cs typeface="Arial" pitchFamily="34" charset="-120"/>
               </a:rPr>
-              <a:t>Bowl mit Gemüse und Huhn 12,90 €</a:t>
+              <a:t>Vegane Bowl 11,90 €</a:t>
+            </a:r>
+            <a:endParaRPr lang="en-US" sz="1300" dirty="0"/>
+          </a:p>
+          <a:p>
+            <a:pPr marL="342900" indent="-342900">
+              <a:spcAft>
+                <a:spcPts val="600"/>
+              </a:spcAft>
+              <a:buSzPct val="100000"/>
+              <a:buChar char="•"/>
+            </a:pPr>
+            <a:r>
+              <a:rPr lang="en-US" sz="1300" dirty="0">
+                <a:solidFill>
+                  <a:schemeClr val="tx1"/>
+                </a:solidFill>
+                <a:latin typeface="Arial" pitchFamily="34" charset="0"/>
+                <a:ea typeface="Arial" pitchFamily="34" charset="-122"/>
+                <a:cs typeface="Arial" pitchFamily="34" charset="-120"/>
+              </a:rPr>
+              <a:t>Salat mit Topping 10,90 €</a:t>
+            </a:r>
+            <a:endParaRPr lang="en-US" sz="1300" dirty="0"/>
+          </a:p>
+          <a:p>
+            <a:pPr marL="342900" indent="-342900">
+              <a:spcAft>
+                <a:spcPts val="600"/>
+              </a:spcAft>
+              <a:buSzPct val="100000"/>
+              <a:buChar char="•"/>
+            </a:pPr>
+            <a:r>
+              <a:rPr lang="en-US" sz="1300" dirty="0">
+                <a:solidFill>
+                  <a:schemeClr val="tx1"/>
+                </a:solidFill>
+                <a:latin typeface="Arial" pitchFamily="34" charset="0"/>
+                <a:ea typeface="Arial" pitchFamily="34" charset="-122"/>
+                <a:cs typeface="Arial" pitchFamily="34" charset="-120"/>
+              </a:rPr>
+              <a:t>Suppe des Tages 6,50 €</a:t>
+            </a:r>
+            <a:endParaRPr lang="en-US" sz="1300" dirty="0"/>
+          </a:p>
+        </p:txBody>
+      </p:sp>
+      <p:sp>
+        <p:nvSpPr>
+          <p:cNvPr id="11" name="Snacks zur Bar"/>
+          <p:cNvSpPr/>
+          <p:nvPr/>
+        </p:nvSpPr>
+        <p:spPr>
+          <a:xfrm>
+            <a:off x="6231636" y="1371600"/>
+            <a:ext cx="2567178" cy="3657600"/>
+          </a:xfrm>
+          <a:prstGeom prst="roundRect">
+            <a:avLst>
+              <a:gd name="adj" fmla="val 2850"/>
+            </a:avLst>
+          </a:prstGeom>
+          <a:solidFill>
+            <a:schemeClr val="bg2"/>
+          </a:solidFill>
+          <a:ln w="12700">
+            <a:solidFill>
+              <a:schemeClr val="bg2"/>
+            </a:solidFill>
+            <a:prstDash val="solid"/>
+          </a:ln>
+        </p:spPr>
+      </p:sp>
+      <p:sp>
+        <p:nvSpPr>
+          <p:cNvPr id="12" name="Text 9"/>
+          <p:cNvSpPr txBox="1"/>
+          <p:nvPr/>
+        </p:nvSpPr>
+        <p:spPr>
+          <a:xfrm>
+            <a:off x="6414516" y="1481328"/>
+            <a:ext cx="2201418" cy="457200"/>
+          </a:xfrm>
+          <a:prstGeom prst="rect">
+            <a:avLst/>
+          </a:prstGeom>
+          <a:noFill/>
+          <a:ln/>
+        </p:spPr>
+        <p:txBody>
+          <a:bodyPr wrap="square" lIns="0" tIns="0" rIns="0" bIns="0" rtlCol="0" anchor="t"/>
+          <a:lstStyle/>
+          <a:p>
+            <a:pPr indent="0" marL="0">
+              <a:buNone/>
+            </a:pPr>
+            <a:r>
+              <a:rPr lang="en-US" sz="1700" dirty="0">
+                <a:solidFill>
+                  <a:schemeClr val="accent1"/>
+                </a:solidFill>
+                <a:latin typeface="Georgia" pitchFamily="34" charset="0"/>
+                <a:ea typeface="Georgia" pitchFamily="34" charset="-122"/>
+                <a:cs typeface="Georgia" pitchFamily="34" charset="-120"/>
+              </a:rPr>
+              <a:t>Snacks zur Bar</a:t>
+            </a:r>
+            <a:endParaRPr lang="en-US" sz="1700" dirty="0"/>
+          </a:p>
+        </p:txBody>
+      </p:sp>
+      <p:sp>
+        <p:nvSpPr>
+          <p:cNvPr id="13" name="Text 10"/>
+          <p:cNvSpPr txBox="1"/>
+          <p:nvPr/>
+        </p:nvSpPr>
+        <p:spPr>
+          <a:xfrm>
+            <a:off x="6414516" y="2011680"/>
+            <a:ext cx="2201418" cy="2926080"/>
+          </a:xfrm>
+          <a:prstGeom prst="rect">
+            <a:avLst/>
+          </a:prstGeom>
+          <a:noFill/>
+          <a:ln/>
+        </p:spPr>
+        <p:txBody>
+          <a:bodyPr wrap="square" lIns="0" tIns="0" rIns="0" bIns="0" rtlCol="0" anchor="t"/>
+          <a:lstStyle/>
+          <a:p>
+            <a:pPr marL="342900" indent="-342900">
+              <a:spcAft>
+                <a:spcPts val="600"/>
+              </a:spcAft>
+              <a:buSzPct val="100000"/>
+              <a:buChar char="•"/>
+            </a:pPr>
+            <a:r>
+              <a:rPr lang="en-US" sz="1300" dirty="0">
+                <a:solidFill>
+                  <a:schemeClr val="tx1"/>
+                </a:solidFill>
+                <a:latin typeface="Arial" pitchFamily="34" charset="0"/>
+                <a:ea typeface="Arial" pitchFamily="34" charset="-122"/>
+                <a:cs typeface="Arial" pitchFamily="34" charset="-120"/>
+              </a:rPr>
+              <a:t>Nachos mit Dip 8,90 €</a:t>
+            </a:r>
+            <a:endParaRPr lang="en-US" sz="1300" dirty="0"/>
+          </a:p>
+          <a:p>
+            <a:pPr marL="342900" indent="-342900">
+              <a:spcAft>
+                <a:spcPts val="600"/>
+              </a:spcAft>
+              <a:buSzPct val="100000"/>
+              <a:buChar char="•"/>
+            </a:pPr>
+            <a:r>
+              <a:rPr lang="en-US" sz="1300" dirty="0">
+                <a:solidFill>
+                  <a:schemeClr val="tx1"/>
+                </a:solidFill>
+                <a:latin typeface="Arial" pitchFamily="34" charset="0"/>
+                <a:ea typeface="Arial" pitchFamily="34" charset="-122"/>
+                <a:cs typeface="Arial" pitchFamily="34" charset="-120"/>
+              </a:rPr>
+              <a:t>Käse- und Wurstplatte 14,90 €</a:t>
             </a:r>
             <a:endParaRPr lang="en-US" sz="1300" dirty="0"/>
           </a:p>
@@ -17664,116 +17836,7 @@
                 <a:ea typeface="Arial" pitchFamily="34" charset="-122"/>
                 <a:cs typeface="Arial" pitchFamily="34" charset="-120"/>
               </a:rPr>
-              <a:t>Suppe des Tages 6,50 €</a:t>
-            </a:r>
-            <a:endParaRPr lang="en-US" sz="1300" dirty="0"/>
-          </a:p>
-        </p:txBody>
-      </p:sp>
-      <p:sp>
-        <p:nvSpPr>
-          <p:cNvPr id="11" name="Abendkarte"/>
-          <p:cNvSpPr/>
-          <p:nvPr/>
-        </p:nvSpPr>
-        <p:spPr>
-          <a:xfrm>
-            <a:off x="6231636" y="1371600"/>
-            <a:ext cx="2567178" cy="3657600"/>
-          </a:xfrm>
-          <a:prstGeom prst="roundRect">
-            <a:avLst>
-              <a:gd name="adj" fmla="val 2850"/>
-            </a:avLst>
-          </a:prstGeom>
-          <a:solidFill>
-            <a:schemeClr val="bg2"/>
-          </a:solidFill>
-          <a:ln w="12700">
-            <a:solidFill>
-              <a:schemeClr val="bg2"/>
-            </a:solidFill>
-            <a:prstDash val="solid"/>
-          </a:ln>
-        </p:spPr>
-      </p:sp>
-      <p:sp>
-        <p:nvSpPr>
-          <p:cNvPr id="12" name="Text 9"/>
-          <p:cNvSpPr txBox="1"/>
-          <p:nvPr/>
-        </p:nvSpPr>
-        <p:spPr>
-          <a:xfrm>
-            <a:off x="6414516" y="1481328"/>
-            <a:ext cx="2201418" cy="457200"/>
-          </a:xfrm>
-          <a:prstGeom prst="rect">
-            <a:avLst/>
-          </a:prstGeom>
-          <a:noFill/>
-          <a:ln/>
-        </p:spPr>
-        <p:txBody>
-          <a:bodyPr wrap="square" lIns="0" tIns="0" rIns="0" bIns="0" rtlCol="0" anchor="t"/>
-          <a:lstStyle/>
-          <a:p>
-            <a:pPr indent="0" marL="0">
-              <a:buNone/>
-            </a:pPr>
-            <a:r>
-              <a:rPr lang="en-US" sz="1700" dirty="0">
-                <a:solidFill>
-                  <a:schemeClr val="accent1"/>
-                </a:solidFill>
-                <a:latin typeface="Georgia" pitchFamily="34" charset="0"/>
-                <a:ea typeface="Georgia" pitchFamily="34" charset="-122"/>
-                <a:cs typeface="Georgia" pitchFamily="34" charset="-120"/>
-              </a:rPr>
-              <a:t>Abendkarte</a:t>
-            </a:r>
-            <a:endParaRPr lang="en-US" sz="1700" dirty="0"/>
-          </a:p>
-        </p:txBody>
-      </p:sp>
-      <p:sp>
-        <p:nvSpPr>
-          <p:cNvPr id="13" name="Text 10"/>
-          <p:cNvSpPr txBox="1"/>
-          <p:nvPr/>
-        </p:nvSpPr>
-        <p:spPr>
-          <a:xfrm>
-            <a:off x="6414516" y="2011680"/>
-            <a:ext cx="2201418" cy="2926080"/>
-          </a:xfrm>
-          <a:prstGeom prst="rect">
-            <a:avLst/>
-          </a:prstGeom>
-          <a:noFill/>
-          <a:ln/>
-        </p:spPr>
-        <p:txBody>
-          <a:bodyPr wrap="square" lIns="0" tIns="0" rIns="0" bIns="0" rtlCol="0" anchor="t"/>
-          <a:lstStyle/>
-          <a:p>
-            <a:pPr marL="342900" indent="-342900">
-              <a:spcAft>
-                <a:spcPts val="600"/>
-              </a:spcAft>
-              <a:buSzPct val="100000"/>
-              <a:buChar char="•"/>
-            </a:pPr>
-            <a:r>
-              <a:rPr lang="en-US" sz="1300" dirty="0">
-                <a:solidFill>
-                  <a:schemeClr val="tx1"/>
-                </a:solidFill>
-                <a:latin typeface="Arial" pitchFamily="34" charset="0"/>
-                <a:ea typeface="Arial" pitchFamily="34" charset="-122"/>
-                <a:cs typeface="Arial" pitchFamily="34" charset="-120"/>
-              </a:rPr>
-              <a:t>Burrata mit Tomaten 11,90 €</a:t>
+              <a:t>Bruschetta 7,90 €</a:t>
             </a:r>
             <a:endParaRPr lang="en-US" sz="1300" dirty="0"/>
           </a:p>
@@ -17794,7 +17857,7 @@
                 <a:ea typeface="Arial" pitchFamily="34" charset="-122"/>
                 <a:cs typeface="Arial" pitchFamily="34" charset="-120"/>
               </a:rPr>
-              <a:t>Burger vom Weiderind 16,90 €</a:t>
+              <a:t>Chicken Wings 9,90 €</a:t>
             </a:r>
             <a:endParaRPr lang="en-US" sz="1300" dirty="0"/>
           </a:p>
@@ -17815,70 +17878,7 @@
                 <a:ea typeface="Arial" pitchFamily="34" charset="-122"/>
                 <a:cs typeface="Arial" pitchFamily="34" charset="-120"/>
               </a:rPr>
-              <a:t>Schnitzel, regional 18,90 €</a:t>
-            </a:r>
-            <a:endParaRPr lang="en-US" sz="1300" dirty="0"/>
-          </a:p>
-          <a:p>
-            <a:pPr marL="342900" indent="-342900">
-              <a:spcAft>
-                <a:spcPts val="600"/>
-              </a:spcAft>
-              <a:buSzPct val="100000"/>
-              <a:buChar char="•"/>
-            </a:pPr>
-            <a:r>
-              <a:rPr lang="en-US" sz="1300" dirty="0">
-                <a:solidFill>
-                  <a:schemeClr val="tx1"/>
-                </a:solidFill>
-                <a:latin typeface="Arial" pitchFamily="34" charset="0"/>
-                <a:ea typeface="Arial" pitchFamily="34" charset="-122"/>
-                <a:cs typeface="Arial" pitchFamily="34" charset="-120"/>
-              </a:rPr>
-              <a:t>Pasta, vegetarisch 14,90 €</a:t>
-            </a:r>
-            <a:endParaRPr lang="en-US" sz="1300" dirty="0"/>
-          </a:p>
-          <a:p>
-            <a:pPr marL="342900" indent="-342900">
-              <a:spcAft>
-                <a:spcPts val="600"/>
-              </a:spcAft>
-              <a:buSzPct val="100000"/>
-              <a:buChar char="•"/>
-            </a:pPr>
-            <a:r>
-              <a:rPr lang="en-US" sz="1300" dirty="0">
-                <a:solidFill>
-                  <a:schemeClr val="tx1"/>
-                </a:solidFill>
-                <a:latin typeface="Arial" pitchFamily="34" charset="0"/>
-                <a:ea typeface="Arial" pitchFamily="34" charset="-122"/>
-                <a:cs typeface="Arial" pitchFamily="34" charset="-120"/>
-              </a:rPr>
-              <a:t>Steak mit Beilage 29,90 €</a:t>
-            </a:r>
-            <a:endParaRPr lang="en-US" sz="1300" dirty="0"/>
-          </a:p>
-          <a:p>
-            <a:pPr marL="342900" indent="-342900">
-              <a:spcAft>
-                <a:spcPts val="600"/>
-              </a:spcAft>
-              <a:buSzPct val="100000"/>
-              <a:buChar char="•"/>
-            </a:pPr>
-            <a:r>
-              <a:rPr lang="en-US" sz="1300" dirty="0">
-                <a:solidFill>
-                  <a:schemeClr val="tx1"/>
-                </a:solidFill>
-                <a:latin typeface="Arial" pitchFamily="34" charset="0"/>
-                <a:ea typeface="Arial" pitchFamily="34" charset="-122"/>
-                <a:cs typeface="Arial" pitchFamily="34" charset="-120"/>
-              </a:rPr>
-              <a:t>Dessert 7,90 €</a:t>
+              <a:t>Süßkartoffel-Pommes 6,90 €</a:t>
             </a:r>
             <a:endParaRPr lang="en-US" sz="1300" dirty="0"/>
           </a:p>
@@ -18110,7 +18110,7 @@
                 <a:ea typeface="Arial" pitchFamily="34" charset="-122"/>
                 <a:cs typeface="Arial" pitchFamily="34" charset="-120"/>
               </a:rPr>
-              <a:t>Durchschnittlicher Bon (Annahme): Frühstück 11 €, Brunch 14 €, Mittag 14 €, Abendessen 32 €, Bar 18–22 €, Feiern 45 €.</a:t>
+              <a:t>Durchschnittlicher Bon (Annahme): Frühstück 11 €, Brunch 14 €, Bowls 13 €, Kaffee 7 €, Bar mit Snacks 20–26 €, Events 40 €.</a:t>
             </a:r>
             <a:endParaRPr lang="en-US" sz="1400" dirty="0"/>
           </a:p>
@@ -18221,7 +18221,7 @@
                 <a:ea typeface="Georgia" pitchFamily="34" charset="-122"/>
                 <a:cs typeface="Georgia" pitchFamily="34" charset="-120"/>
               </a:rPr>
-              <a:t>Hauptfokus Abend: Restaurant und Bar</a:t>
+              <a:t>Hauptfokus Abend: Bar mit Snacks</a:t>
             </a:r>
             <a:endParaRPr lang="en-US" sz="2700" dirty="0"/>
           </a:p>
@@ -18323,7 +18323,7 @@
                 <a:ea typeface="Arial" pitchFamily="34" charset="-122"/>
                 <a:cs typeface="Arial" pitchFamily="34" charset="-120"/>
               </a:rPr>
-              <a:t>Restaurant (17:30–22:00)</a:t>
+              <a:t>Snacks (kleine Küche)</a:t>
             </a:r>
             <a:endParaRPr lang="en-US" sz="1300" dirty="0"/>
           </a:p>
@@ -18344,7 +18344,7 @@
                 <a:ea typeface="Arial" pitchFamily="34" charset="-122"/>
                 <a:cs typeface="Arial" pitchFamily="34" charset="-120"/>
               </a:rPr>
-              <a:t>Kurze, moderne Karte mit regionalen Zutaten, Steaks und Burger, Wein-Empfehlung zum Essen</a:t>
+              <a:t>Kurze Snackkarte: Platten, Flammkuchen, Nachos, Wings, Bruschetta</a:t>
             </a:r>
             <a:endParaRPr lang="en-US" sz="1300" dirty="0"/>
           </a:p>
@@ -18365,7 +18365,7 @@
                 <a:ea typeface="Arial" pitchFamily="34" charset="-122"/>
                 <a:cs typeface="Arial" pitchFamily="34" charset="-120"/>
               </a:rPr>
-              <a:t>Reservierung für Gruppen, Tische für zwei bis acht</a:t>
+              <a:t>Gäste teilen und bleiben, dadurch mehr Getränkeumsatz</a:t>
             </a:r>
             <a:endParaRPr lang="en-US" sz="1300" dirty="0"/>
           </a:p>
@@ -18385,7 +18385,7 @@
                 <a:ea typeface="Arial" pitchFamily="34" charset="-122"/>
                 <a:cs typeface="Arial" pitchFamily="34" charset="-120"/>
               </a:rPr>
-              <a:t>Bar (ab 21:00, Fr und Sa bis 01:00)</a:t>
+              <a:t>Bar (ab 17:00, Fr und Sa bis 01:00)</a:t>
             </a:r>
             <a:endParaRPr lang="en-US" sz="1300" dirty="0"/>
           </a:p>
@@ -18863,7 +18863,7 @@
                           <a:ea typeface="Arial" pitchFamily="34" charset="-122"/>
                           <a:cs typeface="Arial" pitchFamily="34" charset="-120"/>
                         </a:rPr>
-                        <a:t>Abendessen Restaurant</a:t>
+                        <a:t>Bar mit Snacks Di–Do, So</a:t>
                       </a:r>
                       <a:endParaRPr lang="en-US" sz="1250" dirty="0">
                         <a:latin typeface="Arial" charset="0"/>
@@ -18928,7 +18928,7 @@
                           <a:ea typeface="Arial" pitchFamily="34" charset="-122"/>
                           <a:cs typeface="Arial" pitchFamily="34" charset="-120"/>
                         </a:rPr>
-                        <a:t>26</a:t>
+                        <a:t>17</a:t>
                       </a:r>
                       <a:endParaRPr lang="en-US" sz="1250" dirty="0">
                         <a:latin typeface="Arial" charset="0"/>
@@ -18993,7 +18993,7 @@
                           <a:ea typeface="Arial" pitchFamily="34" charset="-122"/>
                           <a:cs typeface="Arial" pitchFamily="34" charset="-120"/>
                         </a:rPr>
-                        <a:t>55</a:t>
+                        <a:t>35</a:t>
                       </a:r>
                       <a:endParaRPr lang="en-US" sz="1250" dirty="0">
                         <a:latin typeface="Arial" charset="0"/>
@@ -19058,7 +19058,7 @@
                           <a:ea typeface="Arial" pitchFamily="34" charset="-122"/>
                           <a:cs typeface="Arial" pitchFamily="34" charset="-120"/>
                         </a:rPr>
-                        <a:t>32 €</a:t>
+                        <a:t>20 €</a:t>
                       </a:r>
                       <a:endParaRPr lang="en-US" sz="1250" dirty="0">
                         <a:latin typeface="Arial" charset="0"/>
@@ -19123,334 +19123,7 @@
                           <a:ea typeface="Arial" pitchFamily="34" charset="-122"/>
                           <a:cs typeface="Arial" pitchFamily="34" charset="-120"/>
                         </a:rPr>
-                        <a:t>45.760 €</a:t>
-                      </a:r>
-                      <a:endParaRPr lang="en-US" sz="1250" dirty="0">
-                        <a:latin typeface="Arial" charset="0"/>
-                        <a:ea typeface="Arial" charset="0"/>
-                        <a:cs typeface="Arial" charset="0"/>
-                      </a:endParaRPr>
-                    </a:p>
-                  </a:txBody>
-                  <a:tcPr marL="91440" marR="91440" marT="45720" marB="45720">
-                    <a:lnL w="12700" cap="flat" cmpd="sng" algn="ctr">
-                      <a:solidFill>
-                        <a:srgbClr val="FFFFFF"/>
-                      </a:solidFill>
-                      <a:prstDash val="solid"/>
-                      <a:round/>
-                      <a:headEnd type="none" w="med" len="med"/>
-                      <a:tailEnd type="none" w="med" len="med"/>
-                    </a:lnL>
-                    <a:lnR w="12700" cap="flat" cmpd="sng" algn="ctr">
-                      <a:solidFill>
-                        <a:srgbClr val="FFFFFF"/>
-                      </a:solidFill>
-                      <a:prstDash val="solid"/>
-                      <a:round/>
-                      <a:headEnd type="none" w="med" len="med"/>
-                      <a:tailEnd type="none" w="med" len="med"/>
-                    </a:lnR>
-                    <a:lnT w="12700" cap="flat" cmpd="sng" algn="ctr">
-                      <a:solidFill>
-                        <a:srgbClr val="FFFFFF"/>
-                      </a:solidFill>
-                      <a:prstDash val="solid"/>
-                      <a:round/>
-                      <a:headEnd type="none" w="med" len="med"/>
-                      <a:tailEnd type="none" w="med" len="med"/>
-                    </a:lnT>
-                    <a:lnB w="12700" cap="flat" cmpd="sng" algn="ctr">
-                      <a:solidFill>
-                        <a:srgbClr val="FFFFFF"/>
-                      </a:solidFill>
-                      <a:prstDash val="solid"/>
-                      <a:round/>
-                      <a:headEnd type="none" w="med" len="med"/>
-                      <a:tailEnd type="none" w="med" len="med"/>
-                    </a:lnB>
-                  </a:tcPr>
-                </a:tc>
-              </a:tr>
-              <a:tr h="246888">
-                <a:tc>
-                  <a:txBody>
-                    <a:bodyPr/>
-                    <a:lstStyle/>
-                    <a:p>
-                      <a:pPr indent="0" marL="0">
-                        <a:buNone/>
-                      </a:pPr>
-                      <a:r>
-                        <a:rPr lang="en-US" sz="1250" dirty="0">
-                          <a:solidFill>
-                            <a:srgbClr val="000000"/>
-                          </a:solidFill>
-                          <a:latin typeface="Arial" pitchFamily="34" charset="0"/>
-                          <a:ea typeface="Arial" pitchFamily="34" charset="-122"/>
-                          <a:cs typeface="Arial" pitchFamily="34" charset="-120"/>
-                        </a:rPr>
-                        <a:t>Bar Di–Do</a:t>
-                      </a:r>
-                      <a:endParaRPr lang="en-US" sz="1250" dirty="0">
-                        <a:latin typeface="Arial" charset="0"/>
-                        <a:ea typeface="Arial" charset="0"/>
-                        <a:cs typeface="Arial" charset="0"/>
-                      </a:endParaRPr>
-                    </a:p>
-                  </a:txBody>
-                  <a:tcPr marL="91440" marR="91440" marT="45720" marB="45720">
-                    <a:lnL w="12700" cap="flat" cmpd="sng" algn="ctr">
-                      <a:solidFill>
-                        <a:srgbClr val="FFFFFF"/>
-                      </a:solidFill>
-                      <a:prstDash val="solid"/>
-                      <a:round/>
-                      <a:headEnd type="none" w="med" len="med"/>
-                      <a:tailEnd type="none" w="med" len="med"/>
-                    </a:lnL>
-                    <a:lnR w="12700" cap="flat" cmpd="sng" algn="ctr">
-                      <a:solidFill>
-                        <a:srgbClr val="FFFFFF"/>
-                      </a:solidFill>
-                      <a:prstDash val="solid"/>
-                      <a:round/>
-                      <a:headEnd type="none" w="med" len="med"/>
-                      <a:tailEnd type="none" w="med" len="med"/>
-                    </a:lnR>
-                    <a:lnT w="12700" cap="flat" cmpd="sng" algn="ctr">
-                      <a:solidFill>
-                        <a:srgbClr val="FFFFFF"/>
-                      </a:solidFill>
-                      <a:prstDash val="solid"/>
-                      <a:round/>
-                      <a:headEnd type="none" w="med" len="med"/>
-                      <a:tailEnd type="none" w="med" len="med"/>
-                    </a:lnT>
-                    <a:lnB w="12700" cap="flat" cmpd="sng" algn="ctr">
-                      <a:solidFill>
-                        <a:srgbClr val="FFFFFF"/>
-                      </a:solidFill>
-                      <a:prstDash val="solid"/>
-                      <a:round/>
-                      <a:headEnd type="none" w="med" len="med"/>
-                      <a:tailEnd type="none" w="med" len="med"/>
-                    </a:lnB>
-                  </a:tcPr>
-                </a:tc>
-                <a:tc>
-                  <a:txBody>
-                    <a:bodyPr/>
-                    <a:lstStyle/>
-                    <a:p>
-                      <a:pPr algn="r" indent="0" marL="0">
-                        <a:buNone/>
-                      </a:pPr>
-                      <a:r>
-                        <a:rPr lang="en-US" sz="1250" dirty="0">
-                          <a:solidFill>
-                            <a:srgbClr val="000000"/>
-                          </a:solidFill>
-                          <a:latin typeface="Arial" pitchFamily="34" charset="0"/>
-                          <a:ea typeface="Arial" pitchFamily="34" charset="-122"/>
-                          <a:cs typeface="Arial" pitchFamily="34" charset="-120"/>
-                        </a:rPr>
-                        <a:t>13</a:t>
-                      </a:r>
-                      <a:endParaRPr lang="en-US" sz="1250" dirty="0">
-                        <a:latin typeface="Arial" charset="0"/>
-                        <a:ea typeface="Arial" charset="0"/>
-                        <a:cs typeface="Arial" charset="0"/>
-                      </a:endParaRPr>
-                    </a:p>
-                  </a:txBody>
-                  <a:tcPr marL="91440" marR="91440" marT="45720" marB="45720">
-                    <a:lnL w="12700" cap="flat" cmpd="sng" algn="ctr">
-                      <a:solidFill>
-                        <a:srgbClr val="FFFFFF"/>
-                      </a:solidFill>
-                      <a:prstDash val="solid"/>
-                      <a:round/>
-                      <a:headEnd type="none" w="med" len="med"/>
-                      <a:tailEnd type="none" w="med" len="med"/>
-                    </a:lnL>
-                    <a:lnR w="12700" cap="flat" cmpd="sng" algn="ctr">
-                      <a:solidFill>
-                        <a:srgbClr val="FFFFFF"/>
-                      </a:solidFill>
-                      <a:prstDash val="solid"/>
-                      <a:round/>
-                      <a:headEnd type="none" w="med" len="med"/>
-                      <a:tailEnd type="none" w="med" len="med"/>
-                    </a:lnR>
-                    <a:lnT w="12700" cap="flat" cmpd="sng" algn="ctr">
-                      <a:solidFill>
-                        <a:srgbClr val="FFFFFF"/>
-                      </a:solidFill>
-                      <a:prstDash val="solid"/>
-                      <a:round/>
-                      <a:headEnd type="none" w="med" len="med"/>
-                      <a:tailEnd type="none" w="med" len="med"/>
-                    </a:lnT>
-                    <a:lnB w="12700" cap="flat" cmpd="sng" algn="ctr">
-                      <a:solidFill>
-                        <a:srgbClr val="FFFFFF"/>
-                      </a:solidFill>
-                      <a:prstDash val="solid"/>
-                      <a:round/>
-                      <a:headEnd type="none" w="med" len="med"/>
-                      <a:tailEnd type="none" w="med" len="med"/>
-                    </a:lnB>
-                  </a:tcPr>
-                </a:tc>
-                <a:tc>
-                  <a:txBody>
-                    <a:bodyPr/>
-                    <a:lstStyle/>
-                    <a:p>
-                      <a:pPr algn="r" indent="0" marL="0">
-                        <a:buNone/>
-                      </a:pPr>
-                      <a:r>
-                        <a:rPr lang="en-US" sz="1250" dirty="0">
-                          <a:solidFill>
-                            <a:srgbClr val="000000"/>
-                          </a:solidFill>
-                          <a:latin typeface="Arial" pitchFamily="34" charset="0"/>
-                          <a:ea typeface="Arial" pitchFamily="34" charset="-122"/>
-                          <a:cs typeface="Arial" pitchFamily="34" charset="-120"/>
-                        </a:rPr>
-                        <a:t>20</a:t>
-                      </a:r>
-                      <a:endParaRPr lang="en-US" sz="1250" dirty="0">
-                        <a:latin typeface="Arial" charset="0"/>
-                        <a:ea typeface="Arial" charset="0"/>
-                        <a:cs typeface="Arial" charset="0"/>
-                      </a:endParaRPr>
-                    </a:p>
-                  </a:txBody>
-                  <a:tcPr marL="91440" marR="91440" marT="45720" marB="45720">
-                    <a:lnL w="12700" cap="flat" cmpd="sng" algn="ctr">
-                      <a:solidFill>
-                        <a:srgbClr val="FFFFFF"/>
-                      </a:solidFill>
-                      <a:prstDash val="solid"/>
-                      <a:round/>
-                      <a:headEnd type="none" w="med" len="med"/>
-                      <a:tailEnd type="none" w="med" len="med"/>
-                    </a:lnL>
-                    <a:lnR w="12700" cap="flat" cmpd="sng" algn="ctr">
-                      <a:solidFill>
-                        <a:srgbClr val="FFFFFF"/>
-                      </a:solidFill>
-                      <a:prstDash val="solid"/>
-                      <a:round/>
-                      <a:headEnd type="none" w="med" len="med"/>
-                      <a:tailEnd type="none" w="med" len="med"/>
-                    </a:lnR>
-                    <a:lnT w="12700" cap="flat" cmpd="sng" algn="ctr">
-                      <a:solidFill>
-                        <a:srgbClr val="FFFFFF"/>
-                      </a:solidFill>
-                      <a:prstDash val="solid"/>
-                      <a:round/>
-                      <a:headEnd type="none" w="med" len="med"/>
-                      <a:tailEnd type="none" w="med" len="med"/>
-                    </a:lnT>
-                    <a:lnB w="12700" cap="flat" cmpd="sng" algn="ctr">
-                      <a:solidFill>
-                        <a:srgbClr val="FFFFFF"/>
-                      </a:solidFill>
-                      <a:prstDash val="solid"/>
-                      <a:round/>
-                      <a:headEnd type="none" w="med" len="med"/>
-                      <a:tailEnd type="none" w="med" len="med"/>
-                    </a:lnB>
-                  </a:tcPr>
-                </a:tc>
-                <a:tc>
-                  <a:txBody>
-                    <a:bodyPr/>
-                    <a:lstStyle/>
-                    <a:p>
-                      <a:pPr algn="r" indent="0" marL="0">
-                        <a:buNone/>
-                      </a:pPr>
-                      <a:r>
-                        <a:rPr lang="en-US" sz="1250" dirty="0">
-                          <a:solidFill>
-                            <a:srgbClr val="000000"/>
-                          </a:solidFill>
-                          <a:latin typeface="Arial" pitchFamily="34" charset="0"/>
-                          <a:ea typeface="Arial" pitchFamily="34" charset="-122"/>
-                          <a:cs typeface="Arial" pitchFamily="34" charset="-120"/>
-                        </a:rPr>
-                        <a:t>18 €</a:t>
-                      </a:r>
-                      <a:endParaRPr lang="en-US" sz="1250" dirty="0">
-                        <a:latin typeface="Arial" charset="0"/>
-                        <a:ea typeface="Arial" charset="0"/>
-                        <a:cs typeface="Arial" charset="0"/>
-                      </a:endParaRPr>
-                    </a:p>
-                  </a:txBody>
-                  <a:tcPr marL="91440" marR="91440" marT="45720" marB="45720">
-                    <a:lnL w="12700" cap="flat" cmpd="sng" algn="ctr">
-                      <a:solidFill>
-                        <a:srgbClr val="FFFFFF"/>
-                      </a:solidFill>
-                      <a:prstDash val="solid"/>
-                      <a:round/>
-                      <a:headEnd type="none" w="med" len="med"/>
-                      <a:tailEnd type="none" w="med" len="med"/>
-                    </a:lnL>
-                    <a:lnR w="12700" cap="flat" cmpd="sng" algn="ctr">
-                      <a:solidFill>
-                        <a:srgbClr val="FFFFFF"/>
-                      </a:solidFill>
-                      <a:prstDash val="solid"/>
-                      <a:round/>
-                      <a:headEnd type="none" w="med" len="med"/>
-                      <a:tailEnd type="none" w="med" len="med"/>
-                    </a:lnR>
-                    <a:lnT w="12700" cap="flat" cmpd="sng" algn="ctr">
-                      <a:solidFill>
-                        <a:srgbClr val="FFFFFF"/>
-                      </a:solidFill>
-                      <a:prstDash val="solid"/>
-                      <a:round/>
-                      <a:headEnd type="none" w="med" len="med"/>
-                      <a:tailEnd type="none" w="med" len="med"/>
-                    </a:lnT>
-                    <a:lnB w="12700" cap="flat" cmpd="sng" algn="ctr">
-                      <a:solidFill>
-                        <a:srgbClr val="FFFFFF"/>
-                      </a:solidFill>
-                      <a:prstDash val="solid"/>
-                      <a:round/>
-                      <a:headEnd type="none" w="med" len="med"/>
-                      <a:tailEnd type="none" w="med" len="med"/>
-                    </a:lnB>
-                  </a:tcPr>
-                </a:tc>
-                <a:tc>
-                  <a:txBody>
-                    <a:bodyPr/>
-                    <a:lstStyle/>
-                    <a:p>
-                      <a:pPr algn="r" indent="0" marL="0">
-                        <a:buNone/>
-                      </a:pPr>
-                      <a:r>
-                        <a:rPr lang="en-US" sz="1250" dirty="0">
-                          <a:solidFill>
-                            <a:srgbClr val="000000"/>
-                          </a:solidFill>
-                          <a:latin typeface="Arial" pitchFamily="34" charset="0"/>
-                          <a:ea typeface="Arial" pitchFamily="34" charset="-122"/>
-                          <a:cs typeface="Arial" pitchFamily="34" charset="-120"/>
-                        </a:rPr>
-                        <a:t>4.680 €</a:t>
+                        <a:t>11.900 €</a:t>
                       </a:r>
                       <a:endParaRPr lang="en-US" sz="1250" dirty="0">
                         <a:latin typeface="Arial" charset="0"/>
@@ -19647,7 +19320,7 @@
                           <a:ea typeface="Arial" pitchFamily="34" charset="-122"/>
                           <a:cs typeface="Arial" pitchFamily="34" charset="-120"/>
                         </a:rPr>
-                        <a:t>70</a:t>
+                        <a:t>90</a:t>
                       </a:r>
                       <a:endParaRPr lang="en-US" sz="1250" dirty="0">
                         <a:latin typeface="Arial" charset="0"/>
@@ -19712,7 +19385,7 @@
                           <a:ea typeface="Arial" pitchFamily="34" charset="-122"/>
                           <a:cs typeface="Arial" pitchFamily="34" charset="-120"/>
                         </a:rPr>
-                        <a:t>22 €</a:t>
+                        <a:t>26 €</a:t>
                       </a:r>
                       <a:endParaRPr lang="en-US" sz="1250" dirty="0">
                         <a:latin typeface="Arial" charset="0"/>
@@ -19777,7 +19450,7 @@
                           <a:ea typeface="Arial" pitchFamily="34" charset="-122"/>
                           <a:cs typeface="Arial" pitchFamily="34" charset="-120"/>
                         </a:rPr>
-                        <a:t>13.860 €</a:t>
+                        <a:t>21.060 €</a:t>
                       </a:r>
                       <a:endParaRPr lang="en-US" sz="1250" dirty="0">
                         <a:latin typeface="Arial" charset="0"/>
@@ -19844,7 +19517,7 @@
                           <a:ea typeface="Arial" pitchFamily="34" charset="-122"/>
                           <a:cs typeface="Arial" pitchFamily="34" charset="-120"/>
                         </a:rPr>
-                        <a:t>Feiern, Live-Abende, Séparée</a:t>
+                        <a:t>Events: Live-Musik, Feiern</a:t>
                       </a:r>
                       <a:endParaRPr lang="en-US" sz="1250" dirty="0">
                         <a:latin typeface="Arial" charset="0"/>
@@ -20039,7 +19712,7 @@
                           <a:ea typeface="Arial" pitchFamily="34" charset="-122"/>
                           <a:cs typeface="Arial" pitchFamily="34" charset="-120"/>
                         </a:rPr>
-                        <a:t>45 €</a:t>
+                        <a:t>40 €</a:t>
                       </a:r>
                       <a:endParaRPr lang="en-US" sz="1250" dirty="0">
                         <a:latin typeface="Arial" charset="0"/>
@@ -20104,7 +19777,7 @@
                           <a:ea typeface="Arial" pitchFamily="34" charset="-122"/>
                           <a:cs typeface="Arial" pitchFamily="34" charset="-120"/>
                         </a:rPr>
-                        <a:t>7.200 €</a:t>
+                        <a:t>6.400 €</a:t>
                       </a:r>
                       <a:endParaRPr lang="en-US" sz="1250" dirty="0">
                         <a:latin typeface="Arial" charset="0"/>
@@ -20398,7 +20071,7 @@
                           <a:ea typeface="Arial" pitchFamily="34" charset="-122"/>
                           <a:cs typeface="Arial" pitchFamily="34" charset="-120"/>
                         </a:rPr>
-                        <a:t>71.500 €</a:t>
+                        <a:t>39.360 €</a:t>
                       </a:r>
                       <a:endParaRPr lang="en-US" sz="1250" dirty="0">
                         <a:latin typeface="Arial" charset="0"/>
@@ -20484,7 +20157,7 @@
                 <a:ea typeface="Georgia" pitchFamily="34" charset="-122"/>
                 <a:cs typeface="Georgia" pitchFamily="34" charset="-120"/>
               </a:rPr>
-              <a:t>75 % vom Gastro-Umsatz</a:t>
+              <a:t>61 % vom Gastro-Umsatz</a:t>
             </a:r>
             <a:endParaRPr lang="en-US" sz="2400" dirty="0"/>
           </a:p>
@@ -22737,7 +22410,7 @@
                           <a:ea typeface="Arial" pitchFamily="34" charset="-122"/>
                           <a:cs typeface="Arial" pitchFamily="34" charset="-120"/>
                         </a:rPr>
-                        <a:t>Bar und Theken-Zone</a:t>
+                        <a:t>Große Bar und Theken-Zone</a:t>
                       </a:r>
                       <a:endParaRPr lang="en-US" sz="1250" dirty="0">
                         <a:latin typeface="Arial" charset="0"/>
@@ -22802,7 +22475,7 @@
                           <a:ea typeface="Arial" pitchFamily="34" charset="-122"/>
                           <a:cs typeface="Arial" pitchFamily="34" charset="-120"/>
                         </a:rPr>
-                        <a:t>ca. 25 m²</a:t>
+                        <a:t>ca. 45 m²</a:t>
                       </a:r>
                       <a:endParaRPr lang="en-US" sz="1250" dirty="0">
                         <a:latin typeface="Arial" charset="0"/>
@@ -23328,7 +23001,7 @@
                           <a:ea typeface="Arial" pitchFamily="34" charset="-122"/>
                           <a:cs typeface="Arial" pitchFamily="34" charset="-120"/>
                         </a:rPr>
-                        <a:t>Küche, Lager, WC, Eingang</a:t>
+                        <a:t>Kleine Küche, Lager, WC, Eingang</a:t>
                       </a:r>
                       <a:endParaRPr lang="en-US" sz="1250" dirty="0">
                         <a:latin typeface="Arial" charset="0"/>
@@ -23393,7 +23066,7 @@
                           <a:ea typeface="Arial" pitchFamily="34" charset="-122"/>
                           <a:cs typeface="Arial" pitchFamily="34" charset="-120"/>
                         </a:rPr>
-                        <a:t>ca. 139 m²</a:t>
+                        <a:t>ca. 119 m²</a:t>
                       </a:r>
                       <a:endParaRPr lang="en-US" sz="1250" dirty="0">
                         <a:latin typeface="Arial" charset="0"/>

</xml_diff>

<commit_message>
Revert "Gastro-Konzept: Frühstück und Bowls tagsüber, abends Bar mit Snacks; Umsatzmodell, Flächen, Personal angepasst"
This reverts commit 93b7f1f13931f73ad5737f3663b8d404f465e8a6.
</commit_message>
<xml_diff>
--- a/praesentation/Neue-Mitte-Werlte_Baufeld3_Gastro-Konzept.pptx
+++ b/praesentation/Neue-Mitte-Werlte_Baufeld3_Gastro-Konzept.pptx
@@ -693,7 +693,7 @@
           <a:p>
             <a:r>
               <a:rPr lang="en-US" dirty="0"/>
-              <a:t>Plausibilitätsrechnung mit Annahmen für Gäste und Bon. Ca. 4.100 € Umsatz je Sitzplatz und Jahr bei 190 Plätzen, Branchen-Median Österreich ca. 12.000 €.</a:t>
+              <a:t>Plausibilitätsrechnung mit Annahmen für Gäste und Bon. Ca. 6.000 € Umsatz je Sitzplatz und Jahr bei 190 Plätzen, Branchen-Median Österreich ca. 12.000 €.</a:t>
             </a:r>
             <a:endParaRPr lang="en-US" dirty="0"/>
           </a:p>
@@ -1397,7 +1397,7 @@
           <a:p>
             <a:r>
               <a:rPr lang="en-US" dirty="0"/>
-              <a:t>Vorschlag für Öffnungszeiten, Ruhetag Montag. Hauptfokus ist der Abend an der Bar. Snacks bis kurz vor Schluss.</a:t>
+              <a:t>Vorschlag für Öffnungszeiten, Ruhetag Montag. Hauptfokus ist der Abend. Küche warm bis ca. 21:30 Uhr.</a:t>
             </a:r>
             <a:endParaRPr lang="en-US" dirty="0"/>
           </a:p>
@@ -2561,7 +2561,7 @@
                 <a:ea typeface="Arial" pitchFamily="34" charset="-122"/>
                 <a:cs typeface="Arial" pitchFamily="34" charset="-120"/>
               </a:rPr>
-              <a:t>Frühstück, Bowls und Bar für den ganzen Tag, ca. 510 m² im ganzen EG</a:t>
+              <a:t>Bar-Restaurant für den ganzen Tag, ca. 510 m² im ganzen EG</a:t>
             </a:r>
             <a:endParaRPr lang="en-US" sz="1700" dirty="0"/>
           </a:p>
@@ -2980,7 +2980,7 @@
                 <a:ea typeface="Georgia" pitchFamily="34" charset="-122"/>
                 <a:cs typeface="Georgia" pitchFamily="34" charset="-120"/>
               </a:rPr>
-              <a:t>Wie 65.010 € Umsatz im Monat zusammenkommen</a:t>
+              <a:t>Wie 95.635 € Umsatz im Monat zusammenkommen</a:t>
             </a:r>
             <a:endParaRPr lang="en-US" sz="2700" dirty="0"/>
           </a:p>
@@ -3541,7 +3541,7 @@
                           <a:ea typeface="Arial" pitchFamily="34" charset="-122"/>
                           <a:cs typeface="Arial" pitchFamily="34" charset="-120"/>
                         </a:rPr>
-                        <a:t>30</a:t>
+                        <a:t>25</a:t>
                       </a:r>
                       <a:endParaRPr lang="en-US" sz="1250" dirty="0">
                         <a:latin typeface="Arial" charset="0"/>
@@ -3671,7 +3671,7 @@
                           <a:ea typeface="Arial" pitchFamily="34" charset="-122"/>
                           <a:cs typeface="Arial" pitchFamily="34" charset="-120"/>
                         </a:rPr>
-                        <a:t>5.610 €</a:t>
+                        <a:t>4.675 €</a:t>
                       </a:r>
                       <a:endParaRPr lang="en-US" sz="1250" dirty="0">
                         <a:latin typeface="Arial" charset="0"/>
@@ -4065,7 +4065,7 @@
                           <a:ea typeface="Arial" pitchFamily="34" charset="-122"/>
                           <a:cs typeface="Arial" pitchFamily="34" charset="-120"/>
                         </a:rPr>
-                        <a:t>Mittag: Bowls, Salate, Suppe (Di–Fr 11:30–14:30)</a:t>
+                        <a:t>Mittagstisch (Di–Fr 11:30–14:30)</a:t>
                       </a:r>
                       <a:endParaRPr lang="en-US" sz="1250" dirty="0">
                         <a:latin typeface="Arial" charset="0"/>
@@ -4195,7 +4195,7 @@
                           <a:ea typeface="Arial" pitchFamily="34" charset="-122"/>
                           <a:cs typeface="Arial" pitchFamily="34" charset="-120"/>
                         </a:rPr>
-                        <a:t>40</a:t>
+                        <a:t>50</a:t>
                       </a:r>
                       <a:endParaRPr lang="en-US" sz="1250" dirty="0">
                         <a:latin typeface="Arial" charset="0"/>
@@ -4260,7 +4260,7 @@
                           <a:ea typeface="Arial" pitchFamily="34" charset="-122"/>
                           <a:cs typeface="Arial" pitchFamily="34" charset="-120"/>
                         </a:rPr>
-                        <a:t>13 €</a:t>
+                        <a:t>14 €</a:t>
                       </a:r>
                       <a:endParaRPr lang="en-US" sz="1250" dirty="0">
                         <a:latin typeface="Arial" charset="0"/>
@@ -4325,7 +4325,7 @@
                           <a:ea typeface="Arial" pitchFamily="34" charset="-122"/>
                           <a:cs typeface="Arial" pitchFamily="34" charset="-120"/>
                         </a:rPr>
-                        <a:t>8.840 €</a:t>
+                        <a:t>11.900 €</a:t>
                       </a:r>
                       <a:endParaRPr lang="en-US" sz="1250" dirty="0">
                         <a:latin typeface="Arial" charset="0"/>
@@ -4392,7 +4392,7 @@
                           <a:ea typeface="Arial" pitchFamily="34" charset="-122"/>
                           <a:cs typeface="Arial" pitchFamily="34" charset="-120"/>
                         </a:rPr>
-                        <a:t>Nachmittag: Kaffee, Kuchen, Snacks (Di–So 14:30–17:00)</a:t>
+                        <a:t>Abendessen Restaurant (Di–So 17:30–22:00)</a:t>
                       </a:r>
                       <a:endParaRPr lang="en-US" sz="1250" dirty="0">
                         <a:latin typeface="Arial" charset="0"/>
@@ -4522,7 +4522,7 @@
                           <a:ea typeface="Arial" pitchFamily="34" charset="-122"/>
                           <a:cs typeface="Arial" pitchFamily="34" charset="-120"/>
                         </a:rPr>
-                        <a:t>20</a:t>
+                        <a:t>55</a:t>
                       </a:r>
                       <a:endParaRPr lang="en-US" sz="1250" dirty="0">
                         <a:latin typeface="Arial" charset="0"/>
@@ -4587,7 +4587,7 @@
                           <a:ea typeface="Arial" pitchFamily="34" charset="-122"/>
                           <a:cs typeface="Arial" pitchFamily="34" charset="-120"/>
                         </a:rPr>
-                        <a:t>7 €</a:t>
+                        <a:t>32 €</a:t>
                       </a:r>
                       <a:endParaRPr lang="en-US" sz="1250" dirty="0">
                         <a:latin typeface="Arial" charset="0"/>
@@ -4652,7 +4652,7 @@
                           <a:ea typeface="Arial" pitchFamily="34" charset="-122"/>
                           <a:cs typeface="Arial" pitchFamily="34" charset="-120"/>
                         </a:rPr>
-                        <a:t>3.640 €</a:t>
+                        <a:t>45.760 €</a:t>
                       </a:r>
                       <a:endParaRPr lang="en-US" sz="1250" dirty="0">
                         <a:latin typeface="Arial" charset="0"/>
@@ -4719,7 +4719,7 @@
                           <a:ea typeface="Arial" pitchFamily="34" charset="-122"/>
                           <a:cs typeface="Arial" pitchFamily="34" charset="-120"/>
                         </a:rPr>
-                        <a:t>Bar mit Snacks Di–Do, So (ab 17:00)</a:t>
+                        <a:t>Bar Di–Do (ab 21:00)</a:t>
                       </a:r>
                       <a:endParaRPr lang="en-US" sz="1250" dirty="0">
                         <a:latin typeface="Arial" charset="0"/>
@@ -4784,7 +4784,7 @@
                           <a:ea typeface="Arial" pitchFamily="34" charset="-122"/>
                           <a:cs typeface="Arial" pitchFamily="34" charset="-120"/>
                         </a:rPr>
-                        <a:t>17</a:t>
+                        <a:t>13</a:t>
                       </a:r>
                       <a:endParaRPr lang="en-US" sz="1250" dirty="0">
                         <a:latin typeface="Arial" charset="0"/>
@@ -4849,7 +4849,7 @@
                           <a:ea typeface="Arial" pitchFamily="34" charset="-122"/>
                           <a:cs typeface="Arial" pitchFamily="34" charset="-120"/>
                         </a:rPr>
-                        <a:t>35</a:t>
+                        <a:t>20</a:t>
                       </a:r>
                       <a:endParaRPr lang="en-US" sz="1250" dirty="0">
                         <a:latin typeface="Arial" charset="0"/>
@@ -4914,7 +4914,7 @@
                           <a:ea typeface="Arial" pitchFamily="34" charset="-122"/>
                           <a:cs typeface="Arial" pitchFamily="34" charset="-120"/>
                         </a:rPr>
-                        <a:t>20 €</a:t>
+                        <a:t>18 €</a:t>
                       </a:r>
                       <a:endParaRPr lang="en-US" sz="1250" dirty="0">
                         <a:latin typeface="Arial" charset="0"/>
@@ -4979,7 +4979,7 @@
                           <a:ea typeface="Arial" pitchFamily="34" charset="-122"/>
                           <a:cs typeface="Arial" pitchFamily="34" charset="-120"/>
                         </a:rPr>
-                        <a:t>11.900 €</a:t>
+                        <a:t>4.680 €</a:t>
                       </a:r>
                       <a:endParaRPr lang="en-US" sz="1250" dirty="0">
                         <a:latin typeface="Arial" charset="0"/>
@@ -5046,7 +5046,7 @@
                           <a:ea typeface="Arial" pitchFamily="34" charset="-122"/>
                           <a:cs typeface="Arial" pitchFamily="34" charset="-120"/>
                         </a:rPr>
-                        <a:t>Bar Fr, Sa (bis 01:00) (Cocktails, Wein, Bier, Snacks)</a:t>
+                        <a:t>Bar Fr, Sa (bis 01:00) (Cocktails, Wein, Bier, Musik)</a:t>
                       </a:r>
                       <a:endParaRPr lang="en-US" sz="1250" dirty="0">
                         <a:latin typeface="Arial" charset="0"/>
@@ -5176,7 +5176,7 @@
                           <a:ea typeface="Arial" pitchFamily="34" charset="-122"/>
                           <a:cs typeface="Arial" pitchFamily="34" charset="-120"/>
                         </a:rPr>
-                        <a:t>90</a:t>
+                        <a:t>70</a:t>
                       </a:r>
                       <a:endParaRPr lang="en-US" sz="1250" dirty="0">
                         <a:latin typeface="Arial" charset="0"/>
@@ -5241,7 +5241,7 @@
                           <a:ea typeface="Arial" pitchFamily="34" charset="-122"/>
                           <a:cs typeface="Arial" pitchFamily="34" charset="-120"/>
                         </a:rPr>
-                        <a:t>26 €</a:t>
+                        <a:t>22 €</a:t>
                       </a:r>
                       <a:endParaRPr lang="en-US" sz="1250" dirty="0">
                         <a:latin typeface="Arial" charset="0"/>
@@ -5306,7 +5306,7 @@
                           <a:ea typeface="Arial" pitchFamily="34" charset="-122"/>
                           <a:cs typeface="Arial" pitchFamily="34" charset="-120"/>
                         </a:rPr>
-                        <a:t>21.060 €</a:t>
+                        <a:t>13.860 €</a:t>
                       </a:r>
                       <a:endParaRPr lang="en-US" sz="1250" dirty="0">
                         <a:latin typeface="Arial" charset="0"/>
@@ -5373,7 +5373,7 @@
                           <a:ea typeface="Arial" pitchFamily="34" charset="-122"/>
                           <a:cs typeface="Arial" pitchFamily="34" charset="-120"/>
                         </a:rPr>
-                        <a:t>Events: Live-Musik, Feiern (nach Absprache, 4 pro Monat)</a:t>
+                        <a:t>Feiern, Live-Abende, Séparée (nach Absprache, 4 pro Monat)</a:t>
                       </a:r>
                       <a:endParaRPr lang="en-US" sz="1250" dirty="0">
                         <a:latin typeface="Arial" charset="0"/>
@@ -5568,7 +5568,7 @@
                           <a:ea typeface="Arial" pitchFamily="34" charset="-122"/>
                           <a:cs typeface="Arial" pitchFamily="34" charset="-120"/>
                         </a:rPr>
-                        <a:t>40 €</a:t>
+                        <a:t>45 €</a:t>
                       </a:r>
                       <a:endParaRPr lang="en-US" sz="1250" dirty="0">
                         <a:latin typeface="Arial" charset="0"/>
@@ -5633,7 +5633,7 @@
                           <a:ea typeface="Arial" pitchFamily="34" charset="-122"/>
                           <a:cs typeface="Arial" pitchFamily="34" charset="-120"/>
                         </a:rPr>
-                        <a:t>6.400 €</a:t>
+                        <a:t>7.200 €</a:t>
                       </a:r>
                       <a:endParaRPr lang="en-US" sz="1250" dirty="0">
                         <a:latin typeface="Arial" charset="0"/>
@@ -5927,7 +5927,7 @@
                           <a:ea typeface="Arial" pitchFamily="34" charset="-122"/>
                           <a:cs typeface="Arial" pitchFamily="34" charset="-120"/>
                         </a:rPr>
-                        <a:t>65.010 €</a:t>
+                        <a:t>95.635 €</a:t>
                       </a:r>
                       <a:endParaRPr lang="en-US" sz="1250" dirty="0">
                         <a:latin typeface="Arial" charset="0"/>
@@ -6057,7 +6057,7 @@
                 <a:ea typeface="Arial" pitchFamily="34" charset="-122"/>
                 <a:cs typeface="Arial" pitchFamily="34" charset="-120"/>
               </a:rPr>
-              <a:t>Ca. 3.815 Gäste im Monat, im Schnitt ca. 147 pro Öffnungstag bei 190 Plätzen. Der Abend (Bar mit Snacks, Events) bringt 61 % vom Umsatz.</a:t>
+              <a:t>Ca. 4.295 Gäste im Monat, im Schnitt ca. 165 pro Öffnungstag bei 190 Plätzen. Der Abend (Restaurant, Bar, Feiern) bringt 75 % vom Umsatz.</a:t>
             </a:r>
             <a:endParaRPr lang="en-US" sz="1300" dirty="0"/>
           </a:p>
@@ -6512,7 +6512,7 @@
                           <a:ea typeface="Arial" pitchFamily="34" charset="-122"/>
                           <a:cs typeface="Arial" pitchFamily="34" charset="-120"/>
                         </a:rPr>
-                        <a:t>Küchenleitung (Bowls, Snacks)</a:t>
+                        <a:t>Küchenchef</a:t>
                       </a:r>
                       <a:endParaRPr lang="en-US" sz="1250" dirty="0">
                         <a:latin typeface="Arial" charset="0"/>
@@ -6642,7 +6642,7 @@
                           <a:ea typeface="Arial" pitchFamily="34" charset="-122"/>
                           <a:cs typeface="Arial" pitchFamily="34" charset="-120"/>
                         </a:rPr>
-                        <a:t>3.400 €</a:t>
+                        <a:t>4.200 €</a:t>
                       </a:r>
                       <a:endParaRPr lang="en-US" sz="1250" dirty="0">
                         <a:latin typeface="Arial" charset="0"/>
@@ -6709,7 +6709,204 @@
                           <a:ea typeface="Arial" pitchFamily="34" charset="-122"/>
                           <a:cs typeface="Arial" pitchFamily="34" charset="-120"/>
                         </a:rPr>
-                        <a:t>Küchenhilfe</a:t>
+                        <a:t>Koch</a:t>
+                      </a:r>
+                      <a:endParaRPr lang="en-US" sz="1250" dirty="0">
+                        <a:latin typeface="Arial" charset="0"/>
+                        <a:ea typeface="Arial" charset="0"/>
+                        <a:cs typeface="Arial" charset="0"/>
+                      </a:endParaRPr>
+                    </a:p>
+                  </a:txBody>
+                  <a:tcPr marL="91440" marR="91440" marT="45720" marB="45720">
+                    <a:lnL w="12700" cap="flat" cmpd="sng" algn="ctr">
+                      <a:solidFill>
+                        <a:srgbClr val="FFFFFF"/>
+                      </a:solidFill>
+                      <a:prstDash val="solid"/>
+                      <a:round/>
+                      <a:headEnd type="none" w="med" len="med"/>
+                      <a:tailEnd type="none" w="med" len="med"/>
+                    </a:lnL>
+                    <a:lnR w="12700" cap="flat" cmpd="sng" algn="ctr">
+                      <a:solidFill>
+                        <a:srgbClr val="FFFFFF"/>
+                      </a:solidFill>
+                      <a:prstDash val="solid"/>
+                      <a:round/>
+                      <a:headEnd type="none" w="med" len="med"/>
+                      <a:tailEnd type="none" w="med" len="med"/>
+                    </a:lnR>
+                    <a:lnT w="12700" cap="flat" cmpd="sng" algn="ctr">
+                      <a:solidFill>
+                        <a:srgbClr val="FFFFFF"/>
+                      </a:solidFill>
+                      <a:prstDash val="solid"/>
+                      <a:round/>
+                      <a:headEnd type="none" w="med" len="med"/>
+                      <a:tailEnd type="none" w="med" len="med"/>
+                    </a:lnT>
+                    <a:lnB w="12700" cap="flat" cmpd="sng" algn="ctr">
+                      <a:solidFill>
+                        <a:srgbClr val="FFFFFF"/>
+                      </a:solidFill>
+                      <a:prstDash val="solid"/>
+                      <a:round/>
+                      <a:headEnd type="none" w="med" len="med"/>
+                      <a:tailEnd type="none" w="med" len="med"/>
+                    </a:lnB>
+                  </a:tcPr>
+                </a:tc>
+                <a:tc>
+                  <a:txBody>
+                    <a:bodyPr/>
+                    <a:lstStyle/>
+                    <a:p>
+                      <a:pPr indent="0" marL="0">
+                        <a:buNone/>
+                      </a:pPr>
+                      <a:r>
+                        <a:rPr lang="en-US" sz="1250" dirty="0">
+                          <a:solidFill>
+                            <a:srgbClr val="000000"/>
+                          </a:solidFill>
+                          <a:latin typeface="Arial" pitchFamily="34" charset="0"/>
+                          <a:ea typeface="Arial" pitchFamily="34" charset="-122"/>
+                          <a:cs typeface="Arial" pitchFamily="34" charset="-120"/>
+                        </a:rPr>
+                        <a:t>1 Vollzeit</a:t>
+                      </a:r>
+                      <a:endParaRPr lang="en-US" sz="1250" dirty="0">
+                        <a:latin typeface="Arial" charset="0"/>
+                        <a:ea typeface="Arial" charset="0"/>
+                        <a:cs typeface="Arial" charset="0"/>
+                      </a:endParaRPr>
+                    </a:p>
+                  </a:txBody>
+                  <a:tcPr marL="91440" marR="91440" marT="45720" marB="45720">
+                    <a:lnL w="12700" cap="flat" cmpd="sng" algn="ctr">
+                      <a:solidFill>
+                        <a:srgbClr val="FFFFFF"/>
+                      </a:solidFill>
+                      <a:prstDash val="solid"/>
+                      <a:round/>
+                      <a:headEnd type="none" w="med" len="med"/>
+                      <a:tailEnd type="none" w="med" len="med"/>
+                    </a:lnL>
+                    <a:lnR w="12700" cap="flat" cmpd="sng" algn="ctr">
+                      <a:solidFill>
+                        <a:srgbClr val="FFFFFF"/>
+                      </a:solidFill>
+                      <a:prstDash val="solid"/>
+                      <a:round/>
+                      <a:headEnd type="none" w="med" len="med"/>
+                      <a:tailEnd type="none" w="med" len="med"/>
+                    </a:lnR>
+                    <a:lnT w="12700" cap="flat" cmpd="sng" algn="ctr">
+                      <a:solidFill>
+                        <a:srgbClr val="FFFFFF"/>
+                      </a:solidFill>
+                      <a:prstDash val="solid"/>
+                      <a:round/>
+                      <a:headEnd type="none" w="med" len="med"/>
+                      <a:tailEnd type="none" w="med" len="med"/>
+                    </a:lnT>
+                    <a:lnB w="12700" cap="flat" cmpd="sng" algn="ctr">
+                      <a:solidFill>
+                        <a:srgbClr val="FFFFFF"/>
+                      </a:solidFill>
+                      <a:prstDash val="solid"/>
+                      <a:round/>
+                      <a:headEnd type="none" w="med" len="med"/>
+                      <a:tailEnd type="none" w="med" len="med"/>
+                    </a:lnB>
+                  </a:tcPr>
+                </a:tc>
+                <a:tc>
+                  <a:txBody>
+                    <a:bodyPr/>
+                    <a:lstStyle/>
+                    <a:p>
+                      <a:pPr algn="r" indent="0" marL="0">
+                        <a:buNone/>
+                      </a:pPr>
+                      <a:r>
+                        <a:rPr lang="en-US" sz="1250" dirty="0">
+                          <a:solidFill>
+                            <a:srgbClr val="000000"/>
+                          </a:solidFill>
+                          <a:latin typeface="Arial" pitchFamily="34" charset="0"/>
+                          <a:ea typeface="Arial" pitchFamily="34" charset="-122"/>
+                          <a:cs typeface="Arial" pitchFamily="34" charset="-120"/>
+                        </a:rPr>
+                        <a:t>3.400 €</a:t>
+                      </a:r>
+                      <a:endParaRPr lang="en-US" sz="1250" dirty="0">
+                        <a:latin typeface="Arial" charset="0"/>
+                        <a:ea typeface="Arial" charset="0"/>
+                        <a:cs typeface="Arial" charset="0"/>
+                      </a:endParaRPr>
+                    </a:p>
+                  </a:txBody>
+                  <a:tcPr marL="91440" marR="91440" marT="45720" marB="45720">
+                    <a:lnL w="12700" cap="flat" cmpd="sng" algn="ctr">
+                      <a:solidFill>
+                        <a:srgbClr val="FFFFFF"/>
+                      </a:solidFill>
+                      <a:prstDash val="solid"/>
+                      <a:round/>
+                      <a:headEnd type="none" w="med" len="med"/>
+                      <a:tailEnd type="none" w="med" len="med"/>
+                    </a:lnL>
+                    <a:lnR w="12700" cap="flat" cmpd="sng" algn="ctr">
+                      <a:solidFill>
+                        <a:srgbClr val="FFFFFF"/>
+                      </a:solidFill>
+                      <a:prstDash val="solid"/>
+                      <a:round/>
+                      <a:headEnd type="none" w="med" len="med"/>
+                      <a:tailEnd type="none" w="med" len="med"/>
+                    </a:lnR>
+                    <a:lnT w="12700" cap="flat" cmpd="sng" algn="ctr">
+                      <a:solidFill>
+                        <a:srgbClr val="FFFFFF"/>
+                      </a:solidFill>
+                      <a:prstDash val="solid"/>
+                      <a:round/>
+                      <a:headEnd type="none" w="med" len="med"/>
+                      <a:tailEnd type="none" w="med" len="med"/>
+                    </a:lnT>
+                    <a:lnB w="12700" cap="flat" cmpd="sng" algn="ctr">
+                      <a:solidFill>
+                        <a:srgbClr val="FFFFFF"/>
+                      </a:solidFill>
+                      <a:prstDash val="solid"/>
+                      <a:round/>
+                      <a:headEnd type="none" w="med" len="med"/>
+                      <a:tailEnd type="none" w="med" len="med"/>
+                    </a:lnB>
+                  </a:tcPr>
+                </a:tc>
+              </a:tr>
+              <a:tr h="502920">
+                <a:tc>
+                  <a:txBody>
+                    <a:bodyPr/>
+                    <a:lstStyle/>
+                    <a:p>
+                      <a:pPr indent="0" marL="0">
+                        <a:buNone/>
+                      </a:pPr>
+                      <a:r>
+                        <a:rPr lang="en-US" sz="1250" dirty="0">
+                          <a:solidFill>
+                            <a:srgbClr val="000000"/>
+                          </a:solidFill>
+                          <a:latin typeface="Arial" pitchFamily="34" charset="0"/>
+                          <a:ea typeface="Arial" pitchFamily="34" charset="-122"/>
+                          <a:cs typeface="Arial" pitchFamily="34" charset="-120"/>
+                        </a:rPr>
+                        <a:t>Koch</a:t>
                       </a:r>
                       <a:endParaRPr lang="en-US" sz="1250" dirty="0">
                         <a:latin typeface="Arial" charset="0"/>
@@ -6906,7 +7103,7 @@
                           <a:ea typeface="Arial" pitchFamily="34" charset="-122"/>
                           <a:cs typeface="Arial" pitchFamily="34" charset="-120"/>
                         </a:rPr>
-                        <a:t>Spülen, Frühstücksservice</a:t>
+                        <a:t>Küchenhilfe, Spülen</a:t>
                       </a:r>
                       <a:endParaRPr lang="en-US" sz="1250" dirty="0">
                         <a:latin typeface="Arial" charset="0"/>
@@ -6971,7 +7168,7 @@
                           <a:ea typeface="Arial" pitchFamily="34" charset="-122"/>
                           <a:cs typeface="Arial" pitchFamily="34" charset="-120"/>
                         </a:rPr>
-                        <a:t>1 Teilzeit</a:t>
+                        <a:t>2 Teilzeit</a:t>
                       </a:r>
                       <a:endParaRPr lang="en-US" sz="1250" dirty="0">
                         <a:latin typeface="Arial" charset="0"/>
@@ -7036,204 +7233,7 @@
                           <a:ea typeface="Arial" pitchFamily="34" charset="-122"/>
                           <a:cs typeface="Arial" pitchFamily="34" charset="-120"/>
                         </a:rPr>
-                        <a:t>1.400 €</a:t>
-                      </a:r>
-                      <a:endParaRPr lang="en-US" sz="1250" dirty="0">
-                        <a:latin typeface="Arial" charset="0"/>
-                        <a:ea typeface="Arial" charset="0"/>
-                        <a:cs typeface="Arial" charset="0"/>
-                      </a:endParaRPr>
-                    </a:p>
-                  </a:txBody>
-                  <a:tcPr marL="91440" marR="91440" marT="45720" marB="45720">
-                    <a:lnL w="12700" cap="flat" cmpd="sng" algn="ctr">
-                      <a:solidFill>
-                        <a:srgbClr val="FFFFFF"/>
-                      </a:solidFill>
-                      <a:prstDash val="solid"/>
-                      <a:round/>
-                      <a:headEnd type="none" w="med" len="med"/>
-                      <a:tailEnd type="none" w="med" len="med"/>
-                    </a:lnL>
-                    <a:lnR w="12700" cap="flat" cmpd="sng" algn="ctr">
-                      <a:solidFill>
-                        <a:srgbClr val="FFFFFF"/>
-                      </a:solidFill>
-                      <a:prstDash val="solid"/>
-                      <a:round/>
-                      <a:headEnd type="none" w="med" len="med"/>
-                      <a:tailEnd type="none" w="med" len="med"/>
-                    </a:lnR>
-                    <a:lnT w="12700" cap="flat" cmpd="sng" algn="ctr">
-                      <a:solidFill>
-                        <a:srgbClr val="FFFFFF"/>
-                      </a:solidFill>
-                      <a:prstDash val="solid"/>
-                      <a:round/>
-                      <a:headEnd type="none" w="med" len="med"/>
-                      <a:tailEnd type="none" w="med" len="med"/>
-                    </a:lnT>
-                    <a:lnB w="12700" cap="flat" cmpd="sng" algn="ctr">
-                      <a:solidFill>
-                        <a:srgbClr val="FFFFFF"/>
-                      </a:solidFill>
-                      <a:prstDash val="solid"/>
-                      <a:round/>
-                      <a:headEnd type="none" w="med" len="med"/>
-                      <a:tailEnd type="none" w="med" len="med"/>
-                    </a:lnB>
-                  </a:tcPr>
-                </a:tc>
-              </a:tr>
-              <a:tr h="502920">
-                <a:tc>
-                  <a:txBody>
-                    <a:bodyPr/>
-                    <a:lstStyle/>
-                    <a:p>
-                      <a:pPr indent="0" marL="0">
-                        <a:buNone/>
-                      </a:pPr>
-                      <a:r>
-                        <a:rPr lang="en-US" sz="1250" dirty="0">
-                          <a:solidFill>
-                            <a:srgbClr val="000000"/>
-                          </a:solidFill>
-                          <a:latin typeface="Arial" pitchFamily="34" charset="0"/>
-                          <a:ea typeface="Arial" pitchFamily="34" charset="-122"/>
-                          <a:cs typeface="Arial" pitchFamily="34" charset="-120"/>
-                        </a:rPr>
-                        <a:t>Barchef</a:t>
-                      </a:r>
-                      <a:endParaRPr lang="en-US" sz="1250" dirty="0">
-                        <a:latin typeface="Arial" charset="0"/>
-                        <a:ea typeface="Arial" charset="0"/>
-                        <a:cs typeface="Arial" charset="0"/>
-                      </a:endParaRPr>
-                    </a:p>
-                  </a:txBody>
-                  <a:tcPr marL="91440" marR="91440" marT="45720" marB="45720">
-                    <a:lnL w="12700" cap="flat" cmpd="sng" algn="ctr">
-                      <a:solidFill>
-                        <a:srgbClr val="FFFFFF"/>
-                      </a:solidFill>
-                      <a:prstDash val="solid"/>
-                      <a:round/>
-                      <a:headEnd type="none" w="med" len="med"/>
-                      <a:tailEnd type="none" w="med" len="med"/>
-                    </a:lnL>
-                    <a:lnR w="12700" cap="flat" cmpd="sng" algn="ctr">
-                      <a:solidFill>
-                        <a:srgbClr val="FFFFFF"/>
-                      </a:solidFill>
-                      <a:prstDash val="solid"/>
-                      <a:round/>
-                      <a:headEnd type="none" w="med" len="med"/>
-                      <a:tailEnd type="none" w="med" len="med"/>
-                    </a:lnR>
-                    <a:lnT w="12700" cap="flat" cmpd="sng" algn="ctr">
-                      <a:solidFill>
-                        <a:srgbClr val="FFFFFF"/>
-                      </a:solidFill>
-                      <a:prstDash val="solid"/>
-                      <a:round/>
-                      <a:headEnd type="none" w="med" len="med"/>
-                      <a:tailEnd type="none" w="med" len="med"/>
-                    </a:lnT>
-                    <a:lnB w="12700" cap="flat" cmpd="sng" algn="ctr">
-                      <a:solidFill>
-                        <a:srgbClr val="FFFFFF"/>
-                      </a:solidFill>
-                      <a:prstDash val="solid"/>
-                      <a:round/>
-                      <a:headEnd type="none" w="med" len="med"/>
-                      <a:tailEnd type="none" w="med" len="med"/>
-                    </a:lnB>
-                  </a:tcPr>
-                </a:tc>
-                <a:tc>
-                  <a:txBody>
-                    <a:bodyPr/>
-                    <a:lstStyle/>
-                    <a:p>
-                      <a:pPr indent="0" marL="0">
-                        <a:buNone/>
-                      </a:pPr>
-                      <a:r>
-                        <a:rPr lang="en-US" sz="1250" dirty="0">
-                          <a:solidFill>
-                            <a:srgbClr val="000000"/>
-                          </a:solidFill>
-                          <a:latin typeface="Arial" pitchFamily="34" charset="0"/>
-                          <a:ea typeface="Arial" pitchFamily="34" charset="-122"/>
-                          <a:cs typeface="Arial" pitchFamily="34" charset="-120"/>
-                        </a:rPr>
-                        <a:t>1 Vollzeit</a:t>
-                      </a:r>
-                      <a:endParaRPr lang="en-US" sz="1250" dirty="0">
-                        <a:latin typeface="Arial" charset="0"/>
-                        <a:ea typeface="Arial" charset="0"/>
-                        <a:cs typeface="Arial" charset="0"/>
-                      </a:endParaRPr>
-                    </a:p>
-                  </a:txBody>
-                  <a:tcPr marL="91440" marR="91440" marT="45720" marB="45720">
-                    <a:lnL w="12700" cap="flat" cmpd="sng" algn="ctr">
-                      <a:solidFill>
-                        <a:srgbClr val="FFFFFF"/>
-                      </a:solidFill>
-                      <a:prstDash val="solid"/>
-                      <a:round/>
-                      <a:headEnd type="none" w="med" len="med"/>
-                      <a:tailEnd type="none" w="med" len="med"/>
-                    </a:lnL>
-                    <a:lnR w="12700" cap="flat" cmpd="sng" algn="ctr">
-                      <a:solidFill>
-                        <a:srgbClr val="FFFFFF"/>
-                      </a:solidFill>
-                      <a:prstDash val="solid"/>
-                      <a:round/>
-                      <a:headEnd type="none" w="med" len="med"/>
-                      <a:tailEnd type="none" w="med" len="med"/>
-                    </a:lnR>
-                    <a:lnT w="12700" cap="flat" cmpd="sng" algn="ctr">
-                      <a:solidFill>
-                        <a:srgbClr val="FFFFFF"/>
-                      </a:solidFill>
-                      <a:prstDash val="solid"/>
-                      <a:round/>
-                      <a:headEnd type="none" w="med" len="med"/>
-                      <a:tailEnd type="none" w="med" len="med"/>
-                    </a:lnT>
-                    <a:lnB w="12700" cap="flat" cmpd="sng" algn="ctr">
-                      <a:solidFill>
-                        <a:srgbClr val="FFFFFF"/>
-                      </a:solidFill>
-                      <a:prstDash val="solid"/>
-                      <a:round/>
-                      <a:headEnd type="none" w="med" len="med"/>
-                      <a:tailEnd type="none" w="med" len="med"/>
-                    </a:lnB>
-                  </a:tcPr>
-                </a:tc>
-                <a:tc>
-                  <a:txBody>
-                    <a:bodyPr/>
-                    <a:lstStyle/>
-                    <a:p>
-                      <a:pPr algn="r" indent="0" marL="0">
-                        <a:buNone/>
-                      </a:pPr>
-                      <a:r>
-                        <a:rPr lang="en-US" sz="1250" dirty="0">
-                          <a:solidFill>
-                            <a:srgbClr val="000000"/>
-                          </a:solidFill>
-                          <a:latin typeface="Arial" pitchFamily="34" charset="0"/>
-                          <a:ea typeface="Arial" pitchFamily="34" charset="-122"/>
-                          <a:cs typeface="Arial" pitchFamily="34" charset="-120"/>
-                        </a:rPr>
-                        <a:t>3.200 €</a:t>
+                        <a:t>2.800 €</a:t>
                       </a:r>
                       <a:endParaRPr lang="en-US" sz="1250" dirty="0">
                         <a:latin typeface="Arial" charset="0"/>
@@ -7365,7 +7365,7 @@
                           <a:ea typeface="Arial" pitchFamily="34" charset="-122"/>
                           <a:cs typeface="Arial" pitchFamily="34" charset="-120"/>
                         </a:rPr>
-                        <a:t>ca. 8 Teilzeit und Minijobs</a:t>
+                        <a:t>ca. 7 Teilzeit und Minijobs</a:t>
                       </a:r>
                       <a:endParaRPr lang="en-US" sz="1250" dirty="0">
                         <a:latin typeface="Arial" charset="0"/>
@@ -7430,7 +7430,7 @@
                           <a:ea typeface="Arial" pitchFamily="34" charset="-122"/>
                           <a:cs typeface="Arial" pitchFamily="34" charset="-120"/>
                         </a:rPr>
-                        <a:t>7.600 €</a:t>
+                        <a:t>6.700 €</a:t>
                       </a:r>
                       <a:endParaRPr lang="en-US" sz="1250" dirty="0">
                         <a:latin typeface="Arial" charset="0"/>
@@ -7562,7 +7562,7 @@
                           <a:ea typeface="Arial" pitchFamily="34" charset="-122"/>
                           <a:cs typeface="Arial" pitchFamily="34" charset="-120"/>
                         </a:rPr>
-                        <a:t>entspricht 28 % vom Umsatz</a:t>
+                        <a:t>entspricht 20 % vom Umsatz</a:t>
                       </a:r>
                       <a:endParaRPr lang="en-US" sz="1250" dirty="0">
                         <a:latin typeface="Arial" charset="0"/>
@@ -7627,7 +7627,7 @@
                           <a:ea typeface="Arial" pitchFamily="34" charset="-122"/>
                           <a:cs typeface="Arial" pitchFamily="34" charset="-120"/>
                         </a:rPr>
-                        <a:t>18.000 €</a:t>
+                        <a:t>19.500 €</a:t>
                       </a:r>
                       <a:endParaRPr lang="en-US" sz="1250" dirty="0">
                         <a:latin typeface="Arial" charset="0"/>
@@ -7757,7 +7757,7 @@
                 <a:ea typeface="Arial" pitchFamily="34" charset="-122"/>
                 <a:cs typeface="Arial" pitchFamily="34" charset="-120"/>
               </a:rPr>
-              <a:t>Du führst die Gastro selbst oder verpachtest sie. Bei Verpachtung zahlt der Betreiber ca. 10 €/m² Pacht, das sind bei 510 m² ca. 5.100 € im Monat (ca. 7.8 % vom Umsatz).</a:t>
+              <a:t>Du führst die Gastro selbst oder verpachtest sie. Bei Verpachtung zahlt der Betreiber ca. 10 €/m² Pacht, das sind bei 510 m² ca. 5.100 € im Monat (ca. 5.3 % vom Umsatz).</a:t>
             </a:r>
             <a:endParaRPr lang="en-US" sz="1300" dirty="0"/>
           </a:p>
@@ -7808,7 +7808,7 @@
                 <a:ea typeface="Arial" pitchFamily="34" charset="-122"/>
                 <a:cs typeface="Arial" pitchFamily="34" charset="-120"/>
               </a:rPr>
-              <a:t>Barchef und Küchenleitung früh einstellen, 4 bis 6 Wochen vor Eröffnung Probebetrieb.</a:t>
+              <a:t>Küchenchef früh einstellen, 4 bis 6 Wochen vor Eröffnung Probebetrieb.</a:t>
             </a:r>
             <a:endParaRPr lang="en-US" sz="1300" dirty="0"/>
           </a:p>
@@ -8281,7 +8281,7 @@
                           <a:ea typeface="Arial" pitchFamily="34" charset="-122"/>
                           <a:cs typeface="Arial" pitchFamily="34" charset="-120"/>
                         </a:rPr>
-                        <a:t>40.000 €</a:t>
+                        <a:t>50.000 €</a:t>
                       </a:r>
                       <a:endParaRPr lang="en-US" sz="1250" dirty="0">
                         <a:latin typeface="Arial" charset="0"/>
@@ -8346,7 +8346,7 @@
                           <a:ea typeface="Arial" pitchFamily="34" charset="-122"/>
                           <a:cs typeface="Arial" pitchFamily="34" charset="-120"/>
                         </a:rPr>
-                        <a:t>12.200 €</a:t>
+                        <a:t>15.250 €</a:t>
                       </a:r>
                       <a:endParaRPr lang="en-US" sz="1250" dirty="0">
                         <a:latin typeface="Arial" charset="0"/>
@@ -8476,7 +8476,7 @@
                           <a:ea typeface="Arial" pitchFamily="34" charset="-122"/>
                           <a:cs typeface="Arial" pitchFamily="34" charset="-120"/>
                         </a:rPr>
-                        <a:t>+7.100 €</a:t>
+                        <a:t>+10.150 €</a:t>
                       </a:r>
                       <a:endParaRPr lang="en-US" sz="1250" dirty="0">
                         <a:latin typeface="Arial" charset="0"/>
@@ -8546,7 +8546,7 @@
                           <a:ea typeface="Arial" pitchFamily="34" charset="-122"/>
                           <a:cs typeface="Arial" pitchFamily="34" charset="-120"/>
                         </a:rPr>
-                        <a:t>50.000 €</a:t>
+                        <a:t>65.000 €</a:t>
                       </a:r>
                       <a:endParaRPr lang="en-US" sz="1250" dirty="0">
                         <a:latin typeface="Arial" charset="0"/>
@@ -8611,7 +8611,7 @@
                           <a:ea typeface="Arial" pitchFamily="34" charset="-122"/>
                           <a:cs typeface="Arial" pitchFamily="34" charset="-120"/>
                         </a:rPr>
-                        <a:t>15.250 €</a:t>
+                        <a:t>19.825 €</a:t>
                       </a:r>
                       <a:endParaRPr lang="en-US" sz="1250" dirty="0">
                         <a:latin typeface="Arial" charset="0"/>
@@ -8741,272 +8741,7 @@
                           <a:ea typeface="Arial" pitchFamily="34" charset="-122"/>
                           <a:cs typeface="Arial" pitchFamily="34" charset="-120"/>
                         </a:rPr>
-                        <a:t>+10.150 €</a:t>
-                      </a:r>
-                      <a:endParaRPr lang="en-US" sz="1250" dirty="0">
-                        <a:latin typeface="Arial" charset="0"/>
-                        <a:ea typeface="Arial" charset="0"/>
-                        <a:cs typeface="Arial" charset="0"/>
-                      </a:endParaRPr>
-                    </a:p>
-                  </a:txBody>
-                  <a:tcPr marL="91440" marR="91440" marT="45720" marB="45720">
-                    <a:lnL w="12700" cap="flat" cmpd="sng" algn="ctr">
-                      <a:solidFill>
-                        <a:srgbClr val="FFFFFF"/>
-                      </a:solidFill>
-                      <a:prstDash val="solid"/>
-                      <a:round/>
-                      <a:headEnd type="none" w="med" len="med"/>
-                      <a:tailEnd type="none" w="med" len="med"/>
-                    </a:lnL>
-                    <a:lnR w="12700" cap="flat" cmpd="sng" algn="ctr">
-                      <a:solidFill>
-                        <a:srgbClr val="FFFFFF"/>
-                      </a:solidFill>
-                      <a:prstDash val="solid"/>
-                      <a:round/>
-                      <a:headEnd type="none" w="med" len="med"/>
-                      <a:tailEnd type="none" w="med" len="med"/>
-                    </a:lnR>
-                    <a:lnT w="12700" cap="flat" cmpd="sng" algn="ctr">
-                      <a:solidFill>
-                        <a:srgbClr val="FFFFFF"/>
-                      </a:solidFill>
-                      <a:prstDash val="solid"/>
-                      <a:round/>
-                      <a:headEnd type="none" w="med" len="med"/>
-                      <a:tailEnd type="none" w="med" len="med"/>
-                    </a:lnT>
-                    <a:lnB w="12700" cap="flat" cmpd="sng" algn="ctr">
-                      <a:solidFill>
-                        <a:srgbClr val="FFFFFF"/>
-                      </a:solidFill>
-                      <a:prstDash val="solid"/>
-                      <a:round/>
-                      <a:headEnd type="none" w="med" len="med"/>
-                      <a:tailEnd type="none" w="med" len="med"/>
-                    </a:lnB>
-                    <a:solidFill>
-                      <a:srgbClr val="E3F1EA"/>
-                    </a:solidFill>
-                  </a:tcPr>
-                </a:tc>
-              </a:tr>
-              <a:tr h="502920">
-                <a:tc>
-                  <a:txBody>
-                    <a:bodyPr/>
-                    <a:lstStyle/>
-                    <a:p>
-                      <a:pPr indent="0" marL="0">
-                        <a:buNone/>
-                      </a:pPr>
-                      <a:r>
-                        <a:rPr lang="en-US" sz="1250" b="1" dirty="0">
-                          <a:solidFill>
-                            <a:srgbClr val="000000"/>
-                          </a:solidFill>
-                          <a:latin typeface="Arial" pitchFamily="34" charset="0"/>
-                          <a:ea typeface="Arial" pitchFamily="34" charset="-122"/>
-                          <a:cs typeface="Arial" pitchFamily="34" charset="-120"/>
-                        </a:rPr>
-                        <a:t>65.010 €</a:t>
-                      </a:r>
-                      <a:endParaRPr lang="en-US" sz="1250" dirty="0">
-                        <a:latin typeface="Arial" charset="0"/>
-                        <a:ea typeface="Arial" charset="0"/>
-                        <a:cs typeface="Arial" charset="0"/>
-                      </a:endParaRPr>
-                    </a:p>
-                  </a:txBody>
-                  <a:tcPr marL="91440" marR="91440" marT="45720" marB="45720">
-                    <a:lnL w="12700" cap="flat" cmpd="sng" algn="ctr">
-                      <a:solidFill>
-                        <a:srgbClr val="FFFFFF"/>
-                      </a:solidFill>
-                      <a:prstDash val="solid"/>
-                      <a:round/>
-                      <a:headEnd type="none" w="med" len="med"/>
-                      <a:tailEnd type="none" w="med" len="med"/>
-                    </a:lnL>
-                    <a:lnR w="12700" cap="flat" cmpd="sng" algn="ctr">
-                      <a:solidFill>
-                        <a:srgbClr val="FFFFFF"/>
-                      </a:solidFill>
-                      <a:prstDash val="solid"/>
-                      <a:round/>
-                      <a:headEnd type="none" w="med" len="med"/>
-                      <a:tailEnd type="none" w="med" len="med"/>
-                    </a:lnR>
-                    <a:lnT w="12700" cap="flat" cmpd="sng" algn="ctr">
-                      <a:solidFill>
-                        <a:srgbClr val="FFFFFF"/>
-                      </a:solidFill>
-                      <a:prstDash val="solid"/>
-                      <a:round/>
-                      <a:headEnd type="none" w="med" len="med"/>
-                      <a:tailEnd type="none" w="med" len="med"/>
-                    </a:lnT>
-                    <a:lnB w="12700" cap="flat" cmpd="sng" algn="ctr">
-                      <a:solidFill>
-                        <a:srgbClr val="FFFFFF"/>
-                      </a:solidFill>
-                      <a:prstDash val="solid"/>
-                      <a:round/>
-                      <a:headEnd type="none" w="med" len="med"/>
-                      <a:tailEnd type="none" w="med" len="med"/>
-                    </a:lnB>
-                  </a:tcPr>
-                </a:tc>
-                <a:tc>
-                  <a:txBody>
-                    <a:bodyPr/>
-                    <a:lstStyle/>
-                    <a:p>
-                      <a:pPr algn="r" indent="0" marL="0">
-                        <a:buNone/>
-                      </a:pPr>
-                      <a:r>
-                        <a:rPr lang="en-US" sz="1250" dirty="0">
-                          <a:solidFill>
-                            <a:srgbClr val="000000"/>
-                          </a:solidFill>
-                          <a:latin typeface="Arial" pitchFamily="34" charset="0"/>
-                          <a:ea typeface="Arial" pitchFamily="34" charset="-122"/>
-                          <a:cs typeface="Arial" pitchFamily="34" charset="-120"/>
-                        </a:rPr>
-                        <a:t>19.828 €</a:t>
-                      </a:r>
-                      <a:endParaRPr lang="en-US" sz="1250" dirty="0">
-                        <a:latin typeface="Arial" charset="0"/>
-                        <a:ea typeface="Arial" charset="0"/>
-                        <a:cs typeface="Arial" charset="0"/>
-                      </a:endParaRPr>
-                    </a:p>
-                  </a:txBody>
-                  <a:tcPr marL="91440" marR="91440" marT="45720" marB="45720">
-                    <a:lnL w="12700" cap="flat" cmpd="sng" algn="ctr">
-                      <a:solidFill>
-                        <a:srgbClr val="FFFFFF"/>
-                      </a:solidFill>
-                      <a:prstDash val="solid"/>
-                      <a:round/>
-                      <a:headEnd type="none" w="med" len="med"/>
-                      <a:tailEnd type="none" w="med" len="med"/>
-                    </a:lnL>
-                    <a:lnR w="12700" cap="flat" cmpd="sng" algn="ctr">
-                      <a:solidFill>
-                        <a:srgbClr val="FFFFFF"/>
-                      </a:solidFill>
-                      <a:prstDash val="solid"/>
-                      <a:round/>
-                      <a:headEnd type="none" w="med" len="med"/>
-                      <a:tailEnd type="none" w="med" len="med"/>
-                    </a:lnR>
-                    <a:lnT w="12700" cap="flat" cmpd="sng" algn="ctr">
-                      <a:solidFill>
-                        <a:srgbClr val="FFFFFF"/>
-                      </a:solidFill>
-                      <a:prstDash val="solid"/>
-                      <a:round/>
-                      <a:headEnd type="none" w="med" len="med"/>
-                      <a:tailEnd type="none" w="med" len="med"/>
-                    </a:lnT>
-                    <a:lnB w="12700" cap="flat" cmpd="sng" algn="ctr">
-                      <a:solidFill>
-                        <a:srgbClr val="FFFFFF"/>
-                      </a:solidFill>
-                      <a:prstDash val="solid"/>
-                      <a:round/>
-                      <a:headEnd type="none" w="med" len="med"/>
-                      <a:tailEnd type="none" w="med" len="med"/>
-                    </a:lnB>
-                  </a:tcPr>
-                </a:tc>
-                <a:tc>
-                  <a:txBody>
-                    <a:bodyPr/>
-                    <a:lstStyle/>
-                    <a:p>
-                      <a:pPr algn="r" indent="0" marL="0">
-                        <a:buNone/>
-                      </a:pPr>
-                      <a:r>
-                        <a:rPr lang="en-US" sz="1250" dirty="0">
-                          <a:solidFill>
-                            <a:srgbClr val="000000"/>
-                          </a:solidFill>
-                          <a:latin typeface="Arial" pitchFamily="34" charset="0"/>
-                          <a:ea typeface="Arial" pitchFamily="34" charset="-122"/>
-                          <a:cs typeface="Arial" pitchFamily="34" charset="-120"/>
-                        </a:rPr>
-                        <a:t>−5.100 €</a:t>
-                      </a:r>
-                      <a:endParaRPr lang="en-US" sz="1250" dirty="0">
-                        <a:latin typeface="Arial" charset="0"/>
-                        <a:ea typeface="Arial" charset="0"/>
-                        <a:cs typeface="Arial" charset="0"/>
-                      </a:endParaRPr>
-                    </a:p>
-                  </a:txBody>
-                  <a:tcPr marL="91440" marR="91440" marT="45720" marB="45720">
-                    <a:lnL w="12700" cap="flat" cmpd="sng" algn="ctr">
-                      <a:solidFill>
-                        <a:srgbClr val="FFFFFF"/>
-                      </a:solidFill>
-                      <a:prstDash val="solid"/>
-                      <a:round/>
-                      <a:headEnd type="none" w="med" len="med"/>
-                      <a:tailEnd type="none" w="med" len="med"/>
-                    </a:lnL>
-                    <a:lnR w="12700" cap="flat" cmpd="sng" algn="ctr">
-                      <a:solidFill>
-                        <a:srgbClr val="FFFFFF"/>
-                      </a:solidFill>
-                      <a:prstDash val="solid"/>
-                      <a:round/>
-                      <a:headEnd type="none" w="med" len="med"/>
-                      <a:tailEnd type="none" w="med" len="med"/>
-                    </a:lnR>
-                    <a:lnT w="12700" cap="flat" cmpd="sng" algn="ctr">
-                      <a:solidFill>
-                        <a:srgbClr val="FFFFFF"/>
-                      </a:solidFill>
-                      <a:prstDash val="solid"/>
-                      <a:round/>
-                      <a:headEnd type="none" w="med" len="med"/>
-                      <a:tailEnd type="none" w="med" len="med"/>
-                    </a:lnT>
-                    <a:lnB w="12700" cap="flat" cmpd="sng" algn="ctr">
-                      <a:solidFill>
-                        <a:srgbClr val="FFFFFF"/>
-                      </a:solidFill>
-                      <a:prstDash val="solid"/>
-                      <a:round/>
-                      <a:headEnd type="none" w="med" len="med"/>
-                      <a:tailEnd type="none" w="med" len="med"/>
-                    </a:lnB>
-                  </a:tcPr>
-                </a:tc>
-                <a:tc>
-                  <a:txBody>
-                    <a:bodyPr/>
-                    <a:lstStyle/>
-                    <a:p>
-                      <a:pPr algn="r" indent="0" marL="0">
-                        <a:buNone/>
-                      </a:pPr>
-                      <a:r>
-                        <a:rPr lang="en-US" sz="1250" b="1" dirty="0">
-                          <a:solidFill>
-                            <a:schemeClr val="accent5"/>
-                          </a:solidFill>
-                          <a:latin typeface="Arial" pitchFamily="34" charset="0"/>
-                          <a:ea typeface="Arial" pitchFamily="34" charset="-122"/>
-                          <a:cs typeface="Arial" pitchFamily="34" charset="-120"/>
-                        </a:rPr>
-                        <a:t>+14.728 €</a:t>
+                        <a:t>+14.725 €</a:t>
                       </a:r>
                       <a:endParaRPr lang="en-US" sz="1250" dirty="0">
                         <a:latin typeface="Arial" charset="0"/>
@@ -9333,7 +9068,7 @@
                         <a:buNone/>
                       </a:pPr>
                       <a:r>
-                        <a:rPr lang="en-US" sz="1250" dirty="0">
+                        <a:rPr lang="en-US" sz="1250" b="1" dirty="0">
                           <a:solidFill>
                             <a:srgbClr val="000000"/>
                           </a:solidFill>
@@ -9341,7 +9076,7 @@
                           <a:ea typeface="Arial" pitchFamily="34" charset="-122"/>
                           <a:cs typeface="Arial" pitchFamily="34" charset="-120"/>
                         </a:rPr>
-                        <a:t>95.000 €</a:t>
+                        <a:t>95.635 €</a:t>
                       </a:r>
                       <a:endParaRPr lang="en-US" sz="1250" dirty="0">
                         <a:latin typeface="Arial" charset="0"/>
@@ -9406,7 +9141,7 @@
                           <a:ea typeface="Arial" pitchFamily="34" charset="-122"/>
                           <a:cs typeface="Arial" pitchFamily="34" charset="-120"/>
                         </a:rPr>
-                        <a:t>28.975 €</a:t>
+                        <a:t>29.169 €</a:t>
                       </a:r>
                       <a:endParaRPr lang="en-US" sz="1250" dirty="0">
                         <a:latin typeface="Arial" charset="0"/>
@@ -9536,7 +9271,272 @@
                           <a:ea typeface="Arial" pitchFamily="34" charset="-122"/>
                           <a:cs typeface="Arial" pitchFamily="34" charset="-120"/>
                         </a:rPr>
-                        <a:t>+23.875 €</a:t>
+                        <a:t>+24.069 €</a:t>
+                      </a:r>
+                      <a:endParaRPr lang="en-US" sz="1250" dirty="0">
+                        <a:latin typeface="Arial" charset="0"/>
+                        <a:ea typeface="Arial" charset="0"/>
+                        <a:cs typeface="Arial" charset="0"/>
+                      </a:endParaRPr>
+                    </a:p>
+                  </a:txBody>
+                  <a:tcPr marL="91440" marR="91440" marT="45720" marB="45720">
+                    <a:lnL w="12700" cap="flat" cmpd="sng" algn="ctr">
+                      <a:solidFill>
+                        <a:srgbClr val="FFFFFF"/>
+                      </a:solidFill>
+                      <a:prstDash val="solid"/>
+                      <a:round/>
+                      <a:headEnd type="none" w="med" len="med"/>
+                      <a:tailEnd type="none" w="med" len="med"/>
+                    </a:lnL>
+                    <a:lnR w="12700" cap="flat" cmpd="sng" algn="ctr">
+                      <a:solidFill>
+                        <a:srgbClr val="FFFFFF"/>
+                      </a:solidFill>
+                      <a:prstDash val="solid"/>
+                      <a:round/>
+                      <a:headEnd type="none" w="med" len="med"/>
+                      <a:tailEnd type="none" w="med" len="med"/>
+                    </a:lnR>
+                    <a:lnT w="12700" cap="flat" cmpd="sng" algn="ctr">
+                      <a:solidFill>
+                        <a:srgbClr val="FFFFFF"/>
+                      </a:solidFill>
+                      <a:prstDash val="solid"/>
+                      <a:round/>
+                      <a:headEnd type="none" w="med" len="med"/>
+                      <a:tailEnd type="none" w="med" len="med"/>
+                    </a:lnT>
+                    <a:lnB w="12700" cap="flat" cmpd="sng" algn="ctr">
+                      <a:solidFill>
+                        <a:srgbClr val="FFFFFF"/>
+                      </a:solidFill>
+                      <a:prstDash val="solid"/>
+                      <a:round/>
+                      <a:headEnd type="none" w="med" len="med"/>
+                      <a:tailEnd type="none" w="med" len="med"/>
+                    </a:lnB>
+                    <a:solidFill>
+                      <a:srgbClr val="E3F1EA"/>
+                    </a:solidFill>
+                  </a:tcPr>
+                </a:tc>
+              </a:tr>
+              <a:tr h="502920">
+                <a:tc>
+                  <a:txBody>
+                    <a:bodyPr/>
+                    <a:lstStyle/>
+                    <a:p>
+                      <a:pPr indent="0" marL="0">
+                        <a:buNone/>
+                      </a:pPr>
+                      <a:r>
+                        <a:rPr lang="en-US" sz="1250" dirty="0">
+                          <a:solidFill>
+                            <a:srgbClr val="000000"/>
+                          </a:solidFill>
+                          <a:latin typeface="Arial" pitchFamily="34" charset="0"/>
+                          <a:ea typeface="Arial" pitchFamily="34" charset="-122"/>
+                          <a:cs typeface="Arial" pitchFamily="34" charset="-120"/>
+                        </a:rPr>
+                        <a:t>110.000 €</a:t>
+                      </a:r>
+                      <a:endParaRPr lang="en-US" sz="1250" dirty="0">
+                        <a:latin typeface="Arial" charset="0"/>
+                        <a:ea typeface="Arial" charset="0"/>
+                        <a:cs typeface="Arial" charset="0"/>
+                      </a:endParaRPr>
+                    </a:p>
+                  </a:txBody>
+                  <a:tcPr marL="91440" marR="91440" marT="45720" marB="45720">
+                    <a:lnL w="12700" cap="flat" cmpd="sng" algn="ctr">
+                      <a:solidFill>
+                        <a:srgbClr val="FFFFFF"/>
+                      </a:solidFill>
+                      <a:prstDash val="solid"/>
+                      <a:round/>
+                      <a:headEnd type="none" w="med" len="med"/>
+                      <a:tailEnd type="none" w="med" len="med"/>
+                    </a:lnL>
+                    <a:lnR w="12700" cap="flat" cmpd="sng" algn="ctr">
+                      <a:solidFill>
+                        <a:srgbClr val="FFFFFF"/>
+                      </a:solidFill>
+                      <a:prstDash val="solid"/>
+                      <a:round/>
+                      <a:headEnd type="none" w="med" len="med"/>
+                      <a:tailEnd type="none" w="med" len="med"/>
+                    </a:lnR>
+                    <a:lnT w="12700" cap="flat" cmpd="sng" algn="ctr">
+                      <a:solidFill>
+                        <a:srgbClr val="FFFFFF"/>
+                      </a:solidFill>
+                      <a:prstDash val="solid"/>
+                      <a:round/>
+                      <a:headEnd type="none" w="med" len="med"/>
+                      <a:tailEnd type="none" w="med" len="med"/>
+                    </a:lnT>
+                    <a:lnB w="12700" cap="flat" cmpd="sng" algn="ctr">
+                      <a:solidFill>
+                        <a:srgbClr val="FFFFFF"/>
+                      </a:solidFill>
+                      <a:prstDash val="solid"/>
+                      <a:round/>
+                      <a:headEnd type="none" w="med" len="med"/>
+                      <a:tailEnd type="none" w="med" len="med"/>
+                    </a:lnB>
+                  </a:tcPr>
+                </a:tc>
+                <a:tc>
+                  <a:txBody>
+                    <a:bodyPr/>
+                    <a:lstStyle/>
+                    <a:p>
+                      <a:pPr algn="r" indent="0" marL="0">
+                        <a:buNone/>
+                      </a:pPr>
+                      <a:r>
+                        <a:rPr lang="en-US" sz="1250" dirty="0">
+                          <a:solidFill>
+                            <a:srgbClr val="000000"/>
+                          </a:solidFill>
+                          <a:latin typeface="Arial" pitchFamily="34" charset="0"/>
+                          <a:ea typeface="Arial" pitchFamily="34" charset="-122"/>
+                          <a:cs typeface="Arial" pitchFamily="34" charset="-120"/>
+                        </a:rPr>
+                        <a:t>33.550 €</a:t>
+                      </a:r>
+                      <a:endParaRPr lang="en-US" sz="1250" dirty="0">
+                        <a:latin typeface="Arial" charset="0"/>
+                        <a:ea typeface="Arial" charset="0"/>
+                        <a:cs typeface="Arial" charset="0"/>
+                      </a:endParaRPr>
+                    </a:p>
+                  </a:txBody>
+                  <a:tcPr marL="91440" marR="91440" marT="45720" marB="45720">
+                    <a:lnL w="12700" cap="flat" cmpd="sng" algn="ctr">
+                      <a:solidFill>
+                        <a:srgbClr val="FFFFFF"/>
+                      </a:solidFill>
+                      <a:prstDash val="solid"/>
+                      <a:round/>
+                      <a:headEnd type="none" w="med" len="med"/>
+                      <a:tailEnd type="none" w="med" len="med"/>
+                    </a:lnL>
+                    <a:lnR w="12700" cap="flat" cmpd="sng" algn="ctr">
+                      <a:solidFill>
+                        <a:srgbClr val="FFFFFF"/>
+                      </a:solidFill>
+                      <a:prstDash val="solid"/>
+                      <a:round/>
+                      <a:headEnd type="none" w="med" len="med"/>
+                      <a:tailEnd type="none" w="med" len="med"/>
+                    </a:lnR>
+                    <a:lnT w="12700" cap="flat" cmpd="sng" algn="ctr">
+                      <a:solidFill>
+                        <a:srgbClr val="FFFFFF"/>
+                      </a:solidFill>
+                      <a:prstDash val="solid"/>
+                      <a:round/>
+                      <a:headEnd type="none" w="med" len="med"/>
+                      <a:tailEnd type="none" w="med" len="med"/>
+                    </a:lnT>
+                    <a:lnB w="12700" cap="flat" cmpd="sng" algn="ctr">
+                      <a:solidFill>
+                        <a:srgbClr val="FFFFFF"/>
+                      </a:solidFill>
+                      <a:prstDash val="solid"/>
+                      <a:round/>
+                      <a:headEnd type="none" w="med" len="med"/>
+                      <a:tailEnd type="none" w="med" len="med"/>
+                    </a:lnB>
+                  </a:tcPr>
+                </a:tc>
+                <a:tc>
+                  <a:txBody>
+                    <a:bodyPr/>
+                    <a:lstStyle/>
+                    <a:p>
+                      <a:pPr algn="r" indent="0" marL="0">
+                        <a:buNone/>
+                      </a:pPr>
+                      <a:r>
+                        <a:rPr lang="en-US" sz="1250" dirty="0">
+                          <a:solidFill>
+                            <a:srgbClr val="000000"/>
+                          </a:solidFill>
+                          <a:latin typeface="Arial" pitchFamily="34" charset="0"/>
+                          <a:ea typeface="Arial" pitchFamily="34" charset="-122"/>
+                          <a:cs typeface="Arial" pitchFamily="34" charset="-120"/>
+                        </a:rPr>
+                        <a:t>−5.100 €</a:t>
+                      </a:r>
+                      <a:endParaRPr lang="en-US" sz="1250" dirty="0">
+                        <a:latin typeface="Arial" charset="0"/>
+                        <a:ea typeface="Arial" charset="0"/>
+                        <a:cs typeface="Arial" charset="0"/>
+                      </a:endParaRPr>
+                    </a:p>
+                  </a:txBody>
+                  <a:tcPr marL="91440" marR="91440" marT="45720" marB="45720">
+                    <a:lnL w="12700" cap="flat" cmpd="sng" algn="ctr">
+                      <a:solidFill>
+                        <a:srgbClr val="FFFFFF"/>
+                      </a:solidFill>
+                      <a:prstDash val="solid"/>
+                      <a:round/>
+                      <a:headEnd type="none" w="med" len="med"/>
+                      <a:tailEnd type="none" w="med" len="med"/>
+                    </a:lnL>
+                    <a:lnR w="12700" cap="flat" cmpd="sng" algn="ctr">
+                      <a:solidFill>
+                        <a:srgbClr val="FFFFFF"/>
+                      </a:solidFill>
+                      <a:prstDash val="solid"/>
+                      <a:round/>
+                      <a:headEnd type="none" w="med" len="med"/>
+                      <a:tailEnd type="none" w="med" len="med"/>
+                    </a:lnR>
+                    <a:lnT w="12700" cap="flat" cmpd="sng" algn="ctr">
+                      <a:solidFill>
+                        <a:srgbClr val="FFFFFF"/>
+                      </a:solidFill>
+                      <a:prstDash val="solid"/>
+                      <a:round/>
+                      <a:headEnd type="none" w="med" len="med"/>
+                      <a:tailEnd type="none" w="med" len="med"/>
+                    </a:lnT>
+                    <a:lnB w="12700" cap="flat" cmpd="sng" algn="ctr">
+                      <a:solidFill>
+                        <a:srgbClr val="FFFFFF"/>
+                      </a:solidFill>
+                      <a:prstDash val="solid"/>
+                      <a:round/>
+                      <a:headEnd type="none" w="med" len="med"/>
+                      <a:tailEnd type="none" w="med" len="med"/>
+                    </a:lnB>
+                  </a:tcPr>
+                </a:tc>
+                <a:tc>
+                  <a:txBody>
+                    <a:bodyPr/>
+                    <a:lstStyle/>
+                    <a:p>
+                      <a:pPr algn="r" indent="0" marL="0">
+                        <a:buNone/>
+                      </a:pPr>
+                      <a:r>
+                        <a:rPr lang="en-US" sz="1250" b="1" dirty="0">
+                          <a:solidFill>
+                            <a:schemeClr val="accent5"/>
+                          </a:solidFill>
+                          <a:latin typeface="Arial" pitchFamily="34" charset="0"/>
+                          <a:ea typeface="Arial" pitchFamily="34" charset="-122"/>
+                          <a:cs typeface="Arial" pitchFamily="34" charset="-120"/>
+                        </a:rPr>
+                        <a:t>+28.450 €</a:t>
                       </a:r>
                       <a:endParaRPr lang="en-US" sz="1250" dirty="0">
                         <a:latin typeface="Arial" charset="0"/>
@@ -9669,7 +9669,7 @@
                 <a:ea typeface="Arial" pitchFamily="34" charset="-122"/>
                 <a:cs typeface="Arial" pitchFamily="34" charset="-120"/>
               </a:rPr>
-              <a:t>Mit 65.010 € Umsatz bleiben im ganzen Haus +9.613 € pro Monat nach Zinsen und Tilgung (KfW-Kredite und Hausbank, ohne Lohn). Die Gastro braucht für Break-even im Haus ca. 33.500 € Umsatz.</a:t>
+              <a:t>Mit 95.635 € Umsatz bleiben im ganzen Haus +18.954 € pro Monat nach Zinsen und Tilgung (KfW-Kredite und Hausbank, ohne Lohn). Die Gastro braucht für Break-even im Haus ca. 33.500 € Umsatz.</a:t>
             </a:r>
             <a:endParaRPr lang="en-US" sz="1300" dirty="0"/>
           </a:p>
@@ -10043,7 +10043,7 @@
                           <a:ea typeface="Arial" pitchFamily="34" charset="-122"/>
                           <a:cs typeface="Arial" pitchFamily="34" charset="-120"/>
                         </a:rPr>
-                        <a:t>Küche (Bowl- und Snackküche, Kühlräume, Spülküche)</a:t>
+                        <a:t>Küche (Herd, Kühlräume, Edelstahl, Spülküche)</a:t>
                       </a:r>
                       <a:endParaRPr lang="en-US" sz="1250" dirty="0">
                         <a:latin typeface="Arial" charset="0"/>
@@ -10108,7 +10108,7 @@
                           <a:ea typeface="Arial" pitchFamily="34" charset="-122"/>
                           <a:cs typeface="Arial" pitchFamily="34" charset="-120"/>
                         </a:rPr>
-                        <a:t>28.000 €</a:t>
+                        <a:t>38.000 €</a:t>
                       </a:r>
                       <a:endParaRPr lang="en-US" sz="1250" dirty="0">
                         <a:latin typeface="Arial" charset="0"/>
@@ -10307,7 +10307,7 @@
                           <a:ea typeface="Arial" pitchFamily="34" charset="-122"/>
                           <a:cs typeface="Arial" pitchFamily="34" charset="-120"/>
                         </a:rPr>
-                        <a:t>Theke und Bar (Zapfanlage, Kühlung, Backbar, große Theke)</a:t>
+                        <a:t>Theke und Bar (Zapfanlage, Kühlung, Backbar)</a:t>
                       </a:r>
                       <a:endParaRPr lang="en-US" sz="1250" dirty="0">
                         <a:latin typeface="Arial" charset="0"/>
@@ -10372,7 +10372,7 @@
                           <a:ea typeface="Arial" pitchFamily="34" charset="-122"/>
                           <a:cs typeface="Arial" pitchFamily="34" charset="-120"/>
                         </a:rPr>
-                        <a:t>35.000 €</a:t>
+                        <a:t>25.000 €</a:t>
                       </a:r>
                       <a:endParaRPr lang="en-US" sz="1250" dirty="0">
                         <a:latin typeface="Arial" charset="0"/>
@@ -12162,7 +12162,7 @@
                 <a:ea typeface="Arial" pitchFamily="34" charset="-122"/>
                 <a:cs typeface="Arial" pitchFamily="34" charset="-120"/>
               </a:rPr>
-              <a:t>Gastro unter Wohnungen: Schallschutz der Decke, leise Technik, Abluft der kleinen Küche über Dach. Nutzungszeiten der Terrasse klären.</a:t>
+              <a:t>Gastro unter Wohnungen: Schallschutz der Decke, leise Technik, Abluft der Küche über Dach. Nutzungszeiten der Terrasse klären.</a:t>
             </a:r>
             <a:endParaRPr lang="en-US" sz="1300" dirty="0"/>
           </a:p>
@@ -12372,7 +12372,7 @@
                 <a:ea typeface="Arial" pitchFamily="34" charset="-122"/>
                 <a:cs typeface="Arial" pitchFamily="34" charset="-120"/>
               </a:rPr>
-              <a:t>Keine Marktdaten für Werlte. Erfahrener Betreiber oder Barchef früh gewinnen, Probebetrieb und vorsichtiger Start.</a:t>
+              <a:t>Keine Marktdaten für Werlte. Erfahrener Betreiber oder Küchenchef früh gewinnen, Probebetrieb und vorsichtiger Start.</a:t>
             </a:r>
             <a:endParaRPr lang="en-US" sz="1300" dirty="0"/>
           </a:p>
@@ -12661,7 +12661,7 @@
                 <a:ea typeface="Arial" pitchFamily="34" charset="-122"/>
                 <a:cs typeface="Arial" pitchFamily="34" charset="-120"/>
               </a:rPr>
-              <a:t>Name, Marke und Zielgruppe festlegen, Betreiber oder Barchef ansprechen</a:t>
+              <a:t>Name, Marke und Zielgruppe festlegen, Betreiber oder Küchenchef ansprechen</a:t>
             </a:r>
             <a:endParaRPr lang="en-US" sz="1500" dirty="0"/>
           </a:p>
@@ -13623,7 +13623,7 @@
                 <a:ea typeface="Arial" pitchFamily="34" charset="-122"/>
                 <a:cs typeface="Arial" pitchFamily="34" charset="-120"/>
               </a:rPr>
-              <a:t>Frühstück, Brunch am Wochenende und Bowls, Salate und Suppe zum Mittag. Frisch, schnell, fair im Preis für Beschäftigte aus Rathaus und Umgebung.</a:t>
+              <a:t>Frühstück, Brunch am Wochenende und Mittagstisch am Marktplatz. Regional, frisch, schnell für Beschäftigte aus Rathaus und Umgebung.</a:t>
             </a:r>
             <a:endParaRPr lang="en-US" sz="1400" dirty="0"/>
           </a:p>
@@ -13631,7 +13631,7 @@
       </p:sp>
       <p:sp>
         <p:nvSpPr>
-          <p:cNvPr id="8" name="Abends: Bar mit Snacks"/>
+          <p:cNvPr id="8" name="Abends (Hauptfokus)"/>
           <p:cNvSpPr/>
           <p:nvPr/>
         </p:nvSpPr>
@@ -13689,7 +13689,7 @@
                 <a:ea typeface="Georgia" pitchFamily="34" charset="-122"/>
                 <a:cs typeface="Georgia" pitchFamily="34" charset="-120"/>
               </a:rPr>
-              <a:t>Abends: Bar mit Snacks</a:t>
+              <a:t>Abends (Hauptfokus)</a:t>
             </a:r>
             <a:endParaRPr lang="en-US" sz="2000" dirty="0"/>
           </a:p>
@@ -13728,7 +13728,7 @@
                 <a:ea typeface="Arial" pitchFamily="34" charset="-122"/>
                 <a:cs typeface="Arial" pitchFamily="34" charset="-120"/>
               </a:rPr>
-              <a:t>Bar mit Snacks in warmer, dunkler Atmosphäre mit Cognac-Banketten und Kerzenlicht, keine große Restaurantküche. Der Abend bringt ca. 61 % vom Umsatz.</a:t>
+              <a:t>Moderne, regionale Küche in warmer, dunkler Atmosphäre mit Cognac-Banketten und Kerzenlicht. Der Abend bringt ca. 75 % vom Umsatz.</a:t>
             </a:r>
             <a:endParaRPr lang="en-US" sz="1400" dirty="0"/>
           </a:p>
@@ -13736,7 +13736,7 @@
       </p:sp>
       <p:sp>
         <p:nvSpPr>
-          <p:cNvPr id="11" name="Cocktails und Events"/>
+          <p:cNvPr id="11" name="Bar und Feiern"/>
           <p:cNvSpPr/>
           <p:nvPr/>
         </p:nvSpPr>
@@ -13794,7 +13794,7 @@
                 <a:ea typeface="Georgia" pitchFamily="34" charset="-122"/>
                 <a:cs typeface="Georgia" pitchFamily="34" charset="-120"/>
               </a:rPr>
-              <a:t>Cocktails und Events</a:t>
+              <a:t>Bar und Feiern</a:t>
             </a:r>
             <a:endParaRPr lang="en-US" sz="2000" dirty="0"/>
           </a:p>
@@ -13833,7 +13833,7 @@
                 <a:ea typeface="Arial" pitchFamily="34" charset="-122"/>
                 <a:cs typeface="Arial" pitchFamily="34" charset="-120"/>
               </a:rPr>
-              <a:t>Cocktails, Wein und Bier an der großen Theke, Fr und Sa bis 01 Uhr. Live-Musik, Séparée mit 30 Plätzen für Feiern.</a:t>
+              <a:t>Ab 21 Uhr Cocktails, Wein und Bier an der Theke, Fr und Sa bis 01 Uhr. Live-Abende, Séparée mit 30 Plätzen für Feiern.</a:t>
             </a:r>
             <a:endParaRPr lang="en-US" sz="1400" dirty="0"/>
           </a:p>
@@ -14292,7 +14292,7 @@
                 <a:ea typeface="Arial" pitchFamily="34" charset="-122"/>
                 <a:cs typeface="Arial" pitchFamily="34" charset="-120"/>
               </a:rPr>
-              <a:t>Arbeitstitel: Café und Bar am Marktplatz. Ein Name und eine Marke sind noch offen.</a:t>
+              <a:t>Arbeitstitel: Bar-Restaurant am Marktplatz. Ein Name und eine Marke sind noch offen.</a:t>
             </a:r>
             <a:endParaRPr lang="en-US" sz="1300" dirty="0"/>
           </a:p>
@@ -15614,7 +15614,7 @@
                           <a:ea typeface="Arial" pitchFamily="34" charset="-122"/>
                           <a:cs typeface="Arial" pitchFamily="34" charset="-120"/>
                         </a:rPr>
-                        <a:t>Terrasse, Kaffee, Bowls</a:t>
+                        <a:t>Terrasse, Kaffee, regionale Küche</a:t>
                       </a:r>
                       <a:endParaRPr lang="en-US" sz="1250" dirty="0">
                         <a:latin typeface="Arial" charset="0"/>
@@ -16407,7 +16407,7 @@
                           <a:ea typeface="Arial" pitchFamily="34" charset="-122"/>
                           <a:cs typeface="Arial" pitchFamily="34" charset="-120"/>
                         </a:rPr>
-                        <a:t>Bowls, Salate, Suppe des Tages</a:t>
+                        <a:t>Mittagstisch, Tagesgericht, Suppe</a:t>
                       </a:r>
                       <a:endParaRPr lang="en-US" sz="1250" dirty="0">
                         <a:latin typeface="Arial" charset="0"/>
@@ -16539,7 +16539,7 @@
                           <a:ea typeface="Arial" pitchFamily="34" charset="-122"/>
                           <a:cs typeface="Arial" pitchFamily="34" charset="-120"/>
                         </a:rPr>
-                        <a:t>14:30–17:00</a:t>
+                        <a:t>14:30–17:30</a:t>
                       </a:r>
                       <a:endParaRPr lang="en-US" sz="1250" dirty="0">
                         <a:latin typeface="Arial" charset="0"/>
@@ -16604,7 +16604,7 @@
                           <a:ea typeface="Arial" pitchFamily="34" charset="-122"/>
                           <a:cs typeface="Arial" pitchFamily="34" charset="-120"/>
                         </a:rPr>
-                        <a:t>Kaffee, Kuchen, kleine Snacks</a:t>
+                        <a:t>Kaffee, Kuchen, kleine Karte</a:t>
                       </a:r>
                       <a:endParaRPr lang="en-US" sz="1250" dirty="0">
                         <a:latin typeface="Arial" charset="0"/>
@@ -16736,7 +16736,7 @@
                           <a:ea typeface="Arial" pitchFamily="34" charset="-122"/>
                           <a:cs typeface="Arial" pitchFamily="34" charset="-120"/>
                         </a:rPr>
-                        <a:t>ab 17:00 (Di–Do, So bis 22:00)</a:t>
+                        <a:t>17:30–22:00 (Di–So)</a:t>
                       </a:r>
                       <a:endParaRPr lang="en-US" sz="1250" dirty="0">
                         <a:latin typeface="Arial" charset="0"/>
@@ -16801,7 +16801,7 @@
                           <a:ea typeface="Arial" pitchFamily="34" charset="-122"/>
                           <a:cs typeface="Arial" pitchFamily="34" charset="-120"/>
                         </a:rPr>
-                        <a:t>Bar mit Snacks, Wein, Bier, Cocktails</a:t>
+                        <a:t>Abendessen, Wein, Bier</a:t>
                       </a:r>
                       <a:endParaRPr lang="en-US" sz="1250" dirty="0">
                         <a:latin typeface="Arial" charset="0"/>
@@ -16933,7 +16933,7 @@
                           <a:ea typeface="Arial" pitchFamily="34" charset="-122"/>
                           <a:cs typeface="Arial" pitchFamily="34" charset="-120"/>
                         </a:rPr>
-                        <a:t>Fr, Sa bis 01:00</a:t>
+                        <a:t>ab 21:00 (Fr, Sa bis 01:00)</a:t>
                       </a:r>
                       <a:endParaRPr lang="en-US" sz="1250" dirty="0">
                         <a:latin typeface="Arial" charset="0"/>
@@ -16998,7 +16998,7 @@
                           <a:ea typeface="Arial" pitchFamily="34" charset="-122"/>
                           <a:cs typeface="Arial" pitchFamily="34" charset="-120"/>
                         </a:rPr>
-                        <a:t>Bar, Cocktails, Snacks, Live-Musik</a:t>
+                        <a:t>Bar, Cocktails, Live-Abende, leise Musik</a:t>
                       </a:r>
                       <a:endParaRPr lang="en-US" sz="1250" dirty="0">
                         <a:latin typeface="Arial" charset="0"/>
@@ -17450,7 +17450,7 @@
                 <a:ea typeface="Arial" pitchFamily="34" charset="-122"/>
                 <a:cs typeface="Arial" pitchFamily="34" charset="-120"/>
               </a:rPr>
-              <a:t>Avocado-Toast mit Ei 10,90 €</a:t>
+              <a:t>Eggs Benedict 13,90 €</a:t>
             </a:r>
             <a:endParaRPr lang="en-US" sz="1300" dirty="0"/>
           </a:p>
@@ -17500,7 +17500,7 @@
       </p:sp>
       <p:sp>
         <p:nvSpPr>
-          <p:cNvPr id="8" name="Bowls und Mittag"/>
+          <p:cNvPr id="8" name="Mittagstisch"/>
           <p:cNvSpPr/>
           <p:nvPr/>
         </p:nvSpPr>
@@ -17558,7 +17558,7 @@
                 <a:ea typeface="Georgia" pitchFamily="34" charset="-122"/>
                 <a:cs typeface="Georgia" pitchFamily="34" charset="-120"/>
               </a:rPr>
-              <a:t>Bowls und Mittag</a:t>
+              <a:t>Mittagstisch</a:t>
             </a:r>
             <a:endParaRPr lang="en-US" sz="1700" dirty="0"/>
           </a:p>
@@ -17601,7 +17601,7 @@
                 <a:ea typeface="Arial" pitchFamily="34" charset="-122"/>
                 <a:cs typeface="Arial" pitchFamily="34" charset="-120"/>
               </a:rPr>
-              <a:t>Bowl mit Huhn und Gemüse 12,90 €</a:t>
+              <a:t>Tagesgericht 10,90–13,90 €</a:t>
             </a:r>
             <a:endParaRPr lang="en-US" sz="1300" dirty="0"/>
           </a:p>
@@ -17622,179 +17622,7 @@
                 <a:ea typeface="Arial" pitchFamily="34" charset="-122"/>
                 <a:cs typeface="Arial" pitchFamily="34" charset="-120"/>
               </a:rPr>
-              <a:t>Vegane Bowl 11,90 €</a:t>
-            </a:r>
-            <a:endParaRPr lang="en-US" sz="1300" dirty="0"/>
-          </a:p>
-          <a:p>
-            <a:pPr marL="342900" indent="-342900">
-              <a:spcAft>
-                <a:spcPts val="600"/>
-              </a:spcAft>
-              <a:buSzPct val="100000"/>
-              <a:buChar char="•"/>
-            </a:pPr>
-            <a:r>
-              <a:rPr lang="en-US" sz="1300" dirty="0">
-                <a:solidFill>
-                  <a:schemeClr val="tx1"/>
-                </a:solidFill>
-                <a:latin typeface="Arial" pitchFamily="34" charset="0"/>
-                <a:ea typeface="Arial" pitchFamily="34" charset="-122"/>
-                <a:cs typeface="Arial" pitchFamily="34" charset="-120"/>
-              </a:rPr>
-              <a:t>Salat mit Topping 10,90 €</a:t>
-            </a:r>
-            <a:endParaRPr lang="en-US" sz="1300" dirty="0"/>
-          </a:p>
-          <a:p>
-            <a:pPr marL="342900" indent="-342900">
-              <a:spcAft>
-                <a:spcPts val="600"/>
-              </a:spcAft>
-              <a:buSzPct val="100000"/>
-              <a:buChar char="•"/>
-            </a:pPr>
-            <a:r>
-              <a:rPr lang="en-US" sz="1300" dirty="0">
-                <a:solidFill>
-                  <a:schemeClr val="tx1"/>
-                </a:solidFill>
-                <a:latin typeface="Arial" pitchFamily="34" charset="0"/>
-                <a:ea typeface="Arial" pitchFamily="34" charset="-122"/>
-                <a:cs typeface="Arial" pitchFamily="34" charset="-120"/>
-              </a:rPr>
-              <a:t>Suppe des Tages 6,50 €</a:t>
-            </a:r>
-            <a:endParaRPr lang="en-US" sz="1300" dirty="0"/>
-          </a:p>
-        </p:txBody>
-      </p:sp>
-      <p:sp>
-        <p:nvSpPr>
-          <p:cNvPr id="11" name="Snacks zur Bar"/>
-          <p:cNvSpPr/>
-          <p:nvPr/>
-        </p:nvSpPr>
-        <p:spPr>
-          <a:xfrm>
-            <a:off x="6231636" y="1371600"/>
-            <a:ext cx="2567178" cy="3657600"/>
-          </a:xfrm>
-          <a:prstGeom prst="roundRect">
-            <a:avLst>
-              <a:gd name="adj" fmla="val 2850"/>
-            </a:avLst>
-          </a:prstGeom>
-          <a:solidFill>
-            <a:schemeClr val="bg2"/>
-          </a:solidFill>
-          <a:ln w="12700">
-            <a:solidFill>
-              <a:schemeClr val="bg2"/>
-            </a:solidFill>
-            <a:prstDash val="solid"/>
-          </a:ln>
-        </p:spPr>
-      </p:sp>
-      <p:sp>
-        <p:nvSpPr>
-          <p:cNvPr id="12" name="Text 9"/>
-          <p:cNvSpPr txBox="1"/>
-          <p:nvPr/>
-        </p:nvSpPr>
-        <p:spPr>
-          <a:xfrm>
-            <a:off x="6414516" y="1481328"/>
-            <a:ext cx="2201418" cy="457200"/>
-          </a:xfrm>
-          <a:prstGeom prst="rect">
-            <a:avLst/>
-          </a:prstGeom>
-          <a:noFill/>
-          <a:ln/>
-        </p:spPr>
-        <p:txBody>
-          <a:bodyPr wrap="square" lIns="0" tIns="0" rIns="0" bIns="0" rtlCol="0" anchor="t"/>
-          <a:lstStyle/>
-          <a:p>
-            <a:pPr indent="0" marL="0">
-              <a:buNone/>
-            </a:pPr>
-            <a:r>
-              <a:rPr lang="en-US" sz="1700" dirty="0">
-                <a:solidFill>
-                  <a:schemeClr val="accent1"/>
-                </a:solidFill>
-                <a:latin typeface="Georgia" pitchFamily="34" charset="0"/>
-                <a:ea typeface="Georgia" pitchFamily="34" charset="-122"/>
-                <a:cs typeface="Georgia" pitchFamily="34" charset="-120"/>
-              </a:rPr>
-              <a:t>Snacks zur Bar</a:t>
-            </a:r>
-            <a:endParaRPr lang="en-US" sz="1700" dirty="0"/>
-          </a:p>
-        </p:txBody>
-      </p:sp>
-      <p:sp>
-        <p:nvSpPr>
-          <p:cNvPr id="13" name="Text 10"/>
-          <p:cNvSpPr txBox="1"/>
-          <p:nvPr/>
-        </p:nvSpPr>
-        <p:spPr>
-          <a:xfrm>
-            <a:off x="6414516" y="2011680"/>
-            <a:ext cx="2201418" cy="2926080"/>
-          </a:xfrm>
-          <a:prstGeom prst="rect">
-            <a:avLst/>
-          </a:prstGeom>
-          <a:noFill/>
-          <a:ln/>
-        </p:spPr>
-        <p:txBody>
-          <a:bodyPr wrap="square" lIns="0" tIns="0" rIns="0" bIns="0" rtlCol="0" anchor="t"/>
-          <a:lstStyle/>
-          <a:p>
-            <a:pPr marL="342900" indent="-342900">
-              <a:spcAft>
-                <a:spcPts val="600"/>
-              </a:spcAft>
-              <a:buSzPct val="100000"/>
-              <a:buChar char="•"/>
-            </a:pPr>
-            <a:r>
-              <a:rPr lang="en-US" sz="1300" dirty="0">
-                <a:solidFill>
-                  <a:schemeClr val="tx1"/>
-                </a:solidFill>
-                <a:latin typeface="Arial" pitchFamily="34" charset="0"/>
-                <a:ea typeface="Arial" pitchFamily="34" charset="-122"/>
-                <a:cs typeface="Arial" pitchFamily="34" charset="-120"/>
-              </a:rPr>
-              <a:t>Nachos mit Dip 8,90 €</a:t>
-            </a:r>
-            <a:endParaRPr lang="en-US" sz="1300" dirty="0"/>
-          </a:p>
-          <a:p>
-            <a:pPr marL="342900" indent="-342900">
-              <a:spcAft>
-                <a:spcPts val="600"/>
-              </a:spcAft>
-              <a:buSzPct val="100000"/>
-              <a:buChar char="•"/>
-            </a:pPr>
-            <a:r>
-              <a:rPr lang="en-US" sz="1300" dirty="0">
-                <a:solidFill>
-                  <a:schemeClr val="tx1"/>
-                </a:solidFill>
-                <a:latin typeface="Arial" pitchFamily="34" charset="0"/>
-                <a:ea typeface="Arial" pitchFamily="34" charset="-122"/>
-                <a:cs typeface="Arial" pitchFamily="34" charset="-120"/>
-              </a:rPr>
-              <a:t>Käse- und Wurstplatte 14,90 €</a:t>
+              <a:t>Bowl mit Gemüse und Huhn 12,90 €</a:t>
             </a:r>
             <a:endParaRPr lang="en-US" sz="1300" dirty="0"/>
           </a:p>
@@ -17836,7 +17664,116 @@
                 <a:ea typeface="Arial" pitchFamily="34" charset="-122"/>
                 <a:cs typeface="Arial" pitchFamily="34" charset="-120"/>
               </a:rPr>
-              <a:t>Bruschetta 7,90 €</a:t>
+              <a:t>Suppe des Tages 6,50 €</a:t>
+            </a:r>
+            <a:endParaRPr lang="en-US" sz="1300" dirty="0"/>
+          </a:p>
+        </p:txBody>
+      </p:sp>
+      <p:sp>
+        <p:nvSpPr>
+          <p:cNvPr id="11" name="Abendkarte"/>
+          <p:cNvSpPr/>
+          <p:nvPr/>
+        </p:nvSpPr>
+        <p:spPr>
+          <a:xfrm>
+            <a:off x="6231636" y="1371600"/>
+            <a:ext cx="2567178" cy="3657600"/>
+          </a:xfrm>
+          <a:prstGeom prst="roundRect">
+            <a:avLst>
+              <a:gd name="adj" fmla="val 2850"/>
+            </a:avLst>
+          </a:prstGeom>
+          <a:solidFill>
+            <a:schemeClr val="bg2"/>
+          </a:solidFill>
+          <a:ln w="12700">
+            <a:solidFill>
+              <a:schemeClr val="bg2"/>
+            </a:solidFill>
+            <a:prstDash val="solid"/>
+          </a:ln>
+        </p:spPr>
+      </p:sp>
+      <p:sp>
+        <p:nvSpPr>
+          <p:cNvPr id="12" name="Text 9"/>
+          <p:cNvSpPr txBox="1"/>
+          <p:nvPr/>
+        </p:nvSpPr>
+        <p:spPr>
+          <a:xfrm>
+            <a:off x="6414516" y="1481328"/>
+            <a:ext cx="2201418" cy="457200"/>
+          </a:xfrm>
+          <a:prstGeom prst="rect">
+            <a:avLst/>
+          </a:prstGeom>
+          <a:noFill/>
+          <a:ln/>
+        </p:spPr>
+        <p:txBody>
+          <a:bodyPr wrap="square" lIns="0" tIns="0" rIns="0" bIns="0" rtlCol="0" anchor="t"/>
+          <a:lstStyle/>
+          <a:p>
+            <a:pPr indent="0" marL="0">
+              <a:buNone/>
+            </a:pPr>
+            <a:r>
+              <a:rPr lang="en-US" sz="1700" dirty="0">
+                <a:solidFill>
+                  <a:schemeClr val="accent1"/>
+                </a:solidFill>
+                <a:latin typeface="Georgia" pitchFamily="34" charset="0"/>
+                <a:ea typeface="Georgia" pitchFamily="34" charset="-122"/>
+                <a:cs typeface="Georgia" pitchFamily="34" charset="-120"/>
+              </a:rPr>
+              <a:t>Abendkarte</a:t>
+            </a:r>
+            <a:endParaRPr lang="en-US" sz="1700" dirty="0"/>
+          </a:p>
+        </p:txBody>
+      </p:sp>
+      <p:sp>
+        <p:nvSpPr>
+          <p:cNvPr id="13" name="Text 10"/>
+          <p:cNvSpPr txBox="1"/>
+          <p:nvPr/>
+        </p:nvSpPr>
+        <p:spPr>
+          <a:xfrm>
+            <a:off x="6414516" y="2011680"/>
+            <a:ext cx="2201418" cy="2926080"/>
+          </a:xfrm>
+          <a:prstGeom prst="rect">
+            <a:avLst/>
+          </a:prstGeom>
+          <a:noFill/>
+          <a:ln/>
+        </p:spPr>
+        <p:txBody>
+          <a:bodyPr wrap="square" lIns="0" tIns="0" rIns="0" bIns="0" rtlCol="0" anchor="t"/>
+          <a:lstStyle/>
+          <a:p>
+            <a:pPr marL="342900" indent="-342900">
+              <a:spcAft>
+                <a:spcPts val="600"/>
+              </a:spcAft>
+              <a:buSzPct val="100000"/>
+              <a:buChar char="•"/>
+            </a:pPr>
+            <a:r>
+              <a:rPr lang="en-US" sz="1300" dirty="0">
+                <a:solidFill>
+                  <a:schemeClr val="tx1"/>
+                </a:solidFill>
+                <a:latin typeface="Arial" pitchFamily="34" charset="0"/>
+                <a:ea typeface="Arial" pitchFamily="34" charset="-122"/>
+                <a:cs typeface="Arial" pitchFamily="34" charset="-120"/>
+              </a:rPr>
+              <a:t>Burrata mit Tomaten 11,90 €</a:t>
             </a:r>
             <a:endParaRPr lang="en-US" sz="1300" dirty="0"/>
           </a:p>
@@ -17857,7 +17794,7 @@
                 <a:ea typeface="Arial" pitchFamily="34" charset="-122"/>
                 <a:cs typeface="Arial" pitchFamily="34" charset="-120"/>
               </a:rPr>
-              <a:t>Chicken Wings 9,90 €</a:t>
+              <a:t>Burger vom Weiderind 16,90 €</a:t>
             </a:r>
             <a:endParaRPr lang="en-US" sz="1300" dirty="0"/>
           </a:p>
@@ -17878,7 +17815,70 @@
                 <a:ea typeface="Arial" pitchFamily="34" charset="-122"/>
                 <a:cs typeface="Arial" pitchFamily="34" charset="-120"/>
               </a:rPr>
-              <a:t>Süßkartoffel-Pommes 6,90 €</a:t>
+              <a:t>Schnitzel, regional 18,90 €</a:t>
+            </a:r>
+            <a:endParaRPr lang="en-US" sz="1300" dirty="0"/>
+          </a:p>
+          <a:p>
+            <a:pPr marL="342900" indent="-342900">
+              <a:spcAft>
+                <a:spcPts val="600"/>
+              </a:spcAft>
+              <a:buSzPct val="100000"/>
+              <a:buChar char="•"/>
+            </a:pPr>
+            <a:r>
+              <a:rPr lang="en-US" sz="1300" dirty="0">
+                <a:solidFill>
+                  <a:schemeClr val="tx1"/>
+                </a:solidFill>
+                <a:latin typeface="Arial" pitchFamily="34" charset="0"/>
+                <a:ea typeface="Arial" pitchFamily="34" charset="-122"/>
+                <a:cs typeface="Arial" pitchFamily="34" charset="-120"/>
+              </a:rPr>
+              <a:t>Pasta, vegetarisch 14,90 €</a:t>
+            </a:r>
+            <a:endParaRPr lang="en-US" sz="1300" dirty="0"/>
+          </a:p>
+          <a:p>
+            <a:pPr marL="342900" indent="-342900">
+              <a:spcAft>
+                <a:spcPts val="600"/>
+              </a:spcAft>
+              <a:buSzPct val="100000"/>
+              <a:buChar char="•"/>
+            </a:pPr>
+            <a:r>
+              <a:rPr lang="en-US" sz="1300" dirty="0">
+                <a:solidFill>
+                  <a:schemeClr val="tx1"/>
+                </a:solidFill>
+                <a:latin typeface="Arial" pitchFamily="34" charset="0"/>
+                <a:ea typeface="Arial" pitchFamily="34" charset="-122"/>
+                <a:cs typeface="Arial" pitchFamily="34" charset="-120"/>
+              </a:rPr>
+              <a:t>Steak mit Beilage 29,90 €</a:t>
+            </a:r>
+            <a:endParaRPr lang="en-US" sz="1300" dirty="0"/>
+          </a:p>
+          <a:p>
+            <a:pPr marL="342900" indent="-342900">
+              <a:spcAft>
+                <a:spcPts val="600"/>
+              </a:spcAft>
+              <a:buSzPct val="100000"/>
+              <a:buChar char="•"/>
+            </a:pPr>
+            <a:r>
+              <a:rPr lang="en-US" sz="1300" dirty="0">
+                <a:solidFill>
+                  <a:schemeClr val="tx1"/>
+                </a:solidFill>
+                <a:latin typeface="Arial" pitchFamily="34" charset="0"/>
+                <a:ea typeface="Arial" pitchFamily="34" charset="-122"/>
+                <a:cs typeface="Arial" pitchFamily="34" charset="-120"/>
+              </a:rPr>
+              <a:t>Dessert 7,90 €</a:t>
             </a:r>
             <a:endParaRPr lang="en-US" sz="1300" dirty="0"/>
           </a:p>
@@ -18110,7 +18110,7 @@
                 <a:ea typeface="Arial" pitchFamily="34" charset="-122"/>
                 <a:cs typeface="Arial" pitchFamily="34" charset="-120"/>
               </a:rPr>
-              <a:t>Durchschnittlicher Bon (Annahme): Frühstück 11 €, Brunch 14 €, Bowls 13 €, Kaffee 7 €, Bar mit Snacks 20–26 €, Events 40 €.</a:t>
+              <a:t>Durchschnittlicher Bon (Annahme): Frühstück 11 €, Brunch 14 €, Mittag 14 €, Abendessen 32 €, Bar 18–22 €, Feiern 45 €.</a:t>
             </a:r>
             <a:endParaRPr lang="en-US" sz="1400" dirty="0"/>
           </a:p>
@@ -18221,7 +18221,7 @@
                 <a:ea typeface="Georgia" pitchFamily="34" charset="-122"/>
                 <a:cs typeface="Georgia" pitchFamily="34" charset="-120"/>
               </a:rPr>
-              <a:t>Hauptfokus Abend: Bar mit Snacks</a:t>
+              <a:t>Hauptfokus Abend: Restaurant und Bar</a:t>
             </a:r>
             <a:endParaRPr lang="en-US" sz="2700" dirty="0"/>
           </a:p>
@@ -18323,7 +18323,7 @@
                 <a:ea typeface="Arial" pitchFamily="34" charset="-122"/>
                 <a:cs typeface="Arial" pitchFamily="34" charset="-120"/>
               </a:rPr>
-              <a:t>Snacks (kleine Küche)</a:t>
+              <a:t>Restaurant (17:30–22:00)</a:t>
             </a:r>
             <a:endParaRPr lang="en-US" sz="1300" dirty="0"/>
           </a:p>
@@ -18344,7 +18344,7 @@
                 <a:ea typeface="Arial" pitchFamily="34" charset="-122"/>
                 <a:cs typeface="Arial" pitchFamily="34" charset="-120"/>
               </a:rPr>
-              <a:t>Kurze Snackkarte: Platten, Flammkuchen, Nachos, Wings, Bruschetta</a:t>
+              <a:t>Kurze, moderne Karte mit regionalen Zutaten, Steaks und Burger, Wein-Empfehlung zum Essen</a:t>
             </a:r>
             <a:endParaRPr lang="en-US" sz="1300" dirty="0"/>
           </a:p>
@@ -18365,7 +18365,7 @@
                 <a:ea typeface="Arial" pitchFamily="34" charset="-122"/>
                 <a:cs typeface="Arial" pitchFamily="34" charset="-120"/>
               </a:rPr>
-              <a:t>Gäste teilen und bleiben, dadurch mehr Getränkeumsatz</a:t>
+              <a:t>Reservierung für Gruppen, Tische für zwei bis acht</a:t>
             </a:r>
             <a:endParaRPr lang="en-US" sz="1300" dirty="0"/>
           </a:p>
@@ -18385,7 +18385,7 @@
                 <a:ea typeface="Arial" pitchFamily="34" charset="-122"/>
                 <a:cs typeface="Arial" pitchFamily="34" charset="-120"/>
               </a:rPr>
-              <a:t>Bar (ab 17:00, Fr und Sa bis 01:00)</a:t>
+              <a:t>Bar (ab 21:00, Fr und Sa bis 01:00)</a:t>
             </a:r>
             <a:endParaRPr lang="en-US" sz="1300" dirty="0"/>
           </a:p>
@@ -18863,7 +18863,7 @@
                           <a:ea typeface="Arial" pitchFamily="34" charset="-122"/>
                           <a:cs typeface="Arial" pitchFamily="34" charset="-120"/>
                         </a:rPr>
-                        <a:t>Bar mit Snacks Di–Do, So</a:t>
+                        <a:t>Abendessen Restaurant</a:t>
                       </a:r>
                       <a:endParaRPr lang="en-US" sz="1250" dirty="0">
                         <a:latin typeface="Arial" charset="0"/>
@@ -18928,7 +18928,7 @@
                           <a:ea typeface="Arial" pitchFamily="34" charset="-122"/>
                           <a:cs typeface="Arial" pitchFamily="34" charset="-120"/>
                         </a:rPr>
-                        <a:t>17</a:t>
+                        <a:t>26</a:t>
                       </a:r>
                       <a:endParaRPr lang="en-US" sz="1250" dirty="0">
                         <a:latin typeface="Arial" charset="0"/>
@@ -18993,7 +18993,7 @@
                           <a:ea typeface="Arial" pitchFamily="34" charset="-122"/>
                           <a:cs typeface="Arial" pitchFamily="34" charset="-120"/>
                         </a:rPr>
-                        <a:t>35</a:t>
+                        <a:t>55</a:t>
                       </a:r>
                       <a:endParaRPr lang="en-US" sz="1250" dirty="0">
                         <a:latin typeface="Arial" charset="0"/>
@@ -19058,7 +19058,7 @@
                           <a:ea typeface="Arial" pitchFamily="34" charset="-122"/>
                           <a:cs typeface="Arial" pitchFamily="34" charset="-120"/>
                         </a:rPr>
-                        <a:t>20 €</a:t>
+                        <a:t>32 €</a:t>
                       </a:r>
                       <a:endParaRPr lang="en-US" sz="1250" dirty="0">
                         <a:latin typeface="Arial" charset="0"/>
@@ -19123,7 +19123,334 @@
                           <a:ea typeface="Arial" pitchFamily="34" charset="-122"/>
                           <a:cs typeface="Arial" pitchFamily="34" charset="-120"/>
                         </a:rPr>
-                        <a:t>11.900 €</a:t>
+                        <a:t>45.760 €</a:t>
+                      </a:r>
+                      <a:endParaRPr lang="en-US" sz="1250" dirty="0">
+                        <a:latin typeface="Arial" charset="0"/>
+                        <a:ea typeface="Arial" charset="0"/>
+                        <a:cs typeface="Arial" charset="0"/>
+                      </a:endParaRPr>
+                    </a:p>
+                  </a:txBody>
+                  <a:tcPr marL="91440" marR="91440" marT="45720" marB="45720">
+                    <a:lnL w="12700" cap="flat" cmpd="sng" algn="ctr">
+                      <a:solidFill>
+                        <a:srgbClr val="FFFFFF"/>
+                      </a:solidFill>
+                      <a:prstDash val="solid"/>
+                      <a:round/>
+                      <a:headEnd type="none" w="med" len="med"/>
+                      <a:tailEnd type="none" w="med" len="med"/>
+                    </a:lnL>
+                    <a:lnR w="12700" cap="flat" cmpd="sng" algn="ctr">
+                      <a:solidFill>
+                        <a:srgbClr val="FFFFFF"/>
+                      </a:solidFill>
+                      <a:prstDash val="solid"/>
+                      <a:round/>
+                      <a:headEnd type="none" w="med" len="med"/>
+                      <a:tailEnd type="none" w="med" len="med"/>
+                    </a:lnR>
+                    <a:lnT w="12700" cap="flat" cmpd="sng" algn="ctr">
+                      <a:solidFill>
+                        <a:srgbClr val="FFFFFF"/>
+                      </a:solidFill>
+                      <a:prstDash val="solid"/>
+                      <a:round/>
+                      <a:headEnd type="none" w="med" len="med"/>
+                      <a:tailEnd type="none" w="med" len="med"/>
+                    </a:lnT>
+                    <a:lnB w="12700" cap="flat" cmpd="sng" algn="ctr">
+                      <a:solidFill>
+                        <a:srgbClr val="FFFFFF"/>
+                      </a:solidFill>
+                      <a:prstDash val="solid"/>
+                      <a:round/>
+                      <a:headEnd type="none" w="med" len="med"/>
+                      <a:tailEnd type="none" w="med" len="med"/>
+                    </a:lnB>
+                  </a:tcPr>
+                </a:tc>
+              </a:tr>
+              <a:tr h="246888">
+                <a:tc>
+                  <a:txBody>
+                    <a:bodyPr/>
+                    <a:lstStyle/>
+                    <a:p>
+                      <a:pPr indent="0" marL="0">
+                        <a:buNone/>
+                      </a:pPr>
+                      <a:r>
+                        <a:rPr lang="en-US" sz="1250" dirty="0">
+                          <a:solidFill>
+                            <a:srgbClr val="000000"/>
+                          </a:solidFill>
+                          <a:latin typeface="Arial" pitchFamily="34" charset="0"/>
+                          <a:ea typeface="Arial" pitchFamily="34" charset="-122"/>
+                          <a:cs typeface="Arial" pitchFamily="34" charset="-120"/>
+                        </a:rPr>
+                        <a:t>Bar Di–Do</a:t>
+                      </a:r>
+                      <a:endParaRPr lang="en-US" sz="1250" dirty="0">
+                        <a:latin typeface="Arial" charset="0"/>
+                        <a:ea typeface="Arial" charset="0"/>
+                        <a:cs typeface="Arial" charset="0"/>
+                      </a:endParaRPr>
+                    </a:p>
+                  </a:txBody>
+                  <a:tcPr marL="91440" marR="91440" marT="45720" marB="45720">
+                    <a:lnL w="12700" cap="flat" cmpd="sng" algn="ctr">
+                      <a:solidFill>
+                        <a:srgbClr val="FFFFFF"/>
+                      </a:solidFill>
+                      <a:prstDash val="solid"/>
+                      <a:round/>
+                      <a:headEnd type="none" w="med" len="med"/>
+                      <a:tailEnd type="none" w="med" len="med"/>
+                    </a:lnL>
+                    <a:lnR w="12700" cap="flat" cmpd="sng" algn="ctr">
+                      <a:solidFill>
+                        <a:srgbClr val="FFFFFF"/>
+                      </a:solidFill>
+                      <a:prstDash val="solid"/>
+                      <a:round/>
+                      <a:headEnd type="none" w="med" len="med"/>
+                      <a:tailEnd type="none" w="med" len="med"/>
+                    </a:lnR>
+                    <a:lnT w="12700" cap="flat" cmpd="sng" algn="ctr">
+                      <a:solidFill>
+                        <a:srgbClr val="FFFFFF"/>
+                      </a:solidFill>
+                      <a:prstDash val="solid"/>
+                      <a:round/>
+                      <a:headEnd type="none" w="med" len="med"/>
+                      <a:tailEnd type="none" w="med" len="med"/>
+                    </a:lnT>
+                    <a:lnB w="12700" cap="flat" cmpd="sng" algn="ctr">
+                      <a:solidFill>
+                        <a:srgbClr val="FFFFFF"/>
+                      </a:solidFill>
+                      <a:prstDash val="solid"/>
+                      <a:round/>
+                      <a:headEnd type="none" w="med" len="med"/>
+                      <a:tailEnd type="none" w="med" len="med"/>
+                    </a:lnB>
+                  </a:tcPr>
+                </a:tc>
+                <a:tc>
+                  <a:txBody>
+                    <a:bodyPr/>
+                    <a:lstStyle/>
+                    <a:p>
+                      <a:pPr algn="r" indent="0" marL="0">
+                        <a:buNone/>
+                      </a:pPr>
+                      <a:r>
+                        <a:rPr lang="en-US" sz="1250" dirty="0">
+                          <a:solidFill>
+                            <a:srgbClr val="000000"/>
+                          </a:solidFill>
+                          <a:latin typeface="Arial" pitchFamily="34" charset="0"/>
+                          <a:ea typeface="Arial" pitchFamily="34" charset="-122"/>
+                          <a:cs typeface="Arial" pitchFamily="34" charset="-120"/>
+                        </a:rPr>
+                        <a:t>13</a:t>
+                      </a:r>
+                      <a:endParaRPr lang="en-US" sz="1250" dirty="0">
+                        <a:latin typeface="Arial" charset="0"/>
+                        <a:ea typeface="Arial" charset="0"/>
+                        <a:cs typeface="Arial" charset="0"/>
+                      </a:endParaRPr>
+                    </a:p>
+                  </a:txBody>
+                  <a:tcPr marL="91440" marR="91440" marT="45720" marB="45720">
+                    <a:lnL w="12700" cap="flat" cmpd="sng" algn="ctr">
+                      <a:solidFill>
+                        <a:srgbClr val="FFFFFF"/>
+                      </a:solidFill>
+                      <a:prstDash val="solid"/>
+                      <a:round/>
+                      <a:headEnd type="none" w="med" len="med"/>
+                      <a:tailEnd type="none" w="med" len="med"/>
+                    </a:lnL>
+                    <a:lnR w="12700" cap="flat" cmpd="sng" algn="ctr">
+                      <a:solidFill>
+                        <a:srgbClr val="FFFFFF"/>
+                      </a:solidFill>
+                      <a:prstDash val="solid"/>
+                      <a:round/>
+                      <a:headEnd type="none" w="med" len="med"/>
+                      <a:tailEnd type="none" w="med" len="med"/>
+                    </a:lnR>
+                    <a:lnT w="12700" cap="flat" cmpd="sng" algn="ctr">
+                      <a:solidFill>
+                        <a:srgbClr val="FFFFFF"/>
+                      </a:solidFill>
+                      <a:prstDash val="solid"/>
+                      <a:round/>
+                      <a:headEnd type="none" w="med" len="med"/>
+                      <a:tailEnd type="none" w="med" len="med"/>
+                    </a:lnT>
+                    <a:lnB w="12700" cap="flat" cmpd="sng" algn="ctr">
+                      <a:solidFill>
+                        <a:srgbClr val="FFFFFF"/>
+                      </a:solidFill>
+                      <a:prstDash val="solid"/>
+                      <a:round/>
+                      <a:headEnd type="none" w="med" len="med"/>
+                      <a:tailEnd type="none" w="med" len="med"/>
+                    </a:lnB>
+                  </a:tcPr>
+                </a:tc>
+                <a:tc>
+                  <a:txBody>
+                    <a:bodyPr/>
+                    <a:lstStyle/>
+                    <a:p>
+                      <a:pPr algn="r" indent="0" marL="0">
+                        <a:buNone/>
+                      </a:pPr>
+                      <a:r>
+                        <a:rPr lang="en-US" sz="1250" dirty="0">
+                          <a:solidFill>
+                            <a:srgbClr val="000000"/>
+                          </a:solidFill>
+                          <a:latin typeface="Arial" pitchFamily="34" charset="0"/>
+                          <a:ea typeface="Arial" pitchFamily="34" charset="-122"/>
+                          <a:cs typeface="Arial" pitchFamily="34" charset="-120"/>
+                        </a:rPr>
+                        <a:t>20</a:t>
+                      </a:r>
+                      <a:endParaRPr lang="en-US" sz="1250" dirty="0">
+                        <a:latin typeface="Arial" charset="0"/>
+                        <a:ea typeface="Arial" charset="0"/>
+                        <a:cs typeface="Arial" charset="0"/>
+                      </a:endParaRPr>
+                    </a:p>
+                  </a:txBody>
+                  <a:tcPr marL="91440" marR="91440" marT="45720" marB="45720">
+                    <a:lnL w="12700" cap="flat" cmpd="sng" algn="ctr">
+                      <a:solidFill>
+                        <a:srgbClr val="FFFFFF"/>
+                      </a:solidFill>
+                      <a:prstDash val="solid"/>
+                      <a:round/>
+                      <a:headEnd type="none" w="med" len="med"/>
+                      <a:tailEnd type="none" w="med" len="med"/>
+                    </a:lnL>
+                    <a:lnR w="12700" cap="flat" cmpd="sng" algn="ctr">
+                      <a:solidFill>
+                        <a:srgbClr val="FFFFFF"/>
+                      </a:solidFill>
+                      <a:prstDash val="solid"/>
+                      <a:round/>
+                      <a:headEnd type="none" w="med" len="med"/>
+                      <a:tailEnd type="none" w="med" len="med"/>
+                    </a:lnR>
+                    <a:lnT w="12700" cap="flat" cmpd="sng" algn="ctr">
+                      <a:solidFill>
+                        <a:srgbClr val="FFFFFF"/>
+                      </a:solidFill>
+                      <a:prstDash val="solid"/>
+                      <a:round/>
+                      <a:headEnd type="none" w="med" len="med"/>
+                      <a:tailEnd type="none" w="med" len="med"/>
+                    </a:lnT>
+                    <a:lnB w="12700" cap="flat" cmpd="sng" algn="ctr">
+                      <a:solidFill>
+                        <a:srgbClr val="FFFFFF"/>
+                      </a:solidFill>
+                      <a:prstDash val="solid"/>
+                      <a:round/>
+                      <a:headEnd type="none" w="med" len="med"/>
+                      <a:tailEnd type="none" w="med" len="med"/>
+                    </a:lnB>
+                  </a:tcPr>
+                </a:tc>
+                <a:tc>
+                  <a:txBody>
+                    <a:bodyPr/>
+                    <a:lstStyle/>
+                    <a:p>
+                      <a:pPr algn="r" indent="0" marL="0">
+                        <a:buNone/>
+                      </a:pPr>
+                      <a:r>
+                        <a:rPr lang="en-US" sz="1250" dirty="0">
+                          <a:solidFill>
+                            <a:srgbClr val="000000"/>
+                          </a:solidFill>
+                          <a:latin typeface="Arial" pitchFamily="34" charset="0"/>
+                          <a:ea typeface="Arial" pitchFamily="34" charset="-122"/>
+                          <a:cs typeface="Arial" pitchFamily="34" charset="-120"/>
+                        </a:rPr>
+                        <a:t>18 €</a:t>
+                      </a:r>
+                      <a:endParaRPr lang="en-US" sz="1250" dirty="0">
+                        <a:latin typeface="Arial" charset="0"/>
+                        <a:ea typeface="Arial" charset="0"/>
+                        <a:cs typeface="Arial" charset="0"/>
+                      </a:endParaRPr>
+                    </a:p>
+                  </a:txBody>
+                  <a:tcPr marL="91440" marR="91440" marT="45720" marB="45720">
+                    <a:lnL w="12700" cap="flat" cmpd="sng" algn="ctr">
+                      <a:solidFill>
+                        <a:srgbClr val="FFFFFF"/>
+                      </a:solidFill>
+                      <a:prstDash val="solid"/>
+                      <a:round/>
+                      <a:headEnd type="none" w="med" len="med"/>
+                      <a:tailEnd type="none" w="med" len="med"/>
+                    </a:lnL>
+                    <a:lnR w="12700" cap="flat" cmpd="sng" algn="ctr">
+                      <a:solidFill>
+                        <a:srgbClr val="FFFFFF"/>
+                      </a:solidFill>
+                      <a:prstDash val="solid"/>
+                      <a:round/>
+                      <a:headEnd type="none" w="med" len="med"/>
+                      <a:tailEnd type="none" w="med" len="med"/>
+                    </a:lnR>
+                    <a:lnT w="12700" cap="flat" cmpd="sng" algn="ctr">
+                      <a:solidFill>
+                        <a:srgbClr val="FFFFFF"/>
+                      </a:solidFill>
+                      <a:prstDash val="solid"/>
+                      <a:round/>
+                      <a:headEnd type="none" w="med" len="med"/>
+                      <a:tailEnd type="none" w="med" len="med"/>
+                    </a:lnT>
+                    <a:lnB w="12700" cap="flat" cmpd="sng" algn="ctr">
+                      <a:solidFill>
+                        <a:srgbClr val="FFFFFF"/>
+                      </a:solidFill>
+                      <a:prstDash val="solid"/>
+                      <a:round/>
+                      <a:headEnd type="none" w="med" len="med"/>
+                      <a:tailEnd type="none" w="med" len="med"/>
+                    </a:lnB>
+                  </a:tcPr>
+                </a:tc>
+                <a:tc>
+                  <a:txBody>
+                    <a:bodyPr/>
+                    <a:lstStyle/>
+                    <a:p>
+                      <a:pPr algn="r" indent="0" marL="0">
+                        <a:buNone/>
+                      </a:pPr>
+                      <a:r>
+                        <a:rPr lang="en-US" sz="1250" dirty="0">
+                          <a:solidFill>
+                            <a:srgbClr val="000000"/>
+                          </a:solidFill>
+                          <a:latin typeface="Arial" pitchFamily="34" charset="0"/>
+                          <a:ea typeface="Arial" pitchFamily="34" charset="-122"/>
+                          <a:cs typeface="Arial" pitchFamily="34" charset="-120"/>
+                        </a:rPr>
+                        <a:t>4.680 €</a:t>
                       </a:r>
                       <a:endParaRPr lang="en-US" sz="1250" dirty="0">
                         <a:latin typeface="Arial" charset="0"/>
@@ -19320,7 +19647,7 @@
                           <a:ea typeface="Arial" pitchFamily="34" charset="-122"/>
                           <a:cs typeface="Arial" pitchFamily="34" charset="-120"/>
                         </a:rPr>
-                        <a:t>90</a:t>
+                        <a:t>70</a:t>
                       </a:r>
                       <a:endParaRPr lang="en-US" sz="1250" dirty="0">
                         <a:latin typeface="Arial" charset="0"/>
@@ -19385,7 +19712,7 @@
                           <a:ea typeface="Arial" pitchFamily="34" charset="-122"/>
                           <a:cs typeface="Arial" pitchFamily="34" charset="-120"/>
                         </a:rPr>
-                        <a:t>26 €</a:t>
+                        <a:t>22 €</a:t>
                       </a:r>
                       <a:endParaRPr lang="en-US" sz="1250" dirty="0">
                         <a:latin typeface="Arial" charset="0"/>
@@ -19450,7 +19777,7 @@
                           <a:ea typeface="Arial" pitchFamily="34" charset="-122"/>
                           <a:cs typeface="Arial" pitchFamily="34" charset="-120"/>
                         </a:rPr>
-                        <a:t>21.060 €</a:t>
+                        <a:t>13.860 €</a:t>
                       </a:r>
                       <a:endParaRPr lang="en-US" sz="1250" dirty="0">
                         <a:latin typeface="Arial" charset="0"/>
@@ -19517,7 +19844,7 @@
                           <a:ea typeface="Arial" pitchFamily="34" charset="-122"/>
                           <a:cs typeface="Arial" pitchFamily="34" charset="-120"/>
                         </a:rPr>
-                        <a:t>Events: Live-Musik, Feiern</a:t>
+                        <a:t>Feiern, Live-Abende, Séparée</a:t>
                       </a:r>
                       <a:endParaRPr lang="en-US" sz="1250" dirty="0">
                         <a:latin typeface="Arial" charset="0"/>
@@ -19712,7 +20039,7 @@
                           <a:ea typeface="Arial" pitchFamily="34" charset="-122"/>
                           <a:cs typeface="Arial" pitchFamily="34" charset="-120"/>
                         </a:rPr>
-                        <a:t>40 €</a:t>
+                        <a:t>45 €</a:t>
                       </a:r>
                       <a:endParaRPr lang="en-US" sz="1250" dirty="0">
                         <a:latin typeface="Arial" charset="0"/>
@@ -19777,7 +20104,7 @@
                           <a:ea typeface="Arial" pitchFamily="34" charset="-122"/>
                           <a:cs typeface="Arial" pitchFamily="34" charset="-120"/>
                         </a:rPr>
-                        <a:t>6.400 €</a:t>
+                        <a:t>7.200 €</a:t>
                       </a:r>
                       <a:endParaRPr lang="en-US" sz="1250" dirty="0">
                         <a:latin typeface="Arial" charset="0"/>
@@ -20071,7 +20398,7 @@
                           <a:ea typeface="Arial" pitchFamily="34" charset="-122"/>
                           <a:cs typeface="Arial" pitchFamily="34" charset="-120"/>
                         </a:rPr>
-                        <a:t>39.360 €</a:t>
+                        <a:t>71.500 €</a:t>
                       </a:r>
                       <a:endParaRPr lang="en-US" sz="1250" dirty="0">
                         <a:latin typeface="Arial" charset="0"/>
@@ -20157,7 +20484,7 @@
                 <a:ea typeface="Georgia" pitchFamily="34" charset="-122"/>
                 <a:cs typeface="Georgia" pitchFamily="34" charset="-120"/>
               </a:rPr>
-              <a:t>61 % vom Gastro-Umsatz</a:t>
+              <a:t>75 % vom Gastro-Umsatz</a:t>
             </a:r>
             <a:endParaRPr lang="en-US" sz="2400" dirty="0"/>
           </a:p>
@@ -22410,7 +22737,7 @@
                           <a:ea typeface="Arial" pitchFamily="34" charset="-122"/>
                           <a:cs typeface="Arial" pitchFamily="34" charset="-120"/>
                         </a:rPr>
-                        <a:t>Große Bar und Theken-Zone</a:t>
+                        <a:t>Bar und Theken-Zone</a:t>
                       </a:r>
                       <a:endParaRPr lang="en-US" sz="1250" dirty="0">
                         <a:latin typeface="Arial" charset="0"/>
@@ -22475,7 +22802,7 @@
                           <a:ea typeface="Arial" pitchFamily="34" charset="-122"/>
                           <a:cs typeface="Arial" pitchFamily="34" charset="-120"/>
                         </a:rPr>
-                        <a:t>ca. 45 m²</a:t>
+                        <a:t>ca. 25 m²</a:t>
                       </a:r>
                       <a:endParaRPr lang="en-US" sz="1250" dirty="0">
                         <a:latin typeface="Arial" charset="0"/>
@@ -23001,7 +23328,7 @@
                           <a:ea typeface="Arial" pitchFamily="34" charset="-122"/>
                           <a:cs typeface="Arial" pitchFamily="34" charset="-120"/>
                         </a:rPr>
-                        <a:t>Kleine Küche, Lager, WC, Eingang</a:t>
+                        <a:t>Küche, Lager, WC, Eingang</a:t>
                       </a:r>
                       <a:endParaRPr lang="en-US" sz="1250" dirty="0">
                         <a:latin typeface="Arial" charset="0"/>
@@ -23066,7 +23393,7 @@
                           <a:ea typeface="Arial" pitchFamily="34" charset="-122"/>
                           <a:cs typeface="Arial" pitchFamily="34" charset="-120"/>
                         </a:rPr>
-                        <a:t>ca. 119 m²</a:t>
+                        <a:t>ca. 139 m²</a:t>
                       </a:r>
                       <a:endParaRPr lang="en-US" sz="1250" dirty="0">
                         <a:latin typeface="Arial" charset="0"/>

</xml_diff>

<commit_message>
12 Wohnungen, Restaurant und Bar, Gastro als getrennte Betreiberfirma, Förderungen, Gesellschafter pro Kopf, Szenarien 12 gegen 8 (Excel, Präsentationen, Businessplan, Skizzen)
Co-Authored-By: Claude Sonnet 5.5 <noreply@anthropic.com>
Claude-Session: https://claude.ai/code/session_01HJGZfxHv7bzYyqdLwg8aFJ
</commit_message>
<xml_diff>
--- a/praesentation/Neue-Mitte-Werlte_Baufeld3_Gastro-Konzept.pptx
+++ b/praesentation/Neue-Mitte-Werlte_Baufeld3_Gastro-Konzept.pptx
@@ -869,7 +869,7 @@
           <a:p>
             <a:r>
               <a:rPr lang="en-US" dirty="0"/>
-              <a:t>Marge vor Pacht 30,5 % vom Umsatz (Branchen-Richtwert, nicht aus Werlte). Bei sehr niedrigem Umsatz drücken die Fixkosten stärker, die Rechnung ist dort zu günstig.</a:t>
+              <a:t>Betreiberfirma: Marge vor Pacht 30,5 % vom Umsatz (Branchen-Richtwert, nicht aus Werlte). Pacht = Maximum aus 10 €/m² und 10 % vom Umsatz. Bei sehr niedrigem Umsatz drücken die Fixkosten stärker.</a:t>
             </a:r>
             <a:endParaRPr lang="en-US" dirty="0"/>
           </a:p>
@@ -7757,7 +7757,7 @@
                 <a:ea typeface="Arial" pitchFamily="34" charset="-122"/>
                 <a:cs typeface="Arial" pitchFamily="34" charset="-120"/>
               </a:rPr>
-              <a:t>Du führst die Gastro selbst oder verpachtest sie. Bei Verpachtung zahlt der Betreiber ca. 10 €/m² Pacht, das sind bei 510 m² ca. 5.100 € im Monat (ca. 5.3 % vom Umsatz).</a:t>
+              <a:t>Eine eigene Betreiberfirma des Bauherrn pachtet die Gastro von der Vermietungs-GbR. Die Pacht beträgt 10 % vom Umsatz, mindestens 10 €/m². Bei Plan-Umsatz sind das 9.564 € im Monat (18.75 €/m²).</a:t>
             </a:r>
             <a:endParaRPr lang="en-US" sz="1300" dirty="0"/>
           </a:p>
@@ -8143,7 +8143,7 @@
                           <a:ea typeface="Arial" pitchFamily="34" charset="-122"/>
                           <a:cs typeface="Arial" pitchFamily="34" charset="-120"/>
                         </a:rPr>
-                        <a:t>Pacht ans Haus</a:t>
+                        <a:t>Pacht an die GbR</a:t>
                       </a:r>
                       <a:endParaRPr lang="en-US" sz="1250" dirty="0">
                         <a:latin typeface="Arial" charset="0"/>
@@ -8676,7 +8676,7 @@
                           <a:ea typeface="Arial" pitchFamily="34" charset="-122"/>
                           <a:cs typeface="Arial" pitchFamily="34" charset="-120"/>
                         </a:rPr>
-                        <a:t>−5.100 €</a:t>
+                        <a:t>−6.500 €</a:t>
                       </a:r>
                       <a:endParaRPr lang="en-US" sz="1250" dirty="0">
                         <a:latin typeface="Arial" charset="0"/>
@@ -8741,7 +8741,7 @@
                           <a:ea typeface="Arial" pitchFamily="34" charset="-122"/>
                           <a:cs typeface="Arial" pitchFamily="34" charset="-120"/>
                         </a:rPr>
-                        <a:t>+14.725 €</a:t>
+                        <a:t>+13.325 €</a:t>
                       </a:r>
                       <a:endParaRPr lang="en-US" sz="1250" dirty="0">
                         <a:latin typeface="Arial" charset="0"/>
@@ -8941,7 +8941,7 @@
                           <a:ea typeface="Arial" pitchFamily="34" charset="-122"/>
                           <a:cs typeface="Arial" pitchFamily="34" charset="-120"/>
                         </a:rPr>
-                        <a:t>−5.100 €</a:t>
+                        <a:t>−8.000 €</a:t>
                       </a:r>
                       <a:endParaRPr lang="en-US" sz="1250" dirty="0">
                         <a:latin typeface="Arial" charset="0"/>
@@ -9006,7 +9006,7 @@
                           <a:ea typeface="Arial" pitchFamily="34" charset="-122"/>
                           <a:cs typeface="Arial" pitchFamily="34" charset="-120"/>
                         </a:rPr>
-                        <a:t>+19.300 €</a:t>
+                        <a:t>+16.400 €</a:t>
                       </a:r>
                       <a:endParaRPr lang="en-US" sz="1250" dirty="0">
                         <a:latin typeface="Arial" charset="0"/>
@@ -9206,7 +9206,7 @@
                           <a:ea typeface="Arial" pitchFamily="34" charset="-122"/>
                           <a:cs typeface="Arial" pitchFamily="34" charset="-120"/>
                         </a:rPr>
-                        <a:t>−5.100 €</a:t>
+                        <a:t>−9.563 €</a:t>
                       </a:r>
                       <a:endParaRPr lang="en-US" sz="1250" dirty="0">
                         <a:latin typeface="Arial" charset="0"/>
@@ -9271,7 +9271,7 @@
                           <a:ea typeface="Arial" pitchFamily="34" charset="-122"/>
                           <a:cs typeface="Arial" pitchFamily="34" charset="-120"/>
                         </a:rPr>
-                        <a:t>+24.069 €</a:t>
+                        <a:t>+19.605 €</a:t>
                       </a:r>
                       <a:endParaRPr lang="en-US" sz="1250" dirty="0">
                         <a:latin typeface="Arial" charset="0"/>
@@ -9471,7 +9471,7 @@
                           <a:ea typeface="Arial" pitchFamily="34" charset="-122"/>
                           <a:cs typeface="Arial" pitchFamily="34" charset="-120"/>
                         </a:rPr>
-                        <a:t>−5.100 €</a:t>
+                        <a:t>−11.000 €</a:t>
                       </a:r>
                       <a:endParaRPr lang="en-US" sz="1250" dirty="0">
                         <a:latin typeface="Arial" charset="0"/>
@@ -9536,7 +9536,7 @@
                           <a:ea typeface="Arial" pitchFamily="34" charset="-122"/>
                           <a:cs typeface="Arial" pitchFamily="34" charset="-120"/>
                         </a:rPr>
-                        <a:t>+28.450 €</a:t>
+                        <a:t>+22.550 €</a:t>
                       </a:r>
                       <a:endParaRPr lang="en-US" sz="1250" dirty="0">
                         <a:latin typeface="Arial" charset="0"/>
@@ -9652,7 +9652,7 @@
                 <a:ea typeface="Arial" pitchFamily="34" charset="-122"/>
                 <a:cs typeface="Arial" pitchFamily="34" charset="-120"/>
               </a:rPr>
-              <a:t>Für das ganze Haus</a:t>
+              <a:t>Betreiberfirma und GbR</a:t>
             </a:r>
             <a:endParaRPr lang="en-US" sz="1300" dirty="0"/>
           </a:p>
@@ -9669,7 +9669,7 @@
                 <a:ea typeface="Arial" pitchFamily="34" charset="-122"/>
                 <a:cs typeface="Arial" pitchFamily="34" charset="-120"/>
               </a:rPr>
-              <a:t>Mit 95.635 € Umsatz bleiben im ganzen Haus +18.954 € pro Monat nach Zinsen und Tilgung (KfW-Kredite und Hausbank, ohne Lohn). Die Gastro braucht für Break-even im Haus ca. 33.500 € Umsatz.</a:t>
+              <a:t>Mit 95.635 € Umsatz verdient die Betreiberfirma +19.605 € pro Monat nach Pacht (ohne Lohn). Die Vermietungs-GbR bekommt 9.564 € Pacht und deckt damit ihre Raten ab ca. 101.800 € Umsatz.</a:t>
             </a:r>
             <a:endParaRPr lang="en-US" sz="1300" dirty="0"/>
           </a:p>

</xml_diff>